<commit_message>
20260819 commit : temped, Notion clear
</commit_message>
<xml_diff>
--- a/notion/create_notion_img.pptx
+++ b/notion/create_notion_img.pptx
@@ -248,7 +248,7 @@
           <a:p>
             <a:fld id="{7237CE1A-8831-48B5-BA93-72483C6E34E8}" type="datetimeFigureOut">
               <a:rPr lang="ko-KR" altLang="en-US" smtClean="0"/>
-              <a:t>2026-08-18</a:t>
+              <a:t>2026-08-19</a:t>
             </a:fld>
             <a:endParaRPr lang="ko-KR" altLang="en-US"/>
           </a:p>
@@ -418,7 +418,7 @@
           <a:p>
             <a:fld id="{7237CE1A-8831-48B5-BA93-72483C6E34E8}" type="datetimeFigureOut">
               <a:rPr lang="ko-KR" altLang="en-US" smtClean="0"/>
-              <a:t>2026-08-18</a:t>
+              <a:t>2026-08-19</a:t>
             </a:fld>
             <a:endParaRPr lang="ko-KR" altLang="en-US"/>
           </a:p>
@@ -598,7 +598,7 @@
           <a:p>
             <a:fld id="{7237CE1A-8831-48B5-BA93-72483C6E34E8}" type="datetimeFigureOut">
               <a:rPr lang="ko-KR" altLang="en-US" smtClean="0"/>
-              <a:t>2026-08-18</a:t>
+              <a:t>2026-08-19</a:t>
             </a:fld>
             <a:endParaRPr lang="ko-KR" altLang="en-US"/>
           </a:p>
@@ -768,7 +768,7 @@
           <a:p>
             <a:fld id="{7237CE1A-8831-48B5-BA93-72483C6E34E8}" type="datetimeFigureOut">
               <a:rPr lang="ko-KR" altLang="en-US" smtClean="0"/>
-              <a:t>2026-08-18</a:t>
+              <a:t>2026-08-19</a:t>
             </a:fld>
             <a:endParaRPr lang="ko-KR" altLang="en-US"/>
           </a:p>
@@ -1014,7 +1014,7 @@
           <a:p>
             <a:fld id="{7237CE1A-8831-48B5-BA93-72483C6E34E8}" type="datetimeFigureOut">
               <a:rPr lang="ko-KR" altLang="en-US" smtClean="0"/>
-              <a:t>2026-08-18</a:t>
+              <a:t>2026-08-19</a:t>
             </a:fld>
             <a:endParaRPr lang="ko-KR" altLang="en-US"/>
           </a:p>
@@ -1246,7 +1246,7 @@
           <a:p>
             <a:fld id="{7237CE1A-8831-48B5-BA93-72483C6E34E8}" type="datetimeFigureOut">
               <a:rPr lang="ko-KR" altLang="en-US" smtClean="0"/>
-              <a:t>2026-08-18</a:t>
+              <a:t>2026-08-19</a:t>
             </a:fld>
             <a:endParaRPr lang="ko-KR" altLang="en-US"/>
           </a:p>
@@ -1613,7 +1613,7 @@
           <a:p>
             <a:fld id="{7237CE1A-8831-48B5-BA93-72483C6E34E8}" type="datetimeFigureOut">
               <a:rPr lang="ko-KR" altLang="en-US" smtClean="0"/>
-              <a:t>2026-08-18</a:t>
+              <a:t>2026-08-19</a:t>
             </a:fld>
             <a:endParaRPr lang="ko-KR" altLang="en-US"/>
           </a:p>
@@ -1731,7 +1731,7 @@
           <a:p>
             <a:fld id="{7237CE1A-8831-48B5-BA93-72483C6E34E8}" type="datetimeFigureOut">
               <a:rPr lang="ko-KR" altLang="en-US" smtClean="0"/>
-              <a:t>2026-08-18</a:t>
+              <a:t>2026-08-19</a:t>
             </a:fld>
             <a:endParaRPr lang="ko-KR" altLang="en-US"/>
           </a:p>
@@ -1826,7 +1826,7 @@
           <a:p>
             <a:fld id="{7237CE1A-8831-48B5-BA93-72483C6E34E8}" type="datetimeFigureOut">
               <a:rPr lang="ko-KR" altLang="en-US" smtClean="0"/>
-              <a:t>2026-08-18</a:t>
+              <a:t>2026-08-19</a:t>
             </a:fld>
             <a:endParaRPr lang="ko-KR" altLang="en-US"/>
           </a:p>
@@ -2103,7 +2103,7 @@
           <a:p>
             <a:fld id="{7237CE1A-8831-48B5-BA93-72483C6E34E8}" type="datetimeFigureOut">
               <a:rPr lang="ko-KR" altLang="en-US" smtClean="0"/>
-              <a:t>2026-08-18</a:t>
+              <a:t>2026-08-19</a:t>
             </a:fld>
             <a:endParaRPr lang="ko-KR" altLang="en-US"/>
           </a:p>
@@ -2356,7 +2356,7 @@
           <a:p>
             <a:fld id="{7237CE1A-8831-48B5-BA93-72483C6E34E8}" type="datetimeFigureOut">
               <a:rPr lang="ko-KR" altLang="en-US" smtClean="0"/>
-              <a:t>2026-08-18</a:t>
+              <a:t>2026-08-19</a:t>
             </a:fld>
             <a:endParaRPr lang="ko-KR" altLang="en-US"/>
           </a:p>
@@ -2569,7 +2569,7 @@
           <a:p>
             <a:fld id="{7237CE1A-8831-48B5-BA93-72483C6E34E8}" type="datetimeFigureOut">
               <a:rPr lang="ko-KR" altLang="en-US" smtClean="0"/>
-              <a:t>2026-08-18</a:t>
+              <a:t>2026-08-19</a:t>
             </a:fld>
             <a:endParaRPr lang="ko-KR" altLang="en-US"/>
           </a:p>
@@ -2976,48 +2976,74 @@
       </p:grpSpPr>
       <p:grpSp>
         <p:nvGrpSpPr>
-          <p:cNvPr id="22" name="그룹 21"/>
+          <p:cNvPr id="29" name="그룹 28"/>
           <p:cNvGrpSpPr/>
           <p:nvPr/>
         </p:nvGrpSpPr>
         <p:grpSpPr>
           <a:xfrm>
-            <a:off x="5486400" y="1308097"/>
-            <a:ext cx="5078284" cy="2492252"/>
-            <a:chOff x="5486400" y="1308097"/>
-            <a:chExt cx="5078284" cy="2492252"/>
+            <a:off x="1072055" y="987972"/>
+            <a:ext cx="8679202" cy="2223878"/>
+            <a:chOff x="1072055" y="987972"/>
+            <a:chExt cx="8679202" cy="2223878"/>
           </a:xfrm>
         </p:grpSpPr>
         <p:sp>
           <p:nvSpPr>
-            <p:cNvPr id="4" name="TextBox 3"/>
-            <p:cNvSpPr txBox="1"/>
+            <p:cNvPr id="2" name="모서리가 둥근 직사각형 1"/>
+            <p:cNvSpPr/>
             <p:nvPr/>
           </p:nvSpPr>
           <p:spPr>
             <a:xfrm>
-              <a:off x="5486400" y="1308097"/>
-              <a:ext cx="569387" cy="1015663"/>
+              <a:off x="1072055" y="987972"/>
+              <a:ext cx="3600000" cy="900000"/>
             </a:xfrm>
-            <a:prstGeom prst="rect">
+            <a:prstGeom prst="roundRect">
               <a:avLst/>
             </a:prstGeom>
-            <a:noFill/>
+            <a:solidFill>
+              <a:schemeClr val="accent5"/>
+            </a:solidFill>
+            <a:ln>
+              <a:noFill/>
+            </a:ln>
           </p:spPr>
+          <p:style>
+            <a:lnRef idx="2">
+              <a:schemeClr val="accent1">
+                <a:shade val="50000"/>
+              </a:schemeClr>
+            </a:lnRef>
+            <a:fillRef idx="1">
+              <a:schemeClr val="accent1"/>
+            </a:fillRef>
+            <a:effectRef idx="0">
+              <a:schemeClr val="accent1"/>
+            </a:effectRef>
+            <a:fontRef idx="minor">
+              <a:schemeClr val="lt1"/>
+            </a:fontRef>
+          </p:style>
           <p:txBody>
-            <a:bodyPr wrap="none" rtlCol="0">
-              <a:spAutoFit/>
-            </a:bodyPr>
+            <a:bodyPr rtlCol="0" anchor="ctr"/>
             <a:lstStyle/>
             <a:p>
+              <a:pPr algn="ctr"/>
               <a:r>
-                <a:rPr lang="en-US" altLang="ko-KR" sz="6000" dirty="0" smtClean="0">
+                <a:rPr lang="en-US" altLang="ko-KR" sz="2800" dirty="0" smtClean="0">
+                  <a:solidFill>
+                    <a:schemeClr val="bg1"/>
+                  </a:solidFill>
                   <a:latin typeface="나눔스퀘어 Bold" panose="020B0600000101010101" pitchFamily="50" charset="-127"/>
                   <a:ea typeface="나눔스퀘어 Bold" panose="020B0600000101010101" pitchFamily="50" charset="-127"/>
                 </a:rPr>
-                <a:t>_</a:t>
+                <a:t>JAVA Application</a:t>
               </a:r>
-              <a:endParaRPr lang="ko-KR" altLang="en-US" sz="6000" dirty="0">
+              <a:endParaRPr lang="ko-KR" altLang="en-US" sz="2800" dirty="0">
+                <a:solidFill>
+                  <a:schemeClr val="bg1"/>
+                </a:solidFill>
                 <a:latin typeface="나눔스퀘어 Bold" panose="020B0600000101010101" pitchFamily="50" charset="-127"/>
                 <a:ea typeface="나눔스퀘어 Bold" panose="020B0600000101010101" pitchFamily="50" charset="-127"/>
               </a:endParaRPr>
@@ -3026,55 +3052,60 @@
         </p:sp>
         <p:sp>
           <p:nvSpPr>
-            <p:cNvPr id="5" name="TextBox 4"/>
-            <p:cNvSpPr txBox="1"/>
+            <p:cNvPr id="15" name="모서리가 둥근 직사각형 14"/>
+            <p:cNvSpPr/>
             <p:nvPr/>
           </p:nvSpPr>
           <p:spPr>
             <a:xfrm>
-              <a:off x="7327900" y="2969951"/>
-              <a:ext cx="2077813" cy="400110"/>
+              <a:off x="7591257" y="987972"/>
+              <a:ext cx="2160000" cy="2160000"/>
             </a:xfrm>
-            <a:prstGeom prst="rect">
+            <a:prstGeom prst="roundRect">
               <a:avLst/>
             </a:prstGeom>
-            <a:noFill/>
+            <a:solidFill>
+              <a:schemeClr val="accent2"/>
+            </a:solidFill>
+            <a:ln>
+              <a:noFill/>
+            </a:ln>
           </p:spPr>
+          <p:style>
+            <a:lnRef idx="2">
+              <a:schemeClr val="accent1">
+                <a:shade val="50000"/>
+              </a:schemeClr>
+            </a:lnRef>
+            <a:fillRef idx="1">
+              <a:schemeClr val="accent1"/>
+            </a:fillRef>
+            <a:effectRef idx="0">
+              <a:schemeClr val="accent1"/>
+            </a:effectRef>
+            <a:fontRef idx="minor">
+              <a:schemeClr val="lt1"/>
+            </a:fontRef>
+          </p:style>
           <p:txBody>
-            <a:bodyPr wrap="none" rtlCol="0">
-              <a:spAutoFit/>
-            </a:bodyPr>
+            <a:bodyPr rtlCol="0" anchor="ctr"/>
             <a:lstStyle/>
             <a:p>
+              <a:pPr algn="ctr"/>
               <a:r>
-                <a:rPr lang="ko-KR" altLang="en-US" sz="2000" dirty="0" smtClean="0">
+                <a:rPr lang="en-US" altLang="ko-KR" sz="4000" dirty="0" smtClean="0">
+                  <a:solidFill>
+                    <a:schemeClr val="bg1"/>
+                  </a:solidFill>
                   <a:latin typeface="나눔스퀘어 Bold" panose="020B0600000101010101" pitchFamily="50" charset="-127"/>
                   <a:ea typeface="나눔스퀘어 Bold" panose="020B0600000101010101" pitchFamily="50" charset="-127"/>
                 </a:rPr>
-                <a:t>두 번째 글자는 </a:t>
+                <a:t>MySQL</a:t>
               </a:r>
-              <a:r>
-                <a:rPr lang="en-US" altLang="ko-KR" sz="2000" dirty="0" smtClean="0">
-                  <a:latin typeface="나눔스퀘어 Bold" panose="020B0600000101010101" pitchFamily="50" charset="-127"/>
-                  <a:ea typeface="나눔스퀘어 Bold" panose="020B0600000101010101" pitchFamily="50" charset="-127"/>
-                </a:rPr>
-                <a:t>‘ </a:t>
-              </a:r>
-              <a:r>
-                <a:rPr lang="en-US" altLang="ko-KR" sz="2000" dirty="0" err="1" smtClean="0">
-                  <a:latin typeface="나눔스퀘어 Bold" panose="020B0600000101010101" pitchFamily="50" charset="-127"/>
-                  <a:ea typeface="나눔스퀘어 Bold" panose="020B0600000101010101" pitchFamily="50" charset="-127"/>
-                </a:rPr>
-                <a:t>i</a:t>
-              </a:r>
-              <a:r>
-                <a:rPr lang="en-US" altLang="ko-KR" sz="2000" dirty="0" smtClean="0">
-                  <a:latin typeface="나눔스퀘어 Bold" panose="020B0600000101010101" pitchFamily="50" charset="-127"/>
-                  <a:ea typeface="나눔스퀘어 Bold" panose="020B0600000101010101" pitchFamily="50" charset="-127"/>
-                </a:rPr>
-                <a:t> ’</a:t>
-              </a:r>
-              <a:endParaRPr lang="ko-KR" altLang="en-US" sz="2000" dirty="0">
+              <a:endParaRPr lang="ko-KR" altLang="en-US" sz="4000" dirty="0">
+                <a:solidFill>
+                  <a:schemeClr val="bg1"/>
+                </a:solidFill>
                 <a:latin typeface="나눔스퀘어 Bold" panose="020B0600000101010101" pitchFamily="50" charset="-127"/>
                 <a:ea typeface="나눔스퀘어 Bold" panose="020B0600000101010101" pitchFamily="50" charset="-127"/>
               </a:endParaRPr>
@@ -3083,170 +3114,49 @@
         </p:sp>
         <p:sp>
           <p:nvSpPr>
-            <p:cNvPr id="6" name="TextBox 5"/>
-            <p:cNvSpPr txBox="1"/>
+            <p:cNvPr id="3" name="오른쪽 대괄호 2"/>
+            <p:cNvSpPr/>
             <p:nvPr/>
           </p:nvSpPr>
           <p:spPr>
             <a:xfrm>
-              <a:off x="7327900" y="3400239"/>
-              <a:ext cx="3236784" cy="400110"/>
+              <a:off x="4951613" y="987972"/>
+              <a:ext cx="288000" cy="2160000"/>
             </a:xfrm>
-            <a:prstGeom prst="rect">
-              <a:avLst/>
+            <a:prstGeom prst="rightBracket">
+              <a:avLst>
+                <a:gd name="adj" fmla="val 38099"/>
+              </a:avLst>
             </a:prstGeom>
-            <a:noFill/>
+            <a:ln w="57150">
+              <a:solidFill>
+                <a:schemeClr val="tx1"/>
+              </a:solidFill>
+            </a:ln>
           </p:spPr>
+          <p:style>
+            <a:lnRef idx="1">
+              <a:schemeClr val="accent1"/>
+            </a:lnRef>
+            <a:fillRef idx="0">
+              <a:schemeClr val="accent1"/>
+            </a:fillRef>
+            <a:effectRef idx="0">
+              <a:schemeClr val="accent1"/>
+            </a:effectRef>
+            <a:fontRef idx="minor">
+              <a:schemeClr val="tx1"/>
+            </a:fontRef>
+          </p:style>
           <p:txBody>
-            <a:bodyPr wrap="none" rtlCol="0">
-              <a:spAutoFit/>
-            </a:bodyPr>
+            <a:bodyPr rtlCol="0" anchor="ctr"/>
             <a:lstStyle/>
             <a:p>
-              <a:r>
-                <a:rPr lang="ko-KR" altLang="en-US" sz="2000" dirty="0" smtClean="0">
-                  <a:latin typeface="나눔스퀘어 Bold" panose="020B0600000101010101" pitchFamily="50" charset="-127"/>
-                  <a:ea typeface="나눔스퀘어 Bold" panose="020B0600000101010101" pitchFamily="50" charset="-127"/>
-                </a:rPr>
-                <a:t>첫 번째 글자는 아무 문자 </a:t>
-              </a:r>
-              <a:r>
-                <a:rPr lang="en-US" altLang="ko-KR" sz="2000" dirty="0" smtClean="0">
-                  <a:latin typeface="나눔스퀘어 Bold" panose="020B0600000101010101" pitchFamily="50" charset="-127"/>
-                  <a:ea typeface="나눔스퀘어 Bold" panose="020B0600000101010101" pitchFamily="50" charset="-127"/>
-                </a:rPr>
-                <a:t>1</a:t>
-              </a:r>
-              <a:r>
-                <a:rPr lang="ko-KR" altLang="en-US" sz="2000" dirty="0" smtClean="0">
-                  <a:latin typeface="나눔스퀘어 Bold" panose="020B0600000101010101" pitchFamily="50" charset="-127"/>
-                  <a:ea typeface="나눔스퀘어 Bold" panose="020B0600000101010101" pitchFamily="50" charset="-127"/>
-                </a:rPr>
-                <a:t>개</a:t>
-              </a:r>
-              <a:endParaRPr lang="ko-KR" altLang="en-US" sz="2000" dirty="0">
-                <a:latin typeface="나눔스퀘어 Bold" panose="020B0600000101010101" pitchFamily="50" charset="-127"/>
-                <a:ea typeface="나눔스퀘어 Bold" panose="020B0600000101010101" pitchFamily="50" charset="-127"/>
-              </a:endParaRPr>
-            </a:p>
-          </p:txBody>
-        </p:sp>
-        <p:sp>
-          <p:nvSpPr>
-            <p:cNvPr id="7" name="TextBox 6"/>
-            <p:cNvSpPr txBox="1"/>
-            <p:nvPr/>
-          </p:nvSpPr>
-          <p:spPr>
-            <a:xfrm>
-              <a:off x="7327900" y="2539663"/>
-              <a:ext cx="2951449" cy="400110"/>
-            </a:xfrm>
-            <a:prstGeom prst="rect">
-              <a:avLst/>
-            </a:prstGeom>
-            <a:noFill/>
-          </p:spPr>
-          <p:txBody>
-            <a:bodyPr wrap="none" rtlCol="0">
-              <a:spAutoFit/>
-            </a:bodyPr>
-            <a:lstStyle/>
-            <a:p>
-              <a:r>
-                <a:rPr lang="ko-KR" altLang="en-US" sz="2000" dirty="0" smtClean="0">
-                  <a:latin typeface="나눔스퀘어 Bold" panose="020B0600000101010101" pitchFamily="50" charset="-127"/>
-                  <a:ea typeface="나눔스퀘어 Bold" panose="020B0600000101010101" pitchFamily="50" charset="-127"/>
-                </a:rPr>
-                <a:t>이후에는 어떤 </a:t>
-              </a:r>
-              <a:r>
-                <a:rPr lang="ko-KR" altLang="en-US" sz="2000" dirty="0" err="1" smtClean="0">
-                  <a:latin typeface="나눔스퀘어 Bold" panose="020B0600000101010101" pitchFamily="50" charset="-127"/>
-                  <a:ea typeface="나눔스퀘어 Bold" panose="020B0600000101010101" pitchFamily="50" charset="-127"/>
-                </a:rPr>
-                <a:t>문자든</a:t>
-              </a:r>
-              <a:r>
-                <a:rPr lang="ko-KR" altLang="en-US" sz="2000" dirty="0" smtClean="0">
-                  <a:latin typeface="나눔스퀘어 Bold" panose="020B0600000101010101" pitchFamily="50" charset="-127"/>
-                  <a:ea typeface="나눔스퀘어 Bold" panose="020B0600000101010101" pitchFamily="50" charset="-127"/>
-                </a:rPr>
-                <a:t> 가능</a:t>
-              </a:r>
-              <a:endParaRPr lang="ko-KR" altLang="en-US" sz="2000" dirty="0">
-                <a:latin typeface="나눔스퀘어 Bold" panose="020B0600000101010101" pitchFamily="50" charset="-127"/>
-                <a:ea typeface="나눔스퀘어 Bold" panose="020B0600000101010101" pitchFamily="50" charset="-127"/>
-              </a:endParaRPr>
-            </a:p>
-          </p:txBody>
-        </p:sp>
-        <p:sp>
-          <p:nvSpPr>
-            <p:cNvPr id="8" name="TextBox 7"/>
-            <p:cNvSpPr txBox="1"/>
-            <p:nvPr/>
-          </p:nvSpPr>
-          <p:spPr>
-            <a:xfrm>
-              <a:off x="6055787" y="1308099"/>
-              <a:ext cx="383438" cy="1015663"/>
-            </a:xfrm>
-            <a:prstGeom prst="rect">
-              <a:avLst/>
-            </a:prstGeom>
-            <a:noFill/>
-          </p:spPr>
-          <p:txBody>
-            <a:bodyPr wrap="none" rtlCol="0">
-              <a:spAutoFit/>
-            </a:bodyPr>
-            <a:lstStyle/>
-            <a:p>
-              <a:r>
-                <a:rPr lang="en-US" altLang="ko-KR" sz="6000" dirty="0" err="1" smtClean="0">
-                  <a:latin typeface="나눔스퀘어 Bold" panose="020B0600000101010101" pitchFamily="50" charset="-127"/>
-                  <a:ea typeface="나눔스퀘어 Bold" panose="020B0600000101010101" pitchFamily="50" charset="-127"/>
-                </a:rPr>
-                <a:t>i</a:t>
-              </a:r>
-              <a:endParaRPr lang="ko-KR" altLang="en-US" sz="6000" dirty="0">
-                <a:latin typeface="나눔스퀘어 Bold" panose="020B0600000101010101" pitchFamily="50" charset="-127"/>
-                <a:ea typeface="나눔스퀘어 Bold" panose="020B0600000101010101" pitchFamily="50" charset="-127"/>
-              </a:endParaRPr>
-            </a:p>
-          </p:txBody>
-        </p:sp>
-        <p:sp>
-          <p:nvSpPr>
-            <p:cNvPr id="10" name="TextBox 9"/>
-            <p:cNvSpPr txBox="1"/>
-            <p:nvPr/>
-          </p:nvSpPr>
-          <p:spPr>
-            <a:xfrm>
-              <a:off x="6324925" y="1308098"/>
-              <a:ext cx="872355" cy="1015663"/>
-            </a:xfrm>
-            <a:prstGeom prst="rect">
-              <a:avLst/>
-            </a:prstGeom>
-            <a:noFill/>
-          </p:spPr>
-          <p:txBody>
-            <a:bodyPr wrap="none" rtlCol="0">
-              <a:spAutoFit/>
-            </a:bodyPr>
-            <a:lstStyle/>
-            <a:p>
-              <a:r>
-                <a:rPr lang="en-US" altLang="ko-KR" sz="6000" dirty="0" smtClean="0">
-                  <a:latin typeface="나눔스퀘어 Bold" panose="020B0600000101010101" pitchFamily="50" charset="-127"/>
-                  <a:ea typeface="나눔스퀘어 Bold" panose="020B0600000101010101" pitchFamily="50" charset="-127"/>
-                </a:rPr>
-                <a:t>%</a:t>
-              </a:r>
-              <a:endParaRPr lang="ko-KR" altLang="en-US" sz="6000" dirty="0">
+              <a:pPr algn="ctr"/>
+              <a:endParaRPr lang="ko-KR" altLang="en-US" sz="2000">
+                <a:solidFill>
+                  <a:schemeClr val="bg1"/>
+                </a:solidFill>
                 <a:latin typeface="나눔스퀘어 Bold" panose="020B0600000101010101" pitchFamily="50" charset="-127"/>
                 <a:ea typeface="나눔스퀘어 Bold" panose="020B0600000101010101" pitchFamily="50" charset="-127"/>
               </a:endParaRPr>
@@ -3255,25 +3165,26 @@
         </p:sp>
         <p:cxnSp>
           <p:nvCxnSpPr>
-            <p:cNvPr id="12" name="꺾인 연결선 11"/>
+            <p:cNvPr id="11" name="직선 화살표 연결선 10"/>
             <p:cNvCxnSpPr>
-              <a:stCxn id="7" idx="1"/>
-              <a:endCxn id="10" idx="2"/>
+              <a:stCxn id="3" idx="2"/>
+              <a:endCxn id="15" idx="1"/>
             </p:cNvCxnSpPr>
             <p:nvPr/>
           </p:nvCxnSpPr>
           <p:spPr>
-            <a:xfrm rot="10800000">
-              <a:off x="6761104" y="2323762"/>
-              <a:ext cx="566797" cy="415957"/>
+            <a:xfrm>
+              <a:off x="5239613" y="2067972"/>
+              <a:ext cx="2351644" cy="0"/>
             </a:xfrm>
-            <a:prstGeom prst="bentConnector2">
+            <a:prstGeom prst="straightConnector1">
               <a:avLst/>
             </a:prstGeom>
-            <a:ln w="38100">
+            <a:ln w="76200">
               <a:solidFill>
-                <a:schemeClr val="accent2"/>
+                <a:srgbClr val="FF0000"/>
               </a:solidFill>
+              <a:headEnd type="triangle"/>
               <a:tailEnd type="triangle"/>
             </a:ln>
           </p:spPr>
@@ -3292,85 +3203,320 @@
             </a:fontRef>
           </p:style>
         </p:cxnSp>
-        <p:cxnSp>
-          <p:nvCxnSpPr>
-            <p:cNvPr id="14" name="꺾인 연결선 13"/>
-            <p:cNvCxnSpPr>
-              <a:stCxn id="5" idx="1"/>
-              <a:endCxn id="8" idx="2"/>
-            </p:cNvCxnSpPr>
+        <p:sp>
+          <p:nvSpPr>
+            <p:cNvPr id="18" name="모서리가 둥근 직사각형 17"/>
+            <p:cNvSpPr/>
             <p:nvPr/>
-          </p:nvCxnSpPr>
+          </p:nvSpPr>
           <p:spPr>
-            <a:xfrm rot="10800000">
-              <a:off x="6247506" y="2323762"/>
-              <a:ext cx="1080394" cy="846244"/>
+            <a:xfrm>
+              <a:off x="1072055" y="2029537"/>
+              <a:ext cx="1728000" cy="540000"/>
             </a:xfrm>
-            <a:prstGeom prst="bentConnector2">
+            <a:prstGeom prst="roundRect">
               <a:avLst/>
             </a:prstGeom>
-            <a:ln w="38100">
-              <a:solidFill>
-                <a:schemeClr val="accent2"/>
-              </a:solidFill>
-              <a:tailEnd type="triangle"/>
+            <a:solidFill>
+              <a:schemeClr val="bg2">
+                <a:lumMod val="90000"/>
+              </a:schemeClr>
+            </a:solidFill>
+            <a:ln>
+              <a:noFill/>
             </a:ln>
           </p:spPr>
           <p:style>
-            <a:lnRef idx="1">
-              <a:schemeClr val="accent1"/>
+            <a:lnRef idx="2">
+              <a:schemeClr val="accent1">
+                <a:shade val="50000"/>
+              </a:schemeClr>
             </a:lnRef>
-            <a:fillRef idx="0">
+            <a:fillRef idx="1">
               <a:schemeClr val="accent1"/>
             </a:fillRef>
             <a:effectRef idx="0">
               <a:schemeClr val="accent1"/>
             </a:effectRef>
             <a:fontRef idx="minor">
-              <a:schemeClr val="tx1"/>
+              <a:schemeClr val="lt1"/>
             </a:fontRef>
           </p:style>
-        </p:cxnSp>
-        <p:cxnSp>
-          <p:nvCxnSpPr>
-            <p:cNvPr id="17" name="꺾인 연결선 16"/>
-            <p:cNvCxnSpPr>
-              <a:stCxn id="6" idx="1"/>
-              <a:endCxn id="4" idx="2"/>
-            </p:cNvCxnSpPr>
+          <p:txBody>
+            <a:bodyPr rtlCol="0" anchor="ctr"/>
+            <a:lstStyle/>
+            <a:p>
+              <a:pPr algn="ctr"/>
+              <a:r>
+                <a:rPr lang="en-US" altLang="ko-KR" sz="2400" dirty="0" smtClean="0">
+                  <a:solidFill>
+                    <a:schemeClr val="tx1"/>
+                  </a:solidFill>
+                  <a:latin typeface="나눔스퀘어 Bold" panose="020B0600000101010101" pitchFamily="50" charset="-127"/>
+                  <a:ea typeface="나눔스퀘어 Bold" panose="020B0600000101010101" pitchFamily="50" charset="-127"/>
+                </a:rPr>
+                <a:t>JBDC</a:t>
+              </a:r>
+              <a:endParaRPr lang="ko-KR" altLang="en-US" sz="2400" dirty="0">
+                <a:solidFill>
+                  <a:schemeClr val="tx1"/>
+                </a:solidFill>
+                <a:latin typeface="나눔스퀘어 Bold" panose="020B0600000101010101" pitchFamily="50" charset="-127"/>
+                <a:ea typeface="나눔스퀘어 Bold" panose="020B0600000101010101" pitchFamily="50" charset="-127"/>
+              </a:endParaRPr>
+            </a:p>
+          </p:txBody>
+        </p:sp>
+        <p:sp>
+          <p:nvSpPr>
+            <p:cNvPr id="26" name="모서리가 둥근 직사각형 25"/>
+            <p:cNvSpPr/>
             <p:nvPr/>
-          </p:nvCxnSpPr>
+          </p:nvSpPr>
           <p:spPr>
-            <a:xfrm rot="10800000">
-              <a:off x="5771094" y="2323760"/>
-              <a:ext cx="1556806" cy="1276534"/>
+            <a:xfrm>
+              <a:off x="2933130" y="2029537"/>
+              <a:ext cx="1728000" cy="540000"/>
             </a:xfrm>
-            <a:prstGeom prst="bentConnector2">
+            <a:prstGeom prst="roundRect">
               <a:avLst/>
             </a:prstGeom>
-            <a:ln w="38100">
-              <a:solidFill>
-                <a:schemeClr val="accent2"/>
-              </a:solidFill>
-              <a:tailEnd type="triangle"/>
+            <a:solidFill>
+              <a:schemeClr val="bg2">
+                <a:lumMod val="90000"/>
+              </a:schemeClr>
+            </a:solidFill>
+            <a:ln>
+              <a:noFill/>
             </a:ln>
           </p:spPr>
           <p:style>
-            <a:lnRef idx="1">
-              <a:schemeClr val="accent1"/>
+            <a:lnRef idx="2">
+              <a:schemeClr val="accent1">
+                <a:shade val="50000"/>
+              </a:schemeClr>
             </a:lnRef>
-            <a:fillRef idx="0">
+            <a:fillRef idx="1">
               <a:schemeClr val="accent1"/>
             </a:fillRef>
             <a:effectRef idx="0">
               <a:schemeClr val="accent1"/>
             </a:effectRef>
             <a:fontRef idx="minor">
-              <a:schemeClr val="tx1"/>
+              <a:schemeClr val="lt1"/>
             </a:fontRef>
           </p:style>
-        </p:cxnSp>
+          <p:txBody>
+            <a:bodyPr rtlCol="0" anchor="ctr"/>
+            <a:lstStyle/>
+            <a:p>
+              <a:pPr algn="ctr"/>
+              <a:r>
+                <a:rPr lang="en-US" altLang="ko-KR" sz="1600" dirty="0" smtClean="0">
+                  <a:solidFill>
+                    <a:schemeClr val="tx1"/>
+                  </a:solidFill>
+                  <a:latin typeface="나눔스퀘어 Bold" panose="020B0600000101010101" pitchFamily="50" charset="-127"/>
+                  <a:ea typeface="나눔스퀘어 Bold" panose="020B0600000101010101" pitchFamily="50" charset="-127"/>
+                </a:rPr>
+                <a:t>JBDC Template</a:t>
+              </a:r>
+              <a:endParaRPr lang="ko-KR" altLang="en-US" sz="1600" dirty="0">
+                <a:solidFill>
+                  <a:schemeClr val="tx1"/>
+                </a:solidFill>
+                <a:latin typeface="나눔스퀘어 Bold" panose="020B0600000101010101" pitchFamily="50" charset="-127"/>
+                <a:ea typeface="나눔스퀘어 Bold" panose="020B0600000101010101" pitchFamily="50" charset="-127"/>
+              </a:endParaRPr>
+            </a:p>
+          </p:txBody>
+        </p:sp>
+        <p:sp>
+          <p:nvSpPr>
+            <p:cNvPr id="27" name="모서리가 둥근 직사각형 26"/>
+            <p:cNvSpPr/>
+            <p:nvPr/>
+          </p:nvSpPr>
+          <p:spPr>
+            <a:xfrm>
+              <a:off x="1072055" y="2671850"/>
+              <a:ext cx="1728000" cy="540000"/>
+            </a:xfrm>
+            <a:prstGeom prst="roundRect">
+              <a:avLst/>
+            </a:prstGeom>
+            <a:solidFill>
+              <a:schemeClr val="bg2">
+                <a:lumMod val="90000"/>
+              </a:schemeClr>
+            </a:solidFill>
+            <a:ln>
+              <a:noFill/>
+            </a:ln>
+          </p:spPr>
+          <p:style>
+            <a:lnRef idx="2">
+              <a:schemeClr val="accent1">
+                <a:shade val="50000"/>
+              </a:schemeClr>
+            </a:lnRef>
+            <a:fillRef idx="1">
+              <a:schemeClr val="accent1"/>
+            </a:fillRef>
+            <a:effectRef idx="0">
+              <a:schemeClr val="accent1"/>
+            </a:effectRef>
+            <a:fontRef idx="minor">
+              <a:schemeClr val="lt1"/>
+            </a:fontRef>
+          </p:style>
+          <p:txBody>
+            <a:bodyPr rtlCol="0" anchor="ctr"/>
+            <a:lstStyle/>
+            <a:p>
+              <a:pPr algn="ctr"/>
+              <a:r>
+                <a:rPr lang="en-US" altLang="ko-KR" sz="2400" dirty="0" err="1" smtClean="0">
+                  <a:solidFill>
+                    <a:schemeClr val="tx1"/>
+                  </a:solidFill>
+                  <a:latin typeface="나눔스퀘어 Bold" panose="020B0600000101010101" pitchFamily="50" charset="-127"/>
+                  <a:ea typeface="나눔스퀘어 Bold" panose="020B0600000101010101" pitchFamily="50" charset="-127"/>
+                </a:rPr>
+                <a:t>MyBatis</a:t>
+              </a:r>
+              <a:endParaRPr lang="ko-KR" altLang="en-US" sz="2400" dirty="0">
+                <a:solidFill>
+                  <a:schemeClr val="tx1"/>
+                </a:solidFill>
+                <a:latin typeface="나눔스퀘어 Bold" panose="020B0600000101010101" pitchFamily="50" charset="-127"/>
+                <a:ea typeface="나눔스퀘어 Bold" panose="020B0600000101010101" pitchFamily="50" charset="-127"/>
+              </a:endParaRPr>
+            </a:p>
+          </p:txBody>
+        </p:sp>
+        <p:sp>
+          <p:nvSpPr>
+            <p:cNvPr id="28" name="모서리가 둥근 직사각형 27"/>
+            <p:cNvSpPr/>
+            <p:nvPr/>
+          </p:nvSpPr>
+          <p:spPr>
+            <a:xfrm>
+              <a:off x="2933130" y="2671850"/>
+              <a:ext cx="1728000" cy="540000"/>
+            </a:xfrm>
+            <a:prstGeom prst="roundRect">
+              <a:avLst/>
+            </a:prstGeom>
+            <a:solidFill>
+              <a:schemeClr val="bg2">
+                <a:lumMod val="90000"/>
+              </a:schemeClr>
+            </a:solidFill>
+            <a:ln>
+              <a:noFill/>
+            </a:ln>
+          </p:spPr>
+          <p:style>
+            <a:lnRef idx="2">
+              <a:schemeClr val="accent1">
+                <a:shade val="50000"/>
+              </a:schemeClr>
+            </a:lnRef>
+            <a:fillRef idx="1">
+              <a:schemeClr val="accent1"/>
+            </a:fillRef>
+            <a:effectRef idx="0">
+              <a:schemeClr val="accent1"/>
+            </a:effectRef>
+            <a:fontRef idx="minor">
+              <a:schemeClr val="lt1"/>
+            </a:fontRef>
+          </p:style>
+          <p:txBody>
+            <a:bodyPr rtlCol="0" anchor="ctr"/>
+            <a:lstStyle/>
+            <a:p>
+              <a:pPr algn="ctr"/>
+              <a:r>
+                <a:rPr lang="en-US" altLang="ko-KR" sz="2400" dirty="0" smtClean="0">
+                  <a:solidFill>
+                    <a:schemeClr val="tx1"/>
+                  </a:solidFill>
+                  <a:latin typeface="나눔스퀘어 Bold" panose="020B0600000101010101" pitchFamily="50" charset="-127"/>
+                  <a:ea typeface="나눔스퀘어 Bold" panose="020B0600000101010101" pitchFamily="50" charset="-127"/>
+                </a:rPr>
+                <a:t>JPA</a:t>
+              </a:r>
+              <a:endParaRPr lang="ko-KR" altLang="en-US" sz="2400" dirty="0">
+                <a:solidFill>
+                  <a:schemeClr val="tx1"/>
+                </a:solidFill>
+                <a:latin typeface="나눔스퀘어 Bold" panose="020B0600000101010101" pitchFamily="50" charset="-127"/>
+                <a:ea typeface="나눔스퀘어 Bold" panose="020B0600000101010101" pitchFamily="50" charset="-127"/>
+              </a:endParaRPr>
+            </a:p>
+          </p:txBody>
+        </p:sp>
       </p:grpSp>
+      <p:graphicFrame>
+        <p:nvGraphicFramePr>
+          <p:cNvPr id="30" name="개체 29"/>
+          <p:cNvGraphicFramePr>
+            <a:graphicFrameLocks noChangeAspect="1"/>
+          </p:cNvGraphicFramePr>
+          <p:nvPr>
+            <p:extLst>
+              <p:ext uri="{D42A27DB-BD31-4B8C-83A1-F6EECF244321}">
+                <p14:modId xmlns:p14="http://schemas.microsoft.com/office/powerpoint/2010/main" val="1438673992"/>
+              </p:ext>
+            </p:extLst>
+          </p:nvPr>
+        </p:nvGraphicFramePr>
+        <p:xfrm>
+          <a:off x="3081338" y="2479675"/>
+          <a:ext cx="6029325" cy="1895475"/>
+        </p:xfrm>
+        <a:graphic>
+          <a:graphicData uri="http://schemas.openxmlformats.org/presentationml/2006/ole">
+            <mc:AlternateContent xmlns:mc="http://schemas.openxmlformats.org/markup-compatibility/2006">
+              <mc:Choice xmlns:v="urn:schemas-microsoft-com:vml" Requires="v">
+                <p:oleObj spid="_x0000_s2050" name="워크시트" r:id="rId3" imgW="6029249" imgH="1895531" progId="Excel.Sheet.12">
+                  <p:embed/>
+                </p:oleObj>
+              </mc:Choice>
+              <mc:Fallback>
+                <p:oleObj name="워크시트" r:id="rId3" imgW="6029249" imgH="1895531" progId="Excel.Sheet.12">
+                  <p:embed/>
+                  <p:pic>
+                    <p:nvPicPr>
+                      <p:cNvPr id="0" name=""/>
+                      <p:cNvPicPr/>
+                      <p:nvPr/>
+                    </p:nvPicPr>
+                    <p:blipFill>
+                      <a:blip r:embed="rId4"/>
+                      <a:stretch>
+                        <a:fillRect/>
+                      </a:stretch>
+                    </p:blipFill>
+                    <p:spPr>
+                      <a:xfrm>
+                        <a:off x="3081338" y="2479675"/>
+                        <a:ext cx="6029325" cy="1895475"/>
+                      </a:xfrm>
+                      <a:prstGeom prst="rect">
+                        <a:avLst/>
+                      </a:prstGeom>
+                    </p:spPr>
+                  </p:pic>
+                </p:oleObj>
+              </mc:Fallback>
+            </mc:AlternateContent>
+          </a:graphicData>
+        </a:graphic>
+      </p:graphicFrame>
     </p:spTree>
     <p:extLst>
       <p:ext uri="{BB962C8B-B14F-4D97-AF65-F5344CB8AC3E}">
@@ -3423,7 +3569,7 @@
           <a:graphicData uri="http://schemas.openxmlformats.org/presentationml/2006/ole">
             <mc:AlternateContent xmlns:mc="http://schemas.openxmlformats.org/markup-compatibility/2006">
               <mc:Choice xmlns:v="urn:schemas-microsoft-com:vml" Requires="v">
-                <p:oleObj spid="_x0000_s1032" name="워크시트" r:id="rId3" imgW="22637898" imgH="17411877" progId="Excel.Sheet.12">
+                <p:oleObj spid="_x0000_s1036" name="워크시트" r:id="rId3" imgW="22637898" imgH="17411877" progId="Excel.Sheet.12">
                   <p:embed/>
                 </p:oleObj>
               </mc:Choice>

</xml_diff>

<commit_message>
20260820 commit : temp_finish
</commit_message>
<xml_diff>
--- a/notion/create_notion_img.pptx
+++ b/notion/create_notion_img.pptx
@@ -248,7 +248,7 @@
           <a:p>
             <a:fld id="{7237CE1A-8831-48B5-BA93-72483C6E34E8}" type="datetimeFigureOut">
               <a:rPr lang="ko-KR" altLang="en-US" smtClean="0"/>
-              <a:t>2026-08-19</a:t>
+              <a:t>2026-08-20</a:t>
             </a:fld>
             <a:endParaRPr lang="ko-KR" altLang="en-US"/>
           </a:p>
@@ -418,7 +418,7 @@
           <a:p>
             <a:fld id="{7237CE1A-8831-48B5-BA93-72483C6E34E8}" type="datetimeFigureOut">
               <a:rPr lang="ko-KR" altLang="en-US" smtClean="0"/>
-              <a:t>2026-08-19</a:t>
+              <a:t>2026-08-20</a:t>
             </a:fld>
             <a:endParaRPr lang="ko-KR" altLang="en-US"/>
           </a:p>
@@ -598,7 +598,7 @@
           <a:p>
             <a:fld id="{7237CE1A-8831-48B5-BA93-72483C6E34E8}" type="datetimeFigureOut">
               <a:rPr lang="ko-KR" altLang="en-US" smtClean="0"/>
-              <a:t>2026-08-19</a:t>
+              <a:t>2026-08-20</a:t>
             </a:fld>
             <a:endParaRPr lang="ko-KR" altLang="en-US"/>
           </a:p>
@@ -768,7 +768,7 @@
           <a:p>
             <a:fld id="{7237CE1A-8831-48B5-BA93-72483C6E34E8}" type="datetimeFigureOut">
               <a:rPr lang="ko-KR" altLang="en-US" smtClean="0"/>
-              <a:t>2026-08-19</a:t>
+              <a:t>2026-08-20</a:t>
             </a:fld>
             <a:endParaRPr lang="ko-KR" altLang="en-US"/>
           </a:p>
@@ -1014,7 +1014,7 @@
           <a:p>
             <a:fld id="{7237CE1A-8831-48B5-BA93-72483C6E34E8}" type="datetimeFigureOut">
               <a:rPr lang="ko-KR" altLang="en-US" smtClean="0"/>
-              <a:t>2026-08-19</a:t>
+              <a:t>2026-08-20</a:t>
             </a:fld>
             <a:endParaRPr lang="ko-KR" altLang="en-US"/>
           </a:p>
@@ -1246,7 +1246,7 @@
           <a:p>
             <a:fld id="{7237CE1A-8831-48B5-BA93-72483C6E34E8}" type="datetimeFigureOut">
               <a:rPr lang="ko-KR" altLang="en-US" smtClean="0"/>
-              <a:t>2026-08-19</a:t>
+              <a:t>2026-08-20</a:t>
             </a:fld>
             <a:endParaRPr lang="ko-KR" altLang="en-US"/>
           </a:p>
@@ -1613,7 +1613,7 @@
           <a:p>
             <a:fld id="{7237CE1A-8831-48B5-BA93-72483C6E34E8}" type="datetimeFigureOut">
               <a:rPr lang="ko-KR" altLang="en-US" smtClean="0"/>
-              <a:t>2026-08-19</a:t>
+              <a:t>2026-08-20</a:t>
             </a:fld>
             <a:endParaRPr lang="ko-KR" altLang="en-US"/>
           </a:p>
@@ -1731,7 +1731,7 @@
           <a:p>
             <a:fld id="{7237CE1A-8831-48B5-BA93-72483C6E34E8}" type="datetimeFigureOut">
               <a:rPr lang="ko-KR" altLang="en-US" smtClean="0"/>
-              <a:t>2026-08-19</a:t>
+              <a:t>2026-08-20</a:t>
             </a:fld>
             <a:endParaRPr lang="ko-KR" altLang="en-US"/>
           </a:p>
@@ -1826,7 +1826,7 @@
           <a:p>
             <a:fld id="{7237CE1A-8831-48B5-BA93-72483C6E34E8}" type="datetimeFigureOut">
               <a:rPr lang="ko-KR" altLang="en-US" smtClean="0"/>
-              <a:t>2026-08-19</a:t>
+              <a:t>2026-08-20</a:t>
             </a:fld>
             <a:endParaRPr lang="ko-KR" altLang="en-US"/>
           </a:p>
@@ -2103,7 +2103,7 @@
           <a:p>
             <a:fld id="{7237CE1A-8831-48B5-BA93-72483C6E34E8}" type="datetimeFigureOut">
               <a:rPr lang="ko-KR" altLang="en-US" smtClean="0"/>
-              <a:t>2026-08-19</a:t>
+              <a:t>2026-08-20</a:t>
             </a:fld>
             <a:endParaRPr lang="ko-KR" altLang="en-US"/>
           </a:p>
@@ -2356,7 +2356,7 @@
           <a:p>
             <a:fld id="{7237CE1A-8831-48B5-BA93-72483C6E34E8}" type="datetimeFigureOut">
               <a:rPr lang="ko-KR" altLang="en-US" smtClean="0"/>
-              <a:t>2026-08-19</a:t>
+              <a:t>2026-08-20</a:t>
             </a:fld>
             <a:endParaRPr lang="ko-KR" altLang="en-US"/>
           </a:p>
@@ -2569,7 +2569,7 @@
           <a:p>
             <a:fld id="{7237CE1A-8831-48B5-BA93-72483C6E34E8}" type="datetimeFigureOut">
               <a:rPr lang="ko-KR" altLang="en-US" smtClean="0"/>
-              <a:t>2026-08-19</a:t>
+              <a:t>2026-08-20</a:t>
             </a:fld>
             <a:endParaRPr lang="ko-KR" altLang="en-US"/>
           </a:p>
@@ -2974,520 +2974,34 @@
           <a:chExt cx="0" cy="0"/>
         </a:xfrm>
       </p:grpSpPr>
-      <p:grpSp>
-        <p:nvGrpSpPr>
-          <p:cNvPr id="29" name="그룹 28"/>
-          <p:cNvGrpSpPr/>
-          <p:nvPr/>
-        </p:nvGrpSpPr>
-        <p:grpSpPr>
-          <a:xfrm>
-            <a:off x="1072055" y="987972"/>
-            <a:ext cx="8679202" cy="2223878"/>
-            <a:chOff x="1072055" y="987972"/>
-            <a:chExt cx="8679202" cy="2223878"/>
-          </a:xfrm>
-        </p:grpSpPr>
-        <p:sp>
-          <p:nvSpPr>
-            <p:cNvPr id="2" name="모서리가 둥근 직사각형 1"/>
-            <p:cNvSpPr/>
-            <p:nvPr/>
-          </p:nvSpPr>
-          <p:spPr>
-            <a:xfrm>
-              <a:off x="1072055" y="987972"/>
-              <a:ext cx="3600000" cy="900000"/>
-            </a:xfrm>
-            <a:prstGeom prst="roundRect">
-              <a:avLst/>
-            </a:prstGeom>
-            <a:solidFill>
-              <a:schemeClr val="accent5"/>
-            </a:solidFill>
-            <a:ln>
-              <a:noFill/>
-            </a:ln>
-          </p:spPr>
-          <p:style>
-            <a:lnRef idx="2">
-              <a:schemeClr val="accent1">
-                <a:shade val="50000"/>
-              </a:schemeClr>
-            </a:lnRef>
-            <a:fillRef idx="1">
-              <a:schemeClr val="accent1"/>
-            </a:fillRef>
-            <a:effectRef idx="0">
-              <a:schemeClr val="accent1"/>
-            </a:effectRef>
-            <a:fontRef idx="minor">
-              <a:schemeClr val="lt1"/>
-            </a:fontRef>
-          </p:style>
-          <p:txBody>
-            <a:bodyPr rtlCol="0" anchor="ctr"/>
-            <a:lstStyle/>
-            <a:p>
-              <a:pPr algn="ctr"/>
-              <a:r>
-                <a:rPr lang="en-US" altLang="ko-KR" sz="2800" dirty="0" smtClean="0">
-                  <a:solidFill>
-                    <a:schemeClr val="bg1"/>
-                  </a:solidFill>
-                  <a:latin typeface="나눔스퀘어 Bold" panose="020B0600000101010101" pitchFamily="50" charset="-127"/>
-                  <a:ea typeface="나눔스퀘어 Bold" panose="020B0600000101010101" pitchFamily="50" charset="-127"/>
-                </a:rPr>
-                <a:t>JAVA Application</a:t>
-              </a:r>
-              <a:endParaRPr lang="ko-KR" altLang="en-US" sz="2800" dirty="0">
-                <a:solidFill>
-                  <a:schemeClr val="bg1"/>
-                </a:solidFill>
-                <a:latin typeface="나눔스퀘어 Bold" panose="020B0600000101010101" pitchFamily="50" charset="-127"/>
-                <a:ea typeface="나눔스퀘어 Bold" panose="020B0600000101010101" pitchFamily="50" charset="-127"/>
-              </a:endParaRPr>
-            </a:p>
-          </p:txBody>
-        </p:sp>
-        <p:sp>
-          <p:nvSpPr>
-            <p:cNvPr id="15" name="모서리가 둥근 직사각형 14"/>
-            <p:cNvSpPr/>
-            <p:nvPr/>
-          </p:nvSpPr>
-          <p:spPr>
-            <a:xfrm>
-              <a:off x="7591257" y="987972"/>
-              <a:ext cx="2160000" cy="2160000"/>
-            </a:xfrm>
-            <a:prstGeom prst="roundRect">
-              <a:avLst/>
-            </a:prstGeom>
-            <a:solidFill>
-              <a:schemeClr val="accent2"/>
-            </a:solidFill>
-            <a:ln>
-              <a:noFill/>
-            </a:ln>
-          </p:spPr>
-          <p:style>
-            <a:lnRef idx="2">
-              <a:schemeClr val="accent1">
-                <a:shade val="50000"/>
-              </a:schemeClr>
-            </a:lnRef>
-            <a:fillRef idx="1">
-              <a:schemeClr val="accent1"/>
-            </a:fillRef>
-            <a:effectRef idx="0">
-              <a:schemeClr val="accent1"/>
-            </a:effectRef>
-            <a:fontRef idx="minor">
-              <a:schemeClr val="lt1"/>
-            </a:fontRef>
-          </p:style>
-          <p:txBody>
-            <a:bodyPr rtlCol="0" anchor="ctr"/>
-            <a:lstStyle/>
-            <a:p>
-              <a:pPr algn="ctr"/>
-              <a:r>
-                <a:rPr lang="en-US" altLang="ko-KR" sz="4000" dirty="0" smtClean="0">
-                  <a:solidFill>
-                    <a:schemeClr val="bg1"/>
-                  </a:solidFill>
-                  <a:latin typeface="나눔스퀘어 Bold" panose="020B0600000101010101" pitchFamily="50" charset="-127"/>
-                  <a:ea typeface="나눔스퀘어 Bold" panose="020B0600000101010101" pitchFamily="50" charset="-127"/>
-                </a:rPr>
-                <a:t>MySQL</a:t>
-              </a:r>
-              <a:endParaRPr lang="ko-KR" altLang="en-US" sz="4000" dirty="0">
-                <a:solidFill>
-                  <a:schemeClr val="bg1"/>
-                </a:solidFill>
-                <a:latin typeface="나눔스퀘어 Bold" panose="020B0600000101010101" pitchFamily="50" charset="-127"/>
-                <a:ea typeface="나눔스퀘어 Bold" panose="020B0600000101010101" pitchFamily="50" charset="-127"/>
-              </a:endParaRPr>
-            </a:p>
-          </p:txBody>
-        </p:sp>
-        <p:sp>
-          <p:nvSpPr>
-            <p:cNvPr id="3" name="오른쪽 대괄호 2"/>
-            <p:cNvSpPr/>
-            <p:nvPr/>
-          </p:nvSpPr>
-          <p:spPr>
-            <a:xfrm>
-              <a:off x="4951613" y="987972"/>
-              <a:ext cx="288000" cy="2160000"/>
-            </a:xfrm>
-            <a:prstGeom prst="rightBracket">
-              <a:avLst>
-                <a:gd name="adj" fmla="val 38099"/>
-              </a:avLst>
-            </a:prstGeom>
-            <a:ln w="57150">
-              <a:solidFill>
-                <a:schemeClr val="tx1"/>
-              </a:solidFill>
-            </a:ln>
-          </p:spPr>
-          <p:style>
-            <a:lnRef idx="1">
-              <a:schemeClr val="accent1"/>
-            </a:lnRef>
-            <a:fillRef idx="0">
-              <a:schemeClr val="accent1"/>
-            </a:fillRef>
-            <a:effectRef idx="0">
-              <a:schemeClr val="accent1"/>
-            </a:effectRef>
-            <a:fontRef idx="minor">
-              <a:schemeClr val="tx1"/>
-            </a:fontRef>
-          </p:style>
-          <p:txBody>
-            <a:bodyPr rtlCol="0" anchor="ctr"/>
-            <a:lstStyle/>
-            <a:p>
-              <a:pPr algn="ctr"/>
-              <a:endParaRPr lang="ko-KR" altLang="en-US" sz="2000">
-                <a:solidFill>
-                  <a:schemeClr val="bg1"/>
-                </a:solidFill>
-                <a:latin typeface="나눔스퀘어 Bold" panose="020B0600000101010101" pitchFamily="50" charset="-127"/>
-                <a:ea typeface="나눔스퀘어 Bold" panose="020B0600000101010101" pitchFamily="50" charset="-127"/>
-              </a:endParaRPr>
-            </a:p>
-          </p:txBody>
-        </p:sp>
-        <p:cxnSp>
-          <p:nvCxnSpPr>
-            <p:cNvPr id="11" name="직선 화살표 연결선 10"/>
-            <p:cNvCxnSpPr>
-              <a:stCxn id="3" idx="2"/>
-              <a:endCxn id="15" idx="1"/>
-            </p:cNvCxnSpPr>
-            <p:nvPr/>
-          </p:nvCxnSpPr>
-          <p:spPr>
-            <a:xfrm>
-              <a:off x="5239613" y="2067972"/>
-              <a:ext cx="2351644" cy="0"/>
-            </a:xfrm>
-            <a:prstGeom prst="straightConnector1">
-              <a:avLst/>
-            </a:prstGeom>
-            <a:ln w="76200">
-              <a:solidFill>
-                <a:srgbClr val="FF0000"/>
-              </a:solidFill>
-              <a:headEnd type="triangle"/>
-              <a:tailEnd type="triangle"/>
-            </a:ln>
-          </p:spPr>
-          <p:style>
-            <a:lnRef idx="1">
-              <a:schemeClr val="accent1"/>
-            </a:lnRef>
-            <a:fillRef idx="0">
-              <a:schemeClr val="accent1"/>
-            </a:fillRef>
-            <a:effectRef idx="0">
-              <a:schemeClr val="accent1"/>
-            </a:effectRef>
-            <a:fontRef idx="minor">
-              <a:schemeClr val="tx1"/>
-            </a:fontRef>
-          </p:style>
-        </p:cxnSp>
-        <p:sp>
-          <p:nvSpPr>
-            <p:cNvPr id="18" name="모서리가 둥근 직사각형 17"/>
-            <p:cNvSpPr/>
-            <p:nvPr/>
-          </p:nvSpPr>
-          <p:spPr>
-            <a:xfrm>
-              <a:off x="1072055" y="2029537"/>
-              <a:ext cx="1728000" cy="540000"/>
-            </a:xfrm>
-            <a:prstGeom prst="roundRect">
-              <a:avLst/>
-            </a:prstGeom>
-            <a:solidFill>
-              <a:schemeClr val="bg2">
-                <a:lumMod val="90000"/>
-              </a:schemeClr>
-            </a:solidFill>
-            <a:ln>
-              <a:noFill/>
-            </a:ln>
-          </p:spPr>
-          <p:style>
-            <a:lnRef idx="2">
-              <a:schemeClr val="accent1">
-                <a:shade val="50000"/>
-              </a:schemeClr>
-            </a:lnRef>
-            <a:fillRef idx="1">
-              <a:schemeClr val="accent1"/>
-            </a:fillRef>
-            <a:effectRef idx="0">
-              <a:schemeClr val="accent1"/>
-            </a:effectRef>
-            <a:fontRef idx="minor">
-              <a:schemeClr val="lt1"/>
-            </a:fontRef>
-          </p:style>
-          <p:txBody>
-            <a:bodyPr rtlCol="0" anchor="ctr"/>
-            <a:lstStyle/>
-            <a:p>
-              <a:pPr algn="ctr"/>
-              <a:r>
-                <a:rPr lang="en-US" altLang="ko-KR" sz="2400" dirty="0" smtClean="0">
-                  <a:solidFill>
-                    <a:schemeClr val="tx1"/>
-                  </a:solidFill>
-                  <a:latin typeface="나눔스퀘어 Bold" panose="020B0600000101010101" pitchFamily="50" charset="-127"/>
-                  <a:ea typeface="나눔스퀘어 Bold" panose="020B0600000101010101" pitchFamily="50" charset="-127"/>
-                </a:rPr>
-                <a:t>JBDC</a:t>
-              </a:r>
-              <a:endParaRPr lang="ko-KR" altLang="en-US" sz="2400" dirty="0">
-                <a:solidFill>
-                  <a:schemeClr val="tx1"/>
-                </a:solidFill>
-                <a:latin typeface="나눔스퀘어 Bold" panose="020B0600000101010101" pitchFamily="50" charset="-127"/>
-                <a:ea typeface="나눔스퀘어 Bold" panose="020B0600000101010101" pitchFamily="50" charset="-127"/>
-              </a:endParaRPr>
-            </a:p>
-          </p:txBody>
-        </p:sp>
-        <p:sp>
-          <p:nvSpPr>
-            <p:cNvPr id="26" name="모서리가 둥근 직사각형 25"/>
-            <p:cNvSpPr/>
-            <p:nvPr/>
-          </p:nvSpPr>
-          <p:spPr>
-            <a:xfrm>
-              <a:off x="2933130" y="2029537"/>
-              <a:ext cx="1728000" cy="540000"/>
-            </a:xfrm>
-            <a:prstGeom prst="roundRect">
-              <a:avLst/>
-            </a:prstGeom>
-            <a:solidFill>
-              <a:schemeClr val="bg2">
-                <a:lumMod val="90000"/>
-              </a:schemeClr>
-            </a:solidFill>
-            <a:ln>
-              <a:noFill/>
-            </a:ln>
-          </p:spPr>
-          <p:style>
-            <a:lnRef idx="2">
-              <a:schemeClr val="accent1">
-                <a:shade val="50000"/>
-              </a:schemeClr>
-            </a:lnRef>
-            <a:fillRef idx="1">
-              <a:schemeClr val="accent1"/>
-            </a:fillRef>
-            <a:effectRef idx="0">
-              <a:schemeClr val="accent1"/>
-            </a:effectRef>
-            <a:fontRef idx="minor">
-              <a:schemeClr val="lt1"/>
-            </a:fontRef>
-          </p:style>
-          <p:txBody>
-            <a:bodyPr rtlCol="0" anchor="ctr"/>
-            <a:lstStyle/>
-            <a:p>
-              <a:pPr algn="ctr"/>
-              <a:r>
-                <a:rPr lang="en-US" altLang="ko-KR" sz="1600" dirty="0" smtClean="0">
-                  <a:solidFill>
-                    <a:schemeClr val="tx1"/>
-                  </a:solidFill>
-                  <a:latin typeface="나눔스퀘어 Bold" panose="020B0600000101010101" pitchFamily="50" charset="-127"/>
-                  <a:ea typeface="나눔스퀘어 Bold" panose="020B0600000101010101" pitchFamily="50" charset="-127"/>
-                </a:rPr>
-                <a:t>JBDC Template</a:t>
-              </a:r>
-              <a:endParaRPr lang="ko-KR" altLang="en-US" sz="1600" dirty="0">
-                <a:solidFill>
-                  <a:schemeClr val="tx1"/>
-                </a:solidFill>
-                <a:latin typeface="나눔스퀘어 Bold" panose="020B0600000101010101" pitchFamily="50" charset="-127"/>
-                <a:ea typeface="나눔스퀘어 Bold" panose="020B0600000101010101" pitchFamily="50" charset="-127"/>
-              </a:endParaRPr>
-            </a:p>
-          </p:txBody>
-        </p:sp>
-        <p:sp>
-          <p:nvSpPr>
-            <p:cNvPr id="27" name="모서리가 둥근 직사각형 26"/>
-            <p:cNvSpPr/>
-            <p:nvPr/>
-          </p:nvSpPr>
-          <p:spPr>
-            <a:xfrm>
-              <a:off x="1072055" y="2671850"/>
-              <a:ext cx="1728000" cy="540000"/>
-            </a:xfrm>
-            <a:prstGeom prst="roundRect">
-              <a:avLst/>
-            </a:prstGeom>
-            <a:solidFill>
-              <a:schemeClr val="bg2">
-                <a:lumMod val="90000"/>
-              </a:schemeClr>
-            </a:solidFill>
-            <a:ln>
-              <a:noFill/>
-            </a:ln>
-          </p:spPr>
-          <p:style>
-            <a:lnRef idx="2">
-              <a:schemeClr val="accent1">
-                <a:shade val="50000"/>
-              </a:schemeClr>
-            </a:lnRef>
-            <a:fillRef idx="1">
-              <a:schemeClr val="accent1"/>
-            </a:fillRef>
-            <a:effectRef idx="0">
-              <a:schemeClr val="accent1"/>
-            </a:effectRef>
-            <a:fontRef idx="minor">
-              <a:schemeClr val="lt1"/>
-            </a:fontRef>
-          </p:style>
-          <p:txBody>
-            <a:bodyPr rtlCol="0" anchor="ctr"/>
-            <a:lstStyle/>
-            <a:p>
-              <a:pPr algn="ctr"/>
-              <a:r>
-                <a:rPr lang="en-US" altLang="ko-KR" sz="2400" dirty="0" err="1" smtClean="0">
-                  <a:solidFill>
-                    <a:schemeClr val="tx1"/>
-                  </a:solidFill>
-                  <a:latin typeface="나눔스퀘어 Bold" panose="020B0600000101010101" pitchFamily="50" charset="-127"/>
-                  <a:ea typeface="나눔스퀘어 Bold" panose="020B0600000101010101" pitchFamily="50" charset="-127"/>
-                </a:rPr>
-                <a:t>MyBatis</a:t>
-              </a:r>
-              <a:endParaRPr lang="ko-KR" altLang="en-US" sz="2400" dirty="0">
-                <a:solidFill>
-                  <a:schemeClr val="tx1"/>
-                </a:solidFill>
-                <a:latin typeface="나눔스퀘어 Bold" panose="020B0600000101010101" pitchFamily="50" charset="-127"/>
-                <a:ea typeface="나눔스퀘어 Bold" panose="020B0600000101010101" pitchFamily="50" charset="-127"/>
-              </a:endParaRPr>
-            </a:p>
-          </p:txBody>
-        </p:sp>
-        <p:sp>
-          <p:nvSpPr>
-            <p:cNvPr id="28" name="모서리가 둥근 직사각형 27"/>
-            <p:cNvSpPr/>
-            <p:nvPr/>
-          </p:nvSpPr>
-          <p:spPr>
-            <a:xfrm>
-              <a:off x="2933130" y="2671850"/>
-              <a:ext cx="1728000" cy="540000"/>
-            </a:xfrm>
-            <a:prstGeom prst="roundRect">
-              <a:avLst/>
-            </a:prstGeom>
-            <a:solidFill>
-              <a:schemeClr val="bg2">
-                <a:lumMod val="90000"/>
-              </a:schemeClr>
-            </a:solidFill>
-            <a:ln>
-              <a:noFill/>
-            </a:ln>
-          </p:spPr>
-          <p:style>
-            <a:lnRef idx="2">
-              <a:schemeClr val="accent1">
-                <a:shade val="50000"/>
-              </a:schemeClr>
-            </a:lnRef>
-            <a:fillRef idx="1">
-              <a:schemeClr val="accent1"/>
-            </a:fillRef>
-            <a:effectRef idx="0">
-              <a:schemeClr val="accent1"/>
-            </a:effectRef>
-            <a:fontRef idx="minor">
-              <a:schemeClr val="lt1"/>
-            </a:fontRef>
-          </p:style>
-          <p:txBody>
-            <a:bodyPr rtlCol="0" anchor="ctr"/>
-            <a:lstStyle/>
-            <a:p>
-              <a:pPr algn="ctr"/>
-              <a:r>
-                <a:rPr lang="en-US" altLang="ko-KR" sz="2400" dirty="0" smtClean="0">
-                  <a:solidFill>
-                    <a:schemeClr val="tx1"/>
-                  </a:solidFill>
-                  <a:latin typeface="나눔스퀘어 Bold" panose="020B0600000101010101" pitchFamily="50" charset="-127"/>
-                  <a:ea typeface="나눔스퀘어 Bold" panose="020B0600000101010101" pitchFamily="50" charset="-127"/>
-                </a:rPr>
-                <a:t>JPA</a:t>
-              </a:r>
-              <a:endParaRPr lang="ko-KR" altLang="en-US" sz="2400" dirty="0">
-                <a:solidFill>
-                  <a:schemeClr val="tx1"/>
-                </a:solidFill>
-                <a:latin typeface="나눔스퀘어 Bold" panose="020B0600000101010101" pitchFamily="50" charset="-127"/>
-                <a:ea typeface="나눔스퀘어 Bold" panose="020B0600000101010101" pitchFamily="50" charset="-127"/>
-              </a:endParaRPr>
-            </a:p>
-          </p:txBody>
-        </p:sp>
-      </p:grpSp>
       <p:graphicFrame>
         <p:nvGraphicFramePr>
-          <p:cNvPr id="30" name="개체 29"/>
+          <p:cNvPr id="7" name="개체 6"/>
           <p:cNvGraphicFramePr>
             <a:graphicFrameLocks noChangeAspect="1"/>
           </p:cNvGraphicFramePr>
           <p:nvPr>
             <p:extLst>
               <p:ext uri="{D42A27DB-BD31-4B8C-83A1-F6EECF244321}">
-                <p14:modId xmlns:p14="http://schemas.microsoft.com/office/powerpoint/2010/main" val="1438673992"/>
+                <p14:modId xmlns:p14="http://schemas.microsoft.com/office/powerpoint/2010/main" val="2319005081"/>
               </p:ext>
             </p:extLst>
           </p:nvPr>
         </p:nvGraphicFramePr>
         <p:xfrm>
-          <a:off x="3081338" y="2479675"/>
-          <a:ext cx="6029325" cy="1895475"/>
+          <a:off x="5062538" y="3003550"/>
+          <a:ext cx="2066925" cy="847725"/>
         </p:xfrm>
         <a:graphic>
           <a:graphicData uri="http://schemas.openxmlformats.org/presentationml/2006/ole">
             <mc:AlternateContent xmlns:mc="http://schemas.openxmlformats.org/markup-compatibility/2006">
               <mc:Choice xmlns:v="urn:schemas-microsoft-com:vml" Requires="v">
-                <p:oleObj spid="_x0000_s2050" name="워크시트" r:id="rId3" imgW="6029249" imgH="1895531" progId="Excel.Sheet.12">
+                <p:oleObj spid="_x0000_s2053" name="워크시트" r:id="rId3" imgW="2066849" imgH="847770" progId="Excel.Sheet.12">
                   <p:embed/>
                 </p:oleObj>
               </mc:Choice>
               <mc:Fallback>
-                <p:oleObj name="워크시트" r:id="rId3" imgW="6029249" imgH="1895531" progId="Excel.Sheet.12">
+                <p:oleObj name="워크시트" r:id="rId3" imgW="2066849" imgH="847770" progId="Excel.Sheet.12">
                   <p:embed/>
                   <p:pic>
                     <p:nvPicPr>
@@ -3503,8 +3017,65 @@
                     </p:blipFill>
                     <p:spPr>
                       <a:xfrm>
-                        <a:off x="3081338" y="2479675"/>
-                        <a:ext cx="6029325" cy="1895475"/>
+                        <a:off x="5062538" y="3003550"/>
+                        <a:ext cx="2066925" cy="847725"/>
+                      </a:xfrm>
+                      <a:prstGeom prst="rect">
+                        <a:avLst/>
+                      </a:prstGeom>
+                    </p:spPr>
+                  </p:pic>
+                </p:oleObj>
+              </mc:Fallback>
+            </mc:AlternateContent>
+          </a:graphicData>
+        </a:graphic>
+      </p:graphicFrame>
+      <p:graphicFrame>
+        <p:nvGraphicFramePr>
+          <p:cNvPr id="8" name="개체 7"/>
+          <p:cNvGraphicFramePr>
+            <a:graphicFrameLocks noChangeAspect="1"/>
+          </p:cNvGraphicFramePr>
+          <p:nvPr>
+            <p:extLst>
+              <p:ext uri="{D42A27DB-BD31-4B8C-83A1-F6EECF244321}">
+                <p14:modId xmlns:p14="http://schemas.microsoft.com/office/powerpoint/2010/main" val="1304314009"/>
+              </p:ext>
+            </p:extLst>
+          </p:nvPr>
+        </p:nvGraphicFramePr>
+        <p:xfrm>
+          <a:off x="8516938" y="3317874"/>
+          <a:ext cx="2066925" cy="219075"/>
+        </p:xfrm>
+        <a:graphic>
+          <a:graphicData uri="http://schemas.openxmlformats.org/presentationml/2006/ole">
+            <mc:AlternateContent xmlns:mc="http://schemas.openxmlformats.org/markup-compatibility/2006">
+              <mc:Choice xmlns:v="urn:schemas-microsoft-com:vml" Requires="v">
+                <p:oleObj spid="_x0000_s2054" name="워크시트" r:id="rId5" imgW="2066849" imgH="219053" progId="Excel.Sheet.12">
+                  <p:embed/>
+                </p:oleObj>
+              </mc:Choice>
+              <mc:Fallback>
+                <p:oleObj name="워크시트" r:id="rId5" imgW="2066849" imgH="219053" progId="Excel.Sheet.12">
+                  <p:embed/>
+                  <p:pic>
+                    <p:nvPicPr>
+                      <p:cNvPr id="0" name=""/>
+                      <p:cNvPicPr/>
+                      <p:nvPr/>
+                    </p:nvPicPr>
+                    <p:blipFill>
+                      <a:blip r:embed="rId6"/>
+                      <a:stretch>
+                        <a:fillRect/>
+                      </a:stretch>
+                    </p:blipFill>
+                    <p:spPr>
+                      <a:xfrm>
+                        <a:off x="8516938" y="3317874"/>
+                        <a:ext cx="2066925" cy="219075"/>
                       </a:xfrm>
                       <a:prstGeom prst="rect">
                         <a:avLst/>
@@ -3569,7 +3140,7 @@
           <a:graphicData uri="http://schemas.openxmlformats.org/presentationml/2006/ole">
             <mc:AlternateContent xmlns:mc="http://schemas.openxmlformats.org/markup-compatibility/2006">
               <mc:Choice xmlns:v="urn:schemas-microsoft-com:vml" Requires="v">
-                <p:oleObj spid="_x0000_s1036" name="워크시트" r:id="rId3" imgW="22637898" imgH="17411877" progId="Excel.Sheet.12">
+                <p:oleObj spid="_x0000_s1039" name="워크시트" r:id="rId3" imgW="22637898" imgH="17411877" progId="Excel.Sheet.12">
                   <p:embed/>
                 </p:oleObj>
               </mc:Choice>

</xml_diff>

<commit_message>
20260820 commit : tomorrow?
</commit_message>
<xml_diff>
--- a/notion/create_notion_img.pptx
+++ b/notion/create_notion_img.pptx
@@ -248,7 +248,7 @@
           <a:p>
             <a:fld id="{7237CE1A-8831-48B5-BA93-72483C6E34E8}" type="datetimeFigureOut">
               <a:rPr lang="ko-KR" altLang="en-US" smtClean="0"/>
-              <a:t>2026-08-20</a:t>
+              <a:t>26-08-20(Thu)</a:t>
             </a:fld>
             <a:endParaRPr lang="ko-KR" altLang="en-US"/>
           </a:p>
@@ -418,7 +418,7 @@
           <a:p>
             <a:fld id="{7237CE1A-8831-48B5-BA93-72483C6E34E8}" type="datetimeFigureOut">
               <a:rPr lang="ko-KR" altLang="en-US" smtClean="0"/>
-              <a:t>2026-08-20</a:t>
+              <a:t>26-08-20(Thu)</a:t>
             </a:fld>
             <a:endParaRPr lang="ko-KR" altLang="en-US"/>
           </a:p>
@@ -598,7 +598,7 @@
           <a:p>
             <a:fld id="{7237CE1A-8831-48B5-BA93-72483C6E34E8}" type="datetimeFigureOut">
               <a:rPr lang="ko-KR" altLang="en-US" smtClean="0"/>
-              <a:t>2026-08-20</a:t>
+              <a:t>26-08-20(Thu)</a:t>
             </a:fld>
             <a:endParaRPr lang="ko-KR" altLang="en-US"/>
           </a:p>
@@ -768,7 +768,7 @@
           <a:p>
             <a:fld id="{7237CE1A-8831-48B5-BA93-72483C6E34E8}" type="datetimeFigureOut">
               <a:rPr lang="ko-KR" altLang="en-US" smtClean="0"/>
-              <a:t>2026-08-20</a:t>
+              <a:t>26-08-20(Thu)</a:t>
             </a:fld>
             <a:endParaRPr lang="ko-KR" altLang="en-US"/>
           </a:p>
@@ -1014,7 +1014,7 @@
           <a:p>
             <a:fld id="{7237CE1A-8831-48B5-BA93-72483C6E34E8}" type="datetimeFigureOut">
               <a:rPr lang="ko-KR" altLang="en-US" smtClean="0"/>
-              <a:t>2026-08-20</a:t>
+              <a:t>26-08-20(Thu)</a:t>
             </a:fld>
             <a:endParaRPr lang="ko-KR" altLang="en-US"/>
           </a:p>
@@ -1246,7 +1246,7 @@
           <a:p>
             <a:fld id="{7237CE1A-8831-48B5-BA93-72483C6E34E8}" type="datetimeFigureOut">
               <a:rPr lang="ko-KR" altLang="en-US" smtClean="0"/>
-              <a:t>2026-08-20</a:t>
+              <a:t>26-08-20(Thu)</a:t>
             </a:fld>
             <a:endParaRPr lang="ko-KR" altLang="en-US"/>
           </a:p>
@@ -1613,7 +1613,7 @@
           <a:p>
             <a:fld id="{7237CE1A-8831-48B5-BA93-72483C6E34E8}" type="datetimeFigureOut">
               <a:rPr lang="ko-KR" altLang="en-US" smtClean="0"/>
-              <a:t>2026-08-20</a:t>
+              <a:t>26-08-20(Thu)</a:t>
             </a:fld>
             <a:endParaRPr lang="ko-KR" altLang="en-US"/>
           </a:p>
@@ -1731,7 +1731,7 @@
           <a:p>
             <a:fld id="{7237CE1A-8831-48B5-BA93-72483C6E34E8}" type="datetimeFigureOut">
               <a:rPr lang="ko-KR" altLang="en-US" smtClean="0"/>
-              <a:t>2026-08-20</a:t>
+              <a:t>26-08-20(Thu)</a:t>
             </a:fld>
             <a:endParaRPr lang="ko-KR" altLang="en-US"/>
           </a:p>
@@ -1826,7 +1826,7 @@
           <a:p>
             <a:fld id="{7237CE1A-8831-48B5-BA93-72483C6E34E8}" type="datetimeFigureOut">
               <a:rPr lang="ko-KR" altLang="en-US" smtClean="0"/>
-              <a:t>2026-08-20</a:t>
+              <a:t>26-08-20(Thu)</a:t>
             </a:fld>
             <a:endParaRPr lang="ko-KR" altLang="en-US"/>
           </a:p>
@@ -2103,7 +2103,7 @@
           <a:p>
             <a:fld id="{7237CE1A-8831-48B5-BA93-72483C6E34E8}" type="datetimeFigureOut">
               <a:rPr lang="ko-KR" altLang="en-US" smtClean="0"/>
-              <a:t>2026-08-20</a:t>
+              <a:t>26-08-20(Thu)</a:t>
             </a:fld>
             <a:endParaRPr lang="ko-KR" altLang="en-US"/>
           </a:p>
@@ -2356,7 +2356,7 @@
           <a:p>
             <a:fld id="{7237CE1A-8831-48B5-BA93-72483C6E34E8}" type="datetimeFigureOut">
               <a:rPr lang="ko-KR" altLang="en-US" smtClean="0"/>
-              <a:t>2026-08-20</a:t>
+              <a:t>26-08-20(Thu)</a:t>
             </a:fld>
             <a:endParaRPr lang="ko-KR" altLang="en-US"/>
           </a:p>
@@ -2569,7 +2569,7 @@
           <a:p>
             <a:fld id="{7237CE1A-8831-48B5-BA93-72483C6E34E8}" type="datetimeFigureOut">
               <a:rPr lang="ko-KR" altLang="en-US" smtClean="0"/>
-              <a:t>2026-08-20</a:t>
+              <a:t>26-08-20(Thu)</a:t>
             </a:fld>
             <a:endParaRPr lang="ko-KR" altLang="en-US"/>
           </a:p>
@@ -2974,120 +2974,636 @@
           <a:chExt cx="0" cy="0"/>
         </a:xfrm>
       </p:grpSpPr>
-      <p:graphicFrame>
-        <p:nvGraphicFramePr>
-          <p:cNvPr id="7" name="개체 6"/>
-          <p:cNvGraphicFramePr>
-            <a:graphicFrameLocks noChangeAspect="1"/>
-          </p:cNvGraphicFramePr>
-          <p:nvPr>
-            <p:extLst>
-              <p:ext uri="{D42A27DB-BD31-4B8C-83A1-F6EECF244321}">
-                <p14:modId xmlns:p14="http://schemas.microsoft.com/office/powerpoint/2010/main" val="2319005081"/>
-              </p:ext>
-            </p:extLst>
-          </p:nvPr>
-        </p:nvGraphicFramePr>
-        <p:xfrm>
-          <a:off x="5062538" y="3003550"/>
-          <a:ext cx="2066925" cy="847725"/>
-        </p:xfrm>
-        <a:graphic>
-          <a:graphicData uri="http://schemas.openxmlformats.org/presentationml/2006/ole">
-            <mc:AlternateContent xmlns:mc="http://schemas.openxmlformats.org/markup-compatibility/2006">
-              <mc:Choice xmlns:v="urn:schemas-microsoft-com:vml" Requires="v">
-                <p:oleObj spid="_x0000_s2053" name="워크시트" r:id="rId3" imgW="2066849" imgH="847770" progId="Excel.Sheet.12">
-                  <p:embed/>
-                </p:oleObj>
-              </mc:Choice>
-              <mc:Fallback>
-                <p:oleObj name="워크시트" r:id="rId3" imgW="2066849" imgH="847770" progId="Excel.Sheet.12">
-                  <p:embed/>
-                  <p:pic>
-                    <p:nvPicPr>
-                      <p:cNvPr id="0" name=""/>
-                      <p:cNvPicPr/>
-                      <p:nvPr/>
-                    </p:nvPicPr>
-                    <p:blipFill>
-                      <a:blip r:embed="rId4"/>
-                      <a:stretch>
-                        <a:fillRect/>
-                      </a:stretch>
-                    </p:blipFill>
-                    <p:spPr>
-                      <a:xfrm>
-                        <a:off x="5062538" y="3003550"/>
-                        <a:ext cx="2066925" cy="847725"/>
-                      </a:xfrm>
-                      <a:prstGeom prst="rect">
-                        <a:avLst/>
-                      </a:prstGeom>
-                    </p:spPr>
-                  </p:pic>
-                </p:oleObj>
-              </mc:Fallback>
-            </mc:AlternateContent>
-          </a:graphicData>
-        </a:graphic>
-      </p:graphicFrame>
-      <p:graphicFrame>
-        <p:nvGraphicFramePr>
-          <p:cNvPr id="8" name="개체 7"/>
-          <p:cNvGraphicFramePr>
-            <a:graphicFrameLocks noChangeAspect="1"/>
-          </p:cNvGraphicFramePr>
-          <p:nvPr>
-            <p:extLst>
-              <p:ext uri="{D42A27DB-BD31-4B8C-83A1-F6EECF244321}">
-                <p14:modId xmlns:p14="http://schemas.microsoft.com/office/powerpoint/2010/main" val="1304314009"/>
-              </p:ext>
-            </p:extLst>
-          </p:nvPr>
-        </p:nvGraphicFramePr>
-        <p:xfrm>
-          <a:off x="8516938" y="3317874"/>
-          <a:ext cx="2066925" cy="219075"/>
-        </p:xfrm>
-        <a:graphic>
-          <a:graphicData uri="http://schemas.openxmlformats.org/presentationml/2006/ole">
-            <mc:AlternateContent xmlns:mc="http://schemas.openxmlformats.org/markup-compatibility/2006">
-              <mc:Choice xmlns:v="urn:schemas-microsoft-com:vml" Requires="v">
-                <p:oleObj spid="_x0000_s2054" name="워크시트" r:id="rId5" imgW="2066849" imgH="219053" progId="Excel.Sheet.12">
-                  <p:embed/>
-                </p:oleObj>
-              </mc:Choice>
-              <mc:Fallback>
-                <p:oleObj name="워크시트" r:id="rId5" imgW="2066849" imgH="219053" progId="Excel.Sheet.12">
-                  <p:embed/>
-                  <p:pic>
-                    <p:nvPicPr>
-                      <p:cNvPr id="0" name=""/>
-                      <p:cNvPicPr/>
-                      <p:nvPr/>
-                    </p:nvPicPr>
-                    <p:blipFill>
-                      <a:blip r:embed="rId6"/>
-                      <a:stretch>
-                        <a:fillRect/>
-                      </a:stretch>
-                    </p:blipFill>
-                    <p:spPr>
-                      <a:xfrm>
-                        <a:off x="8516938" y="3317874"/>
-                        <a:ext cx="2066925" cy="219075"/>
-                      </a:xfrm>
-                      <a:prstGeom prst="rect">
-                        <a:avLst/>
-                      </a:prstGeom>
-                    </p:spPr>
-                  </p:pic>
-                </p:oleObj>
-              </mc:Fallback>
-            </mc:AlternateContent>
-          </a:graphicData>
-        </a:graphic>
-      </p:graphicFrame>
+      <p:grpSp>
+        <p:nvGrpSpPr>
+          <p:cNvPr id="62" name="그룹 61"/>
+          <p:cNvGrpSpPr/>
+          <p:nvPr/>
+        </p:nvGrpSpPr>
+        <p:grpSpPr>
+          <a:xfrm>
+            <a:off x="-252919" y="968054"/>
+            <a:ext cx="12704119" cy="2629657"/>
+            <a:chOff x="-252919" y="968054"/>
+            <a:chExt cx="12704119" cy="2629657"/>
+          </a:xfrm>
+        </p:grpSpPr>
+        <p:sp>
+          <p:nvSpPr>
+            <p:cNvPr id="30" name="직사각형 29"/>
+            <p:cNvSpPr/>
+            <p:nvPr/>
+          </p:nvSpPr>
+          <p:spPr>
+            <a:xfrm>
+              <a:off x="-252919" y="968054"/>
+              <a:ext cx="12704119" cy="1015663"/>
+            </a:xfrm>
+            <a:prstGeom prst="rect">
+              <a:avLst/>
+            </a:prstGeom>
+          </p:spPr>
+          <p:txBody>
+            <a:bodyPr wrap="none">
+              <a:spAutoFit/>
+            </a:bodyPr>
+            <a:lstStyle/>
+            <a:p>
+              <a:r>
+                <a:rPr lang="en-US" altLang="ko-KR" sz="6000" dirty="0">
+                  <a:latin typeface="나눔스퀘어 Bold" panose="020B0600000101010101" pitchFamily="50" charset="-127"/>
+                  <a:ea typeface="나눔스퀘어 Bold" panose="020B0600000101010101" pitchFamily="50" charset="-127"/>
+                </a:rPr>
+                <a:t>http://localhost:8090/MemberPjt/</a:t>
+              </a:r>
+              <a:endParaRPr lang="ko-KR" altLang="en-US" sz="6000" dirty="0">
+                <a:latin typeface="나눔스퀘어 Bold" panose="020B0600000101010101" pitchFamily="50" charset="-127"/>
+                <a:ea typeface="나눔스퀘어 Bold" panose="020B0600000101010101" pitchFamily="50" charset="-127"/>
+              </a:endParaRPr>
+            </a:p>
+          </p:txBody>
+        </p:sp>
+        <p:sp>
+          <p:nvSpPr>
+            <p:cNvPr id="36" name="모서리가 둥근 직사각형 35"/>
+            <p:cNvSpPr/>
+            <p:nvPr/>
+          </p:nvSpPr>
+          <p:spPr>
+            <a:xfrm>
+              <a:off x="-116730" y="2877711"/>
+              <a:ext cx="2880000" cy="720000"/>
+            </a:xfrm>
+            <a:prstGeom prst="roundRect">
+              <a:avLst/>
+            </a:prstGeom>
+            <a:solidFill>
+              <a:schemeClr val="bg1"/>
+            </a:solidFill>
+            <a:ln w="38100">
+              <a:solidFill>
+                <a:schemeClr val="tx1"/>
+              </a:solidFill>
+            </a:ln>
+          </p:spPr>
+          <p:style>
+            <a:lnRef idx="2">
+              <a:schemeClr val="accent1">
+                <a:shade val="50000"/>
+              </a:schemeClr>
+            </a:lnRef>
+            <a:fillRef idx="1">
+              <a:schemeClr val="accent1"/>
+            </a:fillRef>
+            <a:effectRef idx="0">
+              <a:schemeClr val="accent1"/>
+            </a:effectRef>
+            <a:fontRef idx="minor">
+              <a:schemeClr val="lt1"/>
+            </a:fontRef>
+          </p:style>
+          <p:txBody>
+            <a:bodyPr rtlCol="0" anchor="ctr"/>
+            <a:lstStyle/>
+            <a:p>
+              <a:pPr algn="ctr"/>
+              <a:r>
+                <a:rPr lang="en-US" altLang="ko-KR" sz="4000" dirty="0" smtClean="0">
+                  <a:solidFill>
+                    <a:schemeClr val="tx1"/>
+                  </a:solidFill>
+                </a:rPr>
+                <a:t>Protocol</a:t>
+              </a:r>
+              <a:endParaRPr lang="ko-KR" altLang="en-US" sz="4000" dirty="0">
+                <a:solidFill>
+                  <a:schemeClr val="tx1"/>
+                </a:solidFill>
+              </a:endParaRPr>
+            </a:p>
+          </p:txBody>
+        </p:sp>
+        <p:sp>
+          <p:nvSpPr>
+            <p:cNvPr id="37" name="모서리가 둥근 직사각형 36"/>
+            <p:cNvSpPr/>
+            <p:nvPr/>
+          </p:nvSpPr>
+          <p:spPr>
+            <a:xfrm>
+              <a:off x="3070854" y="2867983"/>
+              <a:ext cx="2880000" cy="720000"/>
+            </a:xfrm>
+            <a:prstGeom prst="roundRect">
+              <a:avLst/>
+            </a:prstGeom>
+            <a:solidFill>
+              <a:schemeClr val="bg1"/>
+            </a:solidFill>
+            <a:ln w="38100">
+              <a:solidFill>
+                <a:schemeClr val="tx1"/>
+              </a:solidFill>
+            </a:ln>
+          </p:spPr>
+          <p:style>
+            <a:lnRef idx="2">
+              <a:schemeClr val="accent1">
+                <a:shade val="50000"/>
+              </a:schemeClr>
+            </a:lnRef>
+            <a:fillRef idx="1">
+              <a:schemeClr val="accent1"/>
+            </a:fillRef>
+            <a:effectRef idx="0">
+              <a:schemeClr val="accent1"/>
+            </a:effectRef>
+            <a:fontRef idx="minor">
+              <a:schemeClr val="lt1"/>
+            </a:fontRef>
+          </p:style>
+          <p:txBody>
+            <a:bodyPr rtlCol="0" anchor="ctr"/>
+            <a:lstStyle/>
+            <a:p>
+              <a:pPr algn="ctr"/>
+              <a:r>
+                <a:rPr lang="en-US" altLang="ko-KR" sz="4000" dirty="0" smtClean="0">
+                  <a:solidFill>
+                    <a:schemeClr val="tx1"/>
+                  </a:solidFill>
+                </a:rPr>
+                <a:t>Host</a:t>
+              </a:r>
+              <a:endParaRPr lang="ko-KR" altLang="en-US" sz="4000" dirty="0">
+                <a:solidFill>
+                  <a:schemeClr val="tx1"/>
+                </a:solidFill>
+              </a:endParaRPr>
+            </a:p>
+          </p:txBody>
+        </p:sp>
+        <p:sp>
+          <p:nvSpPr>
+            <p:cNvPr id="38" name="모서리가 둥근 직사각형 37"/>
+            <p:cNvSpPr/>
+            <p:nvPr/>
+          </p:nvSpPr>
+          <p:spPr>
+            <a:xfrm>
+              <a:off x="6258438" y="2877711"/>
+              <a:ext cx="2880000" cy="720000"/>
+            </a:xfrm>
+            <a:prstGeom prst="roundRect">
+              <a:avLst/>
+            </a:prstGeom>
+            <a:solidFill>
+              <a:schemeClr val="bg1"/>
+            </a:solidFill>
+            <a:ln w="38100">
+              <a:solidFill>
+                <a:schemeClr val="tx1"/>
+              </a:solidFill>
+            </a:ln>
+          </p:spPr>
+          <p:style>
+            <a:lnRef idx="2">
+              <a:schemeClr val="accent1">
+                <a:shade val="50000"/>
+              </a:schemeClr>
+            </a:lnRef>
+            <a:fillRef idx="1">
+              <a:schemeClr val="accent1"/>
+            </a:fillRef>
+            <a:effectRef idx="0">
+              <a:schemeClr val="accent1"/>
+            </a:effectRef>
+            <a:fontRef idx="minor">
+              <a:schemeClr val="lt1"/>
+            </a:fontRef>
+          </p:style>
+          <p:txBody>
+            <a:bodyPr rtlCol="0" anchor="ctr"/>
+            <a:lstStyle/>
+            <a:p>
+              <a:pPr algn="ctr"/>
+              <a:r>
+                <a:rPr lang="en-US" altLang="ko-KR" sz="4000" dirty="0" smtClean="0">
+                  <a:solidFill>
+                    <a:schemeClr val="tx1"/>
+                  </a:solidFill>
+                </a:rPr>
+                <a:t>Port</a:t>
+              </a:r>
+              <a:endParaRPr lang="ko-KR" altLang="en-US" sz="4000" dirty="0">
+                <a:solidFill>
+                  <a:schemeClr val="tx1"/>
+                </a:solidFill>
+              </a:endParaRPr>
+            </a:p>
+          </p:txBody>
+        </p:sp>
+        <p:sp>
+          <p:nvSpPr>
+            <p:cNvPr id="39" name="모서리가 둥근 직사각형 38"/>
+            <p:cNvSpPr/>
+            <p:nvPr/>
+          </p:nvSpPr>
+          <p:spPr>
+            <a:xfrm>
+              <a:off x="9446022" y="2877711"/>
+              <a:ext cx="2880000" cy="720000"/>
+            </a:xfrm>
+            <a:prstGeom prst="roundRect">
+              <a:avLst/>
+            </a:prstGeom>
+            <a:solidFill>
+              <a:schemeClr val="bg1"/>
+            </a:solidFill>
+            <a:ln w="38100">
+              <a:solidFill>
+                <a:schemeClr val="tx1"/>
+              </a:solidFill>
+            </a:ln>
+          </p:spPr>
+          <p:style>
+            <a:lnRef idx="2">
+              <a:schemeClr val="accent1">
+                <a:shade val="50000"/>
+              </a:schemeClr>
+            </a:lnRef>
+            <a:fillRef idx="1">
+              <a:schemeClr val="accent1"/>
+            </a:fillRef>
+            <a:effectRef idx="0">
+              <a:schemeClr val="accent1"/>
+            </a:effectRef>
+            <a:fontRef idx="minor">
+              <a:schemeClr val="lt1"/>
+            </a:fontRef>
+          </p:style>
+          <p:txBody>
+            <a:bodyPr rtlCol="0" anchor="ctr"/>
+            <a:lstStyle/>
+            <a:p>
+              <a:pPr algn="ctr"/>
+              <a:r>
+                <a:rPr lang="en-US" altLang="ko-KR" sz="3200" dirty="0" smtClean="0">
+                  <a:solidFill>
+                    <a:schemeClr val="tx1"/>
+                  </a:solidFill>
+                </a:rPr>
+                <a:t>Context Path</a:t>
+              </a:r>
+              <a:endParaRPr lang="ko-KR" altLang="en-US" sz="3200" dirty="0">
+                <a:solidFill>
+                  <a:schemeClr val="tx1"/>
+                </a:solidFill>
+              </a:endParaRPr>
+            </a:p>
+          </p:txBody>
+        </p:sp>
+        <p:sp>
+          <p:nvSpPr>
+            <p:cNvPr id="46" name="직사각형 45"/>
+            <p:cNvSpPr/>
+            <p:nvPr/>
+          </p:nvSpPr>
+          <p:spPr>
+            <a:xfrm>
+              <a:off x="-194554" y="1969647"/>
+              <a:ext cx="2160000" cy="36000"/>
+            </a:xfrm>
+            <a:prstGeom prst="rect">
+              <a:avLst/>
+            </a:prstGeom>
+            <a:solidFill>
+              <a:schemeClr val="tx1"/>
+            </a:solidFill>
+            <a:ln>
+              <a:noFill/>
+            </a:ln>
+          </p:spPr>
+          <p:style>
+            <a:lnRef idx="2">
+              <a:schemeClr val="accent1">
+                <a:shade val="50000"/>
+              </a:schemeClr>
+            </a:lnRef>
+            <a:fillRef idx="1">
+              <a:schemeClr val="accent1"/>
+            </a:fillRef>
+            <a:effectRef idx="0">
+              <a:schemeClr val="accent1"/>
+            </a:effectRef>
+            <a:fontRef idx="minor">
+              <a:schemeClr val="lt1"/>
+            </a:fontRef>
+          </p:style>
+          <p:txBody>
+            <a:bodyPr rtlCol="0" anchor="ctr"/>
+            <a:lstStyle/>
+            <a:p>
+              <a:pPr algn="ctr"/>
+              <a:endParaRPr lang="ko-KR" altLang="en-US"/>
+            </a:p>
+          </p:txBody>
+        </p:sp>
+        <p:sp>
+          <p:nvSpPr>
+            <p:cNvPr id="47" name="직사각형 46"/>
+            <p:cNvSpPr/>
+            <p:nvPr/>
+          </p:nvSpPr>
+          <p:spPr>
+            <a:xfrm>
+              <a:off x="2273029" y="1961116"/>
+              <a:ext cx="3240000" cy="36000"/>
+            </a:xfrm>
+            <a:prstGeom prst="rect">
+              <a:avLst/>
+            </a:prstGeom>
+            <a:solidFill>
+              <a:schemeClr val="tx1"/>
+            </a:solidFill>
+            <a:ln>
+              <a:noFill/>
+            </a:ln>
+          </p:spPr>
+          <p:style>
+            <a:lnRef idx="2">
+              <a:schemeClr val="accent1">
+                <a:shade val="50000"/>
+              </a:schemeClr>
+            </a:lnRef>
+            <a:fillRef idx="1">
+              <a:schemeClr val="accent1"/>
+            </a:fillRef>
+            <a:effectRef idx="0">
+              <a:schemeClr val="accent1"/>
+            </a:effectRef>
+            <a:fontRef idx="minor">
+              <a:schemeClr val="lt1"/>
+            </a:fontRef>
+          </p:style>
+          <p:txBody>
+            <a:bodyPr rtlCol="0" anchor="ctr"/>
+            <a:lstStyle/>
+            <a:p>
+              <a:pPr algn="ctr"/>
+              <a:endParaRPr lang="ko-KR" altLang="en-US"/>
+            </a:p>
+          </p:txBody>
+        </p:sp>
+        <p:sp>
+          <p:nvSpPr>
+            <p:cNvPr id="48" name="직사각형 47"/>
+            <p:cNvSpPr/>
+            <p:nvPr/>
+          </p:nvSpPr>
+          <p:spPr>
+            <a:xfrm>
+              <a:off x="5820612" y="1958922"/>
+              <a:ext cx="1800000" cy="36000"/>
+            </a:xfrm>
+            <a:prstGeom prst="rect">
+              <a:avLst/>
+            </a:prstGeom>
+            <a:solidFill>
+              <a:schemeClr val="tx1"/>
+            </a:solidFill>
+            <a:ln>
+              <a:noFill/>
+            </a:ln>
+          </p:spPr>
+          <p:style>
+            <a:lnRef idx="2">
+              <a:schemeClr val="accent1">
+                <a:shade val="50000"/>
+              </a:schemeClr>
+            </a:lnRef>
+            <a:fillRef idx="1">
+              <a:schemeClr val="accent1"/>
+            </a:fillRef>
+            <a:effectRef idx="0">
+              <a:schemeClr val="accent1"/>
+            </a:effectRef>
+            <a:fontRef idx="minor">
+              <a:schemeClr val="lt1"/>
+            </a:fontRef>
+          </p:style>
+          <p:txBody>
+            <a:bodyPr rtlCol="0" anchor="ctr"/>
+            <a:lstStyle/>
+            <a:p>
+              <a:pPr algn="ctr"/>
+              <a:endParaRPr lang="ko-KR" altLang="en-US"/>
+            </a:p>
+          </p:txBody>
+        </p:sp>
+        <p:sp>
+          <p:nvSpPr>
+            <p:cNvPr id="49" name="직사각형 48"/>
+            <p:cNvSpPr/>
+            <p:nvPr/>
+          </p:nvSpPr>
+          <p:spPr>
+            <a:xfrm>
+              <a:off x="7928195" y="1958922"/>
+              <a:ext cx="3960000" cy="36000"/>
+            </a:xfrm>
+            <a:prstGeom prst="rect">
+              <a:avLst/>
+            </a:prstGeom>
+            <a:solidFill>
+              <a:schemeClr val="tx1"/>
+            </a:solidFill>
+            <a:ln>
+              <a:noFill/>
+            </a:ln>
+          </p:spPr>
+          <p:style>
+            <a:lnRef idx="2">
+              <a:schemeClr val="accent1">
+                <a:shade val="50000"/>
+              </a:schemeClr>
+            </a:lnRef>
+            <a:fillRef idx="1">
+              <a:schemeClr val="accent1"/>
+            </a:fillRef>
+            <a:effectRef idx="0">
+              <a:schemeClr val="accent1"/>
+            </a:effectRef>
+            <a:fontRef idx="minor">
+              <a:schemeClr val="lt1"/>
+            </a:fontRef>
+          </p:style>
+          <p:txBody>
+            <a:bodyPr rtlCol="0" anchor="ctr"/>
+            <a:lstStyle/>
+            <a:p>
+              <a:pPr algn="ctr"/>
+              <a:endParaRPr lang="ko-KR" altLang="en-US"/>
+            </a:p>
+          </p:txBody>
+        </p:sp>
+        <p:cxnSp>
+          <p:nvCxnSpPr>
+            <p:cNvPr id="51" name="직선 화살표 연결선 50"/>
+            <p:cNvCxnSpPr>
+              <a:stCxn id="36" idx="0"/>
+              <a:endCxn id="46" idx="2"/>
+            </p:cNvCxnSpPr>
+            <p:nvPr/>
+          </p:nvCxnSpPr>
+          <p:spPr>
+            <a:xfrm flipH="1" flipV="1">
+              <a:off x="885446" y="2005647"/>
+              <a:ext cx="437824" cy="872064"/>
+            </a:xfrm>
+            <a:prstGeom prst="straightConnector1">
+              <a:avLst/>
+            </a:prstGeom>
+            <a:ln w="76200">
+              <a:solidFill>
+                <a:schemeClr val="accent2"/>
+              </a:solidFill>
+              <a:tailEnd type="triangle"/>
+            </a:ln>
+          </p:spPr>
+          <p:style>
+            <a:lnRef idx="1">
+              <a:schemeClr val="accent1"/>
+            </a:lnRef>
+            <a:fillRef idx="0">
+              <a:schemeClr val="accent1"/>
+            </a:fillRef>
+            <a:effectRef idx="0">
+              <a:schemeClr val="accent1"/>
+            </a:effectRef>
+            <a:fontRef idx="minor">
+              <a:schemeClr val="tx1"/>
+            </a:fontRef>
+          </p:style>
+        </p:cxnSp>
+        <p:cxnSp>
+          <p:nvCxnSpPr>
+            <p:cNvPr id="53" name="직선 화살표 연결선 52"/>
+            <p:cNvCxnSpPr>
+              <a:stCxn id="37" idx="0"/>
+              <a:endCxn id="47" idx="2"/>
+            </p:cNvCxnSpPr>
+            <p:nvPr/>
+          </p:nvCxnSpPr>
+          <p:spPr>
+            <a:xfrm flipH="1" flipV="1">
+              <a:off x="3893029" y="1997116"/>
+              <a:ext cx="617825" cy="870867"/>
+            </a:xfrm>
+            <a:prstGeom prst="straightConnector1">
+              <a:avLst/>
+            </a:prstGeom>
+            <a:ln w="76200">
+              <a:solidFill>
+                <a:schemeClr val="accent2"/>
+              </a:solidFill>
+              <a:tailEnd type="triangle"/>
+            </a:ln>
+          </p:spPr>
+          <p:style>
+            <a:lnRef idx="1">
+              <a:schemeClr val="accent1"/>
+            </a:lnRef>
+            <a:fillRef idx="0">
+              <a:schemeClr val="accent1"/>
+            </a:fillRef>
+            <a:effectRef idx="0">
+              <a:schemeClr val="accent1"/>
+            </a:effectRef>
+            <a:fontRef idx="minor">
+              <a:schemeClr val="tx1"/>
+            </a:fontRef>
+          </p:style>
+        </p:cxnSp>
+        <p:cxnSp>
+          <p:nvCxnSpPr>
+            <p:cNvPr id="56" name="직선 화살표 연결선 55"/>
+            <p:cNvCxnSpPr>
+              <a:stCxn id="38" idx="0"/>
+              <a:endCxn id="48" idx="2"/>
+            </p:cNvCxnSpPr>
+            <p:nvPr/>
+          </p:nvCxnSpPr>
+          <p:spPr>
+            <a:xfrm flipH="1" flipV="1">
+              <a:off x="6720612" y="1994922"/>
+              <a:ext cx="977826" cy="882789"/>
+            </a:xfrm>
+            <a:prstGeom prst="straightConnector1">
+              <a:avLst/>
+            </a:prstGeom>
+            <a:ln w="76200">
+              <a:solidFill>
+                <a:schemeClr val="accent2"/>
+              </a:solidFill>
+              <a:tailEnd type="triangle"/>
+            </a:ln>
+          </p:spPr>
+          <p:style>
+            <a:lnRef idx="1">
+              <a:schemeClr val="accent1"/>
+            </a:lnRef>
+            <a:fillRef idx="0">
+              <a:schemeClr val="accent1"/>
+            </a:fillRef>
+            <a:effectRef idx="0">
+              <a:schemeClr val="accent1"/>
+            </a:effectRef>
+            <a:fontRef idx="minor">
+              <a:schemeClr val="tx1"/>
+            </a:fontRef>
+          </p:style>
+        </p:cxnSp>
+        <p:cxnSp>
+          <p:nvCxnSpPr>
+            <p:cNvPr id="59" name="직선 화살표 연결선 58"/>
+            <p:cNvCxnSpPr>
+              <a:stCxn id="39" idx="0"/>
+              <a:endCxn id="49" idx="2"/>
+            </p:cNvCxnSpPr>
+            <p:nvPr/>
+          </p:nvCxnSpPr>
+          <p:spPr>
+            <a:xfrm flipH="1" flipV="1">
+              <a:off x="9908195" y="1994922"/>
+              <a:ext cx="977827" cy="882789"/>
+            </a:xfrm>
+            <a:prstGeom prst="straightConnector1">
+              <a:avLst/>
+            </a:prstGeom>
+            <a:ln w="76200">
+              <a:solidFill>
+                <a:schemeClr val="accent2"/>
+              </a:solidFill>
+              <a:tailEnd type="triangle"/>
+            </a:ln>
+          </p:spPr>
+          <p:style>
+            <a:lnRef idx="1">
+              <a:schemeClr val="accent1"/>
+            </a:lnRef>
+            <a:fillRef idx="0">
+              <a:schemeClr val="accent1"/>
+            </a:fillRef>
+            <a:effectRef idx="0">
+              <a:schemeClr val="accent1"/>
+            </a:effectRef>
+            <a:fontRef idx="minor">
+              <a:schemeClr val="tx1"/>
+            </a:fontRef>
+          </p:style>
+        </p:cxnSp>
+      </p:grpSp>
     </p:spTree>
     <p:extLst>
       <p:ext uri="{BB962C8B-B14F-4D97-AF65-F5344CB8AC3E}">
@@ -3140,7 +3656,7 @@
           <a:graphicData uri="http://schemas.openxmlformats.org/presentationml/2006/ole">
             <mc:AlternateContent xmlns:mc="http://schemas.openxmlformats.org/markup-compatibility/2006">
               <mc:Choice xmlns:v="urn:schemas-microsoft-com:vml" Requires="v">
-                <p:oleObj spid="_x0000_s1039" name="워크시트" r:id="rId3" imgW="22637898" imgH="17411877" progId="Excel.Sheet.12">
+                <p:oleObj spid="_x0000_s1044" name="워크시트" r:id="rId3" imgW="22637898" imgH="17411877" progId="Excel.Sheet.12">
                   <p:embed/>
                 </p:oleObj>
               </mc:Choice>

</xml_diff>

<commit_message>
20260821 commit : this weekends - Notion Clear?
</commit_message>
<xml_diff>
--- a/notion/create_notion_img.pptx
+++ b/notion/create_notion_img.pptx
@@ -248,7 +248,7 @@
           <a:p>
             <a:fld id="{7237CE1A-8831-48B5-BA93-72483C6E34E8}" type="datetimeFigureOut">
               <a:rPr lang="ko-KR" altLang="en-US" smtClean="0"/>
-              <a:t>26-08-20(Thu)</a:t>
+              <a:t>2026-08-21</a:t>
             </a:fld>
             <a:endParaRPr lang="ko-KR" altLang="en-US"/>
           </a:p>
@@ -418,7 +418,7 @@
           <a:p>
             <a:fld id="{7237CE1A-8831-48B5-BA93-72483C6E34E8}" type="datetimeFigureOut">
               <a:rPr lang="ko-KR" altLang="en-US" smtClean="0"/>
-              <a:t>26-08-20(Thu)</a:t>
+              <a:t>2026-08-21</a:t>
             </a:fld>
             <a:endParaRPr lang="ko-KR" altLang="en-US"/>
           </a:p>
@@ -598,7 +598,7 @@
           <a:p>
             <a:fld id="{7237CE1A-8831-48B5-BA93-72483C6E34E8}" type="datetimeFigureOut">
               <a:rPr lang="ko-KR" altLang="en-US" smtClean="0"/>
-              <a:t>26-08-20(Thu)</a:t>
+              <a:t>2026-08-21</a:t>
             </a:fld>
             <a:endParaRPr lang="ko-KR" altLang="en-US"/>
           </a:p>
@@ -768,7 +768,7 @@
           <a:p>
             <a:fld id="{7237CE1A-8831-48B5-BA93-72483C6E34E8}" type="datetimeFigureOut">
               <a:rPr lang="ko-KR" altLang="en-US" smtClean="0"/>
-              <a:t>26-08-20(Thu)</a:t>
+              <a:t>2026-08-21</a:t>
             </a:fld>
             <a:endParaRPr lang="ko-KR" altLang="en-US"/>
           </a:p>
@@ -1014,7 +1014,7 @@
           <a:p>
             <a:fld id="{7237CE1A-8831-48B5-BA93-72483C6E34E8}" type="datetimeFigureOut">
               <a:rPr lang="ko-KR" altLang="en-US" smtClean="0"/>
-              <a:t>26-08-20(Thu)</a:t>
+              <a:t>2026-08-21</a:t>
             </a:fld>
             <a:endParaRPr lang="ko-KR" altLang="en-US"/>
           </a:p>
@@ -1246,7 +1246,7 @@
           <a:p>
             <a:fld id="{7237CE1A-8831-48B5-BA93-72483C6E34E8}" type="datetimeFigureOut">
               <a:rPr lang="ko-KR" altLang="en-US" smtClean="0"/>
-              <a:t>26-08-20(Thu)</a:t>
+              <a:t>2026-08-21</a:t>
             </a:fld>
             <a:endParaRPr lang="ko-KR" altLang="en-US"/>
           </a:p>
@@ -1613,7 +1613,7 @@
           <a:p>
             <a:fld id="{7237CE1A-8831-48B5-BA93-72483C6E34E8}" type="datetimeFigureOut">
               <a:rPr lang="ko-KR" altLang="en-US" smtClean="0"/>
-              <a:t>26-08-20(Thu)</a:t>
+              <a:t>2026-08-21</a:t>
             </a:fld>
             <a:endParaRPr lang="ko-KR" altLang="en-US"/>
           </a:p>
@@ -1731,7 +1731,7 @@
           <a:p>
             <a:fld id="{7237CE1A-8831-48B5-BA93-72483C6E34E8}" type="datetimeFigureOut">
               <a:rPr lang="ko-KR" altLang="en-US" smtClean="0"/>
-              <a:t>26-08-20(Thu)</a:t>
+              <a:t>2026-08-21</a:t>
             </a:fld>
             <a:endParaRPr lang="ko-KR" altLang="en-US"/>
           </a:p>
@@ -1826,7 +1826,7 @@
           <a:p>
             <a:fld id="{7237CE1A-8831-48B5-BA93-72483C6E34E8}" type="datetimeFigureOut">
               <a:rPr lang="ko-KR" altLang="en-US" smtClean="0"/>
-              <a:t>26-08-20(Thu)</a:t>
+              <a:t>2026-08-21</a:t>
             </a:fld>
             <a:endParaRPr lang="ko-KR" altLang="en-US"/>
           </a:p>
@@ -2103,7 +2103,7 @@
           <a:p>
             <a:fld id="{7237CE1A-8831-48B5-BA93-72483C6E34E8}" type="datetimeFigureOut">
               <a:rPr lang="ko-KR" altLang="en-US" smtClean="0"/>
-              <a:t>26-08-20(Thu)</a:t>
+              <a:t>2026-08-21</a:t>
             </a:fld>
             <a:endParaRPr lang="ko-KR" altLang="en-US"/>
           </a:p>
@@ -2356,7 +2356,7 @@
           <a:p>
             <a:fld id="{7237CE1A-8831-48B5-BA93-72483C6E34E8}" type="datetimeFigureOut">
               <a:rPr lang="ko-KR" altLang="en-US" smtClean="0"/>
-              <a:t>26-08-20(Thu)</a:t>
+              <a:t>2026-08-21</a:t>
             </a:fld>
             <a:endParaRPr lang="ko-KR" altLang="en-US"/>
           </a:p>
@@ -2569,7 +2569,7 @@
           <a:p>
             <a:fld id="{7237CE1A-8831-48B5-BA93-72483C6E34E8}" type="datetimeFigureOut">
               <a:rPr lang="ko-KR" altLang="en-US" smtClean="0"/>
-              <a:t>26-08-20(Thu)</a:t>
+              <a:t>2026-08-21</a:t>
             </a:fld>
             <a:endParaRPr lang="ko-KR" altLang="en-US"/>
           </a:p>
@@ -2976,28 +2976,28 @@
       </p:grpSpPr>
       <p:grpSp>
         <p:nvGrpSpPr>
-          <p:cNvPr id="62" name="그룹 61"/>
+          <p:cNvPr id="11" name="그룹 10"/>
           <p:cNvGrpSpPr/>
           <p:nvPr/>
         </p:nvGrpSpPr>
         <p:grpSpPr>
           <a:xfrm>
-            <a:off x="-252919" y="968054"/>
-            <a:ext cx="12704119" cy="2629657"/>
-            <a:chOff x="-252919" y="968054"/>
-            <a:chExt cx="12704119" cy="2629657"/>
+            <a:off x="2496623" y="1212333"/>
+            <a:ext cx="7873630" cy="2256814"/>
+            <a:chOff x="2496623" y="1212333"/>
+            <a:chExt cx="7873630" cy="2256814"/>
           </a:xfrm>
         </p:grpSpPr>
         <p:sp>
           <p:nvSpPr>
-            <p:cNvPr id="30" name="직사각형 29"/>
+            <p:cNvPr id="2" name="직사각형 1"/>
             <p:cNvSpPr/>
             <p:nvPr/>
           </p:nvSpPr>
           <p:spPr>
             <a:xfrm>
-              <a:off x="-252919" y="968054"/>
-              <a:ext cx="12704119" cy="1015663"/>
+              <a:off x="2496623" y="1212333"/>
+              <a:ext cx="7873630" cy="1015663"/>
             </a:xfrm>
             <a:prstGeom prst="rect">
               <a:avLst/>
@@ -3010,269 +3010,53 @@
             <a:lstStyle/>
             <a:p>
               <a:r>
-                <a:rPr lang="en-US" altLang="ko-KR" sz="6000" dirty="0">
+                <a:rPr lang="ko-KR" altLang="en-US" sz="6000" dirty="0">
                   <a:latin typeface="나눔스퀘어 Bold" panose="020B0600000101010101" pitchFamily="50" charset="-127"/>
                   <a:ea typeface="나눔스퀘어 Bold" panose="020B0600000101010101" pitchFamily="50" charset="-127"/>
                 </a:rPr>
-                <a:t>http://localhost:8090/MemberPjt/</a:t>
+                <a:t>@</a:t>
               </a:r>
-              <a:endParaRPr lang="ko-KR" altLang="en-US" sz="6000" dirty="0">
-                <a:latin typeface="나눔스퀘어 Bold" panose="020B0600000101010101" pitchFamily="50" charset="-127"/>
-                <a:ea typeface="나눔스퀘어 Bold" panose="020B0600000101010101" pitchFamily="50" charset="-127"/>
-              </a:endParaRPr>
+              <a:r>
+                <a:rPr lang="ko-KR" altLang="en-US" sz="6000" dirty="0" err="1">
+                  <a:latin typeface="나눔스퀘어 Bold" panose="020B0600000101010101" pitchFamily="50" charset="-127"/>
+                  <a:ea typeface="나눔스퀘어 Bold" panose="020B0600000101010101" pitchFamily="50" charset="-127"/>
+                </a:rPr>
+                <a:t>WebServlet</a:t>
+              </a:r>
+              <a:r>
+                <a:rPr lang="ko-KR" altLang="en-US" sz="6000" dirty="0">
+                  <a:latin typeface="나눔스퀘어 Bold" panose="020B0600000101010101" pitchFamily="50" charset="-127"/>
+                  <a:ea typeface="나눔스퀘어 Bold" panose="020B0600000101010101" pitchFamily="50" charset="-127"/>
+                </a:rPr>
+                <a:t>("*.</a:t>
+              </a:r>
+              <a:r>
+                <a:rPr lang="ko-KR" altLang="en-US" sz="6000" dirty="0" err="1">
+                  <a:latin typeface="나눔스퀘어 Bold" panose="020B0600000101010101" pitchFamily="50" charset="-127"/>
+                  <a:ea typeface="나눔스퀘어 Bold" panose="020B0600000101010101" pitchFamily="50" charset="-127"/>
+                </a:rPr>
+                <a:t>dw</a:t>
+              </a:r>
+              <a:r>
+                <a:rPr lang="ko-KR" altLang="en-US" sz="6000" dirty="0">
+                  <a:latin typeface="나눔스퀘어 Bold" panose="020B0600000101010101" pitchFamily="50" charset="-127"/>
+                  <a:ea typeface="나눔스퀘어 Bold" panose="020B0600000101010101" pitchFamily="50" charset="-127"/>
+                </a:rPr>
+                <a:t>")</a:t>
+              </a:r>
             </a:p>
           </p:txBody>
         </p:sp>
         <p:sp>
           <p:nvSpPr>
-            <p:cNvPr id="36" name="모서리가 둥근 직사각형 35"/>
+            <p:cNvPr id="3" name="직사각형 2"/>
             <p:cNvSpPr/>
             <p:nvPr/>
           </p:nvSpPr>
           <p:spPr>
             <a:xfrm>
-              <a:off x="-116730" y="2877711"/>
-              <a:ext cx="2880000" cy="720000"/>
-            </a:xfrm>
-            <a:prstGeom prst="roundRect">
-              <a:avLst/>
-            </a:prstGeom>
-            <a:solidFill>
-              <a:schemeClr val="bg1"/>
-            </a:solidFill>
-            <a:ln w="38100">
-              <a:solidFill>
-                <a:schemeClr val="tx1"/>
-              </a:solidFill>
-            </a:ln>
-          </p:spPr>
-          <p:style>
-            <a:lnRef idx="2">
-              <a:schemeClr val="accent1">
-                <a:shade val="50000"/>
-              </a:schemeClr>
-            </a:lnRef>
-            <a:fillRef idx="1">
-              <a:schemeClr val="accent1"/>
-            </a:fillRef>
-            <a:effectRef idx="0">
-              <a:schemeClr val="accent1"/>
-            </a:effectRef>
-            <a:fontRef idx="minor">
-              <a:schemeClr val="lt1"/>
-            </a:fontRef>
-          </p:style>
-          <p:txBody>
-            <a:bodyPr rtlCol="0" anchor="ctr"/>
-            <a:lstStyle/>
-            <a:p>
-              <a:pPr algn="ctr"/>
-              <a:r>
-                <a:rPr lang="en-US" altLang="ko-KR" sz="4000" dirty="0" smtClean="0">
-                  <a:solidFill>
-                    <a:schemeClr val="tx1"/>
-                  </a:solidFill>
-                </a:rPr>
-                <a:t>Protocol</a:t>
-              </a:r>
-              <a:endParaRPr lang="ko-KR" altLang="en-US" sz="4000" dirty="0">
-                <a:solidFill>
-                  <a:schemeClr val="tx1"/>
-                </a:solidFill>
-              </a:endParaRPr>
-            </a:p>
-          </p:txBody>
-        </p:sp>
-        <p:sp>
-          <p:nvSpPr>
-            <p:cNvPr id="37" name="모서리가 둥근 직사각형 36"/>
-            <p:cNvSpPr/>
-            <p:nvPr/>
-          </p:nvSpPr>
-          <p:spPr>
-            <a:xfrm>
-              <a:off x="3070854" y="2867983"/>
-              <a:ext cx="2880000" cy="720000"/>
-            </a:xfrm>
-            <a:prstGeom prst="roundRect">
-              <a:avLst/>
-            </a:prstGeom>
-            <a:solidFill>
-              <a:schemeClr val="bg1"/>
-            </a:solidFill>
-            <a:ln w="38100">
-              <a:solidFill>
-                <a:schemeClr val="tx1"/>
-              </a:solidFill>
-            </a:ln>
-          </p:spPr>
-          <p:style>
-            <a:lnRef idx="2">
-              <a:schemeClr val="accent1">
-                <a:shade val="50000"/>
-              </a:schemeClr>
-            </a:lnRef>
-            <a:fillRef idx="1">
-              <a:schemeClr val="accent1"/>
-            </a:fillRef>
-            <a:effectRef idx="0">
-              <a:schemeClr val="accent1"/>
-            </a:effectRef>
-            <a:fontRef idx="minor">
-              <a:schemeClr val="lt1"/>
-            </a:fontRef>
-          </p:style>
-          <p:txBody>
-            <a:bodyPr rtlCol="0" anchor="ctr"/>
-            <a:lstStyle/>
-            <a:p>
-              <a:pPr algn="ctr"/>
-              <a:r>
-                <a:rPr lang="en-US" altLang="ko-KR" sz="4000" dirty="0" smtClean="0">
-                  <a:solidFill>
-                    <a:schemeClr val="tx1"/>
-                  </a:solidFill>
-                </a:rPr>
-                <a:t>Host</a:t>
-              </a:r>
-              <a:endParaRPr lang="ko-KR" altLang="en-US" sz="4000" dirty="0">
-                <a:solidFill>
-                  <a:schemeClr val="tx1"/>
-                </a:solidFill>
-              </a:endParaRPr>
-            </a:p>
-          </p:txBody>
-        </p:sp>
-        <p:sp>
-          <p:nvSpPr>
-            <p:cNvPr id="38" name="모서리가 둥근 직사각형 37"/>
-            <p:cNvSpPr/>
-            <p:nvPr/>
-          </p:nvSpPr>
-          <p:spPr>
-            <a:xfrm>
-              <a:off x="6258438" y="2877711"/>
-              <a:ext cx="2880000" cy="720000"/>
-            </a:xfrm>
-            <a:prstGeom prst="roundRect">
-              <a:avLst/>
-            </a:prstGeom>
-            <a:solidFill>
-              <a:schemeClr val="bg1"/>
-            </a:solidFill>
-            <a:ln w="38100">
-              <a:solidFill>
-                <a:schemeClr val="tx1"/>
-              </a:solidFill>
-            </a:ln>
-          </p:spPr>
-          <p:style>
-            <a:lnRef idx="2">
-              <a:schemeClr val="accent1">
-                <a:shade val="50000"/>
-              </a:schemeClr>
-            </a:lnRef>
-            <a:fillRef idx="1">
-              <a:schemeClr val="accent1"/>
-            </a:fillRef>
-            <a:effectRef idx="0">
-              <a:schemeClr val="accent1"/>
-            </a:effectRef>
-            <a:fontRef idx="minor">
-              <a:schemeClr val="lt1"/>
-            </a:fontRef>
-          </p:style>
-          <p:txBody>
-            <a:bodyPr rtlCol="0" anchor="ctr"/>
-            <a:lstStyle/>
-            <a:p>
-              <a:pPr algn="ctr"/>
-              <a:r>
-                <a:rPr lang="en-US" altLang="ko-KR" sz="4000" dirty="0" smtClean="0">
-                  <a:solidFill>
-                    <a:schemeClr val="tx1"/>
-                  </a:solidFill>
-                </a:rPr>
-                <a:t>Port</a:t>
-              </a:r>
-              <a:endParaRPr lang="ko-KR" altLang="en-US" sz="4000" dirty="0">
-                <a:solidFill>
-                  <a:schemeClr val="tx1"/>
-                </a:solidFill>
-              </a:endParaRPr>
-            </a:p>
-          </p:txBody>
-        </p:sp>
-        <p:sp>
-          <p:nvSpPr>
-            <p:cNvPr id="39" name="모서리가 둥근 직사각형 38"/>
-            <p:cNvSpPr/>
-            <p:nvPr/>
-          </p:nvSpPr>
-          <p:spPr>
-            <a:xfrm>
-              <a:off x="9446022" y="2877711"/>
-              <a:ext cx="2880000" cy="720000"/>
-            </a:xfrm>
-            <a:prstGeom prst="roundRect">
-              <a:avLst/>
-            </a:prstGeom>
-            <a:solidFill>
-              <a:schemeClr val="bg1"/>
-            </a:solidFill>
-            <a:ln w="38100">
-              <a:solidFill>
-                <a:schemeClr val="tx1"/>
-              </a:solidFill>
-            </a:ln>
-          </p:spPr>
-          <p:style>
-            <a:lnRef idx="2">
-              <a:schemeClr val="accent1">
-                <a:shade val="50000"/>
-              </a:schemeClr>
-            </a:lnRef>
-            <a:fillRef idx="1">
-              <a:schemeClr val="accent1"/>
-            </a:fillRef>
-            <a:effectRef idx="0">
-              <a:schemeClr val="accent1"/>
-            </a:effectRef>
-            <a:fontRef idx="minor">
-              <a:schemeClr val="lt1"/>
-            </a:fontRef>
-          </p:style>
-          <p:txBody>
-            <a:bodyPr rtlCol="0" anchor="ctr"/>
-            <a:lstStyle/>
-            <a:p>
-              <a:pPr algn="ctr"/>
-              <a:r>
-                <a:rPr lang="en-US" altLang="ko-KR" sz="3200" dirty="0" smtClean="0">
-                  <a:solidFill>
-                    <a:schemeClr val="tx1"/>
-                  </a:solidFill>
-                </a:rPr>
-                <a:t>Context Path</a:t>
-              </a:r>
-              <a:endParaRPr lang="ko-KR" altLang="en-US" sz="3200" dirty="0">
-                <a:solidFill>
-                  <a:schemeClr val="tx1"/>
-                </a:solidFill>
-              </a:endParaRPr>
-            </a:p>
-          </p:txBody>
-        </p:sp>
-        <p:sp>
-          <p:nvSpPr>
-            <p:cNvPr id="46" name="직사각형 45"/>
-            <p:cNvSpPr/>
-            <p:nvPr/>
-          </p:nvSpPr>
-          <p:spPr>
-            <a:xfrm>
-              <a:off x="-194554" y="1969647"/>
-              <a:ext cx="2160000" cy="36000"/>
+              <a:off x="2728685" y="2169940"/>
+              <a:ext cx="4680000" cy="72000"/>
             </a:xfrm>
             <a:prstGeom prst="rect">
               <a:avLst/>
@@ -3311,14 +3095,14 @@
         </p:sp>
         <p:sp>
           <p:nvSpPr>
-            <p:cNvPr id="47" name="직사각형 46"/>
+            <p:cNvPr id="18" name="직사각형 17"/>
             <p:cNvSpPr/>
             <p:nvPr/>
           </p:nvSpPr>
           <p:spPr>
             <a:xfrm>
-              <a:off x="2273029" y="1961116"/>
-              <a:ext cx="3240000" cy="36000"/>
+              <a:off x="7751413" y="2169709"/>
+              <a:ext cx="2160000" cy="72000"/>
             </a:xfrm>
             <a:prstGeom prst="rect">
               <a:avLst/>
@@ -3357,23 +3141,23 @@
         </p:sp>
         <p:sp>
           <p:nvSpPr>
-            <p:cNvPr id="48" name="직사각형 47"/>
+            <p:cNvPr id="4" name="직사각형 3"/>
             <p:cNvSpPr/>
             <p:nvPr/>
           </p:nvSpPr>
           <p:spPr>
             <a:xfrm>
-              <a:off x="5820612" y="1958922"/>
-              <a:ext cx="1800000" cy="36000"/>
+              <a:off x="3454404" y="2749147"/>
+              <a:ext cx="2700000" cy="720000"/>
             </a:xfrm>
             <a:prstGeom prst="rect">
               <a:avLst/>
             </a:prstGeom>
-            <a:solidFill>
-              <a:schemeClr val="tx1"/>
-            </a:solidFill>
-            <a:ln>
-              <a:noFill/>
+            <a:noFill/>
+            <a:ln w="38100">
+              <a:solidFill>
+                <a:schemeClr val="tx1"/>
+              </a:solidFill>
             </a:ln>
           </p:spPr>
           <p:style>
@@ -3397,29 +3181,55 @@
             <a:lstStyle/>
             <a:p>
               <a:pPr algn="ctr"/>
-              <a:endParaRPr lang="ko-KR" altLang="en-US"/>
+              <a:r>
+                <a:rPr lang="en-US" altLang="ko-KR" sz="3200" dirty="0" smtClean="0">
+                  <a:solidFill>
+                    <a:schemeClr val="tx1"/>
+                  </a:solidFill>
+                  <a:latin typeface="나눔스퀘어 Bold" panose="020B0600000101010101" pitchFamily="50" charset="-127"/>
+                  <a:ea typeface="나눔스퀘어 Bold" panose="020B0600000101010101" pitchFamily="50" charset="-127"/>
+                </a:rPr>
+                <a:t>Servlet </a:t>
+              </a:r>
+              <a:r>
+                <a:rPr lang="ko-KR" altLang="en-US" sz="3200" dirty="0" smtClean="0">
+                  <a:solidFill>
+                    <a:schemeClr val="tx1"/>
+                  </a:solidFill>
+                  <a:latin typeface="나눔스퀘어 Bold" panose="020B0600000101010101" pitchFamily="50" charset="-127"/>
+                  <a:ea typeface="나눔스퀘어 Bold" panose="020B0600000101010101" pitchFamily="50" charset="-127"/>
+                </a:rPr>
+                <a:t>매핑</a:t>
+              </a:r>
+              <a:endParaRPr lang="ko-KR" altLang="en-US" sz="3200" dirty="0">
+                <a:solidFill>
+                  <a:schemeClr val="tx1"/>
+                </a:solidFill>
+                <a:latin typeface="나눔스퀘어 Bold" panose="020B0600000101010101" pitchFamily="50" charset="-127"/>
+                <a:ea typeface="나눔스퀘어 Bold" panose="020B0600000101010101" pitchFamily="50" charset="-127"/>
+              </a:endParaRPr>
             </a:p>
           </p:txBody>
         </p:sp>
         <p:sp>
           <p:nvSpPr>
-            <p:cNvPr id="49" name="직사각형 48"/>
+            <p:cNvPr id="20" name="직사각형 19"/>
             <p:cNvSpPr/>
             <p:nvPr/>
           </p:nvSpPr>
           <p:spPr>
             <a:xfrm>
-              <a:off x="7928195" y="1958922"/>
-              <a:ext cx="3960000" cy="36000"/>
+              <a:off x="6709208" y="2749147"/>
+              <a:ext cx="2700000" cy="720000"/>
             </a:xfrm>
             <a:prstGeom prst="rect">
               <a:avLst/>
             </a:prstGeom>
-            <a:solidFill>
-              <a:schemeClr val="tx1"/>
-            </a:solidFill>
-            <a:ln>
-              <a:noFill/>
+            <a:noFill/>
+            <a:ln w="38100">
+              <a:solidFill>
+                <a:schemeClr val="tx1"/>
+              </a:solidFill>
             </a:ln>
           </p:spPr>
           <p:style>
@@ -3443,23 +3253,49 @@
             <a:lstStyle/>
             <a:p>
               <a:pPr algn="ctr"/>
-              <a:endParaRPr lang="ko-KR" altLang="en-US"/>
+              <a:r>
+                <a:rPr lang="en-US" altLang="ko-KR" sz="3200" dirty="0" smtClean="0">
+                  <a:solidFill>
+                    <a:schemeClr val="tx1"/>
+                  </a:solidFill>
+                  <a:latin typeface="나눔스퀘어 Bold" panose="020B0600000101010101" pitchFamily="50" charset="-127"/>
+                  <a:ea typeface="나눔스퀘어 Bold" panose="020B0600000101010101" pitchFamily="50" charset="-127"/>
+                </a:rPr>
+                <a:t>URL </a:t>
+              </a:r>
+              <a:r>
+                <a:rPr lang="ko-KR" altLang="en-US" sz="3200" dirty="0" smtClean="0">
+                  <a:solidFill>
+                    <a:schemeClr val="tx1"/>
+                  </a:solidFill>
+                  <a:latin typeface="나눔스퀘어 Bold" panose="020B0600000101010101" pitchFamily="50" charset="-127"/>
+                  <a:ea typeface="나눔스퀘어 Bold" panose="020B0600000101010101" pitchFamily="50" charset="-127"/>
+                </a:rPr>
+                <a:t>패턴</a:t>
+              </a:r>
+              <a:endParaRPr lang="ko-KR" altLang="en-US" sz="3200" dirty="0">
+                <a:solidFill>
+                  <a:schemeClr val="tx1"/>
+                </a:solidFill>
+                <a:latin typeface="나눔스퀘어 Bold" panose="020B0600000101010101" pitchFamily="50" charset="-127"/>
+                <a:ea typeface="나눔스퀘어 Bold" panose="020B0600000101010101" pitchFamily="50" charset="-127"/>
+              </a:endParaRPr>
             </a:p>
           </p:txBody>
         </p:sp>
         <p:cxnSp>
           <p:nvCxnSpPr>
-            <p:cNvPr id="51" name="직선 화살표 연결선 50"/>
+            <p:cNvPr id="7" name="직선 화살표 연결선 6"/>
             <p:cNvCxnSpPr>
-              <a:stCxn id="36" idx="0"/>
-              <a:endCxn id="46" idx="2"/>
+              <a:stCxn id="4" idx="0"/>
+              <a:endCxn id="3" idx="2"/>
             </p:cNvCxnSpPr>
             <p:nvPr/>
           </p:nvCxnSpPr>
           <p:spPr>
-            <a:xfrm flipH="1" flipV="1">
-              <a:off x="885446" y="2005647"/>
-              <a:ext cx="437824" cy="872064"/>
+            <a:xfrm flipV="1">
+              <a:off x="4804404" y="2241940"/>
+              <a:ext cx="264281" cy="507207"/>
             </a:xfrm>
             <a:prstGeom prst="straightConnector1">
               <a:avLst/>
@@ -3488,95 +3324,17 @@
         </p:cxnSp>
         <p:cxnSp>
           <p:nvCxnSpPr>
-            <p:cNvPr id="53" name="직선 화살표 연결선 52"/>
+            <p:cNvPr id="25" name="직선 화살표 연결선 24"/>
             <p:cNvCxnSpPr>
-              <a:stCxn id="37" idx="0"/>
-              <a:endCxn id="47" idx="2"/>
+              <a:stCxn id="20" idx="0"/>
+              <a:endCxn id="18" idx="2"/>
             </p:cNvCxnSpPr>
             <p:nvPr/>
           </p:nvCxnSpPr>
           <p:spPr>
-            <a:xfrm flipH="1" flipV="1">
-              <a:off x="3893029" y="1997116"/>
-              <a:ext cx="617825" cy="870867"/>
-            </a:xfrm>
-            <a:prstGeom prst="straightConnector1">
-              <a:avLst/>
-            </a:prstGeom>
-            <a:ln w="76200">
-              <a:solidFill>
-                <a:schemeClr val="accent2"/>
-              </a:solidFill>
-              <a:tailEnd type="triangle"/>
-            </a:ln>
-          </p:spPr>
-          <p:style>
-            <a:lnRef idx="1">
-              <a:schemeClr val="accent1"/>
-            </a:lnRef>
-            <a:fillRef idx="0">
-              <a:schemeClr val="accent1"/>
-            </a:fillRef>
-            <a:effectRef idx="0">
-              <a:schemeClr val="accent1"/>
-            </a:effectRef>
-            <a:fontRef idx="minor">
-              <a:schemeClr val="tx1"/>
-            </a:fontRef>
-          </p:style>
-        </p:cxnSp>
-        <p:cxnSp>
-          <p:nvCxnSpPr>
-            <p:cNvPr id="56" name="직선 화살표 연결선 55"/>
-            <p:cNvCxnSpPr>
-              <a:stCxn id="38" idx="0"/>
-              <a:endCxn id="48" idx="2"/>
-            </p:cNvCxnSpPr>
-            <p:nvPr/>
-          </p:nvCxnSpPr>
-          <p:spPr>
-            <a:xfrm flipH="1" flipV="1">
-              <a:off x="6720612" y="1994922"/>
-              <a:ext cx="977826" cy="882789"/>
-            </a:xfrm>
-            <a:prstGeom prst="straightConnector1">
-              <a:avLst/>
-            </a:prstGeom>
-            <a:ln w="76200">
-              <a:solidFill>
-                <a:schemeClr val="accent2"/>
-              </a:solidFill>
-              <a:tailEnd type="triangle"/>
-            </a:ln>
-          </p:spPr>
-          <p:style>
-            <a:lnRef idx="1">
-              <a:schemeClr val="accent1"/>
-            </a:lnRef>
-            <a:fillRef idx="0">
-              <a:schemeClr val="accent1"/>
-            </a:fillRef>
-            <a:effectRef idx="0">
-              <a:schemeClr val="accent1"/>
-            </a:effectRef>
-            <a:fontRef idx="minor">
-              <a:schemeClr val="tx1"/>
-            </a:fontRef>
-          </p:style>
-        </p:cxnSp>
-        <p:cxnSp>
-          <p:nvCxnSpPr>
-            <p:cNvPr id="59" name="직선 화살표 연결선 58"/>
-            <p:cNvCxnSpPr>
-              <a:stCxn id="39" idx="0"/>
-              <a:endCxn id="49" idx="2"/>
-            </p:cNvCxnSpPr>
-            <p:nvPr/>
-          </p:nvCxnSpPr>
-          <p:spPr>
-            <a:xfrm flipH="1" flipV="1">
-              <a:off x="9908195" y="1994922"/>
-              <a:ext cx="977827" cy="882789"/>
+            <a:xfrm flipV="1">
+              <a:off x="8059208" y="2241709"/>
+              <a:ext cx="772205" cy="507438"/>
             </a:xfrm>
             <a:prstGeom prst="straightConnector1">
               <a:avLst/>
@@ -3656,7 +3414,7 @@
           <a:graphicData uri="http://schemas.openxmlformats.org/presentationml/2006/ole">
             <mc:AlternateContent xmlns:mc="http://schemas.openxmlformats.org/markup-compatibility/2006">
               <mc:Choice xmlns:v="urn:schemas-microsoft-com:vml" Requires="v">
-                <p:oleObj spid="_x0000_s1044" name="워크시트" r:id="rId3" imgW="22637898" imgH="17411877" progId="Excel.Sheet.12">
+                <p:oleObj spid="_x0000_s1045" name="워크시트" r:id="rId3" imgW="22637898" imgH="17411877" progId="Excel.Sheet.12">
                   <p:embed/>
                 </p:oleObj>
               </mc:Choice>

</xml_diff>

<commit_message>
20260824 commit : weekends thing, morning commit
</commit_message>
<xml_diff>
--- a/notion/create_notion_img.pptx
+++ b/notion/create_notion_img.pptx
@@ -6,11 +6,9 @@
   </p:sldMasterIdLst>
   <p:sldIdLst>
     <p:sldId id="256" r:id="rId2"/>
-    <p:sldId id="260" r:id="rId3"/>
-    <p:sldId id="259" r:id="rId4"/>
-    <p:sldId id="257" r:id="rId5"/>
-    <p:sldId id="258" r:id="rId6"/>
-    <p:sldId id="263" r:id="rId7"/>
+    <p:sldId id="259" r:id="rId3"/>
+    <p:sldId id="257" r:id="rId4"/>
+    <p:sldId id="263" r:id="rId5"/>
   </p:sldIdLst>
   <p:sldSz cx="12192000" cy="6858000"/>
   <p:notesSz cx="6858000" cy="9144000"/>
@@ -248,7 +246,7 @@
           <a:p>
             <a:fld id="{7237CE1A-8831-48B5-BA93-72483C6E34E8}" type="datetimeFigureOut">
               <a:rPr lang="ko-KR" altLang="en-US" smtClean="0"/>
-              <a:t>2026-08-21</a:t>
+              <a:t>26-08-22(Sat)</a:t>
             </a:fld>
             <a:endParaRPr lang="ko-KR" altLang="en-US"/>
           </a:p>
@@ -418,7 +416,7 @@
           <a:p>
             <a:fld id="{7237CE1A-8831-48B5-BA93-72483C6E34E8}" type="datetimeFigureOut">
               <a:rPr lang="ko-KR" altLang="en-US" smtClean="0"/>
-              <a:t>2026-08-21</a:t>
+              <a:t>26-08-22(Sat)</a:t>
             </a:fld>
             <a:endParaRPr lang="ko-KR" altLang="en-US"/>
           </a:p>
@@ -598,7 +596,7 @@
           <a:p>
             <a:fld id="{7237CE1A-8831-48B5-BA93-72483C6E34E8}" type="datetimeFigureOut">
               <a:rPr lang="ko-KR" altLang="en-US" smtClean="0"/>
-              <a:t>2026-08-21</a:t>
+              <a:t>26-08-22(Sat)</a:t>
             </a:fld>
             <a:endParaRPr lang="ko-KR" altLang="en-US"/>
           </a:p>
@@ -768,7 +766,7 @@
           <a:p>
             <a:fld id="{7237CE1A-8831-48B5-BA93-72483C6E34E8}" type="datetimeFigureOut">
               <a:rPr lang="ko-KR" altLang="en-US" smtClean="0"/>
-              <a:t>2026-08-21</a:t>
+              <a:t>26-08-22(Sat)</a:t>
             </a:fld>
             <a:endParaRPr lang="ko-KR" altLang="en-US"/>
           </a:p>
@@ -1014,7 +1012,7 @@
           <a:p>
             <a:fld id="{7237CE1A-8831-48B5-BA93-72483C6E34E8}" type="datetimeFigureOut">
               <a:rPr lang="ko-KR" altLang="en-US" smtClean="0"/>
-              <a:t>2026-08-21</a:t>
+              <a:t>26-08-22(Sat)</a:t>
             </a:fld>
             <a:endParaRPr lang="ko-KR" altLang="en-US"/>
           </a:p>
@@ -1246,7 +1244,7 @@
           <a:p>
             <a:fld id="{7237CE1A-8831-48B5-BA93-72483C6E34E8}" type="datetimeFigureOut">
               <a:rPr lang="ko-KR" altLang="en-US" smtClean="0"/>
-              <a:t>2026-08-21</a:t>
+              <a:t>26-08-22(Sat)</a:t>
             </a:fld>
             <a:endParaRPr lang="ko-KR" altLang="en-US"/>
           </a:p>
@@ -1613,7 +1611,7 @@
           <a:p>
             <a:fld id="{7237CE1A-8831-48B5-BA93-72483C6E34E8}" type="datetimeFigureOut">
               <a:rPr lang="ko-KR" altLang="en-US" smtClean="0"/>
-              <a:t>2026-08-21</a:t>
+              <a:t>26-08-22(Sat)</a:t>
             </a:fld>
             <a:endParaRPr lang="ko-KR" altLang="en-US"/>
           </a:p>
@@ -1731,7 +1729,7 @@
           <a:p>
             <a:fld id="{7237CE1A-8831-48B5-BA93-72483C6E34E8}" type="datetimeFigureOut">
               <a:rPr lang="ko-KR" altLang="en-US" smtClean="0"/>
-              <a:t>2026-08-21</a:t>
+              <a:t>26-08-22(Sat)</a:t>
             </a:fld>
             <a:endParaRPr lang="ko-KR" altLang="en-US"/>
           </a:p>
@@ -1826,7 +1824,7 @@
           <a:p>
             <a:fld id="{7237CE1A-8831-48B5-BA93-72483C6E34E8}" type="datetimeFigureOut">
               <a:rPr lang="ko-KR" altLang="en-US" smtClean="0"/>
-              <a:t>2026-08-21</a:t>
+              <a:t>26-08-22(Sat)</a:t>
             </a:fld>
             <a:endParaRPr lang="ko-KR" altLang="en-US"/>
           </a:p>
@@ -2103,7 +2101,7 @@
           <a:p>
             <a:fld id="{7237CE1A-8831-48B5-BA93-72483C6E34E8}" type="datetimeFigureOut">
               <a:rPr lang="ko-KR" altLang="en-US" smtClean="0"/>
-              <a:t>2026-08-21</a:t>
+              <a:t>26-08-22(Sat)</a:t>
             </a:fld>
             <a:endParaRPr lang="ko-KR" altLang="en-US"/>
           </a:p>
@@ -2356,7 +2354,7 @@
           <a:p>
             <a:fld id="{7237CE1A-8831-48B5-BA93-72483C6E34E8}" type="datetimeFigureOut">
               <a:rPr lang="ko-KR" altLang="en-US" smtClean="0"/>
-              <a:t>2026-08-21</a:t>
+              <a:t>26-08-22(Sat)</a:t>
             </a:fld>
             <a:endParaRPr lang="ko-KR" altLang="en-US"/>
           </a:p>
@@ -2569,7 +2567,7 @@
           <a:p>
             <a:fld id="{7237CE1A-8831-48B5-BA93-72483C6E34E8}" type="datetimeFigureOut">
               <a:rPr lang="ko-KR" altLang="en-US" smtClean="0"/>
-              <a:t>2026-08-21</a:t>
+              <a:t>26-08-22(Sat)</a:t>
             </a:fld>
             <a:endParaRPr lang="ko-KR" altLang="en-US"/>
           </a:p>
@@ -2976,179 +2974,28 @@
       </p:grpSpPr>
       <p:grpSp>
         <p:nvGrpSpPr>
-          <p:cNvPr id="11" name="그룹 10"/>
+          <p:cNvPr id="56" name="그룹 55"/>
           <p:cNvGrpSpPr/>
           <p:nvPr/>
         </p:nvGrpSpPr>
         <p:grpSpPr>
           <a:xfrm>
-            <a:off x="2496623" y="1212333"/>
-            <a:ext cx="7873630" cy="2256814"/>
-            <a:chOff x="2496623" y="1212333"/>
-            <a:chExt cx="7873630" cy="2256814"/>
+            <a:off x="-488868" y="928470"/>
+            <a:ext cx="14924134" cy="3166334"/>
+            <a:chOff x="-488868" y="928470"/>
+            <a:chExt cx="14924134" cy="3166334"/>
           </a:xfrm>
         </p:grpSpPr>
         <p:sp>
           <p:nvSpPr>
-            <p:cNvPr id="2" name="직사각형 1"/>
+            <p:cNvPr id="17" name="직사각형 16"/>
             <p:cNvSpPr/>
             <p:nvPr/>
           </p:nvSpPr>
           <p:spPr>
             <a:xfrm>
-              <a:off x="2496623" y="1212333"/>
-              <a:ext cx="7873630" cy="1015663"/>
-            </a:xfrm>
-            <a:prstGeom prst="rect">
-              <a:avLst/>
-            </a:prstGeom>
-          </p:spPr>
-          <p:txBody>
-            <a:bodyPr wrap="none">
-              <a:spAutoFit/>
-            </a:bodyPr>
-            <a:lstStyle/>
-            <a:p>
-              <a:r>
-                <a:rPr lang="ko-KR" altLang="en-US" sz="6000" dirty="0">
-                  <a:latin typeface="나눔스퀘어 Bold" panose="020B0600000101010101" pitchFamily="50" charset="-127"/>
-                  <a:ea typeface="나눔스퀘어 Bold" panose="020B0600000101010101" pitchFamily="50" charset="-127"/>
-                </a:rPr>
-                <a:t>@</a:t>
-              </a:r>
-              <a:r>
-                <a:rPr lang="ko-KR" altLang="en-US" sz="6000" dirty="0" err="1">
-                  <a:latin typeface="나눔스퀘어 Bold" panose="020B0600000101010101" pitchFamily="50" charset="-127"/>
-                  <a:ea typeface="나눔스퀘어 Bold" panose="020B0600000101010101" pitchFamily="50" charset="-127"/>
-                </a:rPr>
-                <a:t>WebServlet</a:t>
-              </a:r>
-              <a:r>
-                <a:rPr lang="ko-KR" altLang="en-US" sz="6000" dirty="0">
-                  <a:latin typeface="나눔스퀘어 Bold" panose="020B0600000101010101" pitchFamily="50" charset="-127"/>
-                  <a:ea typeface="나눔스퀘어 Bold" panose="020B0600000101010101" pitchFamily="50" charset="-127"/>
-                </a:rPr>
-                <a:t>("*.</a:t>
-              </a:r>
-              <a:r>
-                <a:rPr lang="ko-KR" altLang="en-US" sz="6000" dirty="0" err="1">
-                  <a:latin typeface="나눔스퀘어 Bold" panose="020B0600000101010101" pitchFamily="50" charset="-127"/>
-                  <a:ea typeface="나눔스퀘어 Bold" panose="020B0600000101010101" pitchFamily="50" charset="-127"/>
-                </a:rPr>
-                <a:t>dw</a:t>
-              </a:r>
-              <a:r>
-                <a:rPr lang="ko-KR" altLang="en-US" sz="6000" dirty="0">
-                  <a:latin typeface="나눔스퀘어 Bold" panose="020B0600000101010101" pitchFamily="50" charset="-127"/>
-                  <a:ea typeface="나눔스퀘어 Bold" panose="020B0600000101010101" pitchFamily="50" charset="-127"/>
-                </a:rPr>
-                <a:t>")</a:t>
-              </a:r>
-            </a:p>
-          </p:txBody>
-        </p:sp>
-        <p:sp>
-          <p:nvSpPr>
-            <p:cNvPr id="3" name="직사각형 2"/>
-            <p:cNvSpPr/>
-            <p:nvPr/>
-          </p:nvSpPr>
-          <p:spPr>
-            <a:xfrm>
-              <a:off x="2728685" y="2169940"/>
-              <a:ext cx="4680000" cy="72000"/>
-            </a:xfrm>
-            <a:prstGeom prst="rect">
-              <a:avLst/>
-            </a:prstGeom>
-            <a:solidFill>
-              <a:schemeClr val="tx1"/>
-            </a:solidFill>
-            <a:ln>
-              <a:noFill/>
-            </a:ln>
-          </p:spPr>
-          <p:style>
-            <a:lnRef idx="2">
-              <a:schemeClr val="accent1">
-                <a:shade val="50000"/>
-              </a:schemeClr>
-            </a:lnRef>
-            <a:fillRef idx="1">
-              <a:schemeClr val="accent1"/>
-            </a:fillRef>
-            <a:effectRef idx="0">
-              <a:schemeClr val="accent1"/>
-            </a:effectRef>
-            <a:fontRef idx="minor">
-              <a:schemeClr val="lt1"/>
-            </a:fontRef>
-          </p:style>
-          <p:txBody>
-            <a:bodyPr rtlCol="0" anchor="ctr"/>
-            <a:lstStyle/>
-            <a:p>
-              <a:pPr algn="ctr"/>
-              <a:endParaRPr lang="ko-KR" altLang="en-US"/>
-            </a:p>
-          </p:txBody>
-        </p:sp>
-        <p:sp>
-          <p:nvSpPr>
-            <p:cNvPr id="18" name="직사각형 17"/>
-            <p:cNvSpPr/>
-            <p:nvPr/>
-          </p:nvSpPr>
-          <p:spPr>
-            <a:xfrm>
-              <a:off x="7751413" y="2169709"/>
-              <a:ext cx="2160000" cy="72000"/>
-            </a:xfrm>
-            <a:prstGeom prst="rect">
-              <a:avLst/>
-            </a:prstGeom>
-            <a:solidFill>
-              <a:schemeClr val="tx1"/>
-            </a:solidFill>
-            <a:ln>
-              <a:noFill/>
-            </a:ln>
-          </p:spPr>
-          <p:style>
-            <a:lnRef idx="2">
-              <a:schemeClr val="accent1">
-                <a:shade val="50000"/>
-              </a:schemeClr>
-            </a:lnRef>
-            <a:fillRef idx="1">
-              <a:schemeClr val="accent1"/>
-            </a:fillRef>
-            <a:effectRef idx="0">
-              <a:schemeClr val="accent1"/>
-            </a:effectRef>
-            <a:fontRef idx="minor">
-              <a:schemeClr val="lt1"/>
-            </a:fontRef>
-          </p:style>
-          <p:txBody>
-            <a:bodyPr rtlCol="0" anchor="ctr"/>
-            <a:lstStyle/>
-            <a:p>
-              <a:pPr algn="ctr"/>
-              <a:endParaRPr lang="ko-KR" altLang="en-US"/>
-            </a:p>
-          </p:txBody>
-        </p:sp>
-        <p:sp>
-          <p:nvSpPr>
-            <p:cNvPr id="4" name="직사각형 3"/>
-            <p:cNvSpPr/>
-            <p:nvPr/>
-          </p:nvSpPr>
-          <p:spPr>
-            <a:xfrm>
-              <a:off x="3454404" y="2749147"/>
-              <a:ext cx="2700000" cy="720000"/>
+              <a:off x="2743199" y="1574802"/>
+              <a:ext cx="8460000" cy="2520000"/>
             </a:xfrm>
             <a:prstGeom prst="rect">
               <a:avLst/>
@@ -3181,30 +3028,73 @@
             <a:lstStyle/>
             <a:p>
               <a:pPr algn="ctr"/>
+              <a:endParaRPr lang="ko-KR" altLang="en-US"/>
+            </a:p>
+          </p:txBody>
+        </p:sp>
+        <p:sp>
+          <p:nvSpPr>
+            <p:cNvPr id="21" name="직사각형 20"/>
+            <p:cNvSpPr/>
+            <p:nvPr/>
+          </p:nvSpPr>
+          <p:spPr>
+            <a:xfrm>
+              <a:off x="4190998" y="1765800"/>
+              <a:ext cx="2160000" cy="1440000"/>
+            </a:xfrm>
+            <a:prstGeom prst="rect">
+              <a:avLst/>
+            </a:prstGeom>
+            <a:solidFill>
+              <a:schemeClr val="accent5"/>
+            </a:solidFill>
+            <a:ln>
+              <a:noFill/>
+            </a:ln>
+          </p:spPr>
+          <p:style>
+            <a:lnRef idx="2">
+              <a:schemeClr val="accent1">
+                <a:shade val="50000"/>
+              </a:schemeClr>
+            </a:lnRef>
+            <a:fillRef idx="1">
+              <a:schemeClr val="accent1"/>
+            </a:fillRef>
+            <a:effectRef idx="0">
+              <a:schemeClr val="accent1"/>
+            </a:effectRef>
+            <a:fontRef idx="minor">
+              <a:schemeClr val="lt1"/>
+            </a:fontRef>
+          </p:style>
+          <p:txBody>
+            <a:bodyPr rtlCol="0" anchor="ctr"/>
+            <a:lstStyle/>
+            <a:p>
+              <a:pPr algn="ctr"/>
               <a:r>
                 <a:rPr lang="en-US" altLang="ko-KR" sz="3200" dirty="0" smtClean="0">
-                  <a:solidFill>
-                    <a:schemeClr val="tx1"/>
-                  </a:solidFill>
                   <a:latin typeface="나눔스퀘어 Bold" panose="020B0600000101010101" pitchFamily="50" charset="-127"/>
                   <a:ea typeface="나눔스퀘어 Bold" panose="020B0600000101010101" pitchFamily="50" charset="-127"/>
                 </a:rPr>
-                <a:t>Servlet </a:t>
+                <a:t>Member</a:t>
               </a:r>
-              <a:r>
-                <a:rPr lang="ko-KR" altLang="en-US" sz="3200" dirty="0" smtClean="0">
-                  <a:solidFill>
-                    <a:schemeClr val="tx1"/>
-                  </a:solidFill>
+              <a:br>
+                <a:rPr lang="en-US" altLang="ko-KR" sz="3200" dirty="0" smtClean="0">
                   <a:latin typeface="나눔스퀘어 Bold" panose="020B0600000101010101" pitchFamily="50" charset="-127"/>
                   <a:ea typeface="나눔스퀘어 Bold" panose="020B0600000101010101" pitchFamily="50" charset="-127"/>
                 </a:rPr>
-                <a:t>매핑</a:t>
+              </a:br>
+              <a:r>
+                <a:rPr lang="en-US" altLang="ko-KR" sz="3200" dirty="0" smtClean="0">
+                  <a:latin typeface="나눔스퀘어 Bold" panose="020B0600000101010101" pitchFamily="50" charset="-127"/>
+                  <a:ea typeface="나눔스퀘어 Bold" panose="020B0600000101010101" pitchFamily="50" charset="-127"/>
+                </a:rPr>
+                <a:t>Controller</a:t>
               </a:r>
               <a:endParaRPr lang="ko-KR" altLang="en-US" sz="3200" dirty="0">
-                <a:solidFill>
-                  <a:schemeClr val="tx1"/>
-                </a:solidFill>
                 <a:latin typeface="나눔스퀘어 Bold" panose="020B0600000101010101" pitchFamily="50" charset="-127"/>
                 <a:ea typeface="나눔스퀘어 Bold" panose="020B0600000101010101" pitchFamily="50" charset="-127"/>
               </a:endParaRPr>
@@ -3213,14 +3103,215 @@
         </p:sp>
         <p:sp>
           <p:nvSpPr>
-            <p:cNvPr id="20" name="직사각형 19"/>
+            <p:cNvPr id="22" name="직사각형 21"/>
             <p:cNvSpPr/>
             <p:nvPr/>
           </p:nvSpPr>
           <p:spPr>
             <a:xfrm>
-              <a:off x="6709208" y="2749147"/>
-              <a:ext cx="2700000" cy="720000"/>
+              <a:off x="6524733" y="1765800"/>
+              <a:ext cx="2160000" cy="1440000"/>
+            </a:xfrm>
+            <a:prstGeom prst="rect">
+              <a:avLst/>
+            </a:prstGeom>
+            <a:solidFill>
+              <a:schemeClr val="accent5"/>
+            </a:solidFill>
+            <a:ln>
+              <a:noFill/>
+            </a:ln>
+          </p:spPr>
+          <p:style>
+            <a:lnRef idx="2">
+              <a:schemeClr val="accent1">
+                <a:shade val="50000"/>
+              </a:schemeClr>
+            </a:lnRef>
+            <a:fillRef idx="1">
+              <a:schemeClr val="accent1"/>
+            </a:fillRef>
+            <a:effectRef idx="0">
+              <a:schemeClr val="accent1"/>
+            </a:effectRef>
+            <a:fontRef idx="minor">
+              <a:schemeClr val="lt1"/>
+            </a:fontRef>
+          </p:style>
+          <p:txBody>
+            <a:bodyPr rtlCol="0" anchor="ctr"/>
+            <a:lstStyle/>
+            <a:p>
+              <a:pPr algn="ctr"/>
+              <a:r>
+                <a:rPr lang="en-US" altLang="ko-KR" sz="3200" dirty="0">
+                  <a:latin typeface="나눔스퀘어 Bold" panose="020B0600000101010101" pitchFamily="50" charset="-127"/>
+                  <a:ea typeface="나눔스퀘어 Bold" panose="020B0600000101010101" pitchFamily="50" charset="-127"/>
+                </a:rPr>
+                <a:t>Member</a:t>
+              </a:r>
+              <a:br>
+                <a:rPr lang="en-US" altLang="ko-KR" sz="3200" dirty="0">
+                  <a:latin typeface="나눔스퀘어 Bold" panose="020B0600000101010101" pitchFamily="50" charset="-127"/>
+                  <a:ea typeface="나눔스퀘어 Bold" panose="020B0600000101010101" pitchFamily="50" charset="-127"/>
+                </a:rPr>
+              </a:br>
+              <a:r>
+                <a:rPr lang="en-US" altLang="ko-KR" sz="3200" dirty="0" smtClean="0">
+                  <a:latin typeface="나눔스퀘어 Bold" panose="020B0600000101010101" pitchFamily="50" charset="-127"/>
+                  <a:ea typeface="나눔스퀘어 Bold" panose="020B0600000101010101" pitchFamily="50" charset="-127"/>
+                </a:rPr>
+                <a:t>Service</a:t>
+              </a:r>
+              <a:endParaRPr lang="ko-KR" altLang="en-US" sz="3200" dirty="0">
+                <a:latin typeface="나눔스퀘어 Bold" panose="020B0600000101010101" pitchFamily="50" charset="-127"/>
+                <a:ea typeface="나눔스퀘어 Bold" panose="020B0600000101010101" pitchFamily="50" charset="-127"/>
+              </a:endParaRPr>
+            </a:p>
+          </p:txBody>
+        </p:sp>
+        <p:sp>
+          <p:nvSpPr>
+            <p:cNvPr id="23" name="직사각형 22"/>
+            <p:cNvSpPr/>
+            <p:nvPr/>
+          </p:nvSpPr>
+          <p:spPr>
+            <a:xfrm>
+              <a:off x="8858468" y="1765800"/>
+              <a:ext cx="2160000" cy="1440000"/>
+            </a:xfrm>
+            <a:prstGeom prst="rect">
+              <a:avLst/>
+            </a:prstGeom>
+            <a:solidFill>
+              <a:schemeClr val="accent5"/>
+            </a:solidFill>
+            <a:ln>
+              <a:noFill/>
+            </a:ln>
+          </p:spPr>
+          <p:style>
+            <a:lnRef idx="2">
+              <a:schemeClr val="accent1">
+                <a:shade val="50000"/>
+              </a:schemeClr>
+            </a:lnRef>
+            <a:fillRef idx="1">
+              <a:schemeClr val="accent1"/>
+            </a:fillRef>
+            <a:effectRef idx="0">
+              <a:schemeClr val="accent1"/>
+            </a:effectRef>
+            <a:fontRef idx="minor">
+              <a:schemeClr val="lt1"/>
+            </a:fontRef>
+          </p:style>
+          <p:txBody>
+            <a:bodyPr rtlCol="0" anchor="ctr"/>
+            <a:lstStyle/>
+            <a:p>
+              <a:pPr algn="ctr"/>
+              <a:r>
+                <a:rPr lang="en-US" altLang="ko-KR" sz="3200" dirty="0">
+                  <a:latin typeface="나눔스퀘어 Bold" panose="020B0600000101010101" pitchFamily="50" charset="-127"/>
+                  <a:ea typeface="나눔스퀘어 Bold" panose="020B0600000101010101" pitchFamily="50" charset="-127"/>
+                </a:rPr>
+                <a:t>Member</a:t>
+              </a:r>
+              <a:br>
+                <a:rPr lang="en-US" altLang="ko-KR" sz="3200" dirty="0">
+                  <a:latin typeface="나눔스퀘어 Bold" panose="020B0600000101010101" pitchFamily="50" charset="-127"/>
+                  <a:ea typeface="나눔스퀘어 Bold" panose="020B0600000101010101" pitchFamily="50" charset="-127"/>
+                </a:rPr>
+              </a:br>
+              <a:r>
+                <a:rPr lang="en-US" altLang="ko-KR" sz="3200" dirty="0" smtClean="0">
+                  <a:latin typeface="나눔스퀘어 Bold" panose="020B0600000101010101" pitchFamily="50" charset="-127"/>
+                  <a:ea typeface="나눔스퀘어 Bold" panose="020B0600000101010101" pitchFamily="50" charset="-127"/>
+                </a:rPr>
+                <a:t>Dao</a:t>
+              </a:r>
+              <a:endParaRPr lang="ko-KR" altLang="en-US" sz="3200" dirty="0">
+                <a:latin typeface="나눔스퀘어 Bold" panose="020B0600000101010101" pitchFamily="50" charset="-127"/>
+                <a:ea typeface="나눔스퀘어 Bold" panose="020B0600000101010101" pitchFamily="50" charset="-127"/>
+              </a:endParaRPr>
+            </a:p>
+          </p:txBody>
+        </p:sp>
+        <p:sp>
+          <p:nvSpPr>
+            <p:cNvPr id="27" name="직사각형 26"/>
+            <p:cNvSpPr/>
+            <p:nvPr/>
+          </p:nvSpPr>
+          <p:spPr>
+            <a:xfrm>
+              <a:off x="2935566" y="1765800"/>
+              <a:ext cx="1080000" cy="1440000"/>
+            </a:xfrm>
+            <a:prstGeom prst="rect">
+              <a:avLst/>
+            </a:prstGeom>
+            <a:solidFill>
+              <a:schemeClr val="accent5"/>
+            </a:solidFill>
+            <a:ln>
+              <a:noFill/>
+            </a:ln>
+          </p:spPr>
+          <p:style>
+            <a:lnRef idx="2">
+              <a:schemeClr val="accent1">
+                <a:shade val="50000"/>
+              </a:schemeClr>
+            </a:lnRef>
+            <a:fillRef idx="1">
+              <a:schemeClr val="accent1"/>
+            </a:fillRef>
+            <a:effectRef idx="0">
+              <a:schemeClr val="accent1"/>
+            </a:effectRef>
+            <a:fontRef idx="minor">
+              <a:schemeClr val="lt1"/>
+            </a:fontRef>
+          </p:style>
+          <p:txBody>
+            <a:bodyPr rtlCol="0" anchor="ctr"/>
+            <a:lstStyle/>
+            <a:p>
+              <a:pPr algn="ctr"/>
+              <a:r>
+                <a:rPr lang="en-US" altLang="ko-KR" sz="3200" dirty="0">
+                  <a:latin typeface="나눔스퀘어 Bold" panose="020B0600000101010101" pitchFamily="50" charset="-127"/>
+                  <a:ea typeface="나눔스퀘어 Bold" panose="020B0600000101010101" pitchFamily="50" charset="-127"/>
+                </a:rPr>
+                <a:t>w</a:t>
+              </a:r>
+              <a:r>
+                <a:rPr lang="en-US" altLang="ko-KR" sz="3200" dirty="0" smtClean="0">
+                  <a:latin typeface="나눔스퀘어 Bold" panose="020B0600000101010101" pitchFamily="50" charset="-127"/>
+                  <a:ea typeface="나눔스퀘어 Bold" panose="020B0600000101010101" pitchFamily="50" charset="-127"/>
+                </a:rPr>
+                <a:t>eb.xml</a:t>
+              </a:r>
+              <a:endParaRPr lang="ko-KR" altLang="en-US" sz="3200" dirty="0">
+                <a:latin typeface="나눔스퀘어 Bold" panose="020B0600000101010101" pitchFamily="50" charset="-127"/>
+                <a:ea typeface="나눔스퀘어 Bold" panose="020B0600000101010101" pitchFamily="50" charset="-127"/>
+              </a:endParaRPr>
+            </a:p>
+          </p:txBody>
+        </p:sp>
+        <p:sp>
+          <p:nvSpPr>
+            <p:cNvPr id="28" name="직사각형 27"/>
+            <p:cNvSpPr/>
+            <p:nvPr/>
+          </p:nvSpPr>
+          <p:spPr>
+            <a:xfrm>
+              <a:off x="-488868" y="1574802"/>
+              <a:ext cx="2520000" cy="2520000"/>
             </a:xfrm>
             <a:prstGeom prst="rect">
               <a:avLst/>
@@ -3253,49 +3344,316 @@
             <a:lstStyle/>
             <a:p>
               <a:pPr algn="ctr"/>
+              <a:endParaRPr lang="ko-KR" altLang="en-US"/>
+            </a:p>
+          </p:txBody>
+        </p:sp>
+        <p:sp>
+          <p:nvSpPr>
+            <p:cNvPr id="29" name="직사각형 28"/>
+            <p:cNvSpPr/>
+            <p:nvPr/>
+          </p:nvSpPr>
+          <p:spPr>
+            <a:xfrm>
+              <a:off x="-308868" y="1782736"/>
+              <a:ext cx="2160000" cy="1440000"/>
+            </a:xfrm>
+            <a:prstGeom prst="rect">
+              <a:avLst/>
+            </a:prstGeom>
+            <a:solidFill>
+              <a:schemeClr val="accent5"/>
+            </a:solidFill>
+            <a:ln>
+              <a:noFill/>
+            </a:ln>
+          </p:spPr>
+          <p:style>
+            <a:lnRef idx="2">
+              <a:schemeClr val="accent1">
+                <a:shade val="50000"/>
+              </a:schemeClr>
+            </a:lnRef>
+            <a:fillRef idx="1">
+              <a:schemeClr val="accent1"/>
+            </a:fillRef>
+            <a:effectRef idx="0">
+              <a:schemeClr val="accent1"/>
+            </a:effectRef>
+            <a:fontRef idx="minor">
+              <a:schemeClr val="lt1"/>
+            </a:fontRef>
+          </p:style>
+          <p:txBody>
+            <a:bodyPr rtlCol="0" anchor="ctr"/>
+            <a:lstStyle/>
+            <a:p>
+              <a:pPr algn="ctr"/>
               <a:r>
-                <a:rPr lang="en-US" altLang="ko-KR" sz="3200" dirty="0" smtClean="0">
-                  <a:solidFill>
-                    <a:schemeClr val="tx1"/>
-                  </a:solidFill>
+                <a:rPr lang="en-US" altLang="ko-KR" sz="4400" dirty="0" smtClean="0">
                   <a:latin typeface="나눔스퀘어 Bold" panose="020B0600000101010101" pitchFamily="50" charset="-127"/>
                   <a:ea typeface="나눔스퀘어 Bold" panose="020B0600000101010101" pitchFamily="50" charset="-127"/>
                 </a:rPr>
-                <a:t>URL </a:t>
+                <a:t>View</a:t>
               </a:r>
-              <a:r>
-                <a:rPr lang="ko-KR" altLang="en-US" sz="3200" dirty="0" smtClean="0">
-                  <a:solidFill>
-                    <a:schemeClr val="tx1"/>
-                  </a:solidFill>
-                  <a:latin typeface="나눔스퀘어 Bold" panose="020B0600000101010101" pitchFamily="50" charset="-127"/>
-                  <a:ea typeface="나눔스퀘어 Bold" panose="020B0600000101010101" pitchFamily="50" charset="-127"/>
-                </a:rPr>
-                <a:t>패턴</a:t>
-              </a:r>
-              <a:endParaRPr lang="ko-KR" altLang="en-US" sz="3200" dirty="0">
-                <a:solidFill>
-                  <a:schemeClr val="tx1"/>
-                </a:solidFill>
+              <a:endParaRPr lang="ko-KR" altLang="en-US" sz="4400" dirty="0">
                 <a:latin typeface="나눔스퀘어 Bold" panose="020B0600000101010101" pitchFamily="50" charset="-127"/>
                 <a:ea typeface="나눔스퀘어 Bold" panose="020B0600000101010101" pitchFamily="50" charset="-127"/>
               </a:endParaRPr>
             </a:p>
           </p:txBody>
         </p:sp>
+        <p:sp>
+          <p:nvSpPr>
+            <p:cNvPr id="30" name="직사각형 29"/>
+            <p:cNvSpPr/>
+            <p:nvPr/>
+          </p:nvSpPr>
+          <p:spPr>
+            <a:xfrm>
+              <a:off x="11915266" y="1574804"/>
+              <a:ext cx="2520000" cy="2520000"/>
+            </a:xfrm>
+            <a:prstGeom prst="rect">
+              <a:avLst/>
+            </a:prstGeom>
+            <a:noFill/>
+            <a:ln w="38100">
+              <a:solidFill>
+                <a:schemeClr val="tx1"/>
+              </a:solidFill>
+            </a:ln>
+          </p:spPr>
+          <p:style>
+            <a:lnRef idx="2">
+              <a:schemeClr val="accent1">
+                <a:shade val="50000"/>
+              </a:schemeClr>
+            </a:lnRef>
+            <a:fillRef idx="1">
+              <a:schemeClr val="accent1"/>
+            </a:fillRef>
+            <a:effectRef idx="0">
+              <a:schemeClr val="accent1"/>
+            </a:effectRef>
+            <a:fontRef idx="minor">
+              <a:schemeClr val="lt1"/>
+            </a:fontRef>
+          </p:style>
+          <p:txBody>
+            <a:bodyPr rtlCol="0" anchor="ctr"/>
+            <a:lstStyle/>
+            <a:p>
+              <a:pPr algn="ctr"/>
+              <a:endParaRPr lang="ko-KR" altLang="en-US"/>
+            </a:p>
+          </p:txBody>
+        </p:sp>
+        <p:sp>
+          <p:nvSpPr>
+            <p:cNvPr id="31" name="직사각형 30"/>
+            <p:cNvSpPr/>
+            <p:nvPr/>
+          </p:nvSpPr>
+          <p:spPr>
+            <a:xfrm>
+              <a:off x="12095266" y="1782736"/>
+              <a:ext cx="2160000" cy="1440000"/>
+            </a:xfrm>
+            <a:prstGeom prst="rect">
+              <a:avLst/>
+            </a:prstGeom>
+            <a:solidFill>
+              <a:schemeClr val="accent5"/>
+            </a:solidFill>
+            <a:ln>
+              <a:noFill/>
+            </a:ln>
+          </p:spPr>
+          <p:style>
+            <a:lnRef idx="2">
+              <a:schemeClr val="accent1">
+                <a:shade val="50000"/>
+              </a:schemeClr>
+            </a:lnRef>
+            <a:fillRef idx="1">
+              <a:schemeClr val="accent1"/>
+            </a:fillRef>
+            <a:effectRef idx="0">
+              <a:schemeClr val="accent1"/>
+            </a:effectRef>
+            <a:fontRef idx="minor">
+              <a:schemeClr val="lt1"/>
+            </a:fontRef>
+          </p:style>
+          <p:txBody>
+            <a:bodyPr rtlCol="0" anchor="ctr"/>
+            <a:lstStyle/>
+            <a:p>
+              <a:pPr algn="ctr"/>
+              <a:r>
+                <a:rPr lang="en-US" altLang="ko-KR" sz="4400" dirty="0" smtClean="0">
+                  <a:latin typeface="나눔스퀘어 Bold" panose="020B0600000101010101" pitchFamily="50" charset="-127"/>
+                  <a:ea typeface="나눔스퀘어 Bold" panose="020B0600000101010101" pitchFamily="50" charset="-127"/>
+                </a:rPr>
+                <a:t>DB</a:t>
+              </a:r>
+              <a:endParaRPr lang="ko-KR" altLang="en-US" sz="4400" dirty="0">
+                <a:latin typeface="나눔스퀘어 Bold" panose="020B0600000101010101" pitchFamily="50" charset="-127"/>
+                <a:ea typeface="나눔스퀘어 Bold" panose="020B0600000101010101" pitchFamily="50" charset="-127"/>
+              </a:endParaRPr>
+            </a:p>
+          </p:txBody>
+        </p:sp>
+        <p:sp>
+          <p:nvSpPr>
+            <p:cNvPr id="9" name="TextBox 8"/>
+            <p:cNvSpPr txBox="1"/>
+            <p:nvPr/>
+          </p:nvSpPr>
+          <p:spPr>
+            <a:xfrm>
+              <a:off x="81680" y="928471"/>
+              <a:ext cx="1378904" cy="646331"/>
+            </a:xfrm>
+            <a:prstGeom prst="rect">
+              <a:avLst/>
+            </a:prstGeom>
+            <a:noFill/>
+          </p:spPr>
+          <p:txBody>
+            <a:bodyPr wrap="none" rtlCol="0">
+              <a:spAutoFit/>
+            </a:bodyPr>
+            <a:lstStyle/>
+            <a:p>
+              <a:pPr algn="ctr"/>
+              <a:r>
+                <a:rPr lang="en-US" altLang="ko-KR" sz="3600" dirty="0" smtClean="0"/>
+                <a:t>Client</a:t>
+              </a:r>
+              <a:endParaRPr lang="ko-KR" altLang="en-US" sz="3600" dirty="0"/>
+            </a:p>
+          </p:txBody>
+        </p:sp>
+        <p:sp>
+          <p:nvSpPr>
+            <p:cNvPr id="32" name="TextBox 31"/>
+            <p:cNvSpPr txBox="1"/>
+            <p:nvPr/>
+          </p:nvSpPr>
+          <p:spPr>
+            <a:xfrm>
+              <a:off x="4777694" y="928470"/>
+              <a:ext cx="4391010" cy="646331"/>
+            </a:xfrm>
+            <a:prstGeom prst="rect">
+              <a:avLst/>
+            </a:prstGeom>
+            <a:noFill/>
+          </p:spPr>
+          <p:txBody>
+            <a:bodyPr wrap="none" rtlCol="0">
+              <a:spAutoFit/>
+            </a:bodyPr>
+            <a:lstStyle/>
+            <a:p>
+              <a:pPr algn="ctr"/>
+              <a:r>
+                <a:rPr lang="en-US" altLang="ko-KR" sz="3600" dirty="0"/>
+                <a:t>w</a:t>
+              </a:r>
+              <a:r>
+                <a:rPr lang="en-US" altLang="ko-KR" sz="3600" dirty="0" smtClean="0"/>
+                <a:t>eb server : Tomcat</a:t>
+              </a:r>
+              <a:endParaRPr lang="ko-KR" altLang="en-US" sz="3600" dirty="0"/>
+            </a:p>
+          </p:txBody>
+        </p:sp>
+        <p:sp>
+          <p:nvSpPr>
+            <p:cNvPr id="33" name="TextBox 32"/>
+            <p:cNvSpPr txBox="1"/>
+            <p:nvPr/>
+          </p:nvSpPr>
+          <p:spPr>
+            <a:xfrm>
+              <a:off x="12782369" y="928470"/>
+              <a:ext cx="785793" cy="646331"/>
+            </a:xfrm>
+            <a:prstGeom prst="rect">
+              <a:avLst/>
+            </a:prstGeom>
+            <a:noFill/>
+          </p:spPr>
+          <p:txBody>
+            <a:bodyPr wrap="none" rtlCol="0">
+              <a:spAutoFit/>
+            </a:bodyPr>
+            <a:lstStyle/>
+            <a:p>
+              <a:pPr algn="ctr"/>
+              <a:r>
+                <a:rPr lang="en-US" altLang="ko-KR" sz="3600" dirty="0" smtClean="0"/>
+                <a:t>DB</a:t>
+              </a:r>
+              <a:endParaRPr lang="ko-KR" altLang="en-US" sz="3600" dirty="0"/>
+            </a:p>
+          </p:txBody>
+        </p:sp>
+        <p:sp>
+          <p:nvSpPr>
+            <p:cNvPr id="10" name="TextBox 9"/>
+            <p:cNvSpPr txBox="1"/>
+            <p:nvPr/>
+          </p:nvSpPr>
+          <p:spPr>
+            <a:xfrm>
+              <a:off x="-451607" y="3335603"/>
+              <a:ext cx="2445478" cy="646331"/>
+            </a:xfrm>
+            <a:prstGeom prst="rect">
+              <a:avLst/>
+            </a:prstGeom>
+            <a:noFill/>
+          </p:spPr>
+          <p:txBody>
+            <a:bodyPr wrap="none" rtlCol="0">
+              <a:spAutoFit/>
+            </a:bodyPr>
+            <a:lstStyle/>
+            <a:p>
+              <a:pPr algn="ctr"/>
+              <a:r>
+                <a:rPr lang="en-US" altLang="ko-KR" dirty="0" smtClean="0"/>
+                <a:t>ID, PW, MAIL, PHONE</a:t>
+              </a:r>
+            </a:p>
+            <a:p>
+              <a:pPr algn="ctr"/>
+              <a:r>
+                <a:rPr lang="en-US" altLang="ko-KR" dirty="0" smtClean="0"/>
+                <a:t>[ SUBMIT ]</a:t>
+              </a:r>
+              <a:endParaRPr lang="ko-KR" altLang="en-US" dirty="0"/>
+            </a:p>
+          </p:txBody>
+        </p:sp>
         <p:cxnSp>
           <p:nvCxnSpPr>
-            <p:cNvPr id="7" name="직선 화살표 연결선 6"/>
+            <p:cNvPr id="34" name="직선 화살표 연결선 33"/>
             <p:cNvCxnSpPr>
-              <a:stCxn id="4" idx="0"/>
-              <a:endCxn id="3" idx="2"/>
+              <a:stCxn id="29" idx="3"/>
+              <a:endCxn id="27" idx="1"/>
             </p:cNvCxnSpPr>
             <p:nvPr/>
           </p:nvCxnSpPr>
           <p:spPr>
             <a:xfrm flipV="1">
-              <a:off x="4804404" y="2241940"/>
-              <a:ext cx="264281" cy="507207"/>
+              <a:off x="1851132" y="2485800"/>
+              <a:ext cx="1084434" cy="16936"/>
             </a:xfrm>
             <a:prstGeom prst="straightConnector1">
               <a:avLst/>
@@ -3324,17 +3682,134 @@
         </p:cxnSp>
         <p:cxnSp>
           <p:nvCxnSpPr>
-            <p:cNvPr id="25" name="직선 화살표 연결선 24"/>
+            <p:cNvPr id="37" name="꺾인 연결선 36"/>
             <p:cNvCxnSpPr>
-              <a:stCxn id="20" idx="0"/>
-              <a:endCxn id="18" idx="2"/>
+              <a:stCxn id="27" idx="2"/>
+              <a:endCxn id="21" idx="2"/>
             </p:cNvCxnSpPr>
             <p:nvPr/>
           </p:nvCxnSpPr>
           <p:spPr>
-            <a:xfrm flipV="1">
-              <a:off x="8059208" y="2241709"/>
-              <a:ext cx="772205" cy="507438"/>
+            <a:xfrm rot="16200000" flipH="1">
+              <a:off x="4249566" y="2431800"/>
+              <a:ext cx="12700" cy="1548000"/>
+            </a:xfrm>
+            <a:prstGeom prst="bentConnector3">
+              <a:avLst>
+                <a:gd name="adj1" fmla="val 3666669"/>
+              </a:avLst>
+            </a:prstGeom>
+            <a:ln w="76200">
+              <a:solidFill>
+                <a:schemeClr val="accent2"/>
+              </a:solidFill>
+              <a:tailEnd type="triangle"/>
+            </a:ln>
+          </p:spPr>
+          <p:style>
+            <a:lnRef idx="1">
+              <a:schemeClr val="accent1"/>
+            </a:lnRef>
+            <a:fillRef idx="0">
+              <a:schemeClr val="accent1"/>
+            </a:fillRef>
+            <a:effectRef idx="0">
+              <a:schemeClr val="accent1"/>
+            </a:effectRef>
+            <a:fontRef idx="minor">
+              <a:schemeClr val="tx1"/>
+            </a:fontRef>
+          </p:style>
+        </p:cxnSp>
+        <p:cxnSp>
+          <p:nvCxnSpPr>
+            <p:cNvPr id="41" name="꺾인 연결선 40"/>
+            <p:cNvCxnSpPr/>
+            <p:nvPr/>
+          </p:nvCxnSpPr>
+          <p:spPr>
+            <a:xfrm rot="16200000" flipH="1">
+              <a:off x="6437014" y="2161799"/>
+              <a:ext cx="12700" cy="2088000"/>
+            </a:xfrm>
+            <a:prstGeom prst="bentConnector3">
+              <a:avLst>
+                <a:gd name="adj1" fmla="val 3733331"/>
+              </a:avLst>
+            </a:prstGeom>
+            <a:ln w="76200">
+              <a:solidFill>
+                <a:schemeClr val="accent2"/>
+              </a:solidFill>
+              <a:tailEnd type="triangle"/>
+            </a:ln>
+          </p:spPr>
+          <p:style>
+            <a:lnRef idx="1">
+              <a:schemeClr val="accent1"/>
+            </a:lnRef>
+            <a:fillRef idx="0">
+              <a:schemeClr val="accent1"/>
+            </a:fillRef>
+            <a:effectRef idx="0">
+              <a:schemeClr val="accent1"/>
+            </a:effectRef>
+            <a:fontRef idx="minor">
+              <a:schemeClr val="tx1"/>
+            </a:fontRef>
+          </p:style>
+        </p:cxnSp>
+        <p:cxnSp>
+          <p:nvCxnSpPr>
+            <p:cNvPr id="47" name="꺾인 연결선 46"/>
+            <p:cNvCxnSpPr/>
+            <p:nvPr/>
+          </p:nvCxnSpPr>
+          <p:spPr>
+            <a:xfrm rot="16200000" flipH="1">
+              <a:off x="8896402" y="2125799"/>
+              <a:ext cx="12700" cy="2160000"/>
+            </a:xfrm>
+            <a:prstGeom prst="bentConnector3">
+              <a:avLst>
+                <a:gd name="adj1" fmla="val 3733339"/>
+              </a:avLst>
+            </a:prstGeom>
+            <a:ln w="76200">
+              <a:solidFill>
+                <a:schemeClr val="accent2"/>
+              </a:solidFill>
+              <a:tailEnd type="triangle"/>
+            </a:ln>
+          </p:spPr>
+          <p:style>
+            <a:lnRef idx="1">
+              <a:schemeClr val="accent1"/>
+            </a:lnRef>
+            <a:fillRef idx="0">
+              <a:schemeClr val="accent1"/>
+            </a:fillRef>
+            <a:effectRef idx="0">
+              <a:schemeClr val="accent1"/>
+            </a:effectRef>
+            <a:fontRef idx="minor">
+              <a:schemeClr val="tx1"/>
+            </a:fontRef>
+          </p:style>
+        </p:cxnSp>
+        <p:cxnSp>
+          <p:nvCxnSpPr>
+            <p:cNvPr id="52" name="직선 화살표 연결선 51"/>
+            <p:cNvCxnSpPr>
+              <a:stCxn id="23" idx="3"/>
+              <a:endCxn id="31" idx="1"/>
+            </p:cNvCxnSpPr>
+            <p:nvPr/>
+          </p:nvCxnSpPr>
+          <p:spPr>
+            <a:xfrm>
+              <a:off x="11018468" y="2485800"/>
+              <a:ext cx="1076798" cy="16936"/>
             </a:xfrm>
             <a:prstGeom prst="straightConnector1">
               <a:avLst/>
@@ -3361,6 +3836,62 @@
             </a:fontRef>
           </p:style>
         </p:cxnSp>
+        <p:sp>
+          <p:nvSpPr>
+            <p:cNvPr id="55" name="직사각형 54"/>
+            <p:cNvSpPr/>
+            <p:nvPr/>
+          </p:nvSpPr>
+          <p:spPr>
+            <a:xfrm>
+              <a:off x="8362752" y="3396798"/>
+              <a:ext cx="1080000" cy="540000"/>
+            </a:xfrm>
+            <a:prstGeom prst="rect">
+              <a:avLst/>
+            </a:prstGeom>
+            <a:solidFill>
+              <a:schemeClr val="accent5"/>
+            </a:solidFill>
+            <a:ln>
+              <a:noFill/>
+            </a:ln>
+          </p:spPr>
+          <p:style>
+            <a:lnRef idx="2">
+              <a:schemeClr val="accent1">
+                <a:shade val="50000"/>
+              </a:schemeClr>
+            </a:lnRef>
+            <a:fillRef idx="1">
+              <a:schemeClr val="accent1"/>
+            </a:fillRef>
+            <a:effectRef idx="0">
+              <a:schemeClr val="accent1"/>
+            </a:effectRef>
+            <a:fontRef idx="minor">
+              <a:schemeClr val="lt1"/>
+            </a:fontRef>
+          </p:style>
+          <p:txBody>
+            <a:bodyPr rtlCol="0" anchor="ctr"/>
+            <a:lstStyle/>
+            <a:p>
+              <a:pPr algn="ctr"/>
+              <a:r>
+                <a:rPr lang="en-US" altLang="ko-KR" sz="2400" dirty="0" smtClean="0">
+                  <a:latin typeface="나눔스퀘어 Bold" panose="020B0600000101010101" pitchFamily="50" charset="-127"/>
+                  <a:ea typeface="나눔스퀘어 Bold" panose="020B0600000101010101" pitchFamily="50" charset="-127"/>
+                </a:rPr>
+                <a:t>DTO</a:t>
+              </a:r>
+              <a:endParaRPr lang="ko-KR" altLang="en-US" sz="2400" dirty="0">
+                <a:latin typeface="나눔스퀘어 Bold" panose="020B0600000101010101" pitchFamily="50" charset="-127"/>
+                <a:ea typeface="나눔스퀘어 Bold" panose="020B0600000101010101" pitchFamily="50" charset="-127"/>
+              </a:endParaRPr>
+            </a:p>
+          </p:txBody>
+        </p:sp>
       </p:grpSp>
     </p:spTree>
     <p:extLst>
@@ -3392,93 +3923,6 @@
           <a:chExt cx="0" cy="0"/>
         </a:xfrm>
       </p:grpSpPr>
-      <p:graphicFrame>
-        <p:nvGraphicFramePr>
-          <p:cNvPr id="13" name="개체 12"/>
-          <p:cNvGraphicFramePr>
-            <a:graphicFrameLocks noChangeAspect="1"/>
-          </p:cNvGraphicFramePr>
-          <p:nvPr>
-            <p:extLst>
-              <p:ext uri="{D42A27DB-BD31-4B8C-83A1-F6EECF244321}">
-                <p14:modId xmlns:p14="http://schemas.microsoft.com/office/powerpoint/2010/main" val="3555952625"/>
-              </p:ext>
-            </p:extLst>
-          </p:nvPr>
-        </p:nvGraphicFramePr>
-        <p:xfrm>
-          <a:off x="2573338" y="719138"/>
-          <a:ext cx="7043737" cy="5418137"/>
-        </p:xfrm>
-        <a:graphic>
-          <a:graphicData uri="http://schemas.openxmlformats.org/presentationml/2006/ole">
-            <mc:AlternateContent xmlns:mc="http://schemas.openxmlformats.org/markup-compatibility/2006">
-              <mc:Choice xmlns:v="urn:schemas-microsoft-com:vml" Requires="v">
-                <p:oleObj spid="_x0000_s1045" name="워크시트" r:id="rId3" imgW="22637898" imgH="17411877" progId="Excel.Sheet.12">
-                  <p:embed/>
-                </p:oleObj>
-              </mc:Choice>
-              <mc:Fallback>
-                <p:oleObj name="워크시트" r:id="rId3" imgW="22637898" imgH="17411877" progId="Excel.Sheet.12">
-                  <p:embed/>
-                  <p:pic>
-                    <p:nvPicPr>
-                      <p:cNvPr id="0" name=""/>
-                      <p:cNvPicPr/>
-                      <p:nvPr/>
-                    </p:nvPicPr>
-                    <p:blipFill>
-                      <a:blip r:embed="rId4"/>
-                      <a:stretch>
-                        <a:fillRect/>
-                      </a:stretch>
-                    </p:blipFill>
-                    <p:spPr>
-                      <a:xfrm>
-                        <a:off x="2573338" y="719138"/>
-                        <a:ext cx="7043737" cy="5418137"/>
-                      </a:xfrm>
-                      <a:prstGeom prst="rect">
-                        <a:avLst/>
-                      </a:prstGeom>
-                    </p:spPr>
-                  </p:pic>
-                </p:oleObj>
-              </mc:Fallback>
-            </mc:AlternateContent>
-          </a:graphicData>
-        </a:graphic>
-      </p:graphicFrame>
-    </p:spTree>
-    <p:extLst>
-      <p:ext uri="{BB962C8B-B14F-4D97-AF65-F5344CB8AC3E}">
-        <p14:creationId xmlns:p14="http://schemas.microsoft.com/office/powerpoint/2010/main" val="2557989807"/>
-      </p:ext>
-    </p:extLst>
-  </p:cSld>
-  <p:clrMapOvr>
-    <a:masterClrMapping/>
-  </p:clrMapOvr>
-</p:sld>
-</file>
-
-<file path=ppt/slides/slide3.xml><?xml version="1.0" encoding="utf-8"?>
-<p:sld xmlns:a="http://schemas.openxmlformats.org/drawingml/2006/main" xmlns:r="http://schemas.openxmlformats.org/officeDocument/2006/relationships" xmlns:p="http://schemas.openxmlformats.org/presentationml/2006/main">
-  <p:cSld>
-    <p:spTree>
-      <p:nvGrpSpPr>
-        <p:cNvPr id="1" name=""/>
-        <p:cNvGrpSpPr/>
-        <p:nvPr/>
-      </p:nvGrpSpPr>
-      <p:grpSpPr>
-        <a:xfrm>
-          <a:off x="0" y="0"/>
-          <a:ext cx="0" cy="0"/>
-          <a:chOff x="0" y="0"/>
-          <a:chExt cx="0" cy="0"/>
-        </a:xfrm>
-      </p:grpSpPr>
       <p:sp>
         <p:nvSpPr>
           <p:cNvPr id="81" name="직사각형 80"/>
@@ -8865,7 +9309,7 @@
 </p:sld>
 </file>
 
-<file path=ppt/slides/slide4.xml><?xml version="1.0" encoding="utf-8"?>
+<file path=ppt/slides/slide3.xml><?xml version="1.0" encoding="utf-8"?>
 <p:sld xmlns:a="http://schemas.openxmlformats.org/drawingml/2006/main" xmlns:r="http://schemas.openxmlformats.org/officeDocument/2006/relationships" xmlns:p="http://schemas.openxmlformats.org/presentationml/2006/main">
   <p:cSld>
     <p:spTree>
@@ -9856,471 +10300,7 @@
 </p:sld>
 </file>
 
-<file path=ppt/slides/slide5.xml><?xml version="1.0" encoding="utf-8"?>
-<p:sld xmlns:a="http://schemas.openxmlformats.org/drawingml/2006/main" xmlns:r="http://schemas.openxmlformats.org/officeDocument/2006/relationships" xmlns:p="http://schemas.openxmlformats.org/presentationml/2006/main">
-  <p:cSld>
-    <p:spTree>
-      <p:nvGrpSpPr>
-        <p:cNvPr id="1" name=""/>
-        <p:cNvGrpSpPr/>
-        <p:nvPr/>
-      </p:nvGrpSpPr>
-      <p:grpSpPr>
-        <a:xfrm>
-          <a:off x="0" y="0"/>
-          <a:ext cx="0" cy="0"/>
-          <a:chOff x="0" y="0"/>
-          <a:chExt cx="0" cy="0"/>
-        </a:xfrm>
-      </p:grpSpPr>
-      <p:grpSp>
-        <p:nvGrpSpPr>
-          <p:cNvPr id="82" name="그룹 81"/>
-          <p:cNvGrpSpPr/>
-          <p:nvPr/>
-        </p:nvGrpSpPr>
-        <p:grpSpPr>
-          <a:xfrm>
-            <a:off x="1447800" y="1473200"/>
-            <a:ext cx="8721500" cy="2160000"/>
-            <a:chOff x="1447800" y="1473200"/>
-            <a:chExt cx="8721500" cy="2160000"/>
-          </a:xfrm>
-        </p:grpSpPr>
-        <p:sp>
-          <p:nvSpPr>
-            <p:cNvPr id="69" name="직사각형 68"/>
-            <p:cNvSpPr/>
-            <p:nvPr/>
-          </p:nvSpPr>
-          <p:spPr>
-            <a:xfrm>
-              <a:off x="4368550" y="1473200"/>
-              <a:ext cx="3600000" cy="2160000"/>
-            </a:xfrm>
-            <a:prstGeom prst="rect">
-              <a:avLst/>
-            </a:prstGeom>
-            <a:solidFill>
-              <a:schemeClr val="bg1">
-                <a:lumMod val="95000"/>
-              </a:schemeClr>
-            </a:solidFill>
-            <a:ln w="28575">
-              <a:solidFill>
-                <a:schemeClr val="tx1"/>
-              </a:solidFill>
-            </a:ln>
-          </p:spPr>
-          <p:style>
-            <a:lnRef idx="2">
-              <a:schemeClr val="accent1">
-                <a:shade val="50000"/>
-              </a:schemeClr>
-            </a:lnRef>
-            <a:fillRef idx="1">
-              <a:schemeClr val="accent1"/>
-            </a:fillRef>
-            <a:effectRef idx="0">
-              <a:schemeClr val="accent1"/>
-            </a:effectRef>
-            <a:fontRef idx="minor">
-              <a:schemeClr val="lt1"/>
-            </a:fontRef>
-          </p:style>
-          <p:txBody>
-            <a:bodyPr rtlCol="0" anchor="ctr"/>
-            <a:lstStyle/>
-            <a:p>
-              <a:pPr algn="ctr"/>
-              <a:r>
-                <a:rPr lang="ko-KR" altLang="en-US" sz="2800" dirty="0" smtClean="0">
-                  <a:solidFill>
-                    <a:schemeClr val="tx1"/>
-                  </a:solidFill>
-                  <a:latin typeface="나눔스퀘어 Bold" panose="020B0600000101010101" pitchFamily="50" charset="-127"/>
-                  <a:ea typeface="나눔스퀘어 Bold" panose="020B0600000101010101" pitchFamily="50" charset="-127"/>
-                </a:rPr>
-                <a:t>객체 </a:t>
-              </a:r>
-              <a:r>
-                <a:rPr lang="en-US" altLang="ko-KR" sz="2800" dirty="0" smtClean="0">
-                  <a:solidFill>
-                    <a:schemeClr val="tx1"/>
-                  </a:solidFill>
-                  <a:latin typeface="나눔스퀘어 Bold" panose="020B0600000101010101" pitchFamily="50" charset="-127"/>
-                  <a:ea typeface="나눔스퀘어 Bold" panose="020B0600000101010101" pitchFamily="50" charset="-127"/>
-                </a:rPr>
-                <a:t>1</a:t>
-              </a:r>
-              <a:r>
-                <a:rPr lang="ko-KR" altLang="en-US" sz="2800" dirty="0" smtClean="0">
-                  <a:solidFill>
-                    <a:schemeClr val="tx1"/>
-                  </a:solidFill>
-                  <a:latin typeface="나눔스퀘어 Bold" panose="020B0600000101010101" pitchFamily="50" charset="-127"/>
-                  <a:ea typeface="나눔스퀘어 Bold" panose="020B0600000101010101" pitchFamily="50" charset="-127"/>
-                </a:rPr>
-                <a:t>개</a:t>
-              </a:r>
-              <a:endParaRPr lang="ko-KR" altLang="en-US" sz="2800" dirty="0">
-                <a:solidFill>
-                  <a:schemeClr val="tx1"/>
-                </a:solidFill>
-                <a:latin typeface="나눔스퀘어 Bold" panose="020B0600000101010101" pitchFamily="50" charset="-127"/>
-                <a:ea typeface="나눔스퀘어 Bold" panose="020B0600000101010101" pitchFamily="50" charset="-127"/>
-              </a:endParaRPr>
-            </a:p>
-          </p:txBody>
-        </p:sp>
-        <p:sp>
-          <p:nvSpPr>
-            <p:cNvPr id="70" name="모서리가 둥근 직사각형 69"/>
-            <p:cNvSpPr/>
-            <p:nvPr/>
-          </p:nvSpPr>
-          <p:spPr>
-            <a:xfrm>
-              <a:off x="1447800" y="2193200"/>
-              <a:ext cx="2160000" cy="720000"/>
-            </a:xfrm>
-            <a:prstGeom prst="roundRect">
-              <a:avLst/>
-            </a:prstGeom>
-            <a:solidFill>
-              <a:schemeClr val="accent4">
-                <a:lumMod val="40000"/>
-                <a:lumOff val="60000"/>
-              </a:schemeClr>
-            </a:solidFill>
-            <a:ln>
-              <a:noFill/>
-            </a:ln>
-          </p:spPr>
-          <p:style>
-            <a:lnRef idx="2">
-              <a:schemeClr val="accent1">
-                <a:shade val="50000"/>
-              </a:schemeClr>
-            </a:lnRef>
-            <a:fillRef idx="1">
-              <a:schemeClr val="accent1"/>
-            </a:fillRef>
-            <a:effectRef idx="0">
-              <a:schemeClr val="accent1"/>
-            </a:effectRef>
-            <a:fontRef idx="minor">
-              <a:schemeClr val="lt1"/>
-            </a:fontRef>
-          </p:style>
-          <p:txBody>
-            <a:bodyPr rtlCol="0" anchor="ctr"/>
-            <a:lstStyle/>
-            <a:p>
-              <a:pPr algn="ctr"/>
-              <a:r>
-                <a:rPr lang="en-US" altLang="ko-KR" sz="2400" dirty="0">
-                  <a:solidFill>
-                    <a:schemeClr val="tx1"/>
-                  </a:solidFill>
-                  <a:latin typeface="나눔스퀘어 Bold" panose="020B0600000101010101" pitchFamily="50" charset="-127"/>
-                  <a:ea typeface="나눔스퀘어 Bold" panose="020B0600000101010101" pitchFamily="50" charset="-127"/>
-                </a:rPr>
-                <a:t>Singleton</a:t>
-              </a:r>
-              <a:endParaRPr lang="ko-KR" altLang="en-US" sz="2400" dirty="0">
-                <a:solidFill>
-                  <a:schemeClr val="tx1"/>
-                </a:solidFill>
-                <a:latin typeface="나눔스퀘어 Bold" panose="020B0600000101010101" pitchFamily="50" charset="-127"/>
-                <a:ea typeface="나눔스퀘어 Bold" panose="020B0600000101010101" pitchFamily="50" charset="-127"/>
-              </a:endParaRPr>
-            </a:p>
-          </p:txBody>
-        </p:sp>
-        <p:sp>
-          <p:nvSpPr>
-            <p:cNvPr id="71" name="모서리가 둥근 직사각형 70"/>
-            <p:cNvSpPr/>
-            <p:nvPr/>
-          </p:nvSpPr>
-          <p:spPr>
-            <a:xfrm>
-              <a:off x="8729300" y="1663700"/>
-              <a:ext cx="1440000" cy="720000"/>
-            </a:xfrm>
-            <a:prstGeom prst="roundRect">
-              <a:avLst/>
-            </a:prstGeom>
-            <a:solidFill>
-              <a:schemeClr val="accent4">
-                <a:lumMod val="40000"/>
-                <a:lumOff val="60000"/>
-              </a:schemeClr>
-            </a:solidFill>
-            <a:ln>
-              <a:noFill/>
-            </a:ln>
-          </p:spPr>
-          <p:style>
-            <a:lnRef idx="2">
-              <a:schemeClr val="accent1">
-                <a:shade val="50000"/>
-              </a:schemeClr>
-            </a:lnRef>
-            <a:fillRef idx="1">
-              <a:schemeClr val="accent1"/>
-            </a:fillRef>
-            <a:effectRef idx="0">
-              <a:schemeClr val="accent1"/>
-            </a:effectRef>
-            <a:fontRef idx="minor">
-              <a:schemeClr val="lt1"/>
-            </a:fontRef>
-          </p:style>
-          <p:txBody>
-            <a:bodyPr rtlCol="0" anchor="ctr"/>
-            <a:lstStyle/>
-            <a:p>
-              <a:pPr algn="ctr"/>
-              <a:r>
-                <a:rPr lang="en-US" altLang="ko-KR" sz="2000" dirty="0" smtClean="0">
-                  <a:solidFill>
-                    <a:schemeClr val="tx1"/>
-                  </a:solidFill>
-                  <a:latin typeface="나눔스퀘어 Bold" panose="020B0600000101010101" pitchFamily="50" charset="-127"/>
-                  <a:ea typeface="나눔스퀘어 Bold" panose="020B0600000101010101" pitchFamily="50" charset="-127"/>
-                </a:rPr>
-                <a:t>Object 1</a:t>
-              </a:r>
-              <a:endParaRPr lang="ko-KR" altLang="en-US" sz="2000" dirty="0">
-                <a:solidFill>
-                  <a:schemeClr val="tx1"/>
-                </a:solidFill>
-                <a:latin typeface="나눔스퀘어 Bold" panose="020B0600000101010101" pitchFamily="50" charset="-127"/>
-                <a:ea typeface="나눔스퀘어 Bold" panose="020B0600000101010101" pitchFamily="50" charset="-127"/>
-              </a:endParaRPr>
-            </a:p>
-          </p:txBody>
-        </p:sp>
-        <p:sp>
-          <p:nvSpPr>
-            <p:cNvPr id="72" name="모서리가 둥근 직사각형 71"/>
-            <p:cNvSpPr/>
-            <p:nvPr/>
-          </p:nvSpPr>
-          <p:spPr>
-            <a:xfrm>
-              <a:off x="8729300" y="2722700"/>
-              <a:ext cx="1440000" cy="720000"/>
-            </a:xfrm>
-            <a:prstGeom prst="roundRect">
-              <a:avLst/>
-            </a:prstGeom>
-            <a:solidFill>
-              <a:schemeClr val="accent4">
-                <a:lumMod val="40000"/>
-                <a:lumOff val="60000"/>
-              </a:schemeClr>
-            </a:solidFill>
-            <a:ln>
-              <a:noFill/>
-            </a:ln>
-          </p:spPr>
-          <p:style>
-            <a:lnRef idx="2">
-              <a:schemeClr val="accent1">
-                <a:shade val="50000"/>
-              </a:schemeClr>
-            </a:lnRef>
-            <a:fillRef idx="1">
-              <a:schemeClr val="accent1"/>
-            </a:fillRef>
-            <a:effectRef idx="0">
-              <a:schemeClr val="accent1"/>
-            </a:effectRef>
-            <a:fontRef idx="minor">
-              <a:schemeClr val="lt1"/>
-            </a:fontRef>
-          </p:style>
-          <p:txBody>
-            <a:bodyPr rtlCol="0" anchor="ctr"/>
-            <a:lstStyle/>
-            <a:p>
-              <a:pPr algn="ctr"/>
-              <a:r>
-                <a:rPr lang="en-US" altLang="ko-KR" sz="2000" dirty="0" smtClean="0">
-                  <a:solidFill>
-                    <a:schemeClr val="tx1"/>
-                  </a:solidFill>
-                  <a:latin typeface="나눔스퀘어 Bold" panose="020B0600000101010101" pitchFamily="50" charset="-127"/>
-                  <a:ea typeface="나눔스퀘어 Bold" panose="020B0600000101010101" pitchFamily="50" charset="-127"/>
-                </a:rPr>
-                <a:t>Object 2</a:t>
-              </a:r>
-              <a:endParaRPr lang="ko-KR" altLang="en-US" sz="2000" dirty="0">
-                <a:solidFill>
-                  <a:schemeClr val="tx1"/>
-                </a:solidFill>
-                <a:latin typeface="나눔스퀘어 Bold" panose="020B0600000101010101" pitchFamily="50" charset="-127"/>
-                <a:ea typeface="나눔스퀘어 Bold" panose="020B0600000101010101" pitchFamily="50" charset="-127"/>
-              </a:endParaRPr>
-            </a:p>
-          </p:txBody>
-        </p:sp>
-        <p:sp>
-          <p:nvSpPr>
-            <p:cNvPr id="79" name="오른쪽 화살표 78"/>
-            <p:cNvSpPr/>
-            <p:nvPr/>
-          </p:nvSpPr>
-          <p:spPr>
-            <a:xfrm>
-              <a:off x="3700175" y="2337300"/>
-              <a:ext cx="576000" cy="431800"/>
-            </a:xfrm>
-            <a:prstGeom prst="rightArrow">
-              <a:avLst/>
-            </a:prstGeom>
-            <a:solidFill>
-              <a:schemeClr val="accent2"/>
-            </a:solidFill>
-            <a:ln>
-              <a:noFill/>
-            </a:ln>
-          </p:spPr>
-          <p:style>
-            <a:lnRef idx="2">
-              <a:schemeClr val="accent1">
-                <a:shade val="50000"/>
-              </a:schemeClr>
-            </a:lnRef>
-            <a:fillRef idx="1">
-              <a:schemeClr val="accent1"/>
-            </a:fillRef>
-            <a:effectRef idx="0">
-              <a:schemeClr val="accent1"/>
-            </a:effectRef>
-            <a:fontRef idx="minor">
-              <a:schemeClr val="lt1"/>
-            </a:fontRef>
-          </p:style>
-          <p:txBody>
-            <a:bodyPr rtlCol="0" anchor="ctr"/>
-            <a:lstStyle/>
-            <a:p>
-              <a:pPr algn="ctr"/>
-              <a:endParaRPr lang="ko-KR" altLang="en-US"/>
-            </a:p>
-          </p:txBody>
-        </p:sp>
-        <p:sp>
-          <p:nvSpPr>
-            <p:cNvPr id="80" name="오른쪽 화살표 79"/>
-            <p:cNvSpPr/>
-            <p:nvPr/>
-          </p:nvSpPr>
-          <p:spPr>
-            <a:xfrm flipH="1">
-              <a:off x="8060925" y="1807800"/>
-              <a:ext cx="576000" cy="431800"/>
-            </a:xfrm>
-            <a:prstGeom prst="rightArrow">
-              <a:avLst/>
-            </a:prstGeom>
-            <a:solidFill>
-              <a:schemeClr val="accent2"/>
-            </a:solidFill>
-            <a:ln>
-              <a:noFill/>
-            </a:ln>
-          </p:spPr>
-          <p:style>
-            <a:lnRef idx="2">
-              <a:schemeClr val="accent1">
-                <a:shade val="50000"/>
-              </a:schemeClr>
-            </a:lnRef>
-            <a:fillRef idx="1">
-              <a:schemeClr val="accent1"/>
-            </a:fillRef>
-            <a:effectRef idx="0">
-              <a:schemeClr val="accent1"/>
-            </a:effectRef>
-            <a:fontRef idx="minor">
-              <a:schemeClr val="lt1"/>
-            </a:fontRef>
-          </p:style>
-          <p:txBody>
-            <a:bodyPr rtlCol="0" anchor="ctr"/>
-            <a:lstStyle/>
-            <a:p>
-              <a:pPr algn="ctr"/>
-              <a:endParaRPr lang="ko-KR" altLang="en-US"/>
-            </a:p>
-          </p:txBody>
-        </p:sp>
-        <p:sp>
-          <p:nvSpPr>
-            <p:cNvPr id="81" name="오른쪽 화살표 80"/>
-            <p:cNvSpPr/>
-            <p:nvPr/>
-          </p:nvSpPr>
-          <p:spPr>
-            <a:xfrm flipH="1">
-              <a:off x="8060925" y="2866800"/>
-              <a:ext cx="576000" cy="431800"/>
-            </a:xfrm>
-            <a:prstGeom prst="rightArrow">
-              <a:avLst/>
-            </a:prstGeom>
-            <a:solidFill>
-              <a:schemeClr val="accent2"/>
-            </a:solidFill>
-            <a:ln>
-              <a:noFill/>
-            </a:ln>
-          </p:spPr>
-          <p:style>
-            <a:lnRef idx="2">
-              <a:schemeClr val="accent1">
-                <a:shade val="50000"/>
-              </a:schemeClr>
-            </a:lnRef>
-            <a:fillRef idx="1">
-              <a:schemeClr val="accent1"/>
-            </a:fillRef>
-            <a:effectRef idx="0">
-              <a:schemeClr val="accent1"/>
-            </a:effectRef>
-            <a:fontRef idx="minor">
-              <a:schemeClr val="lt1"/>
-            </a:fontRef>
-          </p:style>
-          <p:txBody>
-            <a:bodyPr rtlCol="0" anchor="ctr"/>
-            <a:lstStyle/>
-            <a:p>
-              <a:pPr algn="ctr"/>
-              <a:endParaRPr lang="ko-KR" altLang="en-US"/>
-            </a:p>
-          </p:txBody>
-        </p:sp>
-      </p:grpSp>
-    </p:spTree>
-    <p:extLst>
-      <p:ext uri="{BB962C8B-B14F-4D97-AF65-F5344CB8AC3E}">
-        <p14:creationId xmlns:p14="http://schemas.microsoft.com/office/powerpoint/2010/main" val="1679211822"/>
-      </p:ext>
-    </p:extLst>
-  </p:cSld>
-  <p:clrMapOvr>
-    <a:masterClrMapping/>
-  </p:clrMapOvr>
-</p:sld>
-</file>
-
-<file path=ppt/slides/slide6.xml><?xml version="1.0" encoding="utf-8"?>
+<file path=ppt/slides/slide4.xml><?xml version="1.0" encoding="utf-8"?>
 <p:sld xmlns:a="http://schemas.openxmlformats.org/drawingml/2006/main" xmlns:r="http://schemas.openxmlformats.org/officeDocument/2006/relationships" xmlns:p="http://schemas.openxmlformats.org/presentationml/2006/main">
   <p:cSld>
     <p:spTree>

</xml_diff>

<commit_message>
20260824 commit : A LITTLE BIT, NOTION, TEMP_CLEAR
</commit_message>
<xml_diff>
--- a/notion/create_notion_img.pptx
+++ b/notion/create_notion_img.pptx
@@ -246,7 +246,7 @@
           <a:p>
             <a:fld id="{7237CE1A-8831-48B5-BA93-72483C6E34E8}" type="datetimeFigureOut">
               <a:rPr lang="ko-KR" altLang="en-US" smtClean="0"/>
-              <a:t>26-08-22(Sat)</a:t>
+              <a:t>2026-08-24</a:t>
             </a:fld>
             <a:endParaRPr lang="ko-KR" altLang="en-US"/>
           </a:p>
@@ -416,7 +416,7 @@
           <a:p>
             <a:fld id="{7237CE1A-8831-48B5-BA93-72483C6E34E8}" type="datetimeFigureOut">
               <a:rPr lang="ko-KR" altLang="en-US" smtClean="0"/>
-              <a:t>26-08-22(Sat)</a:t>
+              <a:t>2026-08-24</a:t>
             </a:fld>
             <a:endParaRPr lang="ko-KR" altLang="en-US"/>
           </a:p>
@@ -596,7 +596,7 @@
           <a:p>
             <a:fld id="{7237CE1A-8831-48B5-BA93-72483C6E34E8}" type="datetimeFigureOut">
               <a:rPr lang="ko-KR" altLang="en-US" smtClean="0"/>
-              <a:t>26-08-22(Sat)</a:t>
+              <a:t>2026-08-24</a:t>
             </a:fld>
             <a:endParaRPr lang="ko-KR" altLang="en-US"/>
           </a:p>
@@ -766,7 +766,7 @@
           <a:p>
             <a:fld id="{7237CE1A-8831-48B5-BA93-72483C6E34E8}" type="datetimeFigureOut">
               <a:rPr lang="ko-KR" altLang="en-US" smtClean="0"/>
-              <a:t>26-08-22(Sat)</a:t>
+              <a:t>2026-08-24</a:t>
             </a:fld>
             <a:endParaRPr lang="ko-KR" altLang="en-US"/>
           </a:p>
@@ -1012,7 +1012,7 @@
           <a:p>
             <a:fld id="{7237CE1A-8831-48B5-BA93-72483C6E34E8}" type="datetimeFigureOut">
               <a:rPr lang="ko-KR" altLang="en-US" smtClean="0"/>
-              <a:t>26-08-22(Sat)</a:t>
+              <a:t>2026-08-24</a:t>
             </a:fld>
             <a:endParaRPr lang="ko-KR" altLang="en-US"/>
           </a:p>
@@ -1244,7 +1244,7 @@
           <a:p>
             <a:fld id="{7237CE1A-8831-48B5-BA93-72483C6E34E8}" type="datetimeFigureOut">
               <a:rPr lang="ko-KR" altLang="en-US" smtClean="0"/>
-              <a:t>26-08-22(Sat)</a:t>
+              <a:t>2026-08-24</a:t>
             </a:fld>
             <a:endParaRPr lang="ko-KR" altLang="en-US"/>
           </a:p>
@@ -1611,7 +1611,7 @@
           <a:p>
             <a:fld id="{7237CE1A-8831-48B5-BA93-72483C6E34E8}" type="datetimeFigureOut">
               <a:rPr lang="ko-KR" altLang="en-US" smtClean="0"/>
-              <a:t>26-08-22(Sat)</a:t>
+              <a:t>2026-08-24</a:t>
             </a:fld>
             <a:endParaRPr lang="ko-KR" altLang="en-US"/>
           </a:p>
@@ -1729,7 +1729,7 @@
           <a:p>
             <a:fld id="{7237CE1A-8831-48B5-BA93-72483C6E34E8}" type="datetimeFigureOut">
               <a:rPr lang="ko-KR" altLang="en-US" smtClean="0"/>
-              <a:t>26-08-22(Sat)</a:t>
+              <a:t>2026-08-24</a:t>
             </a:fld>
             <a:endParaRPr lang="ko-KR" altLang="en-US"/>
           </a:p>
@@ -1824,7 +1824,7 @@
           <a:p>
             <a:fld id="{7237CE1A-8831-48B5-BA93-72483C6E34E8}" type="datetimeFigureOut">
               <a:rPr lang="ko-KR" altLang="en-US" smtClean="0"/>
-              <a:t>26-08-22(Sat)</a:t>
+              <a:t>2026-08-24</a:t>
             </a:fld>
             <a:endParaRPr lang="ko-KR" altLang="en-US"/>
           </a:p>
@@ -2101,7 +2101,7 @@
           <a:p>
             <a:fld id="{7237CE1A-8831-48B5-BA93-72483C6E34E8}" type="datetimeFigureOut">
               <a:rPr lang="ko-KR" altLang="en-US" smtClean="0"/>
-              <a:t>26-08-22(Sat)</a:t>
+              <a:t>2026-08-24</a:t>
             </a:fld>
             <a:endParaRPr lang="ko-KR" altLang="en-US"/>
           </a:p>
@@ -2354,7 +2354,7 @@
           <a:p>
             <a:fld id="{7237CE1A-8831-48B5-BA93-72483C6E34E8}" type="datetimeFigureOut">
               <a:rPr lang="ko-KR" altLang="en-US" smtClean="0"/>
-              <a:t>26-08-22(Sat)</a:t>
+              <a:t>2026-08-24</a:t>
             </a:fld>
             <a:endParaRPr lang="ko-KR" altLang="en-US"/>
           </a:p>
@@ -2567,7 +2567,7 @@
           <a:p>
             <a:fld id="{7237CE1A-8831-48B5-BA93-72483C6E34E8}" type="datetimeFigureOut">
               <a:rPr lang="ko-KR" altLang="en-US" smtClean="0"/>
-              <a:t>26-08-22(Sat)</a:t>
+              <a:t>2026-08-24</a:t>
             </a:fld>
             <a:endParaRPr lang="ko-KR" altLang="en-US"/>
           </a:p>
@@ -2974,73 +2974,27 @@
       </p:grpSpPr>
       <p:grpSp>
         <p:nvGrpSpPr>
-          <p:cNvPr id="56" name="그룹 55"/>
+          <p:cNvPr id="39" name="그룹 38"/>
           <p:cNvGrpSpPr/>
           <p:nvPr/>
         </p:nvGrpSpPr>
         <p:grpSpPr>
           <a:xfrm>
-            <a:off x="-488868" y="928470"/>
-            <a:ext cx="14924134" cy="3166334"/>
-            <a:chOff x="-488868" y="928470"/>
-            <a:chExt cx="14924134" cy="3166334"/>
+            <a:off x="690525" y="800100"/>
+            <a:ext cx="13530220" cy="1440000"/>
+            <a:chOff x="690525" y="800100"/>
+            <a:chExt cx="13530220" cy="1440000"/>
           </a:xfrm>
         </p:grpSpPr>
         <p:sp>
           <p:nvSpPr>
-            <p:cNvPr id="17" name="직사각형 16"/>
+            <p:cNvPr id="6" name="직사각형 5"/>
             <p:cNvSpPr/>
             <p:nvPr/>
           </p:nvSpPr>
           <p:spPr>
             <a:xfrm>
-              <a:off x="2743199" y="1574802"/>
-              <a:ext cx="8460000" cy="2520000"/>
-            </a:xfrm>
-            <a:prstGeom prst="rect">
-              <a:avLst/>
-            </a:prstGeom>
-            <a:noFill/>
-            <a:ln w="38100">
-              <a:solidFill>
-                <a:schemeClr val="tx1"/>
-              </a:solidFill>
-            </a:ln>
-          </p:spPr>
-          <p:style>
-            <a:lnRef idx="2">
-              <a:schemeClr val="accent1">
-                <a:shade val="50000"/>
-              </a:schemeClr>
-            </a:lnRef>
-            <a:fillRef idx="1">
-              <a:schemeClr val="accent1"/>
-            </a:fillRef>
-            <a:effectRef idx="0">
-              <a:schemeClr val="accent1"/>
-            </a:effectRef>
-            <a:fontRef idx="minor">
-              <a:schemeClr val="lt1"/>
-            </a:fontRef>
-          </p:style>
-          <p:txBody>
-            <a:bodyPr rtlCol="0" anchor="ctr"/>
-            <a:lstStyle/>
-            <a:p>
-              <a:pPr algn="ctr"/>
-              <a:endParaRPr lang="ko-KR" altLang="en-US"/>
-            </a:p>
-          </p:txBody>
-        </p:sp>
-        <p:sp>
-          <p:nvSpPr>
-            <p:cNvPr id="21" name="직사각형 20"/>
-            <p:cNvSpPr/>
-            <p:nvPr/>
-          </p:nvSpPr>
-          <p:spPr>
-            <a:xfrm>
-              <a:off x="4190998" y="1765800"/>
+              <a:off x="690525" y="800100"/>
               <a:ext cx="2160000" cy="1440000"/>
             </a:xfrm>
             <a:prstGeom prst="rect">
@@ -3075,26 +3029,27 @@
             <a:p>
               <a:pPr algn="ctr"/>
               <a:r>
-                <a:rPr lang="en-US" altLang="ko-KR" sz="3200" dirty="0" smtClean="0">
+                <a:rPr lang="ko-KR" altLang="en-US" sz="3600" dirty="0" smtClean="0">
                   <a:latin typeface="나눔스퀘어 Bold" panose="020B0600000101010101" pitchFamily="50" charset="-127"/>
                   <a:ea typeface="나눔스퀘어 Bold" panose="020B0600000101010101" pitchFamily="50" charset="-127"/>
                 </a:rPr>
-                <a:t>Member</a:t>
+                <a:t>사용자</a:t>
               </a:r>
-              <a:br>
-                <a:rPr lang="en-US" altLang="ko-KR" sz="3200" dirty="0" smtClean="0">
+              <a:endParaRPr lang="en-US" altLang="ko-KR" sz="3600" dirty="0" smtClean="0">
+                <a:latin typeface="나눔스퀘어 Bold" panose="020B0600000101010101" pitchFamily="50" charset="-127"/>
+                <a:ea typeface="나눔스퀘어 Bold" panose="020B0600000101010101" pitchFamily="50" charset="-127"/>
+              </a:endParaRPr>
+            </a:p>
+            <a:p>
+              <a:pPr algn="ctr"/>
+              <a:r>
+                <a:rPr lang="ko-KR" altLang="en-US" sz="3600" dirty="0" smtClean="0">
                   <a:latin typeface="나눔스퀘어 Bold" panose="020B0600000101010101" pitchFamily="50" charset="-127"/>
                   <a:ea typeface="나눔스퀘어 Bold" panose="020B0600000101010101" pitchFamily="50" charset="-127"/>
                 </a:rPr>
-              </a:br>
-              <a:r>
-                <a:rPr lang="en-US" altLang="ko-KR" sz="3200" dirty="0" smtClean="0">
-                  <a:latin typeface="나눔스퀘어 Bold" panose="020B0600000101010101" pitchFamily="50" charset="-127"/>
-                  <a:ea typeface="나눔스퀘어 Bold" panose="020B0600000101010101" pitchFamily="50" charset="-127"/>
-                </a:rPr>
-                <a:t>Controller</a:t>
+                <a:t>브라우저</a:t>
               </a:r>
-              <a:endParaRPr lang="ko-KR" altLang="en-US" sz="3200" dirty="0">
+              <a:endParaRPr lang="ko-KR" altLang="en-US" sz="3600" dirty="0">
                 <a:latin typeface="나눔스퀘어 Bold" panose="020B0600000101010101" pitchFamily="50" charset="-127"/>
                 <a:ea typeface="나눔스퀘어 Bold" panose="020B0600000101010101" pitchFamily="50" charset="-127"/>
               </a:endParaRPr>
@@ -3103,13 +3058,13 @@
         </p:sp>
         <p:sp>
           <p:nvSpPr>
-            <p:cNvPr id="22" name="직사각형 21"/>
+            <p:cNvPr id="8" name="직사각형 7"/>
             <p:cNvSpPr/>
             <p:nvPr/>
           </p:nvSpPr>
           <p:spPr>
             <a:xfrm>
-              <a:off x="6524733" y="1765800"/>
+              <a:off x="7788544" y="800100"/>
               <a:ext cx="2160000" cy="1440000"/>
             </a:xfrm>
             <a:prstGeom prst="rect">
@@ -3144,26 +3099,27 @@
             <a:p>
               <a:pPr algn="ctr"/>
               <a:r>
-                <a:rPr lang="en-US" altLang="ko-KR" sz="3200" dirty="0">
+                <a:rPr lang="ko-KR" altLang="en-US" sz="3600" b="1" dirty="0" smtClean="0">
                   <a:latin typeface="나눔스퀘어 Bold" panose="020B0600000101010101" pitchFamily="50" charset="-127"/>
                   <a:ea typeface="나눔스퀘어 Bold" panose="020B0600000101010101" pitchFamily="50" charset="-127"/>
                 </a:rPr>
-                <a:t>Member</a:t>
+                <a:t>사용자</a:t>
               </a:r>
-              <a:br>
-                <a:rPr lang="en-US" altLang="ko-KR" sz="3200" dirty="0">
+              <a:endParaRPr lang="en-US" altLang="ko-KR" sz="3600" b="1" dirty="0" smtClean="0">
+                <a:latin typeface="나눔스퀘어 Bold" panose="020B0600000101010101" pitchFamily="50" charset="-127"/>
+                <a:ea typeface="나눔스퀘어 Bold" panose="020B0600000101010101" pitchFamily="50" charset="-127"/>
+              </a:endParaRPr>
+            </a:p>
+            <a:p>
+              <a:pPr algn="ctr"/>
+              <a:r>
+                <a:rPr lang="ko-KR" altLang="en-US" sz="3600" b="1" dirty="0" smtClean="0">
                   <a:latin typeface="나눔스퀘어 Bold" panose="020B0600000101010101" pitchFamily="50" charset="-127"/>
                   <a:ea typeface="나눔스퀘어 Bold" panose="020B0600000101010101" pitchFamily="50" charset="-127"/>
                 </a:rPr>
-              </a:br>
-              <a:r>
-                <a:rPr lang="en-US" altLang="ko-KR" sz="3200" dirty="0" smtClean="0">
-                  <a:latin typeface="나눔스퀘어 Bold" panose="020B0600000101010101" pitchFamily="50" charset="-127"/>
-                  <a:ea typeface="나눔스퀘어 Bold" panose="020B0600000101010101" pitchFamily="50" charset="-127"/>
-                </a:rPr>
-                <a:t>Service</a:t>
+                <a:t>브라우저</a:t>
               </a:r>
-              <a:endParaRPr lang="ko-KR" altLang="en-US" sz="3200" dirty="0">
+              <a:endParaRPr lang="ko-KR" altLang="en-US" sz="3600" b="1" dirty="0">
                 <a:latin typeface="나눔스퀘어 Bold" panose="020B0600000101010101" pitchFamily="50" charset="-127"/>
                 <a:ea typeface="나눔스퀘어 Bold" panose="020B0600000101010101" pitchFamily="50" charset="-127"/>
               </a:endParaRPr>
@@ -3172,13 +3128,13 @@
         </p:sp>
         <p:sp>
           <p:nvSpPr>
-            <p:cNvPr id="23" name="직사각형 22"/>
+            <p:cNvPr id="9" name="직사각형 8"/>
             <p:cNvSpPr/>
             <p:nvPr/>
           </p:nvSpPr>
           <p:spPr>
             <a:xfrm>
-              <a:off x="8858468" y="1765800"/>
+              <a:off x="12060745" y="800100"/>
               <a:ext cx="2160000" cy="1440000"/>
             </a:xfrm>
             <a:prstGeom prst="rect">
@@ -3213,26 +3169,27 @@
             <a:p>
               <a:pPr algn="ctr"/>
               <a:r>
-                <a:rPr lang="en-US" altLang="ko-KR" sz="3200" dirty="0">
+                <a:rPr lang="ko-KR" altLang="en-US" sz="3600" b="1" dirty="0" smtClean="0">
                   <a:latin typeface="나눔스퀘어 Bold" panose="020B0600000101010101" pitchFamily="50" charset="-127"/>
                   <a:ea typeface="나눔스퀘어 Bold" panose="020B0600000101010101" pitchFamily="50" charset="-127"/>
                 </a:rPr>
-                <a:t>Member</a:t>
+                <a:t>화면</a:t>
               </a:r>
-              <a:br>
-                <a:rPr lang="en-US" altLang="ko-KR" sz="3200" dirty="0">
+              <a:endParaRPr lang="en-US" altLang="ko-KR" sz="3600" b="1" dirty="0" smtClean="0">
+                <a:latin typeface="나눔스퀘어 Bold" panose="020B0600000101010101" pitchFamily="50" charset="-127"/>
+                <a:ea typeface="나눔스퀘어 Bold" panose="020B0600000101010101" pitchFamily="50" charset="-127"/>
+              </a:endParaRPr>
+            </a:p>
+            <a:p>
+              <a:pPr algn="ctr"/>
+              <a:r>
+                <a:rPr lang="ko-KR" altLang="en-US" sz="3600" b="1" dirty="0" smtClean="0">
                   <a:latin typeface="나눔스퀘어 Bold" panose="020B0600000101010101" pitchFamily="50" charset="-127"/>
                   <a:ea typeface="나눔스퀘어 Bold" panose="020B0600000101010101" pitchFamily="50" charset="-127"/>
                 </a:rPr>
-              </a:br>
-              <a:r>
-                <a:rPr lang="en-US" altLang="ko-KR" sz="3200" dirty="0" smtClean="0">
-                  <a:latin typeface="나눔스퀘어 Bold" panose="020B0600000101010101" pitchFamily="50" charset="-127"/>
-                  <a:ea typeface="나눔스퀘어 Bold" panose="020B0600000101010101" pitchFamily="50" charset="-127"/>
-                </a:rPr>
-                <a:t>Dao</a:t>
+                <a:t>렌더링</a:t>
               </a:r>
-              <a:endParaRPr lang="ko-KR" altLang="en-US" sz="3200" dirty="0">
+              <a:endParaRPr lang="ko-KR" altLang="en-US" sz="3600" b="1" dirty="0">
                 <a:latin typeface="나눔스퀘어 Bold" panose="020B0600000101010101" pitchFamily="50" charset="-127"/>
                 <a:ea typeface="나눔스퀘어 Bold" panose="020B0600000101010101" pitchFamily="50" charset="-127"/>
               </a:endParaRPr>
@@ -3241,122 +3198,13 @@
         </p:sp>
         <p:sp>
           <p:nvSpPr>
-            <p:cNvPr id="27" name="직사각형 26"/>
+            <p:cNvPr id="10" name="직사각형 9"/>
             <p:cNvSpPr/>
             <p:nvPr/>
           </p:nvSpPr>
           <p:spPr>
             <a:xfrm>
-              <a:off x="2935566" y="1765800"/>
-              <a:ext cx="1080000" cy="1440000"/>
-            </a:xfrm>
-            <a:prstGeom prst="rect">
-              <a:avLst/>
-            </a:prstGeom>
-            <a:solidFill>
-              <a:schemeClr val="accent5"/>
-            </a:solidFill>
-            <a:ln>
-              <a:noFill/>
-            </a:ln>
-          </p:spPr>
-          <p:style>
-            <a:lnRef idx="2">
-              <a:schemeClr val="accent1">
-                <a:shade val="50000"/>
-              </a:schemeClr>
-            </a:lnRef>
-            <a:fillRef idx="1">
-              <a:schemeClr val="accent1"/>
-            </a:fillRef>
-            <a:effectRef idx="0">
-              <a:schemeClr val="accent1"/>
-            </a:effectRef>
-            <a:fontRef idx="minor">
-              <a:schemeClr val="lt1"/>
-            </a:fontRef>
-          </p:style>
-          <p:txBody>
-            <a:bodyPr rtlCol="0" anchor="ctr"/>
-            <a:lstStyle/>
-            <a:p>
-              <a:pPr algn="ctr"/>
-              <a:r>
-                <a:rPr lang="en-US" altLang="ko-KR" sz="3200" dirty="0">
-                  <a:latin typeface="나눔스퀘어 Bold" panose="020B0600000101010101" pitchFamily="50" charset="-127"/>
-                  <a:ea typeface="나눔스퀘어 Bold" panose="020B0600000101010101" pitchFamily="50" charset="-127"/>
-                </a:rPr>
-                <a:t>w</a:t>
-              </a:r>
-              <a:r>
-                <a:rPr lang="en-US" altLang="ko-KR" sz="3200" dirty="0" smtClean="0">
-                  <a:latin typeface="나눔스퀘어 Bold" panose="020B0600000101010101" pitchFamily="50" charset="-127"/>
-                  <a:ea typeface="나눔스퀘어 Bold" panose="020B0600000101010101" pitchFamily="50" charset="-127"/>
-                </a:rPr>
-                <a:t>eb.xml</a:t>
-              </a:r>
-              <a:endParaRPr lang="ko-KR" altLang="en-US" sz="3200" dirty="0">
-                <a:latin typeface="나눔스퀘어 Bold" panose="020B0600000101010101" pitchFamily="50" charset="-127"/>
-                <a:ea typeface="나눔스퀘어 Bold" panose="020B0600000101010101" pitchFamily="50" charset="-127"/>
-              </a:endParaRPr>
-            </a:p>
-          </p:txBody>
-        </p:sp>
-        <p:sp>
-          <p:nvSpPr>
-            <p:cNvPr id="28" name="직사각형 27"/>
-            <p:cNvSpPr/>
-            <p:nvPr/>
-          </p:nvSpPr>
-          <p:spPr>
-            <a:xfrm>
-              <a:off x="-488868" y="1574802"/>
-              <a:ext cx="2520000" cy="2520000"/>
-            </a:xfrm>
-            <a:prstGeom prst="rect">
-              <a:avLst/>
-            </a:prstGeom>
-            <a:noFill/>
-            <a:ln w="38100">
-              <a:solidFill>
-                <a:schemeClr val="tx1"/>
-              </a:solidFill>
-            </a:ln>
-          </p:spPr>
-          <p:style>
-            <a:lnRef idx="2">
-              <a:schemeClr val="accent1">
-                <a:shade val="50000"/>
-              </a:schemeClr>
-            </a:lnRef>
-            <a:fillRef idx="1">
-              <a:schemeClr val="accent1"/>
-            </a:fillRef>
-            <a:effectRef idx="0">
-              <a:schemeClr val="accent1"/>
-            </a:effectRef>
-            <a:fontRef idx="minor">
-              <a:schemeClr val="lt1"/>
-            </a:fontRef>
-          </p:style>
-          <p:txBody>
-            <a:bodyPr rtlCol="0" anchor="ctr"/>
-            <a:lstStyle/>
-            <a:p>
-              <a:pPr algn="ctr"/>
-              <a:endParaRPr lang="ko-KR" altLang="en-US"/>
-            </a:p>
-          </p:txBody>
-        </p:sp>
-        <p:sp>
-          <p:nvSpPr>
-            <p:cNvPr id="29" name="직사각형 28"/>
-            <p:cNvSpPr/>
-            <p:nvPr/>
-          </p:nvSpPr>
-          <p:spPr>
-            <a:xfrm>
-              <a:off x="-308868" y="1782736"/>
+              <a:off x="3958501" y="800100"/>
               <a:ext cx="2160000" cy="1440000"/>
             </a:xfrm>
             <a:prstGeom prst="rect">
@@ -3391,269 +3239,32 @@
             <a:p>
               <a:pPr algn="ctr"/>
               <a:r>
-                <a:rPr lang="en-US" altLang="ko-KR" sz="4400" dirty="0" smtClean="0">
+                <a:rPr lang="ko-KR" altLang="en-US" sz="3600" b="1" dirty="0" smtClean="0">
                   <a:latin typeface="나눔스퀘어 Bold" panose="020B0600000101010101" pitchFamily="50" charset="-127"/>
                   <a:ea typeface="나눔스퀘어 Bold" panose="020B0600000101010101" pitchFamily="50" charset="-127"/>
                 </a:rPr>
-                <a:t>View</a:t>
+                <a:t>서버</a:t>
               </a:r>
-              <a:endParaRPr lang="ko-KR" altLang="en-US" sz="4400" dirty="0">
+              <a:endParaRPr lang="ko-KR" altLang="en-US" sz="3600" b="1" dirty="0">
                 <a:latin typeface="나눔스퀘어 Bold" panose="020B0600000101010101" pitchFamily="50" charset="-127"/>
                 <a:ea typeface="나눔스퀘어 Bold" panose="020B0600000101010101" pitchFamily="50" charset="-127"/>
               </a:endParaRPr>
-            </a:p>
-          </p:txBody>
-        </p:sp>
-        <p:sp>
-          <p:nvSpPr>
-            <p:cNvPr id="30" name="직사각형 29"/>
-            <p:cNvSpPr/>
-            <p:nvPr/>
-          </p:nvSpPr>
-          <p:spPr>
-            <a:xfrm>
-              <a:off x="11915266" y="1574804"/>
-              <a:ext cx="2520000" cy="2520000"/>
-            </a:xfrm>
-            <a:prstGeom prst="rect">
-              <a:avLst/>
-            </a:prstGeom>
-            <a:noFill/>
-            <a:ln w="38100">
-              <a:solidFill>
-                <a:schemeClr val="tx1"/>
-              </a:solidFill>
-            </a:ln>
-          </p:spPr>
-          <p:style>
-            <a:lnRef idx="2">
-              <a:schemeClr val="accent1">
-                <a:shade val="50000"/>
-              </a:schemeClr>
-            </a:lnRef>
-            <a:fillRef idx="1">
-              <a:schemeClr val="accent1"/>
-            </a:fillRef>
-            <a:effectRef idx="0">
-              <a:schemeClr val="accent1"/>
-            </a:effectRef>
-            <a:fontRef idx="minor">
-              <a:schemeClr val="lt1"/>
-            </a:fontRef>
-          </p:style>
-          <p:txBody>
-            <a:bodyPr rtlCol="0" anchor="ctr"/>
-            <a:lstStyle/>
-            <a:p>
-              <a:pPr algn="ctr"/>
-              <a:endParaRPr lang="ko-KR" altLang="en-US"/>
-            </a:p>
-          </p:txBody>
-        </p:sp>
-        <p:sp>
-          <p:nvSpPr>
-            <p:cNvPr id="31" name="직사각형 30"/>
-            <p:cNvSpPr/>
-            <p:nvPr/>
-          </p:nvSpPr>
-          <p:spPr>
-            <a:xfrm>
-              <a:off x="12095266" y="1782736"/>
-              <a:ext cx="2160000" cy="1440000"/>
-            </a:xfrm>
-            <a:prstGeom prst="rect">
-              <a:avLst/>
-            </a:prstGeom>
-            <a:solidFill>
-              <a:schemeClr val="accent5"/>
-            </a:solidFill>
-            <a:ln>
-              <a:noFill/>
-            </a:ln>
-          </p:spPr>
-          <p:style>
-            <a:lnRef idx="2">
-              <a:schemeClr val="accent1">
-                <a:shade val="50000"/>
-              </a:schemeClr>
-            </a:lnRef>
-            <a:fillRef idx="1">
-              <a:schemeClr val="accent1"/>
-            </a:fillRef>
-            <a:effectRef idx="0">
-              <a:schemeClr val="accent1"/>
-            </a:effectRef>
-            <a:fontRef idx="minor">
-              <a:schemeClr val="lt1"/>
-            </a:fontRef>
-          </p:style>
-          <p:txBody>
-            <a:bodyPr rtlCol="0" anchor="ctr"/>
-            <a:lstStyle/>
-            <a:p>
-              <a:pPr algn="ctr"/>
-              <a:r>
-                <a:rPr lang="en-US" altLang="ko-KR" sz="4400" dirty="0" smtClean="0">
-                  <a:latin typeface="나눔스퀘어 Bold" panose="020B0600000101010101" pitchFamily="50" charset="-127"/>
-                  <a:ea typeface="나눔스퀘어 Bold" panose="020B0600000101010101" pitchFamily="50" charset="-127"/>
-                </a:rPr>
-                <a:t>DB</a:t>
-              </a:r>
-              <a:endParaRPr lang="ko-KR" altLang="en-US" sz="4400" dirty="0">
-                <a:latin typeface="나눔스퀘어 Bold" panose="020B0600000101010101" pitchFamily="50" charset="-127"/>
-                <a:ea typeface="나눔스퀘어 Bold" panose="020B0600000101010101" pitchFamily="50" charset="-127"/>
-              </a:endParaRPr>
-            </a:p>
-          </p:txBody>
-        </p:sp>
-        <p:sp>
-          <p:nvSpPr>
-            <p:cNvPr id="9" name="TextBox 8"/>
-            <p:cNvSpPr txBox="1"/>
-            <p:nvPr/>
-          </p:nvSpPr>
-          <p:spPr>
-            <a:xfrm>
-              <a:off x="81680" y="928471"/>
-              <a:ext cx="1378904" cy="646331"/>
-            </a:xfrm>
-            <a:prstGeom prst="rect">
-              <a:avLst/>
-            </a:prstGeom>
-            <a:noFill/>
-          </p:spPr>
-          <p:txBody>
-            <a:bodyPr wrap="none" rtlCol="0">
-              <a:spAutoFit/>
-            </a:bodyPr>
-            <a:lstStyle/>
-            <a:p>
-              <a:pPr algn="ctr"/>
-              <a:r>
-                <a:rPr lang="en-US" altLang="ko-KR" sz="3600" dirty="0" smtClean="0"/>
-                <a:t>Client</a:t>
-              </a:r>
-              <a:endParaRPr lang="ko-KR" altLang="en-US" sz="3600" dirty="0"/>
-            </a:p>
-          </p:txBody>
-        </p:sp>
-        <p:sp>
-          <p:nvSpPr>
-            <p:cNvPr id="32" name="TextBox 31"/>
-            <p:cNvSpPr txBox="1"/>
-            <p:nvPr/>
-          </p:nvSpPr>
-          <p:spPr>
-            <a:xfrm>
-              <a:off x="4777694" y="928470"/>
-              <a:ext cx="4391010" cy="646331"/>
-            </a:xfrm>
-            <a:prstGeom prst="rect">
-              <a:avLst/>
-            </a:prstGeom>
-            <a:noFill/>
-          </p:spPr>
-          <p:txBody>
-            <a:bodyPr wrap="none" rtlCol="0">
-              <a:spAutoFit/>
-            </a:bodyPr>
-            <a:lstStyle/>
-            <a:p>
-              <a:pPr algn="ctr"/>
-              <a:r>
-                <a:rPr lang="en-US" altLang="ko-KR" sz="3600" dirty="0"/>
-                <a:t>w</a:t>
-              </a:r>
-              <a:r>
-                <a:rPr lang="en-US" altLang="ko-KR" sz="3600" dirty="0" smtClean="0"/>
-                <a:t>eb server : Tomcat</a:t>
-              </a:r>
-              <a:endParaRPr lang="ko-KR" altLang="en-US" sz="3600" dirty="0"/>
-            </a:p>
-          </p:txBody>
-        </p:sp>
-        <p:sp>
-          <p:nvSpPr>
-            <p:cNvPr id="33" name="TextBox 32"/>
-            <p:cNvSpPr txBox="1"/>
-            <p:nvPr/>
-          </p:nvSpPr>
-          <p:spPr>
-            <a:xfrm>
-              <a:off x="12782369" y="928470"/>
-              <a:ext cx="785793" cy="646331"/>
-            </a:xfrm>
-            <a:prstGeom prst="rect">
-              <a:avLst/>
-            </a:prstGeom>
-            <a:noFill/>
-          </p:spPr>
-          <p:txBody>
-            <a:bodyPr wrap="none" rtlCol="0">
-              <a:spAutoFit/>
-            </a:bodyPr>
-            <a:lstStyle/>
-            <a:p>
-              <a:pPr algn="ctr"/>
-              <a:r>
-                <a:rPr lang="en-US" altLang="ko-KR" sz="3600" dirty="0" smtClean="0"/>
-                <a:t>DB</a:t>
-              </a:r>
-              <a:endParaRPr lang="ko-KR" altLang="en-US" sz="3600" dirty="0"/>
-            </a:p>
-          </p:txBody>
-        </p:sp>
-        <p:sp>
-          <p:nvSpPr>
-            <p:cNvPr id="10" name="TextBox 9"/>
-            <p:cNvSpPr txBox="1"/>
-            <p:nvPr/>
-          </p:nvSpPr>
-          <p:spPr>
-            <a:xfrm>
-              <a:off x="-451607" y="3335603"/>
-              <a:ext cx="2445478" cy="646331"/>
-            </a:xfrm>
-            <a:prstGeom prst="rect">
-              <a:avLst/>
-            </a:prstGeom>
-            <a:noFill/>
-          </p:spPr>
-          <p:txBody>
-            <a:bodyPr wrap="none" rtlCol="0">
-              <a:spAutoFit/>
-            </a:bodyPr>
-            <a:lstStyle/>
-            <a:p>
-              <a:pPr algn="ctr"/>
-              <a:r>
-                <a:rPr lang="en-US" altLang="ko-KR" dirty="0" smtClean="0"/>
-                <a:t>ID, PW, MAIL, PHONE</a:t>
-              </a:r>
-            </a:p>
-            <a:p>
-              <a:pPr algn="ctr"/>
-              <a:r>
-                <a:rPr lang="en-US" altLang="ko-KR" dirty="0" smtClean="0"/>
-                <a:t>[ SUBMIT ]</a:t>
-              </a:r>
-              <a:endParaRPr lang="ko-KR" altLang="en-US" dirty="0"/>
             </a:p>
           </p:txBody>
         </p:sp>
         <p:cxnSp>
           <p:nvCxnSpPr>
-            <p:cNvPr id="34" name="직선 화살표 연결선 33"/>
+            <p:cNvPr id="12" name="직선 화살표 연결선 11"/>
             <p:cNvCxnSpPr>
-              <a:stCxn id="29" idx="3"/>
-              <a:endCxn id="27" idx="1"/>
+              <a:stCxn id="6" idx="3"/>
+              <a:endCxn id="10" idx="1"/>
             </p:cNvCxnSpPr>
             <p:nvPr/>
           </p:nvCxnSpPr>
           <p:spPr>
-            <a:xfrm flipV="1">
-              <a:off x="1851132" y="2485800"/>
-              <a:ext cx="1084434" cy="16936"/>
+            <a:xfrm>
+              <a:off x="2850525" y="1520100"/>
+              <a:ext cx="1107976" cy="0"/>
             </a:xfrm>
             <a:prstGeom prst="straightConnector1">
               <a:avLst/>
@@ -3682,22 +3293,20 @@
         </p:cxnSp>
         <p:cxnSp>
           <p:nvCxnSpPr>
-            <p:cNvPr id="37" name="꺾인 연결선 36"/>
+            <p:cNvPr id="14" name="직선 화살표 연결선 13"/>
             <p:cNvCxnSpPr>
-              <a:stCxn id="27" idx="2"/>
-              <a:endCxn id="21" idx="2"/>
+              <a:stCxn id="10" idx="3"/>
+              <a:endCxn id="8" idx="1"/>
             </p:cNvCxnSpPr>
             <p:nvPr/>
           </p:nvCxnSpPr>
           <p:spPr>
-            <a:xfrm rot="16200000" flipH="1">
-              <a:off x="4249566" y="2431800"/>
-              <a:ext cx="12700" cy="1548000"/>
+            <a:xfrm>
+              <a:off x="6118501" y="1520100"/>
+              <a:ext cx="1670043" cy="0"/>
             </a:xfrm>
-            <a:prstGeom prst="bentConnector3">
-              <a:avLst>
-                <a:gd name="adj1" fmla="val 3666669"/>
-              </a:avLst>
+            <a:prstGeom prst="straightConnector1">
+              <a:avLst/>
             </a:prstGeom>
             <a:ln w="76200">
               <a:solidFill>
@@ -3723,93 +3332,17 @@
         </p:cxnSp>
         <p:cxnSp>
           <p:nvCxnSpPr>
-            <p:cNvPr id="41" name="꺾인 연결선 40"/>
-            <p:cNvCxnSpPr/>
-            <p:nvPr/>
-          </p:nvCxnSpPr>
-          <p:spPr>
-            <a:xfrm rot="16200000" flipH="1">
-              <a:off x="6437014" y="2161799"/>
-              <a:ext cx="12700" cy="2088000"/>
-            </a:xfrm>
-            <a:prstGeom prst="bentConnector3">
-              <a:avLst>
-                <a:gd name="adj1" fmla="val 3733331"/>
-              </a:avLst>
-            </a:prstGeom>
-            <a:ln w="76200">
-              <a:solidFill>
-                <a:schemeClr val="accent2"/>
-              </a:solidFill>
-              <a:tailEnd type="triangle"/>
-            </a:ln>
-          </p:spPr>
-          <p:style>
-            <a:lnRef idx="1">
-              <a:schemeClr val="accent1"/>
-            </a:lnRef>
-            <a:fillRef idx="0">
-              <a:schemeClr val="accent1"/>
-            </a:fillRef>
-            <a:effectRef idx="0">
-              <a:schemeClr val="accent1"/>
-            </a:effectRef>
-            <a:fontRef idx="minor">
-              <a:schemeClr val="tx1"/>
-            </a:fontRef>
-          </p:style>
-        </p:cxnSp>
-        <p:cxnSp>
-          <p:nvCxnSpPr>
-            <p:cNvPr id="47" name="꺾인 연결선 46"/>
-            <p:cNvCxnSpPr/>
-            <p:nvPr/>
-          </p:nvCxnSpPr>
-          <p:spPr>
-            <a:xfrm rot="16200000" flipH="1">
-              <a:off x="8896402" y="2125799"/>
-              <a:ext cx="12700" cy="2160000"/>
-            </a:xfrm>
-            <a:prstGeom prst="bentConnector3">
-              <a:avLst>
-                <a:gd name="adj1" fmla="val 3733339"/>
-              </a:avLst>
-            </a:prstGeom>
-            <a:ln w="76200">
-              <a:solidFill>
-                <a:schemeClr val="accent2"/>
-              </a:solidFill>
-              <a:tailEnd type="triangle"/>
-            </a:ln>
-          </p:spPr>
-          <p:style>
-            <a:lnRef idx="1">
-              <a:schemeClr val="accent1"/>
-            </a:lnRef>
-            <a:fillRef idx="0">
-              <a:schemeClr val="accent1"/>
-            </a:fillRef>
-            <a:effectRef idx="0">
-              <a:schemeClr val="accent1"/>
-            </a:effectRef>
-            <a:fontRef idx="minor">
-              <a:schemeClr val="tx1"/>
-            </a:fontRef>
-          </p:style>
-        </p:cxnSp>
-        <p:cxnSp>
-          <p:nvCxnSpPr>
-            <p:cNvPr id="52" name="직선 화살표 연결선 51"/>
+            <p:cNvPr id="15" name="직선 화살표 연결선 14"/>
             <p:cNvCxnSpPr>
-              <a:stCxn id="23" idx="3"/>
-              <a:endCxn id="31" idx="1"/>
+              <a:stCxn id="8" idx="3"/>
+              <a:endCxn id="9" idx="1"/>
             </p:cNvCxnSpPr>
             <p:nvPr/>
           </p:nvCxnSpPr>
           <p:spPr>
             <a:xfrm>
-              <a:off x="11018468" y="2485800"/>
-              <a:ext cx="1076798" cy="16936"/>
+              <a:off x="9948544" y="1520100"/>
+              <a:ext cx="2112201" cy="0"/>
             </a:xfrm>
             <a:prstGeom prst="straightConnector1">
               <a:avLst/>
@@ -3838,54 +3371,116 @@
         </p:cxnSp>
         <p:sp>
           <p:nvSpPr>
-            <p:cNvPr id="55" name="직사각형 54"/>
-            <p:cNvSpPr/>
+            <p:cNvPr id="20" name="TextBox 19"/>
+            <p:cNvSpPr txBox="1"/>
             <p:nvPr/>
           </p:nvSpPr>
           <p:spPr>
             <a:xfrm>
-              <a:off x="8362752" y="3396798"/>
-              <a:ext cx="1080000" cy="540000"/>
+              <a:off x="3078141" y="1119990"/>
+              <a:ext cx="652743" cy="400110"/>
             </a:xfrm>
             <a:prstGeom prst="rect">
               <a:avLst/>
             </a:prstGeom>
-            <a:solidFill>
-              <a:schemeClr val="accent5"/>
-            </a:solidFill>
-            <a:ln>
-              <a:noFill/>
-            </a:ln>
+            <a:noFill/>
           </p:spPr>
-          <p:style>
-            <a:lnRef idx="2">
-              <a:schemeClr val="accent1">
-                <a:shade val="50000"/>
-              </a:schemeClr>
-            </a:lnRef>
-            <a:fillRef idx="1">
-              <a:schemeClr val="accent1"/>
-            </a:fillRef>
-            <a:effectRef idx="0">
-              <a:schemeClr val="accent1"/>
-            </a:effectRef>
-            <a:fontRef idx="minor">
-              <a:schemeClr val="lt1"/>
-            </a:fontRef>
-          </p:style>
           <p:txBody>
-            <a:bodyPr rtlCol="0" anchor="ctr"/>
+            <a:bodyPr wrap="none" rtlCol="0">
+              <a:spAutoFit/>
+            </a:bodyPr>
             <a:lstStyle/>
             <a:p>
               <a:pPr algn="ctr"/>
               <a:r>
-                <a:rPr lang="en-US" altLang="ko-KR" sz="2400" dirty="0" smtClean="0">
+                <a:rPr lang="ko-KR" altLang="en-US" sz="2000" dirty="0" smtClean="0">
                   <a:latin typeface="나눔스퀘어 Bold" panose="020B0600000101010101" pitchFamily="50" charset="-127"/>
                   <a:ea typeface="나눔스퀘어 Bold" panose="020B0600000101010101" pitchFamily="50" charset="-127"/>
                 </a:rPr>
-                <a:t>DTO</a:t>
+                <a:t>요청</a:t>
               </a:r>
-              <a:endParaRPr lang="ko-KR" altLang="en-US" sz="2400" dirty="0">
+              <a:endParaRPr lang="ko-KR" altLang="en-US" sz="2000" dirty="0">
+                <a:latin typeface="나눔스퀘어 Bold" panose="020B0600000101010101" pitchFamily="50" charset="-127"/>
+                <a:ea typeface="나눔스퀘어 Bold" panose="020B0600000101010101" pitchFamily="50" charset="-127"/>
+              </a:endParaRPr>
+            </a:p>
+          </p:txBody>
+        </p:sp>
+        <p:sp>
+          <p:nvSpPr>
+            <p:cNvPr id="21" name="TextBox 20"/>
+            <p:cNvSpPr txBox="1"/>
+            <p:nvPr/>
+          </p:nvSpPr>
+          <p:spPr>
+            <a:xfrm>
+              <a:off x="6238422" y="1119990"/>
+              <a:ext cx="1430200" cy="400110"/>
+            </a:xfrm>
+            <a:prstGeom prst="rect">
+              <a:avLst/>
+            </a:prstGeom>
+            <a:noFill/>
+          </p:spPr>
+          <p:txBody>
+            <a:bodyPr wrap="none" rtlCol="0">
+              <a:spAutoFit/>
+            </a:bodyPr>
+            <a:lstStyle/>
+            <a:p>
+              <a:pPr algn="ctr"/>
+              <a:r>
+                <a:rPr lang="en-US" altLang="ko-KR" sz="2000" dirty="0" smtClean="0">
+                  <a:latin typeface="나눔스퀘어 Bold" panose="020B0600000101010101" pitchFamily="50" charset="-127"/>
+                  <a:ea typeface="나눔스퀘어 Bold" panose="020B0600000101010101" pitchFamily="50" charset="-127"/>
+                </a:rPr>
+                <a:t>HTML + JS</a:t>
+              </a:r>
+              <a:endParaRPr lang="ko-KR" altLang="en-US" sz="2000" dirty="0">
+                <a:latin typeface="나눔스퀘어 Bold" panose="020B0600000101010101" pitchFamily="50" charset="-127"/>
+                <a:ea typeface="나눔스퀘어 Bold" panose="020B0600000101010101" pitchFamily="50" charset="-127"/>
+              </a:endParaRPr>
+            </a:p>
+          </p:txBody>
+        </p:sp>
+        <p:sp>
+          <p:nvSpPr>
+            <p:cNvPr id="32" name="TextBox 31"/>
+            <p:cNvSpPr txBox="1"/>
+            <p:nvPr/>
+          </p:nvSpPr>
+          <p:spPr>
+            <a:xfrm>
+              <a:off x="10020240" y="1119990"/>
+              <a:ext cx="1968809" cy="400110"/>
+            </a:xfrm>
+            <a:prstGeom prst="rect">
+              <a:avLst/>
+            </a:prstGeom>
+            <a:noFill/>
+          </p:spPr>
+          <p:txBody>
+            <a:bodyPr wrap="none" rtlCol="0">
+              <a:spAutoFit/>
+            </a:bodyPr>
+            <a:lstStyle/>
+            <a:p>
+              <a:pPr algn="ctr"/>
+              <a:r>
+                <a:rPr lang="en-US" altLang="ko-KR" sz="2000" dirty="0" smtClean="0">
+                  <a:latin typeface="나눔스퀘어 Bold" panose="020B0600000101010101" pitchFamily="50" charset="-127"/>
+                  <a:ea typeface="나눔스퀘어 Bold" panose="020B0600000101010101" pitchFamily="50" charset="-127"/>
+                </a:rPr>
+                <a:t>JavaScript </a:t>
+              </a:r>
+              <a:r>
+                <a:rPr lang="ko-KR" altLang="en-US" sz="2000" dirty="0" smtClean="0">
+                  <a:latin typeface="나눔스퀘어 Bold" panose="020B0600000101010101" pitchFamily="50" charset="-127"/>
+                  <a:ea typeface="나눔스퀘어 Bold" panose="020B0600000101010101" pitchFamily="50" charset="-127"/>
+                </a:rPr>
+                <a:t>실행</a:t>
+              </a:r>
+              <a:endParaRPr lang="ko-KR" altLang="en-US" sz="2000" dirty="0">
                 <a:latin typeface="나눔스퀘어 Bold" panose="020B0600000101010101" pitchFamily="50" charset="-127"/>
                 <a:ea typeface="나눔스퀘어 Bold" panose="020B0600000101010101" pitchFamily="50" charset="-127"/>
               </a:endParaRPr>

</xml_diff>

<commit_message>
20260831 commit : early
</commit_message>
<xml_diff>
--- a/notion/create_notion_img.pptx
+++ b/notion/create_notion_img.pptx
@@ -246,7 +246,7 @@
           <a:p>
             <a:fld id="{7237CE1A-8831-48B5-BA93-72483C6E34E8}" type="datetimeFigureOut">
               <a:rPr lang="ko-KR" altLang="en-US" smtClean="0"/>
-              <a:t>2026-08-24</a:t>
+              <a:t>26-08-30(Sun)</a:t>
             </a:fld>
             <a:endParaRPr lang="ko-KR" altLang="en-US"/>
           </a:p>
@@ -416,7 +416,7 @@
           <a:p>
             <a:fld id="{7237CE1A-8831-48B5-BA93-72483C6E34E8}" type="datetimeFigureOut">
               <a:rPr lang="ko-KR" altLang="en-US" smtClean="0"/>
-              <a:t>2026-08-24</a:t>
+              <a:t>26-08-30(Sun)</a:t>
             </a:fld>
             <a:endParaRPr lang="ko-KR" altLang="en-US"/>
           </a:p>
@@ -596,7 +596,7 @@
           <a:p>
             <a:fld id="{7237CE1A-8831-48B5-BA93-72483C6E34E8}" type="datetimeFigureOut">
               <a:rPr lang="ko-KR" altLang="en-US" smtClean="0"/>
-              <a:t>2026-08-24</a:t>
+              <a:t>26-08-30(Sun)</a:t>
             </a:fld>
             <a:endParaRPr lang="ko-KR" altLang="en-US"/>
           </a:p>
@@ -766,7 +766,7 @@
           <a:p>
             <a:fld id="{7237CE1A-8831-48B5-BA93-72483C6E34E8}" type="datetimeFigureOut">
               <a:rPr lang="ko-KR" altLang="en-US" smtClean="0"/>
-              <a:t>2026-08-24</a:t>
+              <a:t>26-08-30(Sun)</a:t>
             </a:fld>
             <a:endParaRPr lang="ko-KR" altLang="en-US"/>
           </a:p>
@@ -1012,7 +1012,7 @@
           <a:p>
             <a:fld id="{7237CE1A-8831-48B5-BA93-72483C6E34E8}" type="datetimeFigureOut">
               <a:rPr lang="ko-KR" altLang="en-US" smtClean="0"/>
-              <a:t>2026-08-24</a:t>
+              <a:t>26-08-30(Sun)</a:t>
             </a:fld>
             <a:endParaRPr lang="ko-KR" altLang="en-US"/>
           </a:p>
@@ -1244,7 +1244,7 @@
           <a:p>
             <a:fld id="{7237CE1A-8831-48B5-BA93-72483C6E34E8}" type="datetimeFigureOut">
               <a:rPr lang="ko-KR" altLang="en-US" smtClean="0"/>
-              <a:t>2026-08-24</a:t>
+              <a:t>26-08-30(Sun)</a:t>
             </a:fld>
             <a:endParaRPr lang="ko-KR" altLang="en-US"/>
           </a:p>
@@ -1611,7 +1611,7 @@
           <a:p>
             <a:fld id="{7237CE1A-8831-48B5-BA93-72483C6E34E8}" type="datetimeFigureOut">
               <a:rPr lang="ko-KR" altLang="en-US" smtClean="0"/>
-              <a:t>2026-08-24</a:t>
+              <a:t>26-08-30(Sun)</a:t>
             </a:fld>
             <a:endParaRPr lang="ko-KR" altLang="en-US"/>
           </a:p>
@@ -1729,7 +1729,7 @@
           <a:p>
             <a:fld id="{7237CE1A-8831-48B5-BA93-72483C6E34E8}" type="datetimeFigureOut">
               <a:rPr lang="ko-KR" altLang="en-US" smtClean="0"/>
-              <a:t>2026-08-24</a:t>
+              <a:t>26-08-30(Sun)</a:t>
             </a:fld>
             <a:endParaRPr lang="ko-KR" altLang="en-US"/>
           </a:p>
@@ -1824,7 +1824,7 @@
           <a:p>
             <a:fld id="{7237CE1A-8831-48B5-BA93-72483C6E34E8}" type="datetimeFigureOut">
               <a:rPr lang="ko-KR" altLang="en-US" smtClean="0"/>
-              <a:t>2026-08-24</a:t>
+              <a:t>26-08-30(Sun)</a:t>
             </a:fld>
             <a:endParaRPr lang="ko-KR" altLang="en-US"/>
           </a:p>
@@ -2101,7 +2101,7 @@
           <a:p>
             <a:fld id="{7237CE1A-8831-48B5-BA93-72483C6E34E8}" type="datetimeFigureOut">
               <a:rPr lang="ko-KR" altLang="en-US" smtClean="0"/>
-              <a:t>2026-08-24</a:t>
+              <a:t>26-08-30(Sun)</a:t>
             </a:fld>
             <a:endParaRPr lang="ko-KR" altLang="en-US"/>
           </a:p>
@@ -2354,7 +2354,7 @@
           <a:p>
             <a:fld id="{7237CE1A-8831-48B5-BA93-72483C6E34E8}" type="datetimeFigureOut">
               <a:rPr lang="ko-KR" altLang="en-US" smtClean="0"/>
-              <a:t>2026-08-24</a:t>
+              <a:t>26-08-30(Sun)</a:t>
             </a:fld>
             <a:endParaRPr lang="ko-KR" altLang="en-US"/>
           </a:p>
@@ -2567,7 +2567,7 @@
           <a:p>
             <a:fld id="{7237CE1A-8831-48B5-BA93-72483C6E34E8}" type="datetimeFigureOut">
               <a:rPr lang="ko-KR" altLang="en-US" smtClean="0"/>
-              <a:t>2026-08-24</a:t>
+              <a:t>26-08-30(Sun)</a:t>
             </a:fld>
             <a:endParaRPr lang="ko-KR" altLang="en-US"/>
           </a:p>
@@ -2972,522 +2972,674 @@
           <a:chExt cx="0" cy="0"/>
         </a:xfrm>
       </p:grpSpPr>
-      <p:grpSp>
-        <p:nvGrpSpPr>
-          <p:cNvPr id="39" name="그룹 38"/>
-          <p:cNvGrpSpPr/>
-          <p:nvPr/>
-        </p:nvGrpSpPr>
-        <p:grpSpPr>
-          <a:xfrm>
-            <a:off x="690525" y="800100"/>
-            <a:ext cx="13530220" cy="1440000"/>
-            <a:chOff x="690525" y="800100"/>
-            <a:chExt cx="13530220" cy="1440000"/>
-          </a:xfrm>
-        </p:grpSpPr>
-        <p:sp>
-          <p:nvSpPr>
-            <p:cNvPr id="6" name="직사각형 5"/>
-            <p:cNvSpPr/>
-            <p:nvPr/>
-          </p:nvSpPr>
-          <p:spPr>
-            <a:xfrm>
-              <a:off x="690525" y="800100"/>
-              <a:ext cx="2160000" cy="1440000"/>
-            </a:xfrm>
-            <a:prstGeom prst="rect">
-              <a:avLst/>
-            </a:prstGeom>
+      <p:sp>
+        <p:nvSpPr>
+          <p:cNvPr id="273" name="직사각형 272"/>
+          <p:cNvSpPr/>
+          <p:nvPr/>
+        </p:nvSpPr>
+        <p:spPr>
+          <a:xfrm>
+            <a:off x="-6217200" y="761999"/>
+            <a:ext cx="2880000" cy="1440000"/>
+          </a:xfrm>
+          <a:prstGeom prst="rect">
+            <a:avLst/>
+          </a:prstGeom>
+          <a:solidFill>
+            <a:schemeClr val="accent5"/>
+          </a:solidFill>
+          <a:ln>
+            <a:noFill/>
+          </a:ln>
+        </p:spPr>
+        <p:style>
+          <a:lnRef idx="2">
+            <a:schemeClr val="accent1">
+              <a:shade val="50000"/>
+            </a:schemeClr>
+          </a:lnRef>
+          <a:fillRef idx="1">
+            <a:schemeClr val="accent1"/>
+          </a:fillRef>
+          <a:effectRef idx="0">
+            <a:schemeClr val="accent1"/>
+          </a:effectRef>
+          <a:fontRef idx="minor">
+            <a:schemeClr val="lt1"/>
+          </a:fontRef>
+        </p:style>
+        <p:txBody>
+          <a:bodyPr rtlCol="0" anchor="ctr"/>
+          <a:lstStyle/>
+          <a:p>
+            <a:pPr algn="ctr"/>
+            <a:r>
+              <a:rPr lang="ko-KR" altLang="en-US" sz="4000" dirty="0" smtClean="0">
+                <a:latin typeface="나눔스퀘어 Bold" panose="020B0600000101010101" pitchFamily="50" charset="-127"/>
+                <a:ea typeface="나눔스퀘어 Bold" panose="020B0600000101010101" pitchFamily="50" charset="-127"/>
+              </a:rPr>
+              <a:t>협업</a:t>
+            </a:r>
+            <a:endParaRPr lang="ko-KR" altLang="en-US" sz="4000" dirty="0">
+              <a:latin typeface="나눔스퀘어 Bold" panose="020B0600000101010101" pitchFamily="50" charset="-127"/>
+              <a:ea typeface="나눔스퀘어 Bold" panose="020B0600000101010101" pitchFamily="50" charset="-127"/>
+            </a:endParaRPr>
+          </a:p>
+        </p:txBody>
+      </p:sp>
+      <p:sp>
+        <p:nvSpPr>
+          <p:cNvPr id="293" name="직사각형 292"/>
+          <p:cNvSpPr/>
+          <p:nvPr/>
+        </p:nvSpPr>
+        <p:spPr>
+          <a:xfrm>
+            <a:off x="-2381800" y="761999"/>
+            <a:ext cx="2880000" cy="1440000"/>
+          </a:xfrm>
+          <a:prstGeom prst="rect">
+            <a:avLst/>
+          </a:prstGeom>
+          <a:solidFill>
+            <a:schemeClr val="accent5"/>
+          </a:solidFill>
+          <a:ln>
+            <a:noFill/>
+          </a:ln>
+        </p:spPr>
+        <p:style>
+          <a:lnRef idx="2">
+            <a:schemeClr val="accent1">
+              <a:shade val="50000"/>
+            </a:schemeClr>
+          </a:lnRef>
+          <a:fillRef idx="1">
+            <a:schemeClr val="accent1"/>
+          </a:fillRef>
+          <a:effectRef idx="0">
+            <a:schemeClr val="accent1"/>
+          </a:effectRef>
+          <a:fontRef idx="minor">
+            <a:schemeClr val="lt1"/>
+          </a:fontRef>
+        </p:style>
+        <p:txBody>
+          <a:bodyPr rtlCol="0" anchor="ctr"/>
+          <a:lstStyle/>
+          <a:p>
+            <a:pPr algn="ctr"/>
+            <a:r>
+              <a:rPr lang="ko-KR" altLang="en-US" sz="4000" dirty="0" smtClean="0">
+                <a:latin typeface="나눔스퀘어 Bold" panose="020B0600000101010101" pitchFamily="50" charset="-127"/>
+                <a:ea typeface="나눔스퀘어 Bold" panose="020B0600000101010101" pitchFamily="50" charset="-127"/>
+              </a:rPr>
+              <a:t>기획</a:t>
+            </a:r>
+            <a:endParaRPr lang="ko-KR" altLang="en-US" sz="4000" dirty="0">
+              <a:latin typeface="나눔스퀘어 Bold" panose="020B0600000101010101" pitchFamily="50" charset="-127"/>
+              <a:ea typeface="나눔스퀘어 Bold" panose="020B0600000101010101" pitchFamily="50" charset="-127"/>
+            </a:endParaRPr>
+          </a:p>
+        </p:txBody>
+      </p:sp>
+      <p:sp>
+        <p:nvSpPr>
+          <p:cNvPr id="294" name="직사각형 293"/>
+          <p:cNvSpPr/>
+          <p:nvPr/>
+        </p:nvSpPr>
+        <p:spPr>
+          <a:xfrm>
+            <a:off x="1453600" y="761999"/>
+            <a:ext cx="2880000" cy="1440000"/>
+          </a:xfrm>
+          <a:prstGeom prst="rect">
+            <a:avLst/>
+          </a:prstGeom>
+          <a:solidFill>
+            <a:schemeClr val="accent5"/>
+          </a:solidFill>
+          <a:ln>
+            <a:noFill/>
+          </a:ln>
+        </p:spPr>
+        <p:style>
+          <a:lnRef idx="2">
+            <a:schemeClr val="accent1">
+              <a:shade val="50000"/>
+            </a:schemeClr>
+          </a:lnRef>
+          <a:fillRef idx="1">
+            <a:schemeClr val="accent1"/>
+          </a:fillRef>
+          <a:effectRef idx="0">
+            <a:schemeClr val="accent1"/>
+          </a:effectRef>
+          <a:fontRef idx="minor">
+            <a:schemeClr val="lt1"/>
+          </a:fontRef>
+        </p:style>
+        <p:txBody>
+          <a:bodyPr rtlCol="0" anchor="ctr"/>
+          <a:lstStyle/>
+          <a:p>
+            <a:pPr algn="ctr"/>
+            <a:r>
+              <a:rPr lang="ko-KR" altLang="en-US" sz="4000" dirty="0" smtClean="0">
+                <a:latin typeface="나눔스퀘어 Bold" panose="020B0600000101010101" pitchFamily="50" charset="-127"/>
+                <a:ea typeface="나눔스퀘어 Bold" panose="020B0600000101010101" pitchFamily="50" charset="-127"/>
+              </a:rPr>
+              <a:t>요구사항</a:t>
+            </a:r>
+            <a:endParaRPr lang="en-US" altLang="ko-KR" sz="4000" dirty="0" smtClean="0">
+              <a:latin typeface="나눔스퀘어 Bold" panose="020B0600000101010101" pitchFamily="50" charset="-127"/>
+              <a:ea typeface="나눔스퀘어 Bold" panose="020B0600000101010101" pitchFamily="50" charset="-127"/>
+            </a:endParaRPr>
+          </a:p>
+          <a:p>
+            <a:pPr algn="ctr"/>
+            <a:r>
+              <a:rPr lang="ko-KR" altLang="en-US" sz="4000" dirty="0" smtClean="0">
+                <a:latin typeface="나눔스퀘어 Bold" panose="020B0600000101010101" pitchFamily="50" charset="-127"/>
+                <a:ea typeface="나눔스퀘어 Bold" panose="020B0600000101010101" pitchFamily="50" charset="-127"/>
+              </a:rPr>
+              <a:t>명세서</a:t>
+            </a:r>
+            <a:endParaRPr lang="ko-KR" altLang="en-US" sz="4000" dirty="0">
+              <a:latin typeface="나눔스퀘어 Bold" panose="020B0600000101010101" pitchFamily="50" charset="-127"/>
+              <a:ea typeface="나눔스퀘어 Bold" panose="020B0600000101010101" pitchFamily="50" charset="-127"/>
+            </a:endParaRPr>
+          </a:p>
+        </p:txBody>
+      </p:sp>
+      <p:sp>
+        <p:nvSpPr>
+          <p:cNvPr id="295" name="직사각형 294"/>
+          <p:cNvSpPr/>
+          <p:nvPr/>
+        </p:nvSpPr>
+        <p:spPr>
+          <a:xfrm>
+            <a:off x="5289000" y="761999"/>
+            <a:ext cx="2880000" cy="1440000"/>
+          </a:xfrm>
+          <a:prstGeom prst="rect">
+            <a:avLst/>
+          </a:prstGeom>
+          <a:solidFill>
+            <a:schemeClr val="accent5"/>
+          </a:solidFill>
+          <a:ln>
+            <a:noFill/>
+          </a:ln>
+        </p:spPr>
+        <p:style>
+          <a:lnRef idx="2">
+            <a:schemeClr val="accent1">
+              <a:shade val="50000"/>
+            </a:schemeClr>
+          </a:lnRef>
+          <a:fillRef idx="1">
+            <a:schemeClr val="accent1"/>
+          </a:fillRef>
+          <a:effectRef idx="0">
+            <a:schemeClr val="accent1"/>
+          </a:effectRef>
+          <a:fontRef idx="minor">
+            <a:schemeClr val="lt1"/>
+          </a:fontRef>
+        </p:style>
+        <p:txBody>
+          <a:bodyPr rtlCol="0" anchor="ctr"/>
+          <a:lstStyle/>
+          <a:p>
+            <a:pPr algn="ctr"/>
+            <a:r>
+              <a:rPr lang="ko-KR" altLang="en-US" sz="4000" dirty="0" smtClean="0">
+                <a:latin typeface="나눔스퀘어 Bold" panose="020B0600000101010101" pitchFamily="50" charset="-127"/>
+                <a:ea typeface="나눔스퀘어 Bold" panose="020B0600000101010101" pitchFamily="50" charset="-127"/>
+              </a:rPr>
+              <a:t>기능</a:t>
+            </a:r>
+            <a:endParaRPr lang="en-US" altLang="ko-KR" sz="4000" dirty="0" smtClean="0">
+              <a:latin typeface="나눔스퀘어 Bold" panose="020B0600000101010101" pitchFamily="50" charset="-127"/>
+              <a:ea typeface="나눔스퀘어 Bold" panose="020B0600000101010101" pitchFamily="50" charset="-127"/>
+            </a:endParaRPr>
+          </a:p>
+          <a:p>
+            <a:pPr algn="ctr"/>
+            <a:r>
+              <a:rPr lang="ko-KR" altLang="en-US" sz="4000" dirty="0" smtClean="0">
+                <a:latin typeface="나눔스퀘어 Bold" panose="020B0600000101010101" pitchFamily="50" charset="-127"/>
+                <a:ea typeface="나눔스퀘어 Bold" panose="020B0600000101010101" pitchFamily="50" charset="-127"/>
+              </a:rPr>
+              <a:t>명세서</a:t>
+            </a:r>
+            <a:endParaRPr lang="ko-KR" altLang="en-US" sz="4000" dirty="0">
+              <a:latin typeface="나눔스퀘어 Bold" panose="020B0600000101010101" pitchFamily="50" charset="-127"/>
+              <a:ea typeface="나눔스퀘어 Bold" panose="020B0600000101010101" pitchFamily="50" charset="-127"/>
+            </a:endParaRPr>
+          </a:p>
+        </p:txBody>
+      </p:sp>
+      <p:sp>
+        <p:nvSpPr>
+          <p:cNvPr id="296" name="직사각형 295"/>
+          <p:cNvSpPr/>
+          <p:nvPr/>
+        </p:nvSpPr>
+        <p:spPr>
+          <a:xfrm>
+            <a:off x="9124400" y="761999"/>
+            <a:ext cx="2880000" cy="1440000"/>
+          </a:xfrm>
+          <a:prstGeom prst="rect">
+            <a:avLst/>
+          </a:prstGeom>
+          <a:solidFill>
+            <a:schemeClr val="accent5"/>
+          </a:solidFill>
+          <a:ln>
+            <a:noFill/>
+          </a:ln>
+        </p:spPr>
+        <p:style>
+          <a:lnRef idx="2">
+            <a:schemeClr val="accent1">
+              <a:shade val="50000"/>
+            </a:schemeClr>
+          </a:lnRef>
+          <a:fillRef idx="1">
+            <a:schemeClr val="accent1"/>
+          </a:fillRef>
+          <a:effectRef idx="0">
+            <a:schemeClr val="accent1"/>
+          </a:effectRef>
+          <a:fontRef idx="minor">
+            <a:schemeClr val="lt1"/>
+          </a:fontRef>
+        </p:style>
+        <p:txBody>
+          <a:bodyPr rtlCol="0" anchor="ctr"/>
+          <a:lstStyle/>
+          <a:p>
+            <a:pPr algn="ctr"/>
+            <a:r>
+              <a:rPr lang="ko-KR" altLang="en-US" sz="4000" dirty="0" smtClean="0">
+                <a:latin typeface="나눔스퀘어 Bold" panose="020B0600000101010101" pitchFamily="50" charset="-127"/>
+                <a:ea typeface="나눔스퀘어 Bold" panose="020B0600000101010101" pitchFamily="50" charset="-127"/>
+              </a:rPr>
+              <a:t>테이블</a:t>
+            </a:r>
+            <a:endParaRPr lang="en-US" altLang="ko-KR" sz="4000" dirty="0" smtClean="0">
+              <a:latin typeface="나눔스퀘어 Bold" panose="020B0600000101010101" pitchFamily="50" charset="-127"/>
+              <a:ea typeface="나눔스퀘어 Bold" panose="020B0600000101010101" pitchFamily="50" charset="-127"/>
+            </a:endParaRPr>
+          </a:p>
+          <a:p>
+            <a:pPr algn="ctr"/>
+            <a:r>
+              <a:rPr lang="ko-KR" altLang="en-US" sz="4000" dirty="0" smtClean="0">
+                <a:latin typeface="나눔스퀘어 Bold" panose="020B0600000101010101" pitchFamily="50" charset="-127"/>
+                <a:ea typeface="나눔스퀘어 Bold" panose="020B0600000101010101" pitchFamily="50" charset="-127"/>
+              </a:rPr>
+              <a:t>명세서</a:t>
+            </a:r>
+            <a:endParaRPr lang="ko-KR" altLang="en-US" sz="4000" dirty="0">
+              <a:latin typeface="나눔스퀘어 Bold" panose="020B0600000101010101" pitchFamily="50" charset="-127"/>
+              <a:ea typeface="나눔스퀘어 Bold" panose="020B0600000101010101" pitchFamily="50" charset="-127"/>
+            </a:endParaRPr>
+          </a:p>
+        </p:txBody>
+      </p:sp>
+      <p:sp>
+        <p:nvSpPr>
+          <p:cNvPr id="297" name="직사각형 296"/>
+          <p:cNvSpPr/>
+          <p:nvPr/>
+        </p:nvSpPr>
+        <p:spPr>
+          <a:xfrm>
+            <a:off x="12959800" y="761999"/>
+            <a:ext cx="2880000" cy="1440000"/>
+          </a:xfrm>
+          <a:prstGeom prst="rect">
+            <a:avLst/>
+          </a:prstGeom>
+          <a:solidFill>
+            <a:schemeClr val="accent5"/>
+          </a:solidFill>
+          <a:ln>
+            <a:noFill/>
+          </a:ln>
+        </p:spPr>
+        <p:style>
+          <a:lnRef idx="2">
+            <a:schemeClr val="accent1">
+              <a:shade val="50000"/>
+            </a:schemeClr>
+          </a:lnRef>
+          <a:fillRef idx="1">
+            <a:schemeClr val="accent1"/>
+          </a:fillRef>
+          <a:effectRef idx="0">
+            <a:schemeClr val="accent1"/>
+          </a:effectRef>
+          <a:fontRef idx="minor">
+            <a:schemeClr val="lt1"/>
+          </a:fontRef>
+        </p:style>
+        <p:txBody>
+          <a:bodyPr rtlCol="0" anchor="ctr"/>
+          <a:lstStyle/>
+          <a:p>
+            <a:pPr algn="ctr"/>
+            <a:r>
+              <a:rPr lang="ko-KR" altLang="en-US" sz="4000" dirty="0" smtClean="0">
+                <a:latin typeface="나눔스퀘어 Bold" panose="020B0600000101010101" pitchFamily="50" charset="-127"/>
+                <a:ea typeface="나눔스퀘어 Bold" panose="020B0600000101010101" pitchFamily="50" charset="-127"/>
+              </a:rPr>
+              <a:t>스키마</a:t>
+            </a:r>
+            <a:endParaRPr lang="ko-KR" altLang="en-US" sz="4000" dirty="0">
+              <a:latin typeface="나눔스퀘어 Bold" panose="020B0600000101010101" pitchFamily="50" charset="-127"/>
+              <a:ea typeface="나눔스퀘어 Bold" panose="020B0600000101010101" pitchFamily="50" charset="-127"/>
+            </a:endParaRPr>
+          </a:p>
+        </p:txBody>
+      </p:sp>
+      <p:sp>
+        <p:nvSpPr>
+          <p:cNvPr id="298" name="직사각형 297"/>
+          <p:cNvSpPr/>
+          <p:nvPr/>
+        </p:nvSpPr>
+        <p:spPr>
+          <a:xfrm>
+            <a:off x="16795200" y="761999"/>
+            <a:ext cx="2880000" cy="1440000"/>
+          </a:xfrm>
+          <a:prstGeom prst="rect">
+            <a:avLst/>
+          </a:prstGeom>
+          <a:solidFill>
+            <a:schemeClr val="accent5"/>
+          </a:solidFill>
+          <a:ln>
+            <a:noFill/>
+          </a:ln>
+        </p:spPr>
+        <p:style>
+          <a:lnRef idx="2">
+            <a:schemeClr val="accent1">
+              <a:shade val="50000"/>
+            </a:schemeClr>
+          </a:lnRef>
+          <a:fillRef idx="1">
+            <a:schemeClr val="accent1"/>
+          </a:fillRef>
+          <a:effectRef idx="0">
+            <a:schemeClr val="accent1"/>
+          </a:effectRef>
+          <a:fontRef idx="minor">
+            <a:schemeClr val="lt1"/>
+          </a:fontRef>
+        </p:style>
+        <p:txBody>
+          <a:bodyPr rtlCol="0" anchor="ctr"/>
+          <a:lstStyle/>
+          <a:p>
+            <a:pPr algn="ctr"/>
+            <a:r>
+              <a:rPr lang="ko-KR" altLang="en-US" sz="4000" dirty="0" smtClean="0">
+                <a:latin typeface="나눔스퀘어 Bold" panose="020B0600000101010101" pitchFamily="50" charset="-127"/>
+                <a:ea typeface="나눔스퀘어 Bold" panose="020B0600000101010101" pitchFamily="50" charset="-127"/>
+              </a:rPr>
+              <a:t>기능 구현</a:t>
+            </a:r>
+            <a:endParaRPr lang="ko-KR" altLang="en-US" sz="4000" dirty="0">
+              <a:latin typeface="나눔스퀘어 Bold" panose="020B0600000101010101" pitchFamily="50" charset="-127"/>
+              <a:ea typeface="나눔스퀘어 Bold" panose="020B0600000101010101" pitchFamily="50" charset="-127"/>
+            </a:endParaRPr>
+          </a:p>
+        </p:txBody>
+      </p:sp>
+      <p:cxnSp>
+        <p:nvCxnSpPr>
+          <p:cNvPr id="300" name="직선 화살표 연결선 299"/>
+          <p:cNvCxnSpPr>
+            <a:stCxn id="273" idx="3"/>
+            <a:endCxn id="293" idx="1"/>
+          </p:cNvCxnSpPr>
+          <p:nvPr/>
+        </p:nvCxnSpPr>
+        <p:spPr>
+          <a:xfrm>
+            <a:off x="-3337200" y="1481999"/>
+            <a:ext cx="955400" cy="0"/>
+          </a:xfrm>
+          <a:prstGeom prst="straightConnector1">
+            <a:avLst/>
+          </a:prstGeom>
+          <a:ln w="76200">
             <a:solidFill>
-              <a:schemeClr val="accent5"/>
+              <a:schemeClr val="accent2"/>
             </a:solidFill>
-            <a:ln>
-              <a:noFill/>
-            </a:ln>
-          </p:spPr>
-          <p:style>
-            <a:lnRef idx="2">
-              <a:schemeClr val="accent1">
-                <a:shade val="50000"/>
-              </a:schemeClr>
-            </a:lnRef>
-            <a:fillRef idx="1">
-              <a:schemeClr val="accent1"/>
-            </a:fillRef>
-            <a:effectRef idx="0">
-              <a:schemeClr val="accent1"/>
-            </a:effectRef>
-            <a:fontRef idx="minor">
-              <a:schemeClr val="lt1"/>
-            </a:fontRef>
-          </p:style>
-          <p:txBody>
-            <a:bodyPr rtlCol="0" anchor="ctr"/>
-            <a:lstStyle/>
-            <a:p>
-              <a:pPr algn="ctr"/>
-              <a:r>
-                <a:rPr lang="ko-KR" altLang="en-US" sz="3600" dirty="0" smtClean="0">
-                  <a:latin typeface="나눔스퀘어 Bold" panose="020B0600000101010101" pitchFamily="50" charset="-127"/>
-                  <a:ea typeface="나눔스퀘어 Bold" panose="020B0600000101010101" pitchFamily="50" charset="-127"/>
-                </a:rPr>
-                <a:t>사용자</a:t>
-              </a:r>
-              <a:endParaRPr lang="en-US" altLang="ko-KR" sz="3600" dirty="0" smtClean="0">
-                <a:latin typeface="나눔스퀘어 Bold" panose="020B0600000101010101" pitchFamily="50" charset="-127"/>
-                <a:ea typeface="나눔스퀘어 Bold" panose="020B0600000101010101" pitchFamily="50" charset="-127"/>
-              </a:endParaRPr>
-            </a:p>
-            <a:p>
-              <a:pPr algn="ctr"/>
-              <a:r>
-                <a:rPr lang="ko-KR" altLang="en-US" sz="3600" dirty="0" smtClean="0">
-                  <a:latin typeface="나눔스퀘어 Bold" panose="020B0600000101010101" pitchFamily="50" charset="-127"/>
-                  <a:ea typeface="나눔스퀘어 Bold" panose="020B0600000101010101" pitchFamily="50" charset="-127"/>
-                </a:rPr>
-                <a:t>브라우저</a:t>
-              </a:r>
-              <a:endParaRPr lang="ko-KR" altLang="en-US" sz="3600" dirty="0">
-                <a:latin typeface="나눔스퀘어 Bold" panose="020B0600000101010101" pitchFamily="50" charset="-127"/>
-                <a:ea typeface="나눔스퀘어 Bold" panose="020B0600000101010101" pitchFamily="50" charset="-127"/>
-              </a:endParaRPr>
-            </a:p>
-          </p:txBody>
-        </p:sp>
-        <p:sp>
-          <p:nvSpPr>
-            <p:cNvPr id="8" name="직사각형 7"/>
-            <p:cNvSpPr/>
-            <p:nvPr/>
-          </p:nvSpPr>
-          <p:spPr>
-            <a:xfrm>
-              <a:off x="7788544" y="800100"/>
-              <a:ext cx="2160000" cy="1440000"/>
-            </a:xfrm>
-            <a:prstGeom prst="rect">
-              <a:avLst/>
-            </a:prstGeom>
+            <a:tailEnd type="triangle"/>
+          </a:ln>
+        </p:spPr>
+        <p:style>
+          <a:lnRef idx="1">
+            <a:schemeClr val="accent1"/>
+          </a:lnRef>
+          <a:fillRef idx="0">
+            <a:schemeClr val="accent1"/>
+          </a:fillRef>
+          <a:effectRef idx="0">
+            <a:schemeClr val="accent1"/>
+          </a:effectRef>
+          <a:fontRef idx="minor">
+            <a:schemeClr val="tx1"/>
+          </a:fontRef>
+        </p:style>
+      </p:cxnSp>
+      <p:cxnSp>
+        <p:nvCxnSpPr>
+          <p:cNvPr id="303" name="직선 화살표 연결선 302"/>
+          <p:cNvCxnSpPr>
+            <a:stCxn id="293" idx="3"/>
+            <a:endCxn id="294" idx="1"/>
+          </p:cNvCxnSpPr>
+          <p:nvPr/>
+        </p:nvCxnSpPr>
+        <p:spPr>
+          <a:xfrm>
+            <a:off x="498200" y="1481999"/>
+            <a:ext cx="955400" cy="0"/>
+          </a:xfrm>
+          <a:prstGeom prst="straightConnector1">
+            <a:avLst/>
+          </a:prstGeom>
+          <a:ln w="76200">
             <a:solidFill>
-              <a:schemeClr val="accent5"/>
+              <a:schemeClr val="accent2"/>
             </a:solidFill>
-            <a:ln>
-              <a:noFill/>
-            </a:ln>
-          </p:spPr>
-          <p:style>
-            <a:lnRef idx="2">
-              <a:schemeClr val="accent1">
-                <a:shade val="50000"/>
-              </a:schemeClr>
-            </a:lnRef>
-            <a:fillRef idx="1">
-              <a:schemeClr val="accent1"/>
-            </a:fillRef>
-            <a:effectRef idx="0">
-              <a:schemeClr val="accent1"/>
-            </a:effectRef>
-            <a:fontRef idx="minor">
-              <a:schemeClr val="lt1"/>
-            </a:fontRef>
-          </p:style>
-          <p:txBody>
-            <a:bodyPr rtlCol="0" anchor="ctr"/>
-            <a:lstStyle/>
-            <a:p>
-              <a:pPr algn="ctr"/>
-              <a:r>
-                <a:rPr lang="ko-KR" altLang="en-US" sz="3600" b="1" dirty="0" smtClean="0">
-                  <a:latin typeface="나눔스퀘어 Bold" panose="020B0600000101010101" pitchFamily="50" charset="-127"/>
-                  <a:ea typeface="나눔스퀘어 Bold" panose="020B0600000101010101" pitchFamily="50" charset="-127"/>
-                </a:rPr>
-                <a:t>사용자</a:t>
-              </a:r>
-              <a:endParaRPr lang="en-US" altLang="ko-KR" sz="3600" b="1" dirty="0" smtClean="0">
-                <a:latin typeface="나눔스퀘어 Bold" panose="020B0600000101010101" pitchFamily="50" charset="-127"/>
-                <a:ea typeface="나눔스퀘어 Bold" panose="020B0600000101010101" pitchFamily="50" charset="-127"/>
-              </a:endParaRPr>
-            </a:p>
-            <a:p>
-              <a:pPr algn="ctr"/>
-              <a:r>
-                <a:rPr lang="ko-KR" altLang="en-US" sz="3600" b="1" dirty="0" smtClean="0">
-                  <a:latin typeface="나눔스퀘어 Bold" panose="020B0600000101010101" pitchFamily="50" charset="-127"/>
-                  <a:ea typeface="나눔스퀘어 Bold" panose="020B0600000101010101" pitchFamily="50" charset="-127"/>
-                </a:rPr>
-                <a:t>브라우저</a:t>
-              </a:r>
-              <a:endParaRPr lang="ko-KR" altLang="en-US" sz="3600" b="1" dirty="0">
-                <a:latin typeface="나눔스퀘어 Bold" panose="020B0600000101010101" pitchFamily="50" charset="-127"/>
-                <a:ea typeface="나눔스퀘어 Bold" panose="020B0600000101010101" pitchFamily="50" charset="-127"/>
-              </a:endParaRPr>
-            </a:p>
-          </p:txBody>
-        </p:sp>
-        <p:sp>
-          <p:nvSpPr>
-            <p:cNvPr id="9" name="직사각형 8"/>
-            <p:cNvSpPr/>
-            <p:nvPr/>
-          </p:nvSpPr>
-          <p:spPr>
-            <a:xfrm>
-              <a:off x="12060745" y="800100"/>
-              <a:ext cx="2160000" cy="1440000"/>
-            </a:xfrm>
-            <a:prstGeom prst="rect">
-              <a:avLst/>
-            </a:prstGeom>
+            <a:tailEnd type="triangle"/>
+          </a:ln>
+        </p:spPr>
+        <p:style>
+          <a:lnRef idx="1">
+            <a:schemeClr val="accent1"/>
+          </a:lnRef>
+          <a:fillRef idx="0">
+            <a:schemeClr val="accent1"/>
+          </a:fillRef>
+          <a:effectRef idx="0">
+            <a:schemeClr val="accent1"/>
+          </a:effectRef>
+          <a:fontRef idx="minor">
+            <a:schemeClr val="tx1"/>
+          </a:fontRef>
+        </p:style>
+      </p:cxnSp>
+      <p:cxnSp>
+        <p:nvCxnSpPr>
+          <p:cNvPr id="307" name="직선 화살표 연결선 306"/>
+          <p:cNvCxnSpPr>
+            <a:stCxn id="294" idx="3"/>
+            <a:endCxn id="295" idx="1"/>
+          </p:cNvCxnSpPr>
+          <p:nvPr/>
+        </p:nvCxnSpPr>
+        <p:spPr>
+          <a:xfrm>
+            <a:off x="4333600" y="1481999"/>
+            <a:ext cx="955400" cy="0"/>
+          </a:xfrm>
+          <a:prstGeom prst="straightConnector1">
+            <a:avLst/>
+          </a:prstGeom>
+          <a:ln w="76200">
             <a:solidFill>
-              <a:schemeClr val="accent5"/>
+              <a:schemeClr val="accent2"/>
             </a:solidFill>
-            <a:ln>
-              <a:noFill/>
-            </a:ln>
-          </p:spPr>
-          <p:style>
-            <a:lnRef idx="2">
-              <a:schemeClr val="accent1">
-                <a:shade val="50000"/>
-              </a:schemeClr>
-            </a:lnRef>
-            <a:fillRef idx="1">
-              <a:schemeClr val="accent1"/>
-            </a:fillRef>
-            <a:effectRef idx="0">
-              <a:schemeClr val="accent1"/>
-            </a:effectRef>
-            <a:fontRef idx="minor">
-              <a:schemeClr val="lt1"/>
-            </a:fontRef>
-          </p:style>
-          <p:txBody>
-            <a:bodyPr rtlCol="0" anchor="ctr"/>
-            <a:lstStyle/>
-            <a:p>
-              <a:pPr algn="ctr"/>
-              <a:r>
-                <a:rPr lang="ko-KR" altLang="en-US" sz="3600" b="1" dirty="0" smtClean="0">
-                  <a:latin typeface="나눔스퀘어 Bold" panose="020B0600000101010101" pitchFamily="50" charset="-127"/>
-                  <a:ea typeface="나눔스퀘어 Bold" panose="020B0600000101010101" pitchFamily="50" charset="-127"/>
-                </a:rPr>
-                <a:t>화면</a:t>
-              </a:r>
-              <a:endParaRPr lang="en-US" altLang="ko-KR" sz="3600" b="1" dirty="0" smtClean="0">
-                <a:latin typeface="나눔스퀘어 Bold" panose="020B0600000101010101" pitchFamily="50" charset="-127"/>
-                <a:ea typeface="나눔스퀘어 Bold" panose="020B0600000101010101" pitchFamily="50" charset="-127"/>
-              </a:endParaRPr>
-            </a:p>
-            <a:p>
-              <a:pPr algn="ctr"/>
-              <a:r>
-                <a:rPr lang="ko-KR" altLang="en-US" sz="3600" b="1" dirty="0" smtClean="0">
-                  <a:latin typeface="나눔스퀘어 Bold" panose="020B0600000101010101" pitchFamily="50" charset="-127"/>
-                  <a:ea typeface="나눔스퀘어 Bold" panose="020B0600000101010101" pitchFamily="50" charset="-127"/>
-                </a:rPr>
-                <a:t>렌더링</a:t>
-              </a:r>
-              <a:endParaRPr lang="ko-KR" altLang="en-US" sz="3600" b="1" dirty="0">
-                <a:latin typeface="나눔스퀘어 Bold" panose="020B0600000101010101" pitchFamily="50" charset="-127"/>
-                <a:ea typeface="나눔스퀘어 Bold" panose="020B0600000101010101" pitchFamily="50" charset="-127"/>
-              </a:endParaRPr>
-            </a:p>
-          </p:txBody>
-        </p:sp>
-        <p:sp>
-          <p:nvSpPr>
-            <p:cNvPr id="10" name="직사각형 9"/>
-            <p:cNvSpPr/>
-            <p:nvPr/>
-          </p:nvSpPr>
-          <p:spPr>
-            <a:xfrm>
-              <a:off x="3958501" y="800100"/>
-              <a:ext cx="2160000" cy="1440000"/>
-            </a:xfrm>
-            <a:prstGeom prst="rect">
-              <a:avLst/>
-            </a:prstGeom>
+            <a:tailEnd type="triangle"/>
+          </a:ln>
+        </p:spPr>
+        <p:style>
+          <a:lnRef idx="1">
+            <a:schemeClr val="accent1"/>
+          </a:lnRef>
+          <a:fillRef idx="0">
+            <a:schemeClr val="accent1"/>
+          </a:fillRef>
+          <a:effectRef idx="0">
+            <a:schemeClr val="accent1"/>
+          </a:effectRef>
+          <a:fontRef idx="minor">
+            <a:schemeClr val="tx1"/>
+          </a:fontRef>
+        </p:style>
+      </p:cxnSp>
+      <p:cxnSp>
+        <p:nvCxnSpPr>
+          <p:cNvPr id="311" name="직선 화살표 연결선 310"/>
+          <p:cNvCxnSpPr>
+            <a:stCxn id="295" idx="3"/>
+            <a:endCxn id="296" idx="1"/>
+          </p:cNvCxnSpPr>
+          <p:nvPr/>
+        </p:nvCxnSpPr>
+        <p:spPr>
+          <a:xfrm>
+            <a:off x="8169000" y="1481999"/>
+            <a:ext cx="955400" cy="0"/>
+          </a:xfrm>
+          <a:prstGeom prst="straightConnector1">
+            <a:avLst/>
+          </a:prstGeom>
+          <a:ln w="76200">
             <a:solidFill>
-              <a:schemeClr val="accent5"/>
+              <a:schemeClr val="accent2"/>
             </a:solidFill>
-            <a:ln>
-              <a:noFill/>
-            </a:ln>
-          </p:spPr>
-          <p:style>
-            <a:lnRef idx="2">
-              <a:schemeClr val="accent1">
-                <a:shade val="50000"/>
-              </a:schemeClr>
-            </a:lnRef>
-            <a:fillRef idx="1">
-              <a:schemeClr val="accent1"/>
-            </a:fillRef>
-            <a:effectRef idx="0">
-              <a:schemeClr val="accent1"/>
-            </a:effectRef>
-            <a:fontRef idx="minor">
-              <a:schemeClr val="lt1"/>
-            </a:fontRef>
-          </p:style>
-          <p:txBody>
-            <a:bodyPr rtlCol="0" anchor="ctr"/>
-            <a:lstStyle/>
-            <a:p>
-              <a:pPr algn="ctr"/>
-              <a:r>
-                <a:rPr lang="ko-KR" altLang="en-US" sz="3600" b="1" dirty="0" smtClean="0">
-                  <a:latin typeface="나눔스퀘어 Bold" panose="020B0600000101010101" pitchFamily="50" charset="-127"/>
-                  <a:ea typeface="나눔스퀘어 Bold" panose="020B0600000101010101" pitchFamily="50" charset="-127"/>
-                </a:rPr>
-                <a:t>서버</a:t>
-              </a:r>
-              <a:endParaRPr lang="ko-KR" altLang="en-US" sz="3600" b="1" dirty="0">
-                <a:latin typeface="나눔스퀘어 Bold" panose="020B0600000101010101" pitchFamily="50" charset="-127"/>
-                <a:ea typeface="나눔스퀘어 Bold" panose="020B0600000101010101" pitchFamily="50" charset="-127"/>
-              </a:endParaRPr>
-            </a:p>
-          </p:txBody>
-        </p:sp>
-        <p:cxnSp>
-          <p:nvCxnSpPr>
-            <p:cNvPr id="12" name="직선 화살표 연결선 11"/>
-            <p:cNvCxnSpPr>
-              <a:stCxn id="6" idx="3"/>
-              <a:endCxn id="10" idx="1"/>
-            </p:cNvCxnSpPr>
-            <p:nvPr/>
-          </p:nvCxnSpPr>
-          <p:spPr>
-            <a:xfrm>
-              <a:off x="2850525" y="1520100"/>
-              <a:ext cx="1107976" cy="0"/>
-            </a:xfrm>
-            <a:prstGeom prst="straightConnector1">
-              <a:avLst/>
-            </a:prstGeom>
-            <a:ln w="76200">
-              <a:solidFill>
-                <a:schemeClr val="accent2"/>
-              </a:solidFill>
-              <a:tailEnd type="triangle"/>
-            </a:ln>
-          </p:spPr>
-          <p:style>
-            <a:lnRef idx="1">
-              <a:schemeClr val="accent1"/>
-            </a:lnRef>
-            <a:fillRef idx="0">
-              <a:schemeClr val="accent1"/>
-            </a:fillRef>
-            <a:effectRef idx="0">
-              <a:schemeClr val="accent1"/>
-            </a:effectRef>
-            <a:fontRef idx="minor">
-              <a:schemeClr val="tx1"/>
-            </a:fontRef>
-          </p:style>
-        </p:cxnSp>
-        <p:cxnSp>
-          <p:nvCxnSpPr>
-            <p:cNvPr id="14" name="직선 화살표 연결선 13"/>
-            <p:cNvCxnSpPr>
-              <a:stCxn id="10" idx="3"/>
-              <a:endCxn id="8" idx="1"/>
-            </p:cNvCxnSpPr>
-            <p:nvPr/>
-          </p:nvCxnSpPr>
-          <p:spPr>
-            <a:xfrm>
-              <a:off x="6118501" y="1520100"/>
-              <a:ext cx="1670043" cy="0"/>
-            </a:xfrm>
-            <a:prstGeom prst="straightConnector1">
-              <a:avLst/>
-            </a:prstGeom>
-            <a:ln w="76200">
-              <a:solidFill>
-                <a:schemeClr val="accent2"/>
-              </a:solidFill>
-              <a:tailEnd type="triangle"/>
-            </a:ln>
-          </p:spPr>
-          <p:style>
-            <a:lnRef idx="1">
-              <a:schemeClr val="accent1"/>
-            </a:lnRef>
-            <a:fillRef idx="0">
-              <a:schemeClr val="accent1"/>
-            </a:fillRef>
-            <a:effectRef idx="0">
-              <a:schemeClr val="accent1"/>
-            </a:effectRef>
-            <a:fontRef idx="minor">
-              <a:schemeClr val="tx1"/>
-            </a:fontRef>
-          </p:style>
-        </p:cxnSp>
-        <p:cxnSp>
-          <p:nvCxnSpPr>
-            <p:cNvPr id="15" name="직선 화살표 연결선 14"/>
-            <p:cNvCxnSpPr>
-              <a:stCxn id="8" idx="3"/>
-              <a:endCxn id="9" idx="1"/>
-            </p:cNvCxnSpPr>
-            <p:nvPr/>
-          </p:nvCxnSpPr>
-          <p:spPr>
-            <a:xfrm>
-              <a:off x="9948544" y="1520100"/>
-              <a:ext cx="2112201" cy="0"/>
-            </a:xfrm>
-            <a:prstGeom prst="straightConnector1">
-              <a:avLst/>
-            </a:prstGeom>
-            <a:ln w="76200">
-              <a:solidFill>
-                <a:schemeClr val="accent2"/>
-              </a:solidFill>
-              <a:tailEnd type="triangle"/>
-            </a:ln>
-          </p:spPr>
-          <p:style>
-            <a:lnRef idx="1">
-              <a:schemeClr val="accent1"/>
-            </a:lnRef>
-            <a:fillRef idx="0">
-              <a:schemeClr val="accent1"/>
-            </a:fillRef>
-            <a:effectRef idx="0">
-              <a:schemeClr val="accent1"/>
-            </a:effectRef>
-            <a:fontRef idx="minor">
-              <a:schemeClr val="tx1"/>
-            </a:fontRef>
-          </p:style>
-        </p:cxnSp>
-        <p:sp>
-          <p:nvSpPr>
-            <p:cNvPr id="20" name="TextBox 19"/>
-            <p:cNvSpPr txBox="1"/>
-            <p:nvPr/>
-          </p:nvSpPr>
-          <p:spPr>
-            <a:xfrm>
-              <a:off x="3078141" y="1119990"/>
-              <a:ext cx="652743" cy="400110"/>
-            </a:xfrm>
-            <a:prstGeom prst="rect">
-              <a:avLst/>
-            </a:prstGeom>
-            <a:noFill/>
-          </p:spPr>
-          <p:txBody>
-            <a:bodyPr wrap="none" rtlCol="0">
-              <a:spAutoFit/>
-            </a:bodyPr>
-            <a:lstStyle/>
-            <a:p>
-              <a:pPr algn="ctr"/>
-              <a:r>
-                <a:rPr lang="ko-KR" altLang="en-US" sz="2000" dirty="0" smtClean="0">
-                  <a:latin typeface="나눔스퀘어 Bold" panose="020B0600000101010101" pitchFamily="50" charset="-127"/>
-                  <a:ea typeface="나눔스퀘어 Bold" panose="020B0600000101010101" pitchFamily="50" charset="-127"/>
-                </a:rPr>
-                <a:t>요청</a:t>
-              </a:r>
-              <a:endParaRPr lang="ko-KR" altLang="en-US" sz="2000" dirty="0">
-                <a:latin typeface="나눔스퀘어 Bold" panose="020B0600000101010101" pitchFamily="50" charset="-127"/>
-                <a:ea typeface="나눔스퀘어 Bold" panose="020B0600000101010101" pitchFamily="50" charset="-127"/>
-              </a:endParaRPr>
-            </a:p>
-          </p:txBody>
-        </p:sp>
-        <p:sp>
-          <p:nvSpPr>
-            <p:cNvPr id="21" name="TextBox 20"/>
-            <p:cNvSpPr txBox="1"/>
-            <p:nvPr/>
-          </p:nvSpPr>
-          <p:spPr>
-            <a:xfrm>
-              <a:off x="6238422" y="1119990"/>
-              <a:ext cx="1430200" cy="400110"/>
-            </a:xfrm>
-            <a:prstGeom prst="rect">
-              <a:avLst/>
-            </a:prstGeom>
-            <a:noFill/>
-          </p:spPr>
-          <p:txBody>
-            <a:bodyPr wrap="none" rtlCol="0">
-              <a:spAutoFit/>
-            </a:bodyPr>
-            <a:lstStyle/>
-            <a:p>
-              <a:pPr algn="ctr"/>
-              <a:r>
-                <a:rPr lang="en-US" altLang="ko-KR" sz="2000" dirty="0" smtClean="0">
-                  <a:latin typeface="나눔스퀘어 Bold" panose="020B0600000101010101" pitchFamily="50" charset="-127"/>
-                  <a:ea typeface="나눔스퀘어 Bold" panose="020B0600000101010101" pitchFamily="50" charset="-127"/>
-                </a:rPr>
-                <a:t>HTML + JS</a:t>
-              </a:r>
-              <a:endParaRPr lang="ko-KR" altLang="en-US" sz="2000" dirty="0">
-                <a:latin typeface="나눔스퀘어 Bold" panose="020B0600000101010101" pitchFamily="50" charset="-127"/>
-                <a:ea typeface="나눔스퀘어 Bold" panose="020B0600000101010101" pitchFamily="50" charset="-127"/>
-              </a:endParaRPr>
-            </a:p>
-          </p:txBody>
-        </p:sp>
-        <p:sp>
-          <p:nvSpPr>
-            <p:cNvPr id="32" name="TextBox 31"/>
-            <p:cNvSpPr txBox="1"/>
-            <p:nvPr/>
-          </p:nvSpPr>
-          <p:spPr>
-            <a:xfrm>
-              <a:off x="10020240" y="1119990"/>
-              <a:ext cx="1968809" cy="400110"/>
-            </a:xfrm>
-            <a:prstGeom prst="rect">
-              <a:avLst/>
-            </a:prstGeom>
-            <a:noFill/>
-          </p:spPr>
-          <p:txBody>
-            <a:bodyPr wrap="none" rtlCol="0">
-              <a:spAutoFit/>
-            </a:bodyPr>
-            <a:lstStyle/>
-            <a:p>
-              <a:pPr algn="ctr"/>
-              <a:r>
-                <a:rPr lang="en-US" altLang="ko-KR" sz="2000" dirty="0" smtClean="0">
-                  <a:latin typeface="나눔스퀘어 Bold" panose="020B0600000101010101" pitchFamily="50" charset="-127"/>
-                  <a:ea typeface="나눔스퀘어 Bold" panose="020B0600000101010101" pitchFamily="50" charset="-127"/>
-                </a:rPr>
-                <a:t>JavaScript </a:t>
-              </a:r>
-              <a:r>
-                <a:rPr lang="ko-KR" altLang="en-US" sz="2000" dirty="0" smtClean="0">
-                  <a:latin typeface="나눔스퀘어 Bold" panose="020B0600000101010101" pitchFamily="50" charset="-127"/>
-                  <a:ea typeface="나눔스퀘어 Bold" panose="020B0600000101010101" pitchFamily="50" charset="-127"/>
-                </a:rPr>
-                <a:t>실행</a:t>
-              </a:r>
-              <a:endParaRPr lang="ko-KR" altLang="en-US" sz="2000" dirty="0">
-                <a:latin typeface="나눔스퀘어 Bold" panose="020B0600000101010101" pitchFamily="50" charset="-127"/>
-                <a:ea typeface="나눔스퀘어 Bold" panose="020B0600000101010101" pitchFamily="50" charset="-127"/>
-              </a:endParaRPr>
-            </a:p>
-          </p:txBody>
-        </p:sp>
-      </p:grpSp>
+            <a:tailEnd type="triangle"/>
+          </a:ln>
+        </p:spPr>
+        <p:style>
+          <a:lnRef idx="1">
+            <a:schemeClr val="accent1"/>
+          </a:lnRef>
+          <a:fillRef idx="0">
+            <a:schemeClr val="accent1"/>
+          </a:fillRef>
+          <a:effectRef idx="0">
+            <a:schemeClr val="accent1"/>
+          </a:effectRef>
+          <a:fontRef idx="minor">
+            <a:schemeClr val="tx1"/>
+          </a:fontRef>
+        </p:style>
+      </p:cxnSp>
+      <p:cxnSp>
+        <p:nvCxnSpPr>
+          <p:cNvPr id="314" name="직선 화살표 연결선 313"/>
+          <p:cNvCxnSpPr>
+            <a:stCxn id="296" idx="3"/>
+            <a:endCxn id="297" idx="1"/>
+          </p:cNvCxnSpPr>
+          <p:nvPr/>
+        </p:nvCxnSpPr>
+        <p:spPr>
+          <a:xfrm>
+            <a:off x="12004400" y="1481999"/>
+            <a:ext cx="955400" cy="0"/>
+          </a:xfrm>
+          <a:prstGeom prst="straightConnector1">
+            <a:avLst/>
+          </a:prstGeom>
+          <a:ln w="76200">
+            <a:solidFill>
+              <a:schemeClr val="accent2"/>
+            </a:solidFill>
+            <a:tailEnd type="triangle"/>
+          </a:ln>
+        </p:spPr>
+        <p:style>
+          <a:lnRef idx="1">
+            <a:schemeClr val="accent1"/>
+          </a:lnRef>
+          <a:fillRef idx="0">
+            <a:schemeClr val="accent1"/>
+          </a:fillRef>
+          <a:effectRef idx="0">
+            <a:schemeClr val="accent1"/>
+          </a:effectRef>
+          <a:fontRef idx="minor">
+            <a:schemeClr val="tx1"/>
+          </a:fontRef>
+        </p:style>
+      </p:cxnSp>
+      <p:cxnSp>
+        <p:nvCxnSpPr>
+          <p:cNvPr id="318" name="직선 화살표 연결선 317"/>
+          <p:cNvCxnSpPr>
+            <a:stCxn id="297" idx="3"/>
+            <a:endCxn id="298" idx="1"/>
+          </p:cNvCxnSpPr>
+          <p:nvPr/>
+        </p:nvCxnSpPr>
+        <p:spPr>
+          <a:xfrm>
+            <a:off x="15839800" y="1481999"/>
+            <a:ext cx="955400" cy="0"/>
+          </a:xfrm>
+          <a:prstGeom prst="straightConnector1">
+            <a:avLst/>
+          </a:prstGeom>
+          <a:ln w="76200">
+            <a:solidFill>
+              <a:schemeClr val="accent2"/>
+            </a:solidFill>
+            <a:tailEnd type="triangle"/>
+          </a:ln>
+        </p:spPr>
+        <p:style>
+          <a:lnRef idx="1">
+            <a:schemeClr val="accent1"/>
+          </a:lnRef>
+          <a:fillRef idx="0">
+            <a:schemeClr val="accent1"/>
+          </a:fillRef>
+          <a:effectRef idx="0">
+            <a:schemeClr val="accent1"/>
+          </a:effectRef>
+          <a:fontRef idx="minor">
+            <a:schemeClr val="tx1"/>
+          </a:fontRef>
+        </p:style>
+      </p:cxnSp>
     </p:spTree>
     <p:extLst>
       <p:ext uri="{BB962C8B-B14F-4D97-AF65-F5344CB8AC3E}">

</xml_diff>

<commit_message>
20260901 commit : Notion rest, At Home
</commit_message>
<xml_diff>
--- a/notion/create_notion_img.pptx
+++ b/notion/create_notion_img.pptx
@@ -245,7 +245,7 @@
           <a:p>
             <a:fld id="{7237CE1A-8831-48B5-BA93-72483C6E34E8}" type="datetimeFigureOut">
               <a:rPr lang="ko-KR" altLang="en-US" smtClean="0"/>
-              <a:t>2026-08-31</a:t>
+              <a:t>2026-09-01</a:t>
             </a:fld>
             <a:endParaRPr lang="ko-KR" altLang="en-US"/>
           </a:p>
@@ -415,7 +415,7 @@
           <a:p>
             <a:fld id="{7237CE1A-8831-48B5-BA93-72483C6E34E8}" type="datetimeFigureOut">
               <a:rPr lang="ko-KR" altLang="en-US" smtClean="0"/>
-              <a:t>2026-08-31</a:t>
+              <a:t>2026-09-01</a:t>
             </a:fld>
             <a:endParaRPr lang="ko-KR" altLang="en-US"/>
           </a:p>
@@ -595,7 +595,7 @@
           <a:p>
             <a:fld id="{7237CE1A-8831-48B5-BA93-72483C6E34E8}" type="datetimeFigureOut">
               <a:rPr lang="ko-KR" altLang="en-US" smtClean="0"/>
-              <a:t>2026-08-31</a:t>
+              <a:t>2026-09-01</a:t>
             </a:fld>
             <a:endParaRPr lang="ko-KR" altLang="en-US"/>
           </a:p>
@@ -765,7 +765,7 @@
           <a:p>
             <a:fld id="{7237CE1A-8831-48B5-BA93-72483C6E34E8}" type="datetimeFigureOut">
               <a:rPr lang="ko-KR" altLang="en-US" smtClean="0"/>
-              <a:t>2026-08-31</a:t>
+              <a:t>2026-09-01</a:t>
             </a:fld>
             <a:endParaRPr lang="ko-KR" altLang="en-US"/>
           </a:p>
@@ -1011,7 +1011,7 @@
           <a:p>
             <a:fld id="{7237CE1A-8831-48B5-BA93-72483C6E34E8}" type="datetimeFigureOut">
               <a:rPr lang="ko-KR" altLang="en-US" smtClean="0"/>
-              <a:t>2026-08-31</a:t>
+              <a:t>2026-09-01</a:t>
             </a:fld>
             <a:endParaRPr lang="ko-KR" altLang="en-US"/>
           </a:p>
@@ -1243,7 +1243,7 @@
           <a:p>
             <a:fld id="{7237CE1A-8831-48B5-BA93-72483C6E34E8}" type="datetimeFigureOut">
               <a:rPr lang="ko-KR" altLang="en-US" smtClean="0"/>
-              <a:t>2026-08-31</a:t>
+              <a:t>2026-09-01</a:t>
             </a:fld>
             <a:endParaRPr lang="ko-KR" altLang="en-US"/>
           </a:p>
@@ -1610,7 +1610,7 @@
           <a:p>
             <a:fld id="{7237CE1A-8831-48B5-BA93-72483C6E34E8}" type="datetimeFigureOut">
               <a:rPr lang="ko-KR" altLang="en-US" smtClean="0"/>
-              <a:t>2026-08-31</a:t>
+              <a:t>2026-09-01</a:t>
             </a:fld>
             <a:endParaRPr lang="ko-KR" altLang="en-US"/>
           </a:p>
@@ -1728,7 +1728,7 @@
           <a:p>
             <a:fld id="{7237CE1A-8831-48B5-BA93-72483C6E34E8}" type="datetimeFigureOut">
               <a:rPr lang="ko-KR" altLang="en-US" smtClean="0"/>
-              <a:t>2026-08-31</a:t>
+              <a:t>2026-09-01</a:t>
             </a:fld>
             <a:endParaRPr lang="ko-KR" altLang="en-US"/>
           </a:p>
@@ -1823,7 +1823,7 @@
           <a:p>
             <a:fld id="{7237CE1A-8831-48B5-BA93-72483C6E34E8}" type="datetimeFigureOut">
               <a:rPr lang="ko-KR" altLang="en-US" smtClean="0"/>
-              <a:t>2026-08-31</a:t>
+              <a:t>2026-09-01</a:t>
             </a:fld>
             <a:endParaRPr lang="ko-KR" altLang="en-US"/>
           </a:p>
@@ -2100,7 +2100,7 @@
           <a:p>
             <a:fld id="{7237CE1A-8831-48B5-BA93-72483C6E34E8}" type="datetimeFigureOut">
               <a:rPr lang="ko-KR" altLang="en-US" smtClean="0"/>
-              <a:t>2026-08-31</a:t>
+              <a:t>2026-09-01</a:t>
             </a:fld>
             <a:endParaRPr lang="ko-KR" altLang="en-US"/>
           </a:p>
@@ -2353,7 +2353,7 @@
           <a:p>
             <a:fld id="{7237CE1A-8831-48B5-BA93-72483C6E34E8}" type="datetimeFigureOut">
               <a:rPr lang="ko-KR" altLang="en-US" smtClean="0"/>
-              <a:t>2026-08-31</a:t>
+              <a:t>2026-09-01</a:t>
             </a:fld>
             <a:endParaRPr lang="ko-KR" altLang="en-US"/>
           </a:p>
@@ -2566,7 +2566,7 @@
           <a:p>
             <a:fld id="{7237CE1A-8831-48B5-BA93-72483C6E34E8}" type="datetimeFigureOut">
               <a:rPr lang="ko-KR" altLang="en-US" smtClean="0"/>
-              <a:t>2026-08-31</a:t>
+              <a:t>2026-09-01</a:t>
             </a:fld>
             <a:endParaRPr lang="ko-KR" altLang="en-US"/>
           </a:p>
@@ -2973,20 +2973,22 @@
       </p:grpSpPr>
       <p:sp>
         <p:nvSpPr>
-          <p:cNvPr id="273" name="직사각형 272"/>
+          <p:cNvPr id="20" name="직사각형 19"/>
           <p:cNvSpPr/>
           <p:nvPr/>
         </p:nvSpPr>
         <p:spPr>
           <a:xfrm>
-            <a:off x="-6217200" y="761999"/>
-            <a:ext cx="2880000" cy="1440000"/>
+            <a:off x="-1277100" y="1139100"/>
+            <a:ext cx="14760000" cy="1980000"/>
           </a:xfrm>
           <a:prstGeom prst="rect">
             <a:avLst/>
           </a:prstGeom>
           <a:solidFill>
-            <a:schemeClr val="accent5"/>
+            <a:schemeClr val="bg1">
+              <a:lumMod val="95000"/>
+            </a:schemeClr>
           </a:solidFill>
           <a:ln>
             <a:noFill/>
@@ -3013,14 +3015,7 @@
           <a:lstStyle/>
           <a:p>
             <a:pPr algn="ctr"/>
-            <a:r>
-              <a:rPr lang="ko-KR" altLang="en-US" sz="4000" dirty="0" smtClean="0">
-                <a:latin typeface="나눔스퀘어 Bold" panose="020B0600000101010101" pitchFamily="50" charset="-127"/>
-                <a:ea typeface="나눔스퀘어 Bold" panose="020B0600000101010101" pitchFamily="50" charset="-127"/>
-              </a:rPr>
-              <a:t>협업</a:t>
-            </a:r>
-            <a:endParaRPr lang="ko-KR" altLang="en-US" sz="4000" dirty="0">
+            <a:endParaRPr lang="ko-KR" altLang="en-US" sz="2800">
               <a:latin typeface="나눔스퀘어 Bold" panose="020B0600000101010101" pitchFamily="50" charset="-127"/>
               <a:ea typeface="나눔스퀘어 Bold" panose="020B0600000101010101" pitchFamily="50" charset="-127"/>
             </a:endParaRPr>
@@ -3029,14 +3024,14 @@
       </p:sp>
       <p:sp>
         <p:nvSpPr>
-          <p:cNvPr id="293" name="직사각형 292"/>
+          <p:cNvPr id="22" name="직사각형 21"/>
           <p:cNvSpPr/>
           <p:nvPr/>
         </p:nvSpPr>
         <p:spPr>
           <a:xfrm>
-            <a:off x="-2381800" y="761999"/>
-            <a:ext cx="2880000" cy="1440000"/>
+            <a:off x="4662900" y="664800"/>
+            <a:ext cx="2880000" cy="720000"/>
           </a:xfrm>
           <a:prstGeom prst="rect">
             <a:avLst/>
@@ -3070,575 +3065,488 @@
           <a:p>
             <a:pPr algn="ctr"/>
             <a:r>
-              <a:rPr lang="ko-KR" altLang="en-US" sz="4000" dirty="0" smtClean="0">
+              <a:rPr lang="en-US" altLang="ko-KR" sz="2800" dirty="0" smtClean="0">
                 <a:latin typeface="나눔스퀘어 Bold" panose="020B0600000101010101" pitchFamily="50" charset="-127"/>
                 <a:ea typeface="나눔스퀘어 Bold" panose="020B0600000101010101" pitchFamily="50" charset="-127"/>
               </a:rPr>
-              <a:t>기획</a:t>
-            </a:r>
-            <a:endParaRPr lang="ko-KR" altLang="en-US" sz="4000" dirty="0">
+              <a:t>[ Member ]</a:t>
+            </a:r>
+            <a:endParaRPr lang="ko-KR" altLang="en-US" sz="2800" dirty="0">
               <a:latin typeface="나눔스퀘어 Bold" panose="020B0600000101010101" pitchFamily="50" charset="-127"/>
               <a:ea typeface="나눔스퀘어 Bold" panose="020B0600000101010101" pitchFamily="50" charset="-127"/>
             </a:endParaRPr>
           </a:p>
         </p:txBody>
       </p:sp>
-      <p:sp>
-        <p:nvSpPr>
-          <p:cNvPr id="294" name="직사각형 293"/>
-          <p:cNvSpPr/>
-          <p:nvPr/>
-        </p:nvSpPr>
-        <p:spPr>
-          <a:xfrm>
-            <a:off x="1453600" y="761999"/>
-            <a:ext cx="2880000" cy="1440000"/>
-          </a:xfrm>
-          <a:prstGeom prst="rect">
-            <a:avLst/>
-          </a:prstGeom>
-          <a:solidFill>
-            <a:schemeClr val="accent5"/>
-          </a:solidFill>
-          <a:ln>
-            <a:noFill/>
-          </a:ln>
-        </p:spPr>
-        <p:style>
-          <a:lnRef idx="2">
-            <a:schemeClr val="accent1">
-              <a:shade val="50000"/>
-            </a:schemeClr>
-          </a:lnRef>
-          <a:fillRef idx="1">
-            <a:schemeClr val="accent1"/>
-          </a:fillRef>
-          <a:effectRef idx="0">
-            <a:schemeClr val="accent1"/>
-          </a:effectRef>
-          <a:fontRef idx="minor">
-            <a:schemeClr val="lt1"/>
-          </a:fontRef>
-        </p:style>
-        <p:txBody>
-          <a:bodyPr rtlCol="0" anchor="ctr"/>
-          <a:lstStyle/>
-          <a:p>
-            <a:pPr algn="ctr"/>
-            <a:r>
-              <a:rPr lang="ko-KR" altLang="en-US" sz="4000" dirty="0" smtClean="0">
+      <p:grpSp>
+        <p:nvGrpSpPr>
+          <p:cNvPr id="31" name="그룹 30"/>
+          <p:cNvGrpSpPr/>
+          <p:nvPr/>
+        </p:nvGrpSpPr>
+        <p:grpSpPr>
+          <a:xfrm>
+            <a:off x="-1028298" y="1561500"/>
+            <a:ext cx="14262395" cy="1440000"/>
+            <a:chOff x="-1028298" y="1409100"/>
+            <a:chExt cx="14262395" cy="1440000"/>
+          </a:xfrm>
+        </p:grpSpPr>
+        <p:sp>
+          <p:nvSpPr>
+            <p:cNvPr id="23" name="직사각형 22"/>
+            <p:cNvSpPr/>
+            <p:nvPr/>
+          </p:nvSpPr>
+          <p:spPr>
+            <a:xfrm>
+              <a:off x="-1028298" y="1409100"/>
+              <a:ext cx="2880000" cy="1440000"/>
+            </a:xfrm>
+            <a:prstGeom prst="rect">
+              <a:avLst/>
+            </a:prstGeom>
+            <a:solidFill>
+              <a:schemeClr val="bg1">
+                <a:lumMod val="85000"/>
+              </a:schemeClr>
+            </a:solidFill>
+            <a:ln>
+              <a:noFill/>
+            </a:ln>
+          </p:spPr>
+          <p:style>
+            <a:lnRef idx="2">
+              <a:schemeClr val="accent1">
+                <a:shade val="50000"/>
+              </a:schemeClr>
+            </a:lnRef>
+            <a:fillRef idx="1">
+              <a:schemeClr val="accent1"/>
+            </a:fillRef>
+            <a:effectRef idx="0">
+              <a:schemeClr val="accent1"/>
+            </a:effectRef>
+            <a:fontRef idx="minor">
+              <a:schemeClr val="lt1"/>
+            </a:fontRef>
+          </p:style>
+          <p:txBody>
+            <a:bodyPr rtlCol="0" anchor="ctr"/>
+            <a:lstStyle/>
+            <a:p>
+              <a:pPr algn="ctr"/>
+              <a:r>
+                <a:rPr lang="en-US" altLang="ko-KR" sz="2800" dirty="0">
+                  <a:solidFill>
+                    <a:schemeClr val="tx1"/>
+                  </a:solidFill>
+                  <a:latin typeface="나눔스퀘어 Bold" panose="020B0600000101010101" pitchFamily="50" charset="-127"/>
+                  <a:ea typeface="나눔스퀘어 Bold" panose="020B0600000101010101" pitchFamily="50" charset="-127"/>
+                </a:rPr>
+                <a:t>ID = 1</a:t>
+              </a:r>
+            </a:p>
+            <a:p>
+              <a:pPr algn="ctr"/>
+              <a:r>
+                <a:rPr lang="en-US" altLang="ko-KR" sz="2800" dirty="0">
+                  <a:solidFill>
+                    <a:schemeClr val="tx1"/>
+                  </a:solidFill>
+                  <a:latin typeface="나눔스퀘어 Bold" panose="020B0600000101010101" pitchFamily="50" charset="-127"/>
+                  <a:ea typeface="나눔스퀘어 Bold" panose="020B0600000101010101" pitchFamily="50" charset="-127"/>
+                </a:rPr>
+                <a:t>Name = </a:t>
+              </a:r>
+              <a:r>
+                <a:rPr lang="ko-KR" altLang="en-US" sz="2800" dirty="0">
+                  <a:solidFill>
+                    <a:schemeClr val="tx1"/>
+                  </a:solidFill>
+                  <a:latin typeface="나눔스퀘어 Bold" panose="020B0600000101010101" pitchFamily="50" charset="-127"/>
+                  <a:ea typeface="나눔스퀘어 Bold" panose="020B0600000101010101" pitchFamily="50" charset="-127"/>
+                </a:rPr>
+                <a:t>홍길동</a:t>
+              </a:r>
+            </a:p>
+          </p:txBody>
+        </p:sp>
+        <p:sp>
+          <p:nvSpPr>
+            <p:cNvPr id="38" name="직사각형 37"/>
+            <p:cNvSpPr/>
+            <p:nvPr/>
+          </p:nvSpPr>
+          <p:spPr>
+            <a:xfrm>
+              <a:off x="4089497" y="1409100"/>
+              <a:ext cx="2880000" cy="1440000"/>
+            </a:xfrm>
+            <a:prstGeom prst="rect">
+              <a:avLst/>
+            </a:prstGeom>
+            <a:solidFill>
+              <a:schemeClr val="bg1">
+                <a:lumMod val="85000"/>
+              </a:schemeClr>
+            </a:solidFill>
+            <a:ln>
+              <a:noFill/>
+            </a:ln>
+          </p:spPr>
+          <p:style>
+            <a:lnRef idx="2">
+              <a:schemeClr val="accent1">
+                <a:shade val="50000"/>
+              </a:schemeClr>
+            </a:lnRef>
+            <a:fillRef idx="1">
+              <a:schemeClr val="accent1"/>
+            </a:fillRef>
+            <a:effectRef idx="0">
+              <a:schemeClr val="accent1"/>
+            </a:effectRef>
+            <a:fontRef idx="minor">
+              <a:schemeClr val="lt1"/>
+            </a:fontRef>
+          </p:style>
+          <p:txBody>
+            <a:bodyPr rtlCol="0" anchor="ctr"/>
+            <a:lstStyle/>
+            <a:p>
+              <a:pPr algn="ctr"/>
+              <a:r>
+                <a:rPr lang="en-US" altLang="ko-KR" sz="2800" dirty="0">
+                  <a:solidFill>
+                    <a:schemeClr val="tx1"/>
+                  </a:solidFill>
+                  <a:latin typeface="나눔스퀘어 Bold" panose="020B0600000101010101" pitchFamily="50" charset="-127"/>
+                  <a:ea typeface="나눔스퀘어 Bold" panose="020B0600000101010101" pitchFamily="50" charset="-127"/>
+                </a:rPr>
+                <a:t>ID = 1</a:t>
+              </a:r>
+            </a:p>
+            <a:p>
+              <a:pPr algn="ctr"/>
+              <a:r>
+                <a:rPr lang="en-US" altLang="ko-KR" sz="2800" dirty="0">
+                  <a:solidFill>
+                    <a:schemeClr val="tx1"/>
+                  </a:solidFill>
+                  <a:latin typeface="나눔스퀘어 Bold" panose="020B0600000101010101" pitchFamily="50" charset="-127"/>
+                  <a:ea typeface="나눔스퀘어 Bold" panose="020B0600000101010101" pitchFamily="50" charset="-127"/>
+                </a:rPr>
+                <a:t>Name = </a:t>
+              </a:r>
+              <a:r>
+                <a:rPr lang="ko-KR" altLang="en-US" sz="2800" dirty="0">
+                  <a:solidFill>
+                    <a:schemeClr val="tx1"/>
+                  </a:solidFill>
+                  <a:latin typeface="나눔스퀘어 Bold" panose="020B0600000101010101" pitchFamily="50" charset="-127"/>
+                  <a:ea typeface="나눔스퀘어 Bold" panose="020B0600000101010101" pitchFamily="50" charset="-127"/>
+                </a:rPr>
+                <a:t>김철수</a:t>
+              </a:r>
+            </a:p>
+          </p:txBody>
+        </p:sp>
+        <p:sp>
+          <p:nvSpPr>
+            <p:cNvPr id="39" name="직사각형 38"/>
+            <p:cNvSpPr/>
+            <p:nvPr/>
+          </p:nvSpPr>
+          <p:spPr>
+            <a:xfrm>
+              <a:off x="7941797" y="1409100"/>
+              <a:ext cx="2160000" cy="1440000"/>
+            </a:xfrm>
+            <a:prstGeom prst="rect">
+              <a:avLst/>
+            </a:prstGeom>
+            <a:solidFill>
+              <a:schemeClr val="bg1">
+                <a:lumMod val="85000"/>
+              </a:schemeClr>
+            </a:solidFill>
+            <a:ln>
+              <a:noFill/>
+            </a:ln>
+          </p:spPr>
+          <p:style>
+            <a:lnRef idx="2">
+              <a:schemeClr val="accent1">
+                <a:shade val="50000"/>
+              </a:schemeClr>
+            </a:lnRef>
+            <a:fillRef idx="1">
+              <a:schemeClr val="accent1"/>
+            </a:fillRef>
+            <a:effectRef idx="0">
+              <a:schemeClr val="accent1"/>
+            </a:effectRef>
+            <a:fontRef idx="minor">
+              <a:schemeClr val="lt1"/>
+            </a:fontRef>
+          </p:style>
+          <p:txBody>
+            <a:bodyPr rtlCol="0" anchor="ctr"/>
+            <a:lstStyle/>
+            <a:p>
+              <a:pPr algn="ctr"/>
+              <a:r>
+                <a:rPr lang="en-US" altLang="ko-KR" sz="2800" dirty="0">
+                  <a:solidFill>
+                    <a:schemeClr val="tx1"/>
+                  </a:solidFill>
+                  <a:latin typeface="나눔스퀘어 Bold" panose="020B0600000101010101" pitchFamily="50" charset="-127"/>
+                  <a:ea typeface="나눔스퀘어 Bold" panose="020B0600000101010101" pitchFamily="50" charset="-127"/>
+                </a:rPr>
+                <a:t>ID</a:t>
+              </a:r>
+              <a:r>
+                <a:rPr lang="ko-KR" altLang="en-US" sz="2800" dirty="0">
+                  <a:solidFill>
+                    <a:schemeClr val="tx1"/>
+                  </a:solidFill>
+                  <a:latin typeface="나눔스퀘어 Bold" panose="020B0600000101010101" pitchFamily="50" charset="-127"/>
+                  <a:ea typeface="나눔스퀘어 Bold" panose="020B0600000101010101" pitchFamily="50" charset="-127"/>
+                </a:rPr>
+                <a:t>가 동일</a:t>
+              </a:r>
+            </a:p>
+          </p:txBody>
+        </p:sp>
+        <p:sp>
+          <p:nvSpPr>
+            <p:cNvPr id="40" name="직사각형 39"/>
+            <p:cNvSpPr/>
+            <p:nvPr/>
+          </p:nvSpPr>
+          <p:spPr>
+            <a:xfrm>
+              <a:off x="11074097" y="1409100"/>
+              <a:ext cx="2160000" cy="1440000"/>
+            </a:xfrm>
+            <a:prstGeom prst="rect">
+              <a:avLst/>
+            </a:prstGeom>
+            <a:solidFill>
+              <a:schemeClr val="bg1">
+                <a:lumMod val="85000"/>
+              </a:schemeClr>
+            </a:solidFill>
+            <a:ln>
+              <a:noFill/>
+            </a:ln>
+          </p:spPr>
+          <p:style>
+            <a:lnRef idx="2">
+              <a:schemeClr val="accent1">
+                <a:shade val="50000"/>
+              </a:schemeClr>
+            </a:lnRef>
+            <a:fillRef idx="1">
+              <a:schemeClr val="accent1"/>
+            </a:fillRef>
+            <a:effectRef idx="0">
+              <a:schemeClr val="accent1"/>
+            </a:effectRef>
+            <a:fontRef idx="minor">
+              <a:schemeClr val="lt1"/>
+            </a:fontRef>
+          </p:style>
+          <p:txBody>
+            <a:bodyPr rtlCol="0" anchor="ctr"/>
+            <a:lstStyle/>
+            <a:p>
+              <a:pPr algn="ctr"/>
+              <a:r>
+                <a:rPr lang="ko-KR" altLang="en-US" sz="2800" dirty="0">
+                  <a:solidFill>
+                    <a:schemeClr val="tx1"/>
+                  </a:solidFill>
+                  <a:latin typeface="나눔스퀘어 Bold" panose="020B0600000101010101" pitchFamily="50" charset="-127"/>
+                  <a:ea typeface="나눔스퀘어 Bold" panose="020B0600000101010101" pitchFamily="50" charset="-127"/>
+                </a:rPr>
+                <a:t>같은 </a:t>
+              </a:r>
+              <a:r>
+                <a:rPr lang="en-US" altLang="ko-KR" sz="2800" dirty="0">
+                  <a:solidFill>
+                    <a:schemeClr val="tx1"/>
+                  </a:solidFill>
+                  <a:latin typeface="나눔스퀘어 Bold" panose="020B0600000101010101" pitchFamily="50" charset="-127"/>
+                  <a:ea typeface="나눔스퀘어 Bold" panose="020B0600000101010101" pitchFamily="50" charset="-127"/>
+                </a:rPr>
+                <a:t>Entity</a:t>
+              </a:r>
+              <a:endParaRPr lang="ko-KR" altLang="en-US" sz="2800" dirty="0">
+                <a:solidFill>
+                  <a:schemeClr val="tx1"/>
+                </a:solidFill>
                 <a:latin typeface="나눔스퀘어 Bold" panose="020B0600000101010101" pitchFamily="50" charset="-127"/>
                 <a:ea typeface="나눔스퀘어 Bold" panose="020B0600000101010101" pitchFamily="50" charset="-127"/>
-              </a:rPr>
-              <a:t>요구사항</a:t>
-            </a:r>
-            <a:endParaRPr lang="en-US" altLang="ko-KR" sz="4000" dirty="0" smtClean="0">
-              <a:latin typeface="나눔스퀘어 Bold" panose="020B0600000101010101" pitchFamily="50" charset="-127"/>
-              <a:ea typeface="나눔스퀘어 Bold" panose="020B0600000101010101" pitchFamily="50" charset="-127"/>
-            </a:endParaRPr>
-          </a:p>
-          <a:p>
-            <a:pPr algn="ctr"/>
-            <a:r>
-              <a:rPr lang="ko-KR" altLang="en-US" sz="4000" dirty="0" smtClean="0">
-                <a:latin typeface="나눔스퀘어 Bold" panose="020B0600000101010101" pitchFamily="50" charset="-127"/>
-                <a:ea typeface="나눔스퀘어 Bold" panose="020B0600000101010101" pitchFamily="50" charset="-127"/>
-              </a:rPr>
-              <a:t>명세서</a:t>
-            </a:r>
-            <a:endParaRPr lang="ko-KR" altLang="en-US" sz="4000" dirty="0">
-              <a:latin typeface="나눔스퀘어 Bold" panose="020B0600000101010101" pitchFamily="50" charset="-127"/>
-              <a:ea typeface="나눔스퀘어 Bold" panose="020B0600000101010101" pitchFamily="50" charset="-127"/>
-            </a:endParaRPr>
-          </a:p>
-        </p:txBody>
-      </p:sp>
-      <p:sp>
-        <p:nvSpPr>
-          <p:cNvPr id="295" name="직사각형 294"/>
-          <p:cNvSpPr/>
-          <p:nvPr/>
-        </p:nvSpPr>
-        <p:spPr>
-          <a:xfrm>
-            <a:off x="5289000" y="761999"/>
-            <a:ext cx="2880000" cy="1440000"/>
-          </a:xfrm>
-          <a:prstGeom prst="rect">
-            <a:avLst/>
-          </a:prstGeom>
-          <a:solidFill>
-            <a:schemeClr val="accent5"/>
-          </a:solidFill>
-          <a:ln>
-            <a:noFill/>
-          </a:ln>
-        </p:spPr>
-        <p:style>
-          <a:lnRef idx="2">
-            <a:schemeClr val="accent1">
-              <a:shade val="50000"/>
-            </a:schemeClr>
-          </a:lnRef>
-          <a:fillRef idx="1">
-            <a:schemeClr val="accent1"/>
-          </a:fillRef>
-          <a:effectRef idx="0">
-            <a:schemeClr val="accent1"/>
-          </a:effectRef>
-          <a:fontRef idx="minor">
-            <a:schemeClr val="lt1"/>
-          </a:fontRef>
-        </p:style>
-        <p:txBody>
-          <a:bodyPr rtlCol="0" anchor="ctr"/>
-          <a:lstStyle/>
-          <a:p>
-            <a:pPr algn="ctr"/>
-            <a:r>
-              <a:rPr lang="ko-KR" altLang="en-US" sz="4000" dirty="0" smtClean="0">
-                <a:latin typeface="나눔스퀘어 Bold" panose="020B0600000101010101" pitchFamily="50" charset="-127"/>
-                <a:ea typeface="나눔스퀘어 Bold" panose="020B0600000101010101" pitchFamily="50" charset="-127"/>
-              </a:rPr>
-              <a:t>기능</a:t>
-            </a:r>
-            <a:endParaRPr lang="en-US" altLang="ko-KR" sz="4000" dirty="0" smtClean="0">
-              <a:latin typeface="나눔스퀘어 Bold" panose="020B0600000101010101" pitchFamily="50" charset="-127"/>
-              <a:ea typeface="나눔스퀘어 Bold" panose="020B0600000101010101" pitchFamily="50" charset="-127"/>
-            </a:endParaRPr>
-          </a:p>
-          <a:p>
-            <a:pPr algn="ctr"/>
-            <a:r>
-              <a:rPr lang="ko-KR" altLang="en-US" sz="4000" dirty="0" smtClean="0">
-                <a:latin typeface="나눔스퀘어 Bold" panose="020B0600000101010101" pitchFamily="50" charset="-127"/>
-                <a:ea typeface="나눔스퀘어 Bold" panose="020B0600000101010101" pitchFamily="50" charset="-127"/>
-              </a:rPr>
-              <a:t>명세서</a:t>
-            </a:r>
-            <a:endParaRPr lang="ko-KR" altLang="en-US" sz="4000" dirty="0">
-              <a:latin typeface="나눔스퀘어 Bold" panose="020B0600000101010101" pitchFamily="50" charset="-127"/>
-              <a:ea typeface="나눔스퀘어 Bold" panose="020B0600000101010101" pitchFamily="50" charset="-127"/>
-            </a:endParaRPr>
-          </a:p>
-        </p:txBody>
-      </p:sp>
-      <p:sp>
-        <p:nvSpPr>
-          <p:cNvPr id="296" name="직사각형 295"/>
-          <p:cNvSpPr/>
-          <p:nvPr/>
-        </p:nvSpPr>
-        <p:spPr>
-          <a:xfrm>
-            <a:off x="9124400" y="761999"/>
-            <a:ext cx="2880000" cy="1440000"/>
-          </a:xfrm>
-          <a:prstGeom prst="rect">
-            <a:avLst/>
-          </a:prstGeom>
-          <a:solidFill>
-            <a:schemeClr val="accent5"/>
-          </a:solidFill>
-          <a:ln>
-            <a:noFill/>
-          </a:ln>
-        </p:spPr>
-        <p:style>
-          <a:lnRef idx="2">
-            <a:schemeClr val="accent1">
-              <a:shade val="50000"/>
-            </a:schemeClr>
-          </a:lnRef>
-          <a:fillRef idx="1">
-            <a:schemeClr val="accent1"/>
-          </a:fillRef>
-          <a:effectRef idx="0">
-            <a:schemeClr val="accent1"/>
-          </a:effectRef>
-          <a:fontRef idx="minor">
-            <a:schemeClr val="lt1"/>
-          </a:fontRef>
-        </p:style>
-        <p:txBody>
-          <a:bodyPr rtlCol="0" anchor="ctr"/>
-          <a:lstStyle/>
-          <a:p>
-            <a:pPr algn="ctr"/>
-            <a:r>
-              <a:rPr lang="ko-KR" altLang="en-US" sz="4000" dirty="0" smtClean="0">
-                <a:latin typeface="나눔스퀘어 Bold" panose="020B0600000101010101" pitchFamily="50" charset="-127"/>
-                <a:ea typeface="나눔스퀘어 Bold" panose="020B0600000101010101" pitchFamily="50" charset="-127"/>
-              </a:rPr>
-              <a:t>테이블</a:t>
-            </a:r>
-            <a:endParaRPr lang="en-US" altLang="ko-KR" sz="4000" dirty="0" smtClean="0">
-              <a:latin typeface="나눔스퀘어 Bold" panose="020B0600000101010101" pitchFamily="50" charset="-127"/>
-              <a:ea typeface="나눔스퀘어 Bold" panose="020B0600000101010101" pitchFamily="50" charset="-127"/>
-            </a:endParaRPr>
-          </a:p>
-          <a:p>
-            <a:pPr algn="ctr"/>
-            <a:r>
-              <a:rPr lang="ko-KR" altLang="en-US" sz="4000" dirty="0" smtClean="0">
-                <a:latin typeface="나눔스퀘어 Bold" panose="020B0600000101010101" pitchFamily="50" charset="-127"/>
-                <a:ea typeface="나눔스퀘어 Bold" panose="020B0600000101010101" pitchFamily="50" charset="-127"/>
-              </a:rPr>
-              <a:t>명세서</a:t>
-            </a:r>
-            <a:endParaRPr lang="ko-KR" altLang="en-US" sz="4000" dirty="0">
-              <a:latin typeface="나눔스퀘어 Bold" panose="020B0600000101010101" pitchFamily="50" charset="-127"/>
-              <a:ea typeface="나눔스퀘어 Bold" panose="020B0600000101010101" pitchFamily="50" charset="-127"/>
-            </a:endParaRPr>
-          </a:p>
-        </p:txBody>
-      </p:sp>
-      <p:sp>
-        <p:nvSpPr>
-          <p:cNvPr id="297" name="직사각형 296"/>
-          <p:cNvSpPr/>
-          <p:nvPr/>
-        </p:nvSpPr>
-        <p:spPr>
-          <a:xfrm>
-            <a:off x="12959800" y="761999"/>
-            <a:ext cx="2880000" cy="1440000"/>
-          </a:xfrm>
-          <a:prstGeom prst="rect">
-            <a:avLst/>
-          </a:prstGeom>
-          <a:solidFill>
-            <a:schemeClr val="accent5"/>
-          </a:solidFill>
-          <a:ln>
-            <a:noFill/>
-          </a:ln>
-        </p:spPr>
-        <p:style>
-          <a:lnRef idx="2">
-            <a:schemeClr val="accent1">
-              <a:shade val="50000"/>
-            </a:schemeClr>
-          </a:lnRef>
-          <a:fillRef idx="1">
-            <a:schemeClr val="accent1"/>
-          </a:fillRef>
-          <a:effectRef idx="0">
-            <a:schemeClr val="accent1"/>
-          </a:effectRef>
-          <a:fontRef idx="minor">
-            <a:schemeClr val="lt1"/>
-          </a:fontRef>
-        </p:style>
-        <p:txBody>
-          <a:bodyPr rtlCol="0" anchor="ctr"/>
-          <a:lstStyle/>
-          <a:p>
-            <a:pPr algn="ctr"/>
-            <a:r>
-              <a:rPr lang="ko-KR" altLang="en-US" sz="4000" dirty="0" smtClean="0">
-                <a:latin typeface="나눔스퀘어 Bold" panose="020B0600000101010101" pitchFamily="50" charset="-127"/>
-                <a:ea typeface="나눔스퀘어 Bold" panose="020B0600000101010101" pitchFamily="50" charset="-127"/>
-              </a:rPr>
-              <a:t>스키마</a:t>
-            </a:r>
-            <a:endParaRPr lang="ko-KR" altLang="en-US" sz="4000" dirty="0">
-              <a:latin typeface="나눔스퀘어 Bold" panose="020B0600000101010101" pitchFamily="50" charset="-127"/>
-              <a:ea typeface="나눔스퀘어 Bold" panose="020B0600000101010101" pitchFamily="50" charset="-127"/>
-            </a:endParaRPr>
-          </a:p>
-        </p:txBody>
-      </p:sp>
-      <p:sp>
-        <p:nvSpPr>
-          <p:cNvPr id="298" name="직사각형 297"/>
-          <p:cNvSpPr/>
-          <p:nvPr/>
-        </p:nvSpPr>
-        <p:spPr>
-          <a:xfrm>
-            <a:off x="16795200" y="761999"/>
-            <a:ext cx="2880000" cy="1440000"/>
-          </a:xfrm>
-          <a:prstGeom prst="rect">
-            <a:avLst/>
-          </a:prstGeom>
-          <a:solidFill>
-            <a:schemeClr val="accent5"/>
-          </a:solidFill>
-          <a:ln>
-            <a:noFill/>
-          </a:ln>
-        </p:spPr>
-        <p:style>
-          <a:lnRef idx="2">
-            <a:schemeClr val="accent1">
-              <a:shade val="50000"/>
-            </a:schemeClr>
-          </a:lnRef>
-          <a:fillRef idx="1">
-            <a:schemeClr val="accent1"/>
-          </a:fillRef>
-          <a:effectRef idx="0">
-            <a:schemeClr val="accent1"/>
-          </a:effectRef>
-          <a:fontRef idx="minor">
-            <a:schemeClr val="lt1"/>
-          </a:fontRef>
-        </p:style>
-        <p:txBody>
-          <a:bodyPr rtlCol="0" anchor="ctr"/>
-          <a:lstStyle/>
-          <a:p>
-            <a:pPr algn="ctr"/>
-            <a:r>
-              <a:rPr lang="ko-KR" altLang="en-US" sz="4000" dirty="0" smtClean="0">
-                <a:latin typeface="나눔스퀘어 Bold" panose="020B0600000101010101" pitchFamily="50" charset="-127"/>
-                <a:ea typeface="나눔스퀘어 Bold" panose="020B0600000101010101" pitchFamily="50" charset="-127"/>
-              </a:rPr>
-              <a:t>기능 구현</a:t>
-            </a:r>
-            <a:endParaRPr lang="ko-KR" altLang="en-US" sz="4000" dirty="0">
-              <a:latin typeface="나눔스퀘어 Bold" panose="020B0600000101010101" pitchFamily="50" charset="-127"/>
-              <a:ea typeface="나눔스퀘어 Bold" panose="020B0600000101010101" pitchFamily="50" charset="-127"/>
-            </a:endParaRPr>
-          </a:p>
-        </p:txBody>
-      </p:sp>
-      <p:cxnSp>
-        <p:nvCxnSpPr>
-          <p:cNvPr id="300" name="직선 화살표 연결선 299"/>
-          <p:cNvCxnSpPr>
-            <a:stCxn id="273" idx="3"/>
-            <a:endCxn id="293" idx="1"/>
-          </p:cNvCxnSpPr>
-          <p:nvPr/>
-        </p:nvCxnSpPr>
-        <p:spPr>
-          <a:xfrm>
-            <a:off x="-3337200" y="1481999"/>
-            <a:ext cx="955400" cy="0"/>
-          </a:xfrm>
-          <a:prstGeom prst="straightConnector1">
-            <a:avLst/>
-          </a:prstGeom>
-          <a:ln w="76200">
+              </a:endParaRPr>
+            </a:p>
+          </p:txBody>
+        </p:sp>
+        <p:sp>
+          <p:nvSpPr>
+            <p:cNvPr id="27" name="오른쪽 화살표 26"/>
+            <p:cNvSpPr/>
+            <p:nvPr/>
+          </p:nvSpPr>
+          <p:spPr>
+            <a:xfrm>
+              <a:off x="1980599" y="1409100"/>
+              <a:ext cx="1980000" cy="1440000"/>
+            </a:xfrm>
+            <a:prstGeom prst="rightArrow">
+              <a:avLst/>
+            </a:prstGeom>
             <a:solidFill>
               <a:schemeClr val="accent2"/>
             </a:solidFill>
-            <a:tailEnd type="triangle"/>
-          </a:ln>
-        </p:spPr>
-        <p:style>
-          <a:lnRef idx="1">
-            <a:schemeClr val="accent1"/>
-          </a:lnRef>
-          <a:fillRef idx="0">
-            <a:schemeClr val="accent1"/>
-          </a:fillRef>
-          <a:effectRef idx="0">
-            <a:schemeClr val="accent1"/>
-          </a:effectRef>
-          <a:fontRef idx="minor">
-            <a:schemeClr val="tx1"/>
-          </a:fontRef>
-        </p:style>
-      </p:cxnSp>
-      <p:cxnSp>
-        <p:nvCxnSpPr>
-          <p:cNvPr id="303" name="직선 화살표 연결선 302"/>
-          <p:cNvCxnSpPr>
-            <a:stCxn id="293" idx="3"/>
-            <a:endCxn id="294" idx="1"/>
-          </p:cNvCxnSpPr>
-          <p:nvPr/>
-        </p:nvCxnSpPr>
-        <p:spPr>
-          <a:xfrm>
-            <a:off x="498200" y="1481999"/>
-            <a:ext cx="955400" cy="0"/>
-          </a:xfrm>
-          <a:prstGeom prst="straightConnector1">
-            <a:avLst/>
-          </a:prstGeom>
-          <a:ln w="76200">
+            <a:ln>
+              <a:noFill/>
+            </a:ln>
+          </p:spPr>
+          <p:style>
+            <a:lnRef idx="2">
+              <a:schemeClr val="accent1">
+                <a:shade val="50000"/>
+              </a:schemeClr>
+            </a:lnRef>
+            <a:fillRef idx="1">
+              <a:schemeClr val="accent1"/>
+            </a:fillRef>
+            <a:effectRef idx="0">
+              <a:schemeClr val="accent1"/>
+            </a:effectRef>
+            <a:fontRef idx="minor">
+              <a:schemeClr val="lt1"/>
+            </a:fontRef>
+          </p:style>
+          <p:txBody>
+            <a:bodyPr rtlCol="0" anchor="ctr"/>
+            <a:lstStyle/>
+            <a:p>
+              <a:pPr algn="ctr"/>
+              <a:r>
+                <a:rPr lang="ko-KR" altLang="en-US" sz="2800" dirty="0">
+                  <a:solidFill>
+                    <a:schemeClr val="tx1"/>
+                  </a:solidFill>
+                  <a:latin typeface="나눔스퀘어 Bold" panose="020B0600000101010101" pitchFamily="50" charset="-127"/>
+                  <a:ea typeface="나눔스퀘어 Bold" panose="020B0600000101010101" pitchFamily="50" charset="-127"/>
+                </a:rPr>
+                <a:t>이름 변경</a:t>
+              </a:r>
+            </a:p>
+          </p:txBody>
+        </p:sp>
+        <p:sp>
+          <p:nvSpPr>
+            <p:cNvPr id="29" name="오른쪽 화살표 28"/>
+            <p:cNvSpPr/>
+            <p:nvPr/>
+          </p:nvSpPr>
+          <p:spPr>
+            <a:xfrm>
+              <a:off x="7095647" y="1409100"/>
+              <a:ext cx="720000" cy="1440000"/>
+            </a:xfrm>
+            <a:prstGeom prst="rightArrow">
+              <a:avLst/>
+            </a:prstGeom>
             <a:solidFill>
               <a:schemeClr val="accent2"/>
             </a:solidFill>
-            <a:tailEnd type="triangle"/>
-          </a:ln>
-        </p:spPr>
-        <p:style>
-          <a:lnRef idx="1">
-            <a:schemeClr val="accent1"/>
-          </a:lnRef>
-          <a:fillRef idx="0">
-            <a:schemeClr val="accent1"/>
-          </a:fillRef>
-          <a:effectRef idx="0">
-            <a:schemeClr val="accent1"/>
-          </a:effectRef>
-          <a:fontRef idx="minor">
-            <a:schemeClr val="tx1"/>
-          </a:fontRef>
-        </p:style>
-      </p:cxnSp>
-      <p:cxnSp>
-        <p:nvCxnSpPr>
-          <p:cNvPr id="307" name="직선 화살표 연결선 306"/>
-          <p:cNvCxnSpPr>
-            <a:stCxn id="294" idx="3"/>
-            <a:endCxn id="295" idx="1"/>
-          </p:cNvCxnSpPr>
-          <p:nvPr/>
-        </p:nvCxnSpPr>
-        <p:spPr>
-          <a:xfrm>
-            <a:off x="4333600" y="1481999"/>
-            <a:ext cx="955400" cy="0"/>
-          </a:xfrm>
-          <a:prstGeom prst="straightConnector1">
-            <a:avLst/>
-          </a:prstGeom>
-          <a:ln w="76200">
+            <a:ln>
+              <a:noFill/>
+            </a:ln>
+          </p:spPr>
+          <p:style>
+            <a:lnRef idx="2">
+              <a:schemeClr val="accent1">
+                <a:shade val="50000"/>
+              </a:schemeClr>
+            </a:lnRef>
+            <a:fillRef idx="1">
+              <a:schemeClr val="accent1"/>
+            </a:fillRef>
+            <a:effectRef idx="0">
+              <a:schemeClr val="accent1"/>
+            </a:effectRef>
+            <a:fontRef idx="minor">
+              <a:schemeClr val="lt1"/>
+            </a:fontRef>
+          </p:style>
+          <p:txBody>
+            <a:bodyPr rtlCol="0" anchor="ctr"/>
+            <a:lstStyle/>
+            <a:p>
+              <a:pPr algn="ctr"/>
+              <a:endParaRPr lang="ko-KR" altLang="en-US">
+                <a:latin typeface="나눔스퀘어 Bold" panose="020B0600000101010101" pitchFamily="50" charset="-127"/>
+                <a:ea typeface="나눔스퀘어 Bold" panose="020B0600000101010101" pitchFamily="50" charset="-127"/>
+              </a:endParaRPr>
+            </a:p>
+          </p:txBody>
+        </p:sp>
+        <p:sp>
+          <p:nvSpPr>
+            <p:cNvPr id="46" name="오른쪽 화살표 45"/>
+            <p:cNvSpPr/>
+            <p:nvPr/>
+          </p:nvSpPr>
+          <p:spPr>
+            <a:xfrm>
+              <a:off x="10227947" y="1409100"/>
+              <a:ext cx="720000" cy="1440000"/>
+            </a:xfrm>
+            <a:prstGeom prst="rightArrow">
+              <a:avLst/>
+            </a:prstGeom>
             <a:solidFill>
               <a:schemeClr val="accent2"/>
             </a:solidFill>
-            <a:tailEnd type="triangle"/>
-          </a:ln>
-        </p:spPr>
-        <p:style>
-          <a:lnRef idx="1">
-            <a:schemeClr val="accent1"/>
-          </a:lnRef>
-          <a:fillRef idx="0">
-            <a:schemeClr val="accent1"/>
-          </a:fillRef>
-          <a:effectRef idx="0">
-            <a:schemeClr val="accent1"/>
-          </a:effectRef>
-          <a:fontRef idx="minor">
-            <a:schemeClr val="tx1"/>
-          </a:fontRef>
-        </p:style>
-      </p:cxnSp>
-      <p:cxnSp>
-        <p:nvCxnSpPr>
-          <p:cNvPr id="311" name="직선 화살표 연결선 310"/>
-          <p:cNvCxnSpPr>
-            <a:stCxn id="295" idx="3"/>
-            <a:endCxn id="296" idx="1"/>
-          </p:cNvCxnSpPr>
-          <p:nvPr/>
-        </p:nvCxnSpPr>
-        <p:spPr>
-          <a:xfrm>
-            <a:off x="8169000" y="1481999"/>
-            <a:ext cx="955400" cy="0"/>
-          </a:xfrm>
-          <a:prstGeom prst="straightConnector1">
-            <a:avLst/>
-          </a:prstGeom>
-          <a:ln w="76200">
-            <a:solidFill>
-              <a:schemeClr val="accent2"/>
-            </a:solidFill>
-            <a:tailEnd type="triangle"/>
-          </a:ln>
-        </p:spPr>
-        <p:style>
-          <a:lnRef idx="1">
-            <a:schemeClr val="accent1"/>
-          </a:lnRef>
-          <a:fillRef idx="0">
-            <a:schemeClr val="accent1"/>
-          </a:fillRef>
-          <a:effectRef idx="0">
-            <a:schemeClr val="accent1"/>
-          </a:effectRef>
-          <a:fontRef idx="minor">
-            <a:schemeClr val="tx1"/>
-          </a:fontRef>
-        </p:style>
-      </p:cxnSp>
-      <p:cxnSp>
-        <p:nvCxnSpPr>
-          <p:cNvPr id="314" name="직선 화살표 연결선 313"/>
-          <p:cNvCxnSpPr>
-            <a:stCxn id="296" idx="3"/>
-            <a:endCxn id="297" idx="1"/>
-          </p:cNvCxnSpPr>
-          <p:nvPr/>
-        </p:nvCxnSpPr>
-        <p:spPr>
-          <a:xfrm>
-            <a:off x="12004400" y="1481999"/>
-            <a:ext cx="955400" cy="0"/>
-          </a:xfrm>
-          <a:prstGeom prst="straightConnector1">
-            <a:avLst/>
-          </a:prstGeom>
-          <a:ln w="76200">
-            <a:solidFill>
-              <a:schemeClr val="accent2"/>
-            </a:solidFill>
-            <a:tailEnd type="triangle"/>
-          </a:ln>
-        </p:spPr>
-        <p:style>
-          <a:lnRef idx="1">
-            <a:schemeClr val="accent1"/>
-          </a:lnRef>
-          <a:fillRef idx="0">
-            <a:schemeClr val="accent1"/>
-          </a:fillRef>
-          <a:effectRef idx="0">
-            <a:schemeClr val="accent1"/>
-          </a:effectRef>
-          <a:fontRef idx="minor">
-            <a:schemeClr val="tx1"/>
-          </a:fontRef>
-        </p:style>
-      </p:cxnSp>
-      <p:cxnSp>
-        <p:nvCxnSpPr>
-          <p:cNvPr id="318" name="직선 화살표 연결선 317"/>
-          <p:cNvCxnSpPr>
-            <a:stCxn id="297" idx="3"/>
-            <a:endCxn id="298" idx="1"/>
-          </p:cNvCxnSpPr>
-          <p:nvPr/>
-        </p:nvCxnSpPr>
-        <p:spPr>
-          <a:xfrm>
-            <a:off x="15839800" y="1481999"/>
-            <a:ext cx="955400" cy="0"/>
-          </a:xfrm>
-          <a:prstGeom prst="straightConnector1">
-            <a:avLst/>
-          </a:prstGeom>
-          <a:ln w="76200">
-            <a:solidFill>
-              <a:schemeClr val="accent2"/>
-            </a:solidFill>
-            <a:tailEnd type="triangle"/>
-          </a:ln>
-        </p:spPr>
-        <p:style>
-          <a:lnRef idx="1">
-            <a:schemeClr val="accent1"/>
-          </a:lnRef>
-          <a:fillRef idx="0">
-            <a:schemeClr val="accent1"/>
-          </a:fillRef>
-          <a:effectRef idx="0">
-            <a:schemeClr val="accent1"/>
-          </a:effectRef>
-          <a:fontRef idx="minor">
-            <a:schemeClr val="tx1"/>
-          </a:fontRef>
-        </p:style>
-      </p:cxnSp>
+            <a:ln>
+              <a:noFill/>
+            </a:ln>
+          </p:spPr>
+          <p:style>
+            <a:lnRef idx="2">
+              <a:schemeClr val="accent1">
+                <a:shade val="50000"/>
+              </a:schemeClr>
+            </a:lnRef>
+            <a:fillRef idx="1">
+              <a:schemeClr val="accent1"/>
+            </a:fillRef>
+            <a:effectRef idx="0">
+              <a:schemeClr val="accent1"/>
+            </a:effectRef>
+            <a:fontRef idx="minor">
+              <a:schemeClr val="lt1"/>
+            </a:fontRef>
+          </p:style>
+          <p:txBody>
+            <a:bodyPr rtlCol="0" anchor="ctr"/>
+            <a:lstStyle/>
+            <a:p>
+              <a:pPr algn="ctr"/>
+              <a:endParaRPr lang="ko-KR" altLang="en-US">
+                <a:latin typeface="나눔스퀘어 Bold" panose="020B0600000101010101" pitchFamily="50" charset="-127"/>
+                <a:ea typeface="나눔스퀘어 Bold" panose="020B0600000101010101" pitchFamily="50" charset="-127"/>
+              </a:endParaRPr>
+            </a:p>
+          </p:txBody>
+        </p:sp>
+      </p:grpSp>
     </p:spTree>
     <p:extLst>
       <p:ext uri="{BB962C8B-B14F-4D97-AF65-F5344CB8AC3E}">

</xml_diff>

<commit_message>
20260901 commit : 260901 Notepad++ 부터 시작할 것
</commit_message>
<xml_diff>
--- a/notion/create_notion_img.pptx
+++ b/notion/create_notion_img.pptx
@@ -245,7 +245,7 @@
           <a:p>
             <a:fld id="{7237CE1A-8831-48B5-BA93-72483C6E34E8}" type="datetimeFigureOut">
               <a:rPr lang="ko-KR" altLang="en-US" smtClean="0"/>
-              <a:t>2026-09-01</a:t>
+              <a:t>26-09-01(Tue)</a:t>
             </a:fld>
             <a:endParaRPr lang="ko-KR" altLang="en-US"/>
           </a:p>
@@ -415,7 +415,7 @@
           <a:p>
             <a:fld id="{7237CE1A-8831-48B5-BA93-72483C6E34E8}" type="datetimeFigureOut">
               <a:rPr lang="ko-KR" altLang="en-US" smtClean="0"/>
-              <a:t>2026-09-01</a:t>
+              <a:t>26-09-01(Tue)</a:t>
             </a:fld>
             <a:endParaRPr lang="ko-KR" altLang="en-US"/>
           </a:p>
@@ -595,7 +595,7 @@
           <a:p>
             <a:fld id="{7237CE1A-8831-48B5-BA93-72483C6E34E8}" type="datetimeFigureOut">
               <a:rPr lang="ko-KR" altLang="en-US" smtClean="0"/>
-              <a:t>2026-09-01</a:t>
+              <a:t>26-09-01(Tue)</a:t>
             </a:fld>
             <a:endParaRPr lang="ko-KR" altLang="en-US"/>
           </a:p>
@@ -765,7 +765,7 @@
           <a:p>
             <a:fld id="{7237CE1A-8831-48B5-BA93-72483C6E34E8}" type="datetimeFigureOut">
               <a:rPr lang="ko-KR" altLang="en-US" smtClean="0"/>
-              <a:t>2026-09-01</a:t>
+              <a:t>26-09-01(Tue)</a:t>
             </a:fld>
             <a:endParaRPr lang="ko-KR" altLang="en-US"/>
           </a:p>
@@ -1011,7 +1011,7 @@
           <a:p>
             <a:fld id="{7237CE1A-8831-48B5-BA93-72483C6E34E8}" type="datetimeFigureOut">
               <a:rPr lang="ko-KR" altLang="en-US" smtClean="0"/>
-              <a:t>2026-09-01</a:t>
+              <a:t>26-09-01(Tue)</a:t>
             </a:fld>
             <a:endParaRPr lang="ko-KR" altLang="en-US"/>
           </a:p>
@@ -1243,7 +1243,7 @@
           <a:p>
             <a:fld id="{7237CE1A-8831-48B5-BA93-72483C6E34E8}" type="datetimeFigureOut">
               <a:rPr lang="ko-KR" altLang="en-US" smtClean="0"/>
-              <a:t>2026-09-01</a:t>
+              <a:t>26-09-01(Tue)</a:t>
             </a:fld>
             <a:endParaRPr lang="ko-KR" altLang="en-US"/>
           </a:p>
@@ -1610,7 +1610,7 @@
           <a:p>
             <a:fld id="{7237CE1A-8831-48B5-BA93-72483C6E34E8}" type="datetimeFigureOut">
               <a:rPr lang="ko-KR" altLang="en-US" smtClean="0"/>
-              <a:t>2026-09-01</a:t>
+              <a:t>26-09-01(Tue)</a:t>
             </a:fld>
             <a:endParaRPr lang="ko-KR" altLang="en-US"/>
           </a:p>
@@ -1728,7 +1728,7 @@
           <a:p>
             <a:fld id="{7237CE1A-8831-48B5-BA93-72483C6E34E8}" type="datetimeFigureOut">
               <a:rPr lang="ko-KR" altLang="en-US" smtClean="0"/>
-              <a:t>2026-09-01</a:t>
+              <a:t>26-09-01(Tue)</a:t>
             </a:fld>
             <a:endParaRPr lang="ko-KR" altLang="en-US"/>
           </a:p>
@@ -1823,7 +1823,7 @@
           <a:p>
             <a:fld id="{7237CE1A-8831-48B5-BA93-72483C6E34E8}" type="datetimeFigureOut">
               <a:rPr lang="ko-KR" altLang="en-US" smtClean="0"/>
-              <a:t>2026-09-01</a:t>
+              <a:t>26-09-01(Tue)</a:t>
             </a:fld>
             <a:endParaRPr lang="ko-KR" altLang="en-US"/>
           </a:p>
@@ -2100,7 +2100,7 @@
           <a:p>
             <a:fld id="{7237CE1A-8831-48B5-BA93-72483C6E34E8}" type="datetimeFigureOut">
               <a:rPr lang="ko-KR" altLang="en-US" smtClean="0"/>
-              <a:t>2026-09-01</a:t>
+              <a:t>26-09-01(Tue)</a:t>
             </a:fld>
             <a:endParaRPr lang="ko-KR" altLang="en-US"/>
           </a:p>
@@ -2353,7 +2353,7 @@
           <a:p>
             <a:fld id="{7237CE1A-8831-48B5-BA93-72483C6E34E8}" type="datetimeFigureOut">
               <a:rPr lang="ko-KR" altLang="en-US" smtClean="0"/>
-              <a:t>2026-09-01</a:t>
+              <a:t>26-09-01(Tue)</a:t>
             </a:fld>
             <a:endParaRPr lang="ko-KR" altLang="en-US"/>
           </a:p>
@@ -2566,7 +2566,7 @@
           <a:p>
             <a:fld id="{7237CE1A-8831-48B5-BA93-72483C6E34E8}" type="datetimeFigureOut">
               <a:rPr lang="ko-KR" altLang="en-US" smtClean="0"/>
-              <a:t>2026-09-01</a:t>
+              <a:t>26-09-01(Tue)</a:t>
             </a:fld>
             <a:endParaRPr lang="ko-KR" altLang="en-US"/>
           </a:p>
@@ -2973,25 +2973,23 @@
       </p:grpSpPr>
       <p:sp>
         <p:nvSpPr>
-          <p:cNvPr id="20" name="직사각형 19"/>
+          <p:cNvPr id="21" name="직사각형 20"/>
           <p:cNvSpPr/>
           <p:nvPr/>
         </p:nvSpPr>
         <p:spPr>
           <a:xfrm>
-            <a:off x="-1277100" y="1139100"/>
-            <a:ext cx="14760000" cy="1980000"/>
-          </a:xfrm>
-          <a:prstGeom prst="rect">
-            <a:avLst/>
-          </a:prstGeom>
-          <a:solidFill>
-            <a:schemeClr val="bg1">
-              <a:lumMod val="95000"/>
-            </a:schemeClr>
-          </a:solidFill>
-          <a:ln>
-            <a:noFill/>
+            <a:off x="525447" y="3356322"/>
+            <a:ext cx="4320000" cy="900000"/>
+          </a:xfrm>
+          <a:prstGeom prst="rect">
+            <a:avLst/>
+          </a:prstGeom>
+          <a:noFill/>
+          <a:ln w="57150">
+            <a:solidFill>
+              <a:schemeClr val="tx1"/>
+            </a:solidFill>
           </a:ln>
         </p:spPr>
         <p:style>
@@ -3015,7 +3013,7 @@
           <a:lstStyle/>
           <a:p>
             <a:pPr algn="ctr"/>
-            <a:endParaRPr lang="ko-KR" altLang="en-US" sz="2800">
+            <a:endParaRPr lang="ko-KR" altLang="en-US" sz="2400">
               <a:latin typeface="나눔스퀘어 Bold" panose="020B0600000101010101" pitchFamily="50" charset="-127"/>
               <a:ea typeface="나눔스퀘어 Bold" panose="020B0600000101010101" pitchFamily="50" charset="-127"/>
             </a:endParaRPr>
@@ -3024,23 +3022,23 @@
       </p:sp>
       <p:sp>
         <p:nvSpPr>
-          <p:cNvPr id="22" name="직사각형 21"/>
+          <p:cNvPr id="2" name="직사각형 1"/>
           <p:cNvSpPr/>
           <p:nvPr/>
         </p:nvSpPr>
         <p:spPr>
           <a:xfrm>
-            <a:off x="4662900" y="664800"/>
-            <a:ext cx="2880000" cy="720000"/>
-          </a:xfrm>
-          <a:prstGeom prst="rect">
-            <a:avLst/>
-          </a:prstGeom>
-          <a:solidFill>
-            <a:schemeClr val="accent5"/>
-          </a:solidFill>
-          <a:ln>
-            <a:noFill/>
+            <a:off x="194553" y="875490"/>
+            <a:ext cx="5040000" cy="3600000"/>
+          </a:xfrm>
+          <a:prstGeom prst="rect">
+            <a:avLst/>
+          </a:prstGeom>
+          <a:noFill/>
+          <a:ln w="57150">
+            <a:solidFill>
+              <a:schemeClr val="tx1"/>
+            </a:solidFill>
           </a:ln>
         </p:spPr>
         <p:style>
@@ -3064,489 +3062,550 @@
           <a:lstStyle/>
           <a:p>
             <a:pPr algn="ctr"/>
-            <a:r>
-              <a:rPr lang="en-US" altLang="ko-KR" sz="2800" dirty="0" smtClean="0">
+            <a:endParaRPr lang="ko-KR" altLang="en-US" sz="2400">
+              <a:latin typeface="나눔스퀘어 Bold" panose="020B0600000101010101" pitchFamily="50" charset="-127"/>
+              <a:ea typeface="나눔스퀘어 Bold" panose="020B0600000101010101" pitchFamily="50" charset="-127"/>
+            </a:endParaRPr>
+          </a:p>
+        </p:txBody>
+      </p:sp>
+      <p:sp>
+        <p:nvSpPr>
+          <p:cNvPr id="13" name="직사각형 12"/>
+          <p:cNvSpPr/>
+          <p:nvPr/>
+        </p:nvSpPr>
+        <p:spPr>
+          <a:xfrm>
+            <a:off x="7818384" y="1055490"/>
+            <a:ext cx="3600000" cy="1620000"/>
+          </a:xfrm>
+          <a:prstGeom prst="rect">
+            <a:avLst/>
+          </a:prstGeom>
+        </p:spPr>
+        <p:style>
+          <a:lnRef idx="2">
+            <a:schemeClr val="accent1">
+              <a:shade val="50000"/>
+            </a:schemeClr>
+          </a:lnRef>
+          <a:fillRef idx="1">
+            <a:schemeClr val="accent1"/>
+          </a:fillRef>
+          <a:effectRef idx="0">
+            <a:schemeClr val="accent1"/>
+          </a:effectRef>
+          <a:fontRef idx="minor">
+            <a:schemeClr val="lt1"/>
+          </a:fontRef>
+        </p:style>
+        <p:txBody>
+          <a:bodyPr rtlCol="0" anchor="ctr"/>
+          <a:lstStyle/>
+          <a:p>
+            <a:pPr algn="ctr"/>
+            <a:r>
+              <a:rPr lang="en-US" altLang="ko-KR" sz="6000" dirty="0" smtClean="0">
                 <a:latin typeface="나눔스퀘어 Bold" panose="020B0600000101010101" pitchFamily="50" charset="-127"/>
                 <a:ea typeface="나눔스퀘어 Bold" panose="020B0600000101010101" pitchFamily="50" charset="-127"/>
               </a:rPr>
-              <a:t>[ Member ]</a:t>
-            </a:r>
-            <a:endParaRPr lang="ko-KR" altLang="en-US" sz="2800" dirty="0">
+              <a:t>DB</a:t>
+            </a:r>
+          </a:p>
+        </p:txBody>
+      </p:sp>
+      <p:sp>
+        <p:nvSpPr>
+          <p:cNvPr id="14" name="직사각형 13"/>
+          <p:cNvSpPr/>
+          <p:nvPr/>
+        </p:nvSpPr>
+        <p:spPr>
+          <a:xfrm>
+            <a:off x="525447" y="1055490"/>
+            <a:ext cx="3600000" cy="1620000"/>
+          </a:xfrm>
+          <a:prstGeom prst="rect">
+            <a:avLst/>
+          </a:prstGeom>
+        </p:spPr>
+        <p:style>
+          <a:lnRef idx="2">
+            <a:schemeClr val="accent1">
+              <a:shade val="50000"/>
+            </a:schemeClr>
+          </a:lnRef>
+          <a:fillRef idx="1">
+            <a:schemeClr val="accent1"/>
+          </a:fillRef>
+          <a:effectRef idx="0">
+            <a:schemeClr val="accent1"/>
+          </a:effectRef>
+          <a:fontRef idx="minor">
+            <a:schemeClr val="lt1"/>
+          </a:fontRef>
+        </p:style>
+        <p:txBody>
+          <a:bodyPr rtlCol="0" anchor="ctr"/>
+          <a:lstStyle/>
+          <a:p>
+            <a:pPr algn="ctr"/>
+            <a:r>
+              <a:rPr lang="en-US" altLang="ko-KR" sz="4400" dirty="0" smtClean="0">
+                <a:latin typeface="나눔스퀘어 Bold" panose="020B0600000101010101" pitchFamily="50" charset="-127"/>
+                <a:ea typeface="나눔스퀘어 Bold" panose="020B0600000101010101" pitchFamily="50" charset="-127"/>
+              </a:rPr>
+              <a:t>application</a:t>
+            </a:r>
+            <a:endParaRPr lang="ko-KR" altLang="en-US" sz="4400" dirty="0">
               <a:latin typeface="나눔스퀘어 Bold" panose="020B0600000101010101" pitchFamily="50" charset="-127"/>
               <a:ea typeface="나눔스퀘어 Bold" panose="020B0600000101010101" pitchFamily="50" charset="-127"/>
             </a:endParaRPr>
           </a:p>
         </p:txBody>
       </p:sp>
-      <p:grpSp>
-        <p:nvGrpSpPr>
-          <p:cNvPr id="31" name="그룹 30"/>
-          <p:cNvGrpSpPr/>
-          <p:nvPr/>
-        </p:nvGrpSpPr>
-        <p:grpSpPr>
-          <a:xfrm>
-            <a:off x="-1028298" y="1561500"/>
-            <a:ext cx="14262395" cy="1440000"/>
-            <a:chOff x="-1028298" y="1409100"/>
-            <a:chExt cx="14262395" cy="1440000"/>
-          </a:xfrm>
-        </p:grpSpPr>
-        <p:sp>
-          <p:nvSpPr>
-            <p:cNvPr id="23" name="직사각형 22"/>
-            <p:cNvSpPr/>
-            <p:nvPr/>
-          </p:nvSpPr>
-          <p:spPr>
-            <a:xfrm>
-              <a:off x="-1028298" y="1409100"/>
-              <a:ext cx="2880000" cy="1440000"/>
-            </a:xfrm>
-            <a:prstGeom prst="rect">
-              <a:avLst/>
-            </a:prstGeom>
-            <a:solidFill>
-              <a:schemeClr val="bg1">
-                <a:lumMod val="85000"/>
-              </a:schemeClr>
-            </a:solidFill>
-            <a:ln>
-              <a:noFill/>
-            </a:ln>
-          </p:spPr>
-          <p:style>
-            <a:lnRef idx="2">
-              <a:schemeClr val="accent1">
-                <a:shade val="50000"/>
-              </a:schemeClr>
-            </a:lnRef>
-            <a:fillRef idx="1">
-              <a:schemeClr val="accent1"/>
-            </a:fillRef>
-            <a:effectRef idx="0">
-              <a:schemeClr val="accent1"/>
-            </a:effectRef>
-            <a:fontRef idx="minor">
-              <a:schemeClr val="lt1"/>
-            </a:fontRef>
-          </p:style>
-          <p:txBody>
-            <a:bodyPr rtlCol="0" anchor="ctr"/>
-            <a:lstStyle/>
-            <a:p>
-              <a:pPr algn="ctr"/>
-              <a:r>
-                <a:rPr lang="en-US" altLang="ko-KR" sz="2800" dirty="0">
-                  <a:solidFill>
-                    <a:schemeClr val="tx1"/>
-                  </a:solidFill>
-                  <a:latin typeface="나눔스퀘어 Bold" panose="020B0600000101010101" pitchFamily="50" charset="-127"/>
-                  <a:ea typeface="나눔스퀘어 Bold" panose="020B0600000101010101" pitchFamily="50" charset="-127"/>
-                </a:rPr>
-                <a:t>ID = 1</a:t>
-              </a:r>
-            </a:p>
-            <a:p>
-              <a:pPr algn="ctr"/>
-              <a:r>
-                <a:rPr lang="en-US" altLang="ko-KR" sz="2800" dirty="0">
-                  <a:solidFill>
-                    <a:schemeClr val="tx1"/>
-                  </a:solidFill>
-                  <a:latin typeface="나눔스퀘어 Bold" panose="020B0600000101010101" pitchFamily="50" charset="-127"/>
-                  <a:ea typeface="나눔스퀘어 Bold" panose="020B0600000101010101" pitchFamily="50" charset="-127"/>
-                </a:rPr>
-                <a:t>Name = </a:t>
-              </a:r>
-              <a:r>
-                <a:rPr lang="ko-KR" altLang="en-US" sz="2800" dirty="0">
-                  <a:solidFill>
-                    <a:schemeClr val="tx1"/>
-                  </a:solidFill>
-                  <a:latin typeface="나눔스퀘어 Bold" panose="020B0600000101010101" pitchFamily="50" charset="-127"/>
-                  <a:ea typeface="나눔스퀘어 Bold" panose="020B0600000101010101" pitchFamily="50" charset="-127"/>
-                </a:rPr>
-                <a:t>홍길동</a:t>
-              </a:r>
-            </a:p>
-          </p:txBody>
-        </p:sp>
-        <p:sp>
-          <p:nvSpPr>
-            <p:cNvPr id="38" name="직사각형 37"/>
-            <p:cNvSpPr/>
-            <p:nvPr/>
-          </p:nvSpPr>
-          <p:spPr>
-            <a:xfrm>
-              <a:off x="4089497" y="1409100"/>
-              <a:ext cx="2880000" cy="1440000"/>
-            </a:xfrm>
-            <a:prstGeom prst="rect">
-              <a:avLst/>
-            </a:prstGeom>
-            <a:solidFill>
-              <a:schemeClr val="bg1">
-                <a:lumMod val="85000"/>
-              </a:schemeClr>
-            </a:solidFill>
-            <a:ln>
-              <a:noFill/>
-            </a:ln>
-          </p:spPr>
-          <p:style>
-            <a:lnRef idx="2">
-              <a:schemeClr val="accent1">
-                <a:shade val="50000"/>
-              </a:schemeClr>
-            </a:lnRef>
-            <a:fillRef idx="1">
-              <a:schemeClr val="accent1"/>
-            </a:fillRef>
-            <a:effectRef idx="0">
-              <a:schemeClr val="accent1"/>
-            </a:effectRef>
-            <a:fontRef idx="minor">
-              <a:schemeClr val="lt1"/>
-            </a:fontRef>
-          </p:style>
-          <p:txBody>
-            <a:bodyPr rtlCol="0" anchor="ctr"/>
-            <a:lstStyle/>
-            <a:p>
-              <a:pPr algn="ctr"/>
-              <a:r>
-                <a:rPr lang="en-US" altLang="ko-KR" sz="2800" dirty="0">
-                  <a:solidFill>
-                    <a:schemeClr val="tx1"/>
-                  </a:solidFill>
-                  <a:latin typeface="나눔스퀘어 Bold" panose="020B0600000101010101" pitchFamily="50" charset="-127"/>
-                  <a:ea typeface="나눔스퀘어 Bold" panose="020B0600000101010101" pitchFamily="50" charset="-127"/>
-                </a:rPr>
-                <a:t>ID = 1</a:t>
-              </a:r>
-            </a:p>
-            <a:p>
-              <a:pPr algn="ctr"/>
-              <a:r>
-                <a:rPr lang="en-US" altLang="ko-KR" sz="2800" dirty="0">
-                  <a:solidFill>
-                    <a:schemeClr val="tx1"/>
-                  </a:solidFill>
-                  <a:latin typeface="나눔스퀘어 Bold" panose="020B0600000101010101" pitchFamily="50" charset="-127"/>
-                  <a:ea typeface="나눔스퀘어 Bold" panose="020B0600000101010101" pitchFamily="50" charset="-127"/>
-                </a:rPr>
-                <a:t>Name = </a:t>
-              </a:r>
-              <a:r>
-                <a:rPr lang="ko-KR" altLang="en-US" sz="2800" dirty="0">
-                  <a:solidFill>
-                    <a:schemeClr val="tx1"/>
-                  </a:solidFill>
-                  <a:latin typeface="나눔스퀘어 Bold" panose="020B0600000101010101" pitchFamily="50" charset="-127"/>
-                  <a:ea typeface="나눔스퀘어 Bold" panose="020B0600000101010101" pitchFamily="50" charset="-127"/>
-                </a:rPr>
-                <a:t>김철수</a:t>
-              </a:r>
-            </a:p>
-          </p:txBody>
-        </p:sp>
-        <p:sp>
-          <p:nvSpPr>
-            <p:cNvPr id="39" name="직사각형 38"/>
-            <p:cNvSpPr/>
-            <p:nvPr/>
-          </p:nvSpPr>
-          <p:spPr>
-            <a:xfrm>
-              <a:off x="7941797" y="1409100"/>
-              <a:ext cx="2160000" cy="1440000"/>
-            </a:xfrm>
-            <a:prstGeom prst="rect">
-              <a:avLst/>
-            </a:prstGeom>
-            <a:solidFill>
-              <a:schemeClr val="bg1">
-                <a:lumMod val="85000"/>
-              </a:schemeClr>
-            </a:solidFill>
-            <a:ln>
-              <a:noFill/>
-            </a:ln>
-          </p:spPr>
-          <p:style>
-            <a:lnRef idx="2">
-              <a:schemeClr val="accent1">
-                <a:shade val="50000"/>
-              </a:schemeClr>
-            </a:lnRef>
-            <a:fillRef idx="1">
-              <a:schemeClr val="accent1"/>
-            </a:fillRef>
-            <a:effectRef idx="0">
-              <a:schemeClr val="accent1"/>
-            </a:effectRef>
-            <a:fontRef idx="minor">
-              <a:schemeClr val="lt1"/>
-            </a:fontRef>
-          </p:style>
-          <p:txBody>
-            <a:bodyPr rtlCol="0" anchor="ctr"/>
-            <a:lstStyle/>
-            <a:p>
-              <a:pPr algn="ctr"/>
-              <a:r>
-                <a:rPr lang="en-US" altLang="ko-KR" sz="2800" dirty="0">
-                  <a:solidFill>
-                    <a:schemeClr val="tx1"/>
-                  </a:solidFill>
-                  <a:latin typeface="나눔스퀘어 Bold" panose="020B0600000101010101" pitchFamily="50" charset="-127"/>
-                  <a:ea typeface="나눔스퀘어 Bold" panose="020B0600000101010101" pitchFamily="50" charset="-127"/>
-                </a:rPr>
-                <a:t>ID</a:t>
-              </a:r>
-              <a:r>
-                <a:rPr lang="ko-KR" altLang="en-US" sz="2800" dirty="0">
-                  <a:solidFill>
-                    <a:schemeClr val="tx1"/>
-                  </a:solidFill>
-                  <a:latin typeface="나눔스퀘어 Bold" panose="020B0600000101010101" pitchFamily="50" charset="-127"/>
-                  <a:ea typeface="나눔스퀘어 Bold" panose="020B0600000101010101" pitchFamily="50" charset="-127"/>
-                </a:rPr>
-                <a:t>가 동일</a:t>
-              </a:r>
-            </a:p>
-          </p:txBody>
-        </p:sp>
-        <p:sp>
-          <p:nvSpPr>
-            <p:cNvPr id="40" name="직사각형 39"/>
-            <p:cNvSpPr/>
-            <p:nvPr/>
-          </p:nvSpPr>
-          <p:spPr>
-            <a:xfrm>
-              <a:off x="11074097" y="1409100"/>
-              <a:ext cx="2160000" cy="1440000"/>
-            </a:xfrm>
-            <a:prstGeom prst="rect">
-              <a:avLst/>
-            </a:prstGeom>
-            <a:solidFill>
-              <a:schemeClr val="bg1">
-                <a:lumMod val="85000"/>
-              </a:schemeClr>
-            </a:solidFill>
-            <a:ln>
-              <a:noFill/>
-            </a:ln>
-          </p:spPr>
-          <p:style>
-            <a:lnRef idx="2">
-              <a:schemeClr val="accent1">
-                <a:shade val="50000"/>
-              </a:schemeClr>
-            </a:lnRef>
-            <a:fillRef idx="1">
-              <a:schemeClr val="accent1"/>
-            </a:fillRef>
-            <a:effectRef idx="0">
-              <a:schemeClr val="accent1"/>
-            </a:effectRef>
-            <a:fontRef idx="minor">
-              <a:schemeClr val="lt1"/>
-            </a:fontRef>
-          </p:style>
-          <p:txBody>
-            <a:bodyPr rtlCol="0" anchor="ctr"/>
-            <a:lstStyle/>
-            <a:p>
-              <a:pPr algn="ctr"/>
-              <a:r>
-                <a:rPr lang="ko-KR" altLang="en-US" sz="2800" dirty="0">
-                  <a:solidFill>
-                    <a:schemeClr val="tx1"/>
-                  </a:solidFill>
-                  <a:latin typeface="나눔스퀘어 Bold" panose="020B0600000101010101" pitchFamily="50" charset="-127"/>
-                  <a:ea typeface="나눔스퀘어 Bold" panose="020B0600000101010101" pitchFamily="50" charset="-127"/>
-                </a:rPr>
-                <a:t>같은 </a:t>
-              </a:r>
-              <a:r>
-                <a:rPr lang="en-US" altLang="ko-KR" sz="2800" dirty="0">
-                  <a:solidFill>
-                    <a:schemeClr val="tx1"/>
-                  </a:solidFill>
-                  <a:latin typeface="나눔스퀘어 Bold" panose="020B0600000101010101" pitchFamily="50" charset="-127"/>
-                  <a:ea typeface="나눔스퀘어 Bold" panose="020B0600000101010101" pitchFamily="50" charset="-127"/>
-                </a:rPr>
-                <a:t>Entity</a:t>
-              </a:r>
-              <a:endParaRPr lang="ko-KR" altLang="en-US" sz="2800" dirty="0">
-                <a:solidFill>
-                  <a:schemeClr val="tx1"/>
-                </a:solidFill>
+      <p:sp>
+        <p:nvSpPr>
+          <p:cNvPr id="3" name="타원 2"/>
+          <p:cNvSpPr>
+            <a:spLocks noChangeAspect="1"/>
+          </p:cNvSpPr>
+          <p:nvPr/>
+        </p:nvSpPr>
+        <p:spPr>
+          <a:xfrm>
+            <a:off x="993319" y="3536322"/>
+            <a:ext cx="540000" cy="540000"/>
+          </a:xfrm>
+          <a:prstGeom prst="ellipse">
+            <a:avLst/>
+          </a:prstGeom>
+        </p:spPr>
+        <p:style>
+          <a:lnRef idx="2">
+            <a:schemeClr val="accent1">
+              <a:shade val="50000"/>
+            </a:schemeClr>
+          </a:lnRef>
+          <a:fillRef idx="1">
+            <a:schemeClr val="accent1"/>
+          </a:fillRef>
+          <a:effectRef idx="0">
+            <a:schemeClr val="accent1"/>
+          </a:effectRef>
+          <a:fontRef idx="minor">
+            <a:schemeClr val="lt1"/>
+          </a:fontRef>
+        </p:style>
+        <p:txBody>
+          <a:bodyPr rtlCol="0" anchor="ctr"/>
+          <a:lstStyle/>
+          <a:p>
+            <a:pPr algn="ctr"/>
+            <a:endParaRPr lang="ko-KR" altLang="en-US" sz="2400">
+              <a:latin typeface="나눔스퀘어 Bold" panose="020B0600000101010101" pitchFamily="50" charset="-127"/>
+              <a:ea typeface="나눔스퀘어 Bold" panose="020B0600000101010101" pitchFamily="50" charset="-127"/>
+            </a:endParaRPr>
+          </a:p>
+        </p:txBody>
+      </p:sp>
+      <p:sp>
+        <p:nvSpPr>
+          <p:cNvPr id="16" name="타원 15"/>
+          <p:cNvSpPr>
+            <a:spLocks noChangeAspect="1"/>
+          </p:cNvSpPr>
+          <p:nvPr/>
+        </p:nvSpPr>
+        <p:spPr>
+          <a:xfrm>
+            <a:off x="1704383" y="3536322"/>
+            <a:ext cx="540000" cy="540000"/>
+          </a:xfrm>
+          <a:prstGeom prst="ellipse">
+            <a:avLst/>
+          </a:prstGeom>
+        </p:spPr>
+        <p:style>
+          <a:lnRef idx="2">
+            <a:schemeClr val="accent1">
+              <a:shade val="50000"/>
+            </a:schemeClr>
+          </a:lnRef>
+          <a:fillRef idx="1">
+            <a:schemeClr val="accent1"/>
+          </a:fillRef>
+          <a:effectRef idx="0">
+            <a:schemeClr val="accent1"/>
+          </a:effectRef>
+          <a:fontRef idx="minor">
+            <a:schemeClr val="lt1"/>
+          </a:fontRef>
+        </p:style>
+        <p:txBody>
+          <a:bodyPr rtlCol="0" anchor="ctr"/>
+          <a:lstStyle/>
+          <a:p>
+            <a:pPr algn="ctr"/>
+            <a:endParaRPr lang="ko-KR" altLang="en-US" sz="2400">
+              <a:latin typeface="나눔스퀘어 Bold" panose="020B0600000101010101" pitchFamily="50" charset="-127"/>
+              <a:ea typeface="나눔스퀘어 Bold" panose="020B0600000101010101" pitchFamily="50" charset="-127"/>
+            </a:endParaRPr>
+          </a:p>
+        </p:txBody>
+      </p:sp>
+      <p:sp>
+        <p:nvSpPr>
+          <p:cNvPr id="17" name="타원 16"/>
+          <p:cNvSpPr>
+            <a:spLocks noChangeAspect="1"/>
+          </p:cNvSpPr>
+          <p:nvPr/>
+        </p:nvSpPr>
+        <p:spPr>
+          <a:xfrm>
+            <a:off x="2415447" y="3536322"/>
+            <a:ext cx="540000" cy="540000"/>
+          </a:xfrm>
+          <a:prstGeom prst="ellipse">
+            <a:avLst/>
+          </a:prstGeom>
+        </p:spPr>
+        <p:style>
+          <a:lnRef idx="2">
+            <a:schemeClr val="accent1">
+              <a:shade val="50000"/>
+            </a:schemeClr>
+          </a:lnRef>
+          <a:fillRef idx="1">
+            <a:schemeClr val="accent1"/>
+          </a:fillRef>
+          <a:effectRef idx="0">
+            <a:schemeClr val="accent1"/>
+          </a:effectRef>
+          <a:fontRef idx="minor">
+            <a:schemeClr val="lt1"/>
+          </a:fontRef>
+        </p:style>
+        <p:txBody>
+          <a:bodyPr rtlCol="0" anchor="ctr"/>
+          <a:lstStyle/>
+          <a:p>
+            <a:pPr algn="ctr"/>
+            <a:endParaRPr lang="ko-KR" altLang="en-US" sz="2400">
+              <a:latin typeface="나눔스퀘어 Bold" panose="020B0600000101010101" pitchFamily="50" charset="-127"/>
+              <a:ea typeface="나눔스퀘어 Bold" panose="020B0600000101010101" pitchFamily="50" charset="-127"/>
+            </a:endParaRPr>
+          </a:p>
+        </p:txBody>
+      </p:sp>
+      <p:sp>
+        <p:nvSpPr>
+          <p:cNvPr id="18" name="타원 17"/>
+          <p:cNvSpPr>
+            <a:spLocks noChangeAspect="1"/>
+          </p:cNvSpPr>
+          <p:nvPr/>
+        </p:nvSpPr>
+        <p:spPr>
+          <a:xfrm>
+            <a:off x="3126511" y="3536322"/>
+            <a:ext cx="540000" cy="540000"/>
+          </a:xfrm>
+          <a:prstGeom prst="ellipse">
+            <a:avLst/>
+          </a:prstGeom>
+        </p:spPr>
+        <p:style>
+          <a:lnRef idx="2">
+            <a:schemeClr val="accent1">
+              <a:shade val="50000"/>
+            </a:schemeClr>
+          </a:lnRef>
+          <a:fillRef idx="1">
+            <a:schemeClr val="accent1"/>
+          </a:fillRef>
+          <a:effectRef idx="0">
+            <a:schemeClr val="accent1"/>
+          </a:effectRef>
+          <a:fontRef idx="minor">
+            <a:schemeClr val="lt1"/>
+          </a:fontRef>
+        </p:style>
+        <p:txBody>
+          <a:bodyPr rtlCol="0" anchor="ctr"/>
+          <a:lstStyle/>
+          <a:p>
+            <a:pPr algn="ctr"/>
+            <a:endParaRPr lang="ko-KR" altLang="en-US" sz="2400">
+              <a:latin typeface="나눔스퀘어 Bold" panose="020B0600000101010101" pitchFamily="50" charset="-127"/>
+              <a:ea typeface="나눔스퀘어 Bold" panose="020B0600000101010101" pitchFamily="50" charset="-127"/>
+            </a:endParaRPr>
+          </a:p>
+        </p:txBody>
+      </p:sp>
+      <p:sp>
+        <p:nvSpPr>
+          <p:cNvPr id="19" name="타원 18"/>
+          <p:cNvSpPr>
+            <a:spLocks noChangeAspect="1"/>
+          </p:cNvSpPr>
+          <p:nvPr/>
+        </p:nvSpPr>
+        <p:spPr>
+          <a:xfrm>
+            <a:off x="3837575" y="3536322"/>
+            <a:ext cx="540000" cy="540000"/>
+          </a:xfrm>
+          <a:prstGeom prst="ellipse">
+            <a:avLst/>
+          </a:prstGeom>
+        </p:spPr>
+        <p:style>
+          <a:lnRef idx="2">
+            <a:schemeClr val="accent1">
+              <a:shade val="50000"/>
+            </a:schemeClr>
+          </a:lnRef>
+          <a:fillRef idx="1">
+            <a:schemeClr val="accent1"/>
+          </a:fillRef>
+          <a:effectRef idx="0">
+            <a:schemeClr val="accent1"/>
+          </a:effectRef>
+          <a:fontRef idx="minor">
+            <a:schemeClr val="lt1"/>
+          </a:fontRef>
+        </p:style>
+        <p:txBody>
+          <a:bodyPr rtlCol="0" anchor="ctr"/>
+          <a:lstStyle/>
+          <a:p>
+            <a:pPr algn="ctr"/>
+            <a:endParaRPr lang="ko-KR" altLang="en-US" sz="2400">
+              <a:latin typeface="나눔스퀘어 Bold" panose="020B0600000101010101" pitchFamily="50" charset="-127"/>
+              <a:ea typeface="나눔스퀘어 Bold" panose="020B0600000101010101" pitchFamily="50" charset="-127"/>
+            </a:endParaRPr>
+          </a:p>
+        </p:txBody>
+      </p:sp>
+      <p:sp>
+        <p:nvSpPr>
+          <p:cNvPr id="4" name="TextBox 3"/>
+          <p:cNvSpPr txBox="1"/>
+          <p:nvPr/>
+        </p:nvSpPr>
+        <p:spPr>
+          <a:xfrm>
+            <a:off x="2109259" y="413825"/>
+            <a:ext cx="1210588" cy="461665"/>
+          </a:xfrm>
+          <a:prstGeom prst="rect">
+            <a:avLst/>
+          </a:prstGeom>
+          <a:noFill/>
+        </p:spPr>
+        <p:txBody>
+          <a:bodyPr wrap="none" rtlCol="0">
+            <a:spAutoFit/>
+          </a:bodyPr>
+          <a:lstStyle/>
+          <a:p>
+            <a:pPr algn="ctr"/>
+            <a:r>
+              <a:rPr lang="en-US" altLang="ko-KR" sz="2400" dirty="0" smtClean="0">
                 <a:latin typeface="나눔스퀘어 Bold" panose="020B0600000101010101" pitchFamily="50" charset="-127"/>
                 <a:ea typeface="나눔스퀘어 Bold" panose="020B0600000101010101" pitchFamily="50" charset="-127"/>
-              </a:endParaRPr>
-            </a:p>
-          </p:txBody>
-        </p:sp>
-        <p:sp>
-          <p:nvSpPr>
-            <p:cNvPr id="27" name="오른쪽 화살표 26"/>
-            <p:cNvSpPr/>
-            <p:nvPr/>
-          </p:nvSpPr>
-          <p:spPr>
-            <a:xfrm>
-              <a:off x="1980599" y="1409100"/>
-              <a:ext cx="1980000" cy="1440000"/>
-            </a:xfrm>
-            <a:prstGeom prst="rightArrow">
-              <a:avLst/>
-            </a:prstGeom>
+              </a:rPr>
+              <a:t>tomcat</a:t>
+            </a:r>
+            <a:endParaRPr lang="ko-KR" altLang="en-US" sz="2400" dirty="0">
+              <a:latin typeface="나눔스퀘어 Bold" panose="020B0600000101010101" pitchFamily="50" charset="-127"/>
+              <a:ea typeface="나눔스퀘어 Bold" panose="020B0600000101010101" pitchFamily="50" charset="-127"/>
+            </a:endParaRPr>
+          </a:p>
+        </p:txBody>
+      </p:sp>
+      <p:sp>
+        <p:nvSpPr>
+          <p:cNvPr id="5" name="TextBox 4"/>
+          <p:cNvSpPr txBox="1"/>
+          <p:nvPr/>
+        </p:nvSpPr>
+        <p:spPr>
+          <a:xfrm>
+            <a:off x="1422056" y="2894657"/>
+            <a:ext cx="2526782" cy="461665"/>
+          </a:xfrm>
+          <a:prstGeom prst="rect">
+            <a:avLst/>
+          </a:prstGeom>
+          <a:noFill/>
+        </p:spPr>
+        <p:txBody>
+          <a:bodyPr wrap="none" rtlCol="0">
+            <a:spAutoFit/>
+          </a:bodyPr>
+          <a:lstStyle/>
+          <a:p>
+            <a:pPr algn="ctr"/>
+            <a:r>
+              <a:rPr lang="en-US" altLang="ko-KR" sz="2400" dirty="0" smtClean="0">
+                <a:latin typeface="나눔스퀘어 Bold" panose="020B0600000101010101" pitchFamily="50" charset="-127"/>
+                <a:ea typeface="나눔스퀘어 Bold" panose="020B0600000101010101" pitchFamily="50" charset="-127"/>
+              </a:rPr>
+              <a:t>Connection pool</a:t>
+            </a:r>
+            <a:endParaRPr lang="ko-KR" altLang="en-US" sz="2400" dirty="0">
+              <a:latin typeface="나눔스퀘어 Bold" panose="020B0600000101010101" pitchFamily="50" charset="-127"/>
+              <a:ea typeface="나눔스퀘어 Bold" panose="020B0600000101010101" pitchFamily="50" charset="-127"/>
+            </a:endParaRPr>
+          </a:p>
+        </p:txBody>
+      </p:sp>
+      <p:cxnSp>
+        <p:nvCxnSpPr>
+          <p:cNvPr id="7" name="직선 화살표 연결선 6"/>
+          <p:cNvCxnSpPr/>
+          <p:nvPr/>
+        </p:nvCxnSpPr>
+        <p:spPr>
+          <a:xfrm>
+            <a:off x="4125447" y="1556426"/>
+            <a:ext cx="3600000" cy="0"/>
+          </a:xfrm>
+          <a:prstGeom prst="straightConnector1">
+            <a:avLst/>
+          </a:prstGeom>
+          <a:ln w="76200">
             <a:solidFill>
               <a:schemeClr val="accent2"/>
             </a:solidFill>
-            <a:ln>
-              <a:noFill/>
-            </a:ln>
-          </p:spPr>
-          <p:style>
-            <a:lnRef idx="2">
-              <a:schemeClr val="accent1">
-                <a:shade val="50000"/>
-              </a:schemeClr>
-            </a:lnRef>
-            <a:fillRef idx="1">
-              <a:schemeClr val="accent1"/>
-            </a:fillRef>
-            <a:effectRef idx="0">
-              <a:schemeClr val="accent1"/>
-            </a:effectRef>
-            <a:fontRef idx="minor">
-              <a:schemeClr val="lt1"/>
-            </a:fontRef>
-          </p:style>
-          <p:txBody>
-            <a:bodyPr rtlCol="0" anchor="ctr"/>
-            <a:lstStyle/>
-            <a:p>
-              <a:pPr algn="ctr"/>
-              <a:r>
-                <a:rPr lang="ko-KR" altLang="en-US" sz="2800" dirty="0">
-                  <a:solidFill>
-                    <a:schemeClr val="tx1"/>
-                  </a:solidFill>
-                  <a:latin typeface="나눔스퀘어 Bold" panose="020B0600000101010101" pitchFamily="50" charset="-127"/>
-                  <a:ea typeface="나눔스퀘어 Bold" panose="020B0600000101010101" pitchFamily="50" charset="-127"/>
-                </a:rPr>
-                <a:t>이름 변경</a:t>
-              </a:r>
-            </a:p>
-          </p:txBody>
-        </p:sp>
-        <p:sp>
-          <p:nvSpPr>
-            <p:cNvPr id="29" name="오른쪽 화살표 28"/>
-            <p:cNvSpPr/>
-            <p:nvPr/>
-          </p:nvSpPr>
-          <p:spPr>
-            <a:xfrm>
-              <a:off x="7095647" y="1409100"/>
-              <a:ext cx="720000" cy="1440000"/>
-            </a:xfrm>
-            <a:prstGeom prst="rightArrow">
-              <a:avLst/>
-            </a:prstGeom>
+            <a:tailEnd type="triangle"/>
+          </a:ln>
+        </p:spPr>
+        <p:style>
+          <a:lnRef idx="1">
+            <a:schemeClr val="accent1"/>
+          </a:lnRef>
+          <a:fillRef idx="0">
+            <a:schemeClr val="accent1"/>
+          </a:fillRef>
+          <a:effectRef idx="0">
+            <a:schemeClr val="accent1"/>
+          </a:effectRef>
+          <a:fontRef idx="minor">
+            <a:schemeClr val="tx1"/>
+          </a:fontRef>
+        </p:style>
+      </p:cxnSp>
+      <p:cxnSp>
+        <p:nvCxnSpPr>
+          <p:cNvPr id="25" name="직선 화살표 연결선 24"/>
+          <p:cNvCxnSpPr/>
+          <p:nvPr/>
+        </p:nvCxnSpPr>
+        <p:spPr>
+          <a:xfrm flipH="1" flipV="1">
+            <a:off x="4218384" y="2214664"/>
+            <a:ext cx="3600000" cy="0"/>
+          </a:xfrm>
+          <a:prstGeom prst="straightConnector1">
+            <a:avLst/>
+          </a:prstGeom>
+          <a:ln w="76200">
             <a:solidFill>
               <a:schemeClr val="accent2"/>
             </a:solidFill>
-            <a:ln>
-              <a:noFill/>
-            </a:ln>
-          </p:spPr>
-          <p:style>
-            <a:lnRef idx="2">
-              <a:schemeClr val="accent1">
-                <a:shade val="50000"/>
-              </a:schemeClr>
-            </a:lnRef>
-            <a:fillRef idx="1">
-              <a:schemeClr val="accent1"/>
-            </a:fillRef>
-            <a:effectRef idx="0">
-              <a:schemeClr val="accent1"/>
-            </a:effectRef>
-            <a:fontRef idx="minor">
-              <a:schemeClr val="lt1"/>
-            </a:fontRef>
-          </p:style>
-          <p:txBody>
-            <a:bodyPr rtlCol="0" anchor="ctr"/>
-            <a:lstStyle/>
-            <a:p>
-              <a:pPr algn="ctr"/>
-              <a:endParaRPr lang="ko-KR" altLang="en-US">
-                <a:latin typeface="나눔스퀘어 Bold" panose="020B0600000101010101" pitchFamily="50" charset="-127"/>
-                <a:ea typeface="나눔스퀘어 Bold" panose="020B0600000101010101" pitchFamily="50" charset="-127"/>
-              </a:endParaRPr>
-            </a:p>
-          </p:txBody>
-        </p:sp>
-        <p:sp>
-          <p:nvSpPr>
-            <p:cNvPr id="46" name="오른쪽 화살표 45"/>
-            <p:cNvSpPr/>
-            <p:nvPr/>
-          </p:nvSpPr>
-          <p:spPr>
-            <a:xfrm>
-              <a:off x="10227947" y="1409100"/>
-              <a:ext cx="720000" cy="1440000"/>
-            </a:xfrm>
-            <a:prstGeom prst="rightArrow">
-              <a:avLst/>
-            </a:prstGeom>
+            <a:tailEnd type="triangle"/>
+          </a:ln>
+        </p:spPr>
+        <p:style>
+          <a:lnRef idx="1">
+            <a:schemeClr val="accent1"/>
+          </a:lnRef>
+          <a:fillRef idx="0">
+            <a:schemeClr val="accent1"/>
+          </a:fillRef>
+          <a:effectRef idx="0">
+            <a:schemeClr val="accent1"/>
+          </a:effectRef>
+          <a:fontRef idx="minor">
+            <a:schemeClr val="tx1"/>
+          </a:fontRef>
+        </p:style>
+      </p:cxnSp>
+      <p:cxnSp>
+        <p:nvCxnSpPr>
+          <p:cNvPr id="10" name="직선 연결선 9"/>
+          <p:cNvCxnSpPr/>
+          <p:nvPr/>
+        </p:nvCxnSpPr>
+        <p:spPr>
+          <a:xfrm>
+            <a:off x="5954553" y="1844118"/>
+            <a:ext cx="720000" cy="720000"/>
+          </a:xfrm>
+          <a:prstGeom prst="line">
+            <a:avLst/>
+          </a:prstGeom>
+          <a:ln w="76200">
             <a:solidFill>
-              <a:schemeClr val="accent2"/>
+              <a:srgbClr val="C00000"/>
             </a:solidFill>
-            <a:ln>
-              <a:noFill/>
-            </a:ln>
-          </p:spPr>
-          <p:style>
-            <a:lnRef idx="2">
-              <a:schemeClr val="accent1">
-                <a:shade val="50000"/>
-              </a:schemeClr>
-            </a:lnRef>
-            <a:fillRef idx="1">
-              <a:schemeClr val="accent1"/>
-            </a:fillRef>
-            <a:effectRef idx="0">
-              <a:schemeClr val="accent1"/>
-            </a:effectRef>
-            <a:fontRef idx="minor">
-              <a:schemeClr val="lt1"/>
-            </a:fontRef>
-          </p:style>
-          <p:txBody>
-            <a:bodyPr rtlCol="0" anchor="ctr"/>
-            <a:lstStyle/>
-            <a:p>
-              <a:pPr algn="ctr"/>
-              <a:endParaRPr lang="ko-KR" altLang="en-US">
-                <a:latin typeface="나눔스퀘어 Bold" panose="020B0600000101010101" pitchFamily="50" charset="-127"/>
-                <a:ea typeface="나눔스퀘어 Bold" panose="020B0600000101010101" pitchFamily="50" charset="-127"/>
-              </a:endParaRPr>
-            </a:p>
-          </p:txBody>
-        </p:sp>
-      </p:grpSp>
+          </a:ln>
+        </p:spPr>
+        <p:style>
+          <a:lnRef idx="1">
+            <a:schemeClr val="accent1"/>
+          </a:lnRef>
+          <a:fillRef idx="0">
+            <a:schemeClr val="accent1"/>
+          </a:fillRef>
+          <a:effectRef idx="0">
+            <a:schemeClr val="accent1"/>
+          </a:effectRef>
+          <a:fontRef idx="minor">
+            <a:schemeClr val="tx1"/>
+          </a:fontRef>
+        </p:style>
+      </p:cxnSp>
+      <p:cxnSp>
+        <p:nvCxnSpPr>
+          <p:cNvPr id="32" name="직선 연결선 31"/>
+          <p:cNvCxnSpPr/>
+          <p:nvPr/>
+        </p:nvCxnSpPr>
+        <p:spPr>
+          <a:xfrm flipH="1">
+            <a:off x="5954553" y="1854664"/>
+            <a:ext cx="720000" cy="720000"/>
+          </a:xfrm>
+          <a:prstGeom prst="line">
+            <a:avLst/>
+          </a:prstGeom>
+          <a:ln w="76200">
+            <a:solidFill>
+              <a:srgbClr val="C00000"/>
+            </a:solidFill>
+          </a:ln>
+        </p:spPr>
+        <p:style>
+          <a:lnRef idx="1">
+            <a:schemeClr val="accent1"/>
+          </a:lnRef>
+          <a:fillRef idx="0">
+            <a:schemeClr val="accent1"/>
+          </a:fillRef>
+          <a:effectRef idx="0">
+            <a:schemeClr val="accent1"/>
+          </a:effectRef>
+          <a:fontRef idx="minor">
+            <a:schemeClr val="tx1"/>
+          </a:fontRef>
+        </p:style>
+      </p:cxnSp>
     </p:spTree>
     <p:extLst>
       <p:ext uri="{BB962C8B-B14F-4D97-AF65-F5344CB8AC3E}">

</xml_diff>

<commit_message>
20260902 commit : Notion rest, At Home
</commit_message>
<xml_diff>
--- a/notion/create_notion_img.pptx
+++ b/notion/create_notion_img.pptx
@@ -245,7 +245,7 @@
           <a:p>
             <a:fld id="{7237CE1A-8831-48B5-BA93-72483C6E34E8}" type="datetimeFigureOut">
               <a:rPr lang="ko-KR" altLang="en-US" smtClean="0"/>
-              <a:t>26-09-01(Tue)</a:t>
+              <a:t>2026-09-02</a:t>
             </a:fld>
             <a:endParaRPr lang="ko-KR" altLang="en-US"/>
           </a:p>
@@ -415,7 +415,7 @@
           <a:p>
             <a:fld id="{7237CE1A-8831-48B5-BA93-72483C6E34E8}" type="datetimeFigureOut">
               <a:rPr lang="ko-KR" altLang="en-US" smtClean="0"/>
-              <a:t>26-09-01(Tue)</a:t>
+              <a:t>2026-09-02</a:t>
             </a:fld>
             <a:endParaRPr lang="ko-KR" altLang="en-US"/>
           </a:p>
@@ -595,7 +595,7 @@
           <a:p>
             <a:fld id="{7237CE1A-8831-48B5-BA93-72483C6E34E8}" type="datetimeFigureOut">
               <a:rPr lang="ko-KR" altLang="en-US" smtClean="0"/>
-              <a:t>26-09-01(Tue)</a:t>
+              <a:t>2026-09-02</a:t>
             </a:fld>
             <a:endParaRPr lang="ko-KR" altLang="en-US"/>
           </a:p>
@@ -765,7 +765,7 @@
           <a:p>
             <a:fld id="{7237CE1A-8831-48B5-BA93-72483C6E34E8}" type="datetimeFigureOut">
               <a:rPr lang="ko-KR" altLang="en-US" smtClean="0"/>
-              <a:t>26-09-01(Tue)</a:t>
+              <a:t>2026-09-02</a:t>
             </a:fld>
             <a:endParaRPr lang="ko-KR" altLang="en-US"/>
           </a:p>
@@ -1011,7 +1011,7 @@
           <a:p>
             <a:fld id="{7237CE1A-8831-48B5-BA93-72483C6E34E8}" type="datetimeFigureOut">
               <a:rPr lang="ko-KR" altLang="en-US" smtClean="0"/>
-              <a:t>26-09-01(Tue)</a:t>
+              <a:t>2026-09-02</a:t>
             </a:fld>
             <a:endParaRPr lang="ko-KR" altLang="en-US"/>
           </a:p>
@@ -1243,7 +1243,7 @@
           <a:p>
             <a:fld id="{7237CE1A-8831-48B5-BA93-72483C6E34E8}" type="datetimeFigureOut">
               <a:rPr lang="ko-KR" altLang="en-US" smtClean="0"/>
-              <a:t>26-09-01(Tue)</a:t>
+              <a:t>2026-09-02</a:t>
             </a:fld>
             <a:endParaRPr lang="ko-KR" altLang="en-US"/>
           </a:p>
@@ -1610,7 +1610,7 @@
           <a:p>
             <a:fld id="{7237CE1A-8831-48B5-BA93-72483C6E34E8}" type="datetimeFigureOut">
               <a:rPr lang="ko-KR" altLang="en-US" smtClean="0"/>
-              <a:t>26-09-01(Tue)</a:t>
+              <a:t>2026-09-02</a:t>
             </a:fld>
             <a:endParaRPr lang="ko-KR" altLang="en-US"/>
           </a:p>
@@ -1728,7 +1728,7 @@
           <a:p>
             <a:fld id="{7237CE1A-8831-48B5-BA93-72483C6E34E8}" type="datetimeFigureOut">
               <a:rPr lang="ko-KR" altLang="en-US" smtClean="0"/>
-              <a:t>26-09-01(Tue)</a:t>
+              <a:t>2026-09-02</a:t>
             </a:fld>
             <a:endParaRPr lang="ko-KR" altLang="en-US"/>
           </a:p>
@@ -1823,7 +1823,7 @@
           <a:p>
             <a:fld id="{7237CE1A-8831-48B5-BA93-72483C6E34E8}" type="datetimeFigureOut">
               <a:rPr lang="ko-KR" altLang="en-US" smtClean="0"/>
-              <a:t>26-09-01(Tue)</a:t>
+              <a:t>2026-09-02</a:t>
             </a:fld>
             <a:endParaRPr lang="ko-KR" altLang="en-US"/>
           </a:p>
@@ -2100,7 +2100,7 @@
           <a:p>
             <a:fld id="{7237CE1A-8831-48B5-BA93-72483C6E34E8}" type="datetimeFigureOut">
               <a:rPr lang="ko-KR" altLang="en-US" smtClean="0"/>
-              <a:t>26-09-01(Tue)</a:t>
+              <a:t>2026-09-02</a:t>
             </a:fld>
             <a:endParaRPr lang="ko-KR" altLang="en-US"/>
           </a:p>
@@ -2353,7 +2353,7 @@
           <a:p>
             <a:fld id="{7237CE1A-8831-48B5-BA93-72483C6E34E8}" type="datetimeFigureOut">
               <a:rPr lang="ko-KR" altLang="en-US" smtClean="0"/>
-              <a:t>26-09-01(Tue)</a:t>
+              <a:t>2026-09-02</a:t>
             </a:fld>
             <a:endParaRPr lang="ko-KR" altLang="en-US"/>
           </a:p>
@@ -2566,7 +2566,7 @@
           <a:p>
             <a:fld id="{7237CE1A-8831-48B5-BA93-72483C6E34E8}" type="datetimeFigureOut">
               <a:rPr lang="ko-KR" altLang="en-US" smtClean="0"/>
-              <a:t>26-09-01(Tue)</a:t>
+              <a:t>2026-09-02</a:t>
             </a:fld>
             <a:endParaRPr lang="ko-KR" altLang="en-US"/>
           </a:p>
@@ -2971,641 +2971,810 @@
           <a:chExt cx="0" cy="0"/>
         </a:xfrm>
       </p:grpSpPr>
-      <p:sp>
-        <p:nvSpPr>
-          <p:cNvPr id="21" name="직사각형 20"/>
-          <p:cNvSpPr/>
-          <p:nvPr/>
-        </p:nvSpPr>
-        <p:spPr>
-          <a:xfrm>
-            <a:off x="525447" y="3356322"/>
-            <a:ext cx="4320000" cy="900000"/>
-          </a:xfrm>
-          <a:prstGeom prst="rect">
-            <a:avLst/>
-          </a:prstGeom>
-          <a:noFill/>
-          <a:ln w="57150">
+      <p:grpSp>
+        <p:nvGrpSpPr>
+          <p:cNvPr id="34" name="그룹 33"/>
+          <p:cNvGrpSpPr/>
+          <p:nvPr/>
+        </p:nvGrpSpPr>
+        <p:grpSpPr>
+          <a:xfrm>
+            <a:off x="1364343" y="5058000"/>
+            <a:ext cx="8114172" cy="1807027"/>
+            <a:chOff x="1364343" y="5058000"/>
+            <a:chExt cx="8114172" cy="1807027"/>
+          </a:xfrm>
+        </p:grpSpPr>
+        <p:sp>
+          <p:nvSpPr>
+            <p:cNvPr id="23" name="직사각형 22"/>
+            <p:cNvSpPr/>
+            <p:nvPr/>
+          </p:nvSpPr>
+          <p:spPr>
+            <a:xfrm>
+              <a:off x="1364343" y="5065027"/>
+              <a:ext cx="3600000" cy="1800000"/>
+            </a:xfrm>
+            <a:prstGeom prst="rect">
+              <a:avLst/>
+            </a:prstGeom>
             <a:solidFill>
+              <a:schemeClr val="accent5"/>
+            </a:solidFill>
+            <a:ln>
+              <a:noFill/>
+            </a:ln>
+          </p:spPr>
+          <p:style>
+            <a:lnRef idx="2">
+              <a:schemeClr val="accent1">
+                <a:shade val="50000"/>
+              </a:schemeClr>
+            </a:lnRef>
+            <a:fillRef idx="1">
+              <a:schemeClr val="accent1"/>
+            </a:fillRef>
+            <a:effectRef idx="0">
+              <a:schemeClr val="accent1"/>
+            </a:effectRef>
+            <a:fontRef idx="minor">
+              <a:schemeClr val="lt1"/>
+            </a:fontRef>
+          </p:style>
+          <p:txBody>
+            <a:bodyPr rtlCol="0" anchor="ctr"/>
+            <a:lstStyle/>
+            <a:p>
+              <a:pPr algn="ctr"/>
+              <a:r>
+                <a:rPr lang="en-US" altLang="ko-KR" sz="3200" dirty="0">
+                  <a:latin typeface="나눔스퀘어 Bold" panose="020B0600000101010101" pitchFamily="50" charset="-127"/>
+                  <a:ea typeface="나눔스퀘어 Bold" panose="020B0600000101010101" pitchFamily="50" charset="-127"/>
+                </a:rPr>
+                <a:t>Application</a:t>
+              </a:r>
+            </a:p>
+            <a:p>
+              <a:pPr algn="ctr"/>
+              <a:r>
+                <a:rPr lang="en-US" altLang="ko-KR" sz="3200" dirty="0">
+                  <a:latin typeface="나눔스퀘어 Bold" panose="020B0600000101010101" pitchFamily="50" charset="-127"/>
+                  <a:ea typeface="나눔스퀘어 Bold" panose="020B0600000101010101" pitchFamily="50" charset="-127"/>
+                </a:rPr>
+                <a:t>(Service &gt; Dao</a:t>
+              </a:r>
+              <a:r>
+                <a:rPr lang="en-US" altLang="ko-KR" sz="3200" dirty="0" smtClean="0">
+                  <a:latin typeface="나눔스퀘어 Bold" panose="020B0600000101010101" pitchFamily="50" charset="-127"/>
+                  <a:ea typeface="나눔스퀘어 Bold" panose="020B0600000101010101" pitchFamily="50" charset="-127"/>
+                </a:rPr>
+                <a:t>)</a:t>
+              </a:r>
+            </a:p>
+            <a:p>
+              <a:pPr algn="ctr"/>
+              <a:endParaRPr lang="ko-KR" altLang="en-US" sz="3200" dirty="0">
+                <a:latin typeface="나눔스퀘어 Bold" panose="020B0600000101010101" pitchFamily="50" charset="-127"/>
+                <a:ea typeface="나눔스퀘어 Bold" panose="020B0600000101010101" pitchFamily="50" charset="-127"/>
+              </a:endParaRPr>
+            </a:p>
+          </p:txBody>
+        </p:sp>
+        <p:sp>
+          <p:nvSpPr>
+            <p:cNvPr id="24" name="직사각형 23"/>
+            <p:cNvSpPr/>
+            <p:nvPr/>
+          </p:nvSpPr>
+          <p:spPr>
+            <a:xfrm>
+              <a:off x="7678515" y="5058000"/>
+              <a:ext cx="1800000" cy="1800000"/>
+            </a:xfrm>
+            <a:prstGeom prst="rect">
+              <a:avLst/>
+            </a:prstGeom>
+            <a:solidFill>
+              <a:schemeClr val="accent5"/>
+            </a:solidFill>
+            <a:ln>
+              <a:noFill/>
+            </a:ln>
+          </p:spPr>
+          <p:style>
+            <a:lnRef idx="2">
+              <a:schemeClr val="accent1">
+                <a:shade val="50000"/>
+              </a:schemeClr>
+            </a:lnRef>
+            <a:fillRef idx="1">
+              <a:schemeClr val="accent1"/>
+            </a:fillRef>
+            <a:effectRef idx="0">
+              <a:schemeClr val="accent1"/>
+            </a:effectRef>
+            <a:fontRef idx="minor">
+              <a:schemeClr val="lt1"/>
+            </a:fontRef>
+          </p:style>
+          <p:txBody>
+            <a:bodyPr rtlCol="0" anchor="ctr"/>
+            <a:lstStyle/>
+            <a:p>
+              <a:pPr algn="ctr"/>
+              <a:r>
+                <a:rPr lang="en-US" altLang="ko-KR" sz="3200" dirty="0">
+                  <a:latin typeface="나눔스퀘어 Bold" panose="020B0600000101010101" pitchFamily="50" charset="-127"/>
+                  <a:ea typeface="나눔스퀘어 Bold" panose="020B0600000101010101" pitchFamily="50" charset="-127"/>
+                </a:rPr>
+                <a:t>DB</a:t>
+              </a:r>
+              <a:endParaRPr lang="ko-KR" altLang="en-US" sz="3200" dirty="0">
+                <a:latin typeface="나눔스퀘어 Bold" panose="020B0600000101010101" pitchFamily="50" charset="-127"/>
+                <a:ea typeface="나눔스퀘어 Bold" panose="020B0600000101010101" pitchFamily="50" charset="-127"/>
+              </a:endParaRPr>
+            </a:p>
+            <a:p>
+              <a:pPr algn="ctr"/>
+              <a:endParaRPr lang="ko-KR" altLang="en-US" sz="3200" dirty="0">
+                <a:latin typeface="나눔스퀘어 Bold" panose="020B0600000101010101" pitchFamily="50" charset="-127"/>
+                <a:ea typeface="나눔스퀘어 Bold" panose="020B0600000101010101" pitchFamily="50" charset="-127"/>
+              </a:endParaRPr>
+            </a:p>
+          </p:txBody>
+        </p:sp>
+        <p:cxnSp>
+          <p:nvCxnSpPr>
+            <p:cNvPr id="26" name="직선 화살표 연결선 25"/>
+            <p:cNvCxnSpPr/>
+            <p:nvPr/>
+          </p:nvCxnSpPr>
+          <p:spPr>
+            <a:xfrm>
+              <a:off x="4964343" y="5667600"/>
+              <a:ext cx="2520000" cy="0"/>
+            </a:xfrm>
+            <a:prstGeom prst="straightConnector1">
+              <a:avLst/>
+            </a:prstGeom>
+            <a:ln w="76200">
+              <a:solidFill>
+                <a:srgbClr val="ED7D31"/>
+              </a:solidFill>
+              <a:tailEnd type="triangle"/>
+            </a:ln>
+          </p:spPr>
+          <p:style>
+            <a:lnRef idx="1">
+              <a:schemeClr val="accent1"/>
+            </a:lnRef>
+            <a:fillRef idx="0">
+              <a:schemeClr val="accent1"/>
+            </a:fillRef>
+            <a:effectRef idx="0">
+              <a:schemeClr val="accent1"/>
+            </a:effectRef>
+            <a:fontRef idx="minor">
               <a:schemeClr val="tx1"/>
+            </a:fontRef>
+          </p:style>
+        </p:cxnSp>
+        <p:cxnSp>
+          <p:nvCxnSpPr>
+            <p:cNvPr id="27" name="직선 화살표 연결선 26"/>
+            <p:cNvCxnSpPr/>
+            <p:nvPr/>
+          </p:nvCxnSpPr>
+          <p:spPr>
+            <a:xfrm flipH="1" flipV="1">
+              <a:off x="5158515" y="6386056"/>
+              <a:ext cx="2520000" cy="0"/>
+            </a:xfrm>
+            <a:prstGeom prst="straightConnector1">
+              <a:avLst/>
+            </a:prstGeom>
+            <a:ln w="76200">
+              <a:solidFill>
+                <a:srgbClr val="ED7D31"/>
+              </a:solidFill>
+              <a:tailEnd type="triangle"/>
+            </a:ln>
+          </p:spPr>
+          <p:style>
+            <a:lnRef idx="1">
+              <a:schemeClr val="accent1"/>
+            </a:lnRef>
+            <a:fillRef idx="0">
+              <a:schemeClr val="accent1"/>
+            </a:fillRef>
+            <a:effectRef idx="0">
+              <a:schemeClr val="accent1"/>
+            </a:effectRef>
+            <a:fontRef idx="minor">
+              <a:schemeClr val="tx1"/>
+            </a:fontRef>
+          </p:style>
+        </p:cxnSp>
+        <p:sp>
+          <p:nvSpPr>
+            <p:cNvPr id="29" name="모서리가 둥근 직사각형 28"/>
+            <p:cNvSpPr/>
+            <p:nvPr/>
+          </p:nvSpPr>
+          <p:spPr>
+            <a:xfrm>
+              <a:off x="1724343" y="6228112"/>
+              <a:ext cx="2880000" cy="432000"/>
+            </a:xfrm>
+            <a:prstGeom prst="roundRect">
+              <a:avLst/>
+            </a:prstGeom>
+            <a:solidFill>
+              <a:schemeClr val="bg1"/>
             </a:solidFill>
-          </a:ln>
-        </p:spPr>
-        <p:style>
-          <a:lnRef idx="2">
-            <a:schemeClr val="accent1">
-              <a:shade val="50000"/>
-            </a:schemeClr>
-          </a:lnRef>
-          <a:fillRef idx="1">
-            <a:schemeClr val="accent1"/>
-          </a:fillRef>
-          <a:effectRef idx="0">
-            <a:schemeClr val="accent1"/>
-          </a:effectRef>
-          <a:fontRef idx="minor">
-            <a:schemeClr val="lt1"/>
-          </a:fontRef>
-        </p:style>
-        <p:txBody>
-          <a:bodyPr rtlCol="0" anchor="ctr"/>
-          <a:lstStyle/>
-          <a:p>
-            <a:pPr algn="ctr"/>
-            <a:endParaRPr lang="ko-KR" altLang="en-US" sz="2400">
-              <a:latin typeface="나눔스퀘어 Bold" panose="020B0600000101010101" pitchFamily="50" charset="-127"/>
-              <a:ea typeface="나눔스퀘어 Bold" panose="020B0600000101010101" pitchFamily="50" charset="-127"/>
-            </a:endParaRPr>
-          </a:p>
-        </p:txBody>
-      </p:sp>
-      <p:sp>
-        <p:nvSpPr>
-          <p:cNvPr id="2" name="직사각형 1"/>
-          <p:cNvSpPr/>
-          <p:nvPr/>
-        </p:nvSpPr>
-        <p:spPr>
-          <a:xfrm>
-            <a:off x="194553" y="875490"/>
-            <a:ext cx="5040000" cy="3600000"/>
-          </a:xfrm>
-          <a:prstGeom prst="rect">
-            <a:avLst/>
-          </a:prstGeom>
-          <a:noFill/>
-          <a:ln w="57150">
+            <a:ln>
+              <a:noFill/>
+            </a:ln>
+          </p:spPr>
+          <p:style>
+            <a:lnRef idx="2">
+              <a:schemeClr val="accent1">
+                <a:shade val="50000"/>
+              </a:schemeClr>
+            </a:lnRef>
+            <a:fillRef idx="1">
+              <a:schemeClr val="accent1"/>
+            </a:fillRef>
+            <a:effectRef idx="0">
+              <a:schemeClr val="accent1"/>
+            </a:effectRef>
+            <a:fontRef idx="minor">
+              <a:schemeClr val="lt1"/>
+            </a:fontRef>
+          </p:style>
+          <p:txBody>
+            <a:bodyPr rtlCol="0" anchor="ctr"/>
+            <a:lstStyle/>
+            <a:p>
+              <a:pPr algn="ctr"/>
+              <a:r>
+                <a:rPr lang="ko-KR" altLang="en-US" dirty="0" smtClean="0">
+                  <a:solidFill>
+                    <a:schemeClr val="tx1"/>
+                  </a:solidFill>
+                  <a:latin typeface="나눔스퀘어 Bold" panose="020B0600000101010101" pitchFamily="50" charset="-127"/>
+                  <a:ea typeface="나눔스퀘어 Bold" panose="020B0600000101010101" pitchFamily="50" charset="-127"/>
+                </a:rPr>
+                <a:t>내림차순</a:t>
+              </a:r>
+              <a:endParaRPr lang="ko-KR" altLang="en-US" dirty="0">
+                <a:solidFill>
+                  <a:schemeClr val="tx1"/>
+                </a:solidFill>
+                <a:latin typeface="나눔스퀘어 Bold" panose="020B0600000101010101" pitchFamily="50" charset="-127"/>
+                <a:ea typeface="나눔스퀘어 Bold" panose="020B0600000101010101" pitchFamily="50" charset="-127"/>
+              </a:endParaRPr>
+            </a:p>
+          </p:txBody>
+        </p:sp>
+        <p:sp>
+          <p:nvSpPr>
+            <p:cNvPr id="30" name="모서리가 둥근 직사각형 29"/>
+            <p:cNvSpPr/>
+            <p:nvPr/>
+          </p:nvSpPr>
+          <p:spPr>
+            <a:xfrm>
+              <a:off x="7858515" y="6228112"/>
+              <a:ext cx="1440000" cy="432000"/>
+            </a:xfrm>
+            <a:prstGeom prst="roundRect">
+              <a:avLst/>
+            </a:prstGeom>
             <a:solidFill>
+              <a:schemeClr val="bg1"/>
+            </a:solidFill>
+            <a:ln>
+              <a:noFill/>
+            </a:ln>
+          </p:spPr>
+          <p:style>
+            <a:lnRef idx="2">
+              <a:schemeClr val="accent1">
+                <a:shade val="50000"/>
+              </a:schemeClr>
+            </a:lnRef>
+            <a:fillRef idx="1">
+              <a:schemeClr val="accent1"/>
+            </a:fillRef>
+            <a:effectRef idx="0">
+              <a:schemeClr val="accent1"/>
+            </a:effectRef>
+            <a:fontRef idx="minor">
+              <a:schemeClr val="lt1"/>
+            </a:fontRef>
+          </p:style>
+          <p:txBody>
+            <a:bodyPr rtlCol="0" anchor="ctr"/>
+            <a:lstStyle/>
+            <a:p>
+              <a:pPr algn="ctr"/>
+              <a:r>
+                <a:rPr lang="ko-KR" altLang="en-US" sz="1100" dirty="0" smtClean="0">
+                  <a:solidFill>
+                    <a:schemeClr val="tx1"/>
+                  </a:solidFill>
+                  <a:latin typeface="나눔스퀘어 Bold" panose="020B0600000101010101" pitchFamily="50" charset="-127"/>
+                  <a:ea typeface="나눔스퀘어 Bold" panose="020B0600000101010101" pitchFamily="50" charset="-127"/>
+                </a:rPr>
+                <a:t>오름차순 </a:t>
+              </a:r>
+              <a:r>
+                <a:rPr lang="en-US" altLang="ko-KR" sz="1100" dirty="0" smtClean="0">
+                  <a:solidFill>
+                    <a:schemeClr val="tx1"/>
+                  </a:solidFill>
+                  <a:latin typeface="나눔스퀘어 Bold" panose="020B0600000101010101" pitchFamily="50" charset="-127"/>
+                  <a:ea typeface="나눔스퀘어 Bold" panose="020B0600000101010101" pitchFamily="50" charset="-127"/>
+                </a:rPr>
+                <a:t>&gt; </a:t>
+              </a:r>
+              <a:r>
+                <a:rPr lang="ko-KR" altLang="en-US" sz="1100" dirty="0" smtClean="0">
+                  <a:solidFill>
+                    <a:schemeClr val="tx1"/>
+                  </a:solidFill>
+                  <a:latin typeface="나눔스퀘어 Bold" panose="020B0600000101010101" pitchFamily="50" charset="-127"/>
+                  <a:ea typeface="나눔스퀘어 Bold" panose="020B0600000101010101" pitchFamily="50" charset="-127"/>
+                </a:rPr>
+                <a:t>내림차순</a:t>
+              </a:r>
+              <a:endParaRPr lang="ko-KR" altLang="en-US" sz="1100" dirty="0">
+                <a:solidFill>
+                  <a:schemeClr val="tx1"/>
+                </a:solidFill>
+                <a:latin typeface="나눔스퀘어 Bold" panose="020B0600000101010101" pitchFamily="50" charset="-127"/>
+                <a:ea typeface="나눔스퀘어 Bold" panose="020B0600000101010101" pitchFamily="50" charset="-127"/>
+              </a:endParaRPr>
+            </a:p>
+          </p:txBody>
+        </p:sp>
+        <p:sp>
+          <p:nvSpPr>
+            <p:cNvPr id="31" name="모서리가 둥근 직사각형 30"/>
+            <p:cNvSpPr/>
+            <p:nvPr/>
+          </p:nvSpPr>
+          <p:spPr>
+            <a:xfrm>
+              <a:off x="5504343" y="6426000"/>
+              <a:ext cx="1440000" cy="432000"/>
+            </a:xfrm>
+            <a:prstGeom prst="roundRect">
+              <a:avLst/>
+            </a:prstGeom>
+            <a:solidFill>
+              <a:schemeClr val="bg1"/>
+            </a:solidFill>
+            <a:ln>
+              <a:noFill/>
+            </a:ln>
+          </p:spPr>
+          <p:style>
+            <a:lnRef idx="2">
+              <a:schemeClr val="accent1">
+                <a:shade val="50000"/>
+              </a:schemeClr>
+            </a:lnRef>
+            <a:fillRef idx="1">
+              <a:schemeClr val="accent1"/>
+            </a:fillRef>
+            <a:effectRef idx="0">
+              <a:schemeClr val="accent1"/>
+            </a:effectRef>
+            <a:fontRef idx="minor">
+              <a:schemeClr val="lt1"/>
+            </a:fontRef>
+          </p:style>
+          <p:txBody>
+            <a:bodyPr rtlCol="0" anchor="ctr"/>
+            <a:lstStyle/>
+            <a:p>
+              <a:pPr algn="ctr"/>
+              <a:r>
+                <a:rPr lang="ko-KR" altLang="en-US" dirty="0" smtClean="0">
+                  <a:solidFill>
+                    <a:schemeClr val="tx1"/>
+                  </a:solidFill>
+                  <a:latin typeface="나눔스퀘어 Bold" panose="020B0600000101010101" pitchFamily="50" charset="-127"/>
+                  <a:ea typeface="나눔스퀘어 Bold" panose="020B0600000101010101" pitchFamily="50" charset="-127"/>
+                </a:rPr>
+                <a:t>내림차순</a:t>
+              </a:r>
+              <a:endParaRPr lang="ko-KR" altLang="en-US" dirty="0">
+                <a:solidFill>
+                  <a:schemeClr val="tx1"/>
+                </a:solidFill>
+                <a:latin typeface="나눔스퀘어 Bold" panose="020B0600000101010101" pitchFamily="50" charset="-127"/>
+                <a:ea typeface="나눔스퀘어 Bold" panose="020B0600000101010101" pitchFamily="50" charset="-127"/>
+              </a:endParaRPr>
+            </a:p>
+          </p:txBody>
+        </p:sp>
+      </p:grpSp>
+      <p:grpSp>
+        <p:nvGrpSpPr>
+          <p:cNvPr id="28" name="그룹 27"/>
+          <p:cNvGrpSpPr/>
+          <p:nvPr/>
+        </p:nvGrpSpPr>
+        <p:grpSpPr>
+          <a:xfrm>
+            <a:off x="1364343" y="0"/>
+            <a:ext cx="8114172" cy="1807027"/>
+            <a:chOff x="1364343" y="0"/>
+            <a:chExt cx="8114172" cy="1807027"/>
+          </a:xfrm>
+        </p:grpSpPr>
+        <p:sp>
+          <p:nvSpPr>
+            <p:cNvPr id="6" name="직사각형 5"/>
+            <p:cNvSpPr/>
+            <p:nvPr/>
+          </p:nvSpPr>
+          <p:spPr>
+            <a:xfrm>
+              <a:off x="1364343" y="7027"/>
+              <a:ext cx="3600000" cy="1800000"/>
+            </a:xfrm>
+            <a:prstGeom prst="rect">
+              <a:avLst/>
+            </a:prstGeom>
+            <a:solidFill>
+              <a:schemeClr val="accent5"/>
+            </a:solidFill>
+            <a:ln>
+              <a:noFill/>
+            </a:ln>
+          </p:spPr>
+          <p:style>
+            <a:lnRef idx="2">
+              <a:schemeClr val="accent1">
+                <a:shade val="50000"/>
+              </a:schemeClr>
+            </a:lnRef>
+            <a:fillRef idx="1">
+              <a:schemeClr val="accent1"/>
+            </a:fillRef>
+            <a:effectRef idx="0">
+              <a:schemeClr val="accent1"/>
+            </a:effectRef>
+            <a:fontRef idx="minor">
+              <a:schemeClr val="lt1"/>
+            </a:fontRef>
+          </p:style>
+          <p:txBody>
+            <a:bodyPr rtlCol="0" anchor="ctr"/>
+            <a:lstStyle/>
+            <a:p>
+              <a:pPr algn="ctr"/>
+              <a:r>
+                <a:rPr lang="en-US" altLang="ko-KR" sz="3200" dirty="0" smtClean="0">
+                  <a:latin typeface="나눔스퀘어 Bold" panose="020B0600000101010101" pitchFamily="50" charset="-127"/>
+                  <a:ea typeface="나눔스퀘어 Bold" panose="020B0600000101010101" pitchFamily="50" charset="-127"/>
+                </a:rPr>
+                <a:t>Application</a:t>
+              </a:r>
+            </a:p>
+            <a:p>
+              <a:pPr algn="ctr"/>
+              <a:r>
+                <a:rPr lang="en-US" altLang="ko-KR" sz="3200" dirty="0" smtClean="0">
+                  <a:latin typeface="나눔스퀘어 Bold" panose="020B0600000101010101" pitchFamily="50" charset="-127"/>
+                  <a:ea typeface="나눔스퀘어 Bold" panose="020B0600000101010101" pitchFamily="50" charset="-127"/>
+                </a:rPr>
+                <a:t>(Service &gt; Dao)</a:t>
+              </a:r>
+            </a:p>
+            <a:p>
+              <a:pPr algn="ctr"/>
+              <a:endParaRPr lang="ko-KR" altLang="en-US" sz="3200" dirty="0">
+                <a:latin typeface="나눔스퀘어 Bold" panose="020B0600000101010101" pitchFamily="50" charset="-127"/>
+                <a:ea typeface="나눔스퀘어 Bold" panose="020B0600000101010101" pitchFamily="50" charset="-127"/>
+              </a:endParaRPr>
+            </a:p>
+          </p:txBody>
+        </p:sp>
+        <p:sp>
+          <p:nvSpPr>
+            <p:cNvPr id="20" name="직사각형 19"/>
+            <p:cNvSpPr/>
+            <p:nvPr/>
+          </p:nvSpPr>
+          <p:spPr>
+            <a:xfrm>
+              <a:off x="7678515" y="0"/>
+              <a:ext cx="1800000" cy="1800000"/>
+            </a:xfrm>
+            <a:prstGeom prst="rect">
+              <a:avLst/>
+            </a:prstGeom>
+            <a:solidFill>
+              <a:schemeClr val="accent5"/>
+            </a:solidFill>
+            <a:ln>
+              <a:noFill/>
+            </a:ln>
+          </p:spPr>
+          <p:style>
+            <a:lnRef idx="2">
+              <a:schemeClr val="accent1">
+                <a:shade val="50000"/>
+              </a:schemeClr>
+            </a:lnRef>
+            <a:fillRef idx="1">
+              <a:schemeClr val="accent1"/>
+            </a:fillRef>
+            <a:effectRef idx="0">
+              <a:schemeClr val="accent1"/>
+            </a:effectRef>
+            <a:fontRef idx="minor">
+              <a:schemeClr val="lt1"/>
+            </a:fontRef>
+          </p:style>
+          <p:txBody>
+            <a:bodyPr rtlCol="0" anchor="ctr"/>
+            <a:lstStyle/>
+            <a:p>
+              <a:pPr algn="ctr"/>
+              <a:r>
+                <a:rPr lang="en-US" altLang="ko-KR" sz="3200" dirty="0" smtClean="0">
+                  <a:latin typeface="나눔스퀘어 Bold" panose="020B0600000101010101" pitchFamily="50" charset="-127"/>
+                  <a:ea typeface="나눔스퀘어 Bold" panose="020B0600000101010101" pitchFamily="50" charset="-127"/>
+                </a:rPr>
+                <a:t>DB</a:t>
+              </a:r>
+            </a:p>
+          </p:txBody>
+        </p:sp>
+        <p:cxnSp>
+          <p:nvCxnSpPr>
+            <p:cNvPr id="9" name="직선 화살표 연결선 8"/>
+            <p:cNvCxnSpPr/>
+            <p:nvPr/>
+          </p:nvCxnSpPr>
+          <p:spPr>
+            <a:xfrm>
+              <a:off x="4964343" y="609600"/>
+              <a:ext cx="2520000" cy="0"/>
+            </a:xfrm>
+            <a:prstGeom prst="straightConnector1">
+              <a:avLst/>
+            </a:prstGeom>
+            <a:ln w="76200">
+              <a:solidFill>
+                <a:srgbClr val="ED7D31"/>
+              </a:solidFill>
+              <a:tailEnd type="triangle"/>
+            </a:ln>
+          </p:spPr>
+          <p:style>
+            <a:lnRef idx="1">
+              <a:schemeClr val="accent1"/>
+            </a:lnRef>
+            <a:fillRef idx="0">
+              <a:schemeClr val="accent1"/>
+            </a:fillRef>
+            <a:effectRef idx="0">
+              <a:schemeClr val="accent1"/>
+            </a:effectRef>
+            <a:fontRef idx="minor">
               <a:schemeClr val="tx1"/>
+            </a:fontRef>
+          </p:style>
+        </p:cxnSp>
+        <p:cxnSp>
+          <p:nvCxnSpPr>
+            <p:cNvPr id="22" name="직선 화살표 연결선 21"/>
+            <p:cNvCxnSpPr/>
+            <p:nvPr/>
+          </p:nvCxnSpPr>
+          <p:spPr>
+            <a:xfrm flipH="1" flipV="1">
+              <a:off x="5158515" y="1328056"/>
+              <a:ext cx="2520000" cy="0"/>
+            </a:xfrm>
+            <a:prstGeom prst="straightConnector1">
+              <a:avLst/>
+            </a:prstGeom>
+            <a:ln w="76200">
+              <a:solidFill>
+                <a:srgbClr val="ED7D31"/>
+              </a:solidFill>
+              <a:tailEnd type="triangle"/>
+            </a:ln>
+          </p:spPr>
+          <p:style>
+            <a:lnRef idx="1">
+              <a:schemeClr val="accent1"/>
+            </a:lnRef>
+            <a:fillRef idx="0">
+              <a:schemeClr val="accent1"/>
+            </a:fillRef>
+            <a:effectRef idx="0">
+              <a:schemeClr val="accent1"/>
+            </a:effectRef>
+            <a:fontRef idx="minor">
+              <a:schemeClr val="tx1"/>
+            </a:fontRef>
+          </p:style>
+        </p:cxnSp>
+        <p:sp>
+          <p:nvSpPr>
+            <p:cNvPr id="15" name="모서리가 둥근 직사각형 14"/>
+            <p:cNvSpPr/>
+            <p:nvPr/>
+          </p:nvSpPr>
+          <p:spPr>
+            <a:xfrm>
+              <a:off x="1724343" y="1184626"/>
+              <a:ext cx="2880000" cy="432000"/>
+            </a:xfrm>
+            <a:prstGeom prst="roundRect">
+              <a:avLst/>
+            </a:prstGeom>
+            <a:solidFill>
+              <a:schemeClr val="bg1"/>
             </a:solidFill>
-          </a:ln>
-        </p:spPr>
-        <p:style>
-          <a:lnRef idx="2">
-            <a:schemeClr val="accent1">
-              <a:shade val="50000"/>
-            </a:schemeClr>
-          </a:lnRef>
-          <a:fillRef idx="1">
-            <a:schemeClr val="accent1"/>
-          </a:fillRef>
-          <a:effectRef idx="0">
-            <a:schemeClr val="accent1"/>
-          </a:effectRef>
-          <a:fontRef idx="minor">
-            <a:schemeClr val="lt1"/>
-          </a:fontRef>
-        </p:style>
-        <p:txBody>
-          <a:bodyPr rtlCol="0" anchor="ctr"/>
-          <a:lstStyle/>
-          <a:p>
-            <a:pPr algn="ctr"/>
-            <a:endParaRPr lang="ko-KR" altLang="en-US" sz="2400">
-              <a:latin typeface="나눔스퀘어 Bold" panose="020B0600000101010101" pitchFamily="50" charset="-127"/>
-              <a:ea typeface="나눔스퀘어 Bold" panose="020B0600000101010101" pitchFamily="50" charset="-127"/>
-            </a:endParaRPr>
-          </a:p>
-        </p:txBody>
-      </p:sp>
-      <p:sp>
-        <p:nvSpPr>
-          <p:cNvPr id="13" name="직사각형 12"/>
-          <p:cNvSpPr/>
-          <p:nvPr/>
-        </p:nvSpPr>
-        <p:spPr>
-          <a:xfrm>
-            <a:off x="7818384" y="1055490"/>
-            <a:ext cx="3600000" cy="1620000"/>
-          </a:xfrm>
-          <a:prstGeom prst="rect">
-            <a:avLst/>
-          </a:prstGeom>
-        </p:spPr>
-        <p:style>
-          <a:lnRef idx="2">
-            <a:schemeClr val="accent1">
-              <a:shade val="50000"/>
-            </a:schemeClr>
-          </a:lnRef>
-          <a:fillRef idx="1">
-            <a:schemeClr val="accent1"/>
-          </a:fillRef>
-          <a:effectRef idx="0">
-            <a:schemeClr val="accent1"/>
-          </a:effectRef>
-          <a:fontRef idx="minor">
-            <a:schemeClr val="lt1"/>
-          </a:fontRef>
-        </p:style>
-        <p:txBody>
-          <a:bodyPr rtlCol="0" anchor="ctr"/>
-          <a:lstStyle/>
-          <a:p>
-            <a:pPr algn="ctr"/>
-            <a:r>
-              <a:rPr lang="en-US" altLang="ko-KR" sz="6000" dirty="0" smtClean="0">
-                <a:latin typeface="나눔스퀘어 Bold" panose="020B0600000101010101" pitchFamily="50" charset="-127"/>
-                <a:ea typeface="나눔스퀘어 Bold" panose="020B0600000101010101" pitchFamily="50" charset="-127"/>
-              </a:rPr>
-              <a:t>DB</a:t>
-            </a:r>
-          </a:p>
-        </p:txBody>
-      </p:sp>
-      <p:sp>
-        <p:nvSpPr>
-          <p:cNvPr id="14" name="직사각형 13"/>
-          <p:cNvSpPr/>
-          <p:nvPr/>
-        </p:nvSpPr>
-        <p:spPr>
-          <a:xfrm>
-            <a:off x="525447" y="1055490"/>
-            <a:ext cx="3600000" cy="1620000"/>
-          </a:xfrm>
-          <a:prstGeom prst="rect">
-            <a:avLst/>
-          </a:prstGeom>
-        </p:spPr>
-        <p:style>
-          <a:lnRef idx="2">
-            <a:schemeClr val="accent1">
-              <a:shade val="50000"/>
-            </a:schemeClr>
-          </a:lnRef>
-          <a:fillRef idx="1">
-            <a:schemeClr val="accent1"/>
-          </a:fillRef>
-          <a:effectRef idx="0">
-            <a:schemeClr val="accent1"/>
-          </a:effectRef>
-          <a:fontRef idx="minor">
-            <a:schemeClr val="lt1"/>
-          </a:fontRef>
-        </p:style>
-        <p:txBody>
-          <a:bodyPr rtlCol="0" anchor="ctr"/>
-          <a:lstStyle/>
-          <a:p>
-            <a:pPr algn="ctr"/>
-            <a:r>
-              <a:rPr lang="en-US" altLang="ko-KR" sz="4400" dirty="0" smtClean="0">
-                <a:latin typeface="나눔스퀘어 Bold" panose="020B0600000101010101" pitchFamily="50" charset="-127"/>
-                <a:ea typeface="나눔스퀘어 Bold" panose="020B0600000101010101" pitchFamily="50" charset="-127"/>
-              </a:rPr>
-              <a:t>application</a:t>
-            </a:r>
-            <a:endParaRPr lang="ko-KR" altLang="en-US" sz="4400" dirty="0">
-              <a:latin typeface="나눔스퀘어 Bold" panose="020B0600000101010101" pitchFamily="50" charset="-127"/>
-              <a:ea typeface="나눔스퀘어 Bold" panose="020B0600000101010101" pitchFamily="50" charset="-127"/>
-            </a:endParaRPr>
-          </a:p>
-        </p:txBody>
-      </p:sp>
-      <p:sp>
-        <p:nvSpPr>
-          <p:cNvPr id="3" name="타원 2"/>
-          <p:cNvSpPr>
-            <a:spLocks noChangeAspect="1"/>
-          </p:cNvSpPr>
-          <p:nvPr/>
-        </p:nvSpPr>
-        <p:spPr>
-          <a:xfrm>
-            <a:off x="993319" y="3536322"/>
-            <a:ext cx="540000" cy="540000"/>
-          </a:xfrm>
-          <a:prstGeom prst="ellipse">
-            <a:avLst/>
-          </a:prstGeom>
-        </p:spPr>
-        <p:style>
-          <a:lnRef idx="2">
-            <a:schemeClr val="accent1">
-              <a:shade val="50000"/>
-            </a:schemeClr>
-          </a:lnRef>
-          <a:fillRef idx="1">
-            <a:schemeClr val="accent1"/>
-          </a:fillRef>
-          <a:effectRef idx="0">
-            <a:schemeClr val="accent1"/>
-          </a:effectRef>
-          <a:fontRef idx="minor">
-            <a:schemeClr val="lt1"/>
-          </a:fontRef>
-        </p:style>
-        <p:txBody>
-          <a:bodyPr rtlCol="0" anchor="ctr"/>
-          <a:lstStyle/>
-          <a:p>
-            <a:pPr algn="ctr"/>
-            <a:endParaRPr lang="ko-KR" altLang="en-US" sz="2400">
-              <a:latin typeface="나눔스퀘어 Bold" panose="020B0600000101010101" pitchFamily="50" charset="-127"/>
-              <a:ea typeface="나눔스퀘어 Bold" panose="020B0600000101010101" pitchFamily="50" charset="-127"/>
-            </a:endParaRPr>
-          </a:p>
-        </p:txBody>
-      </p:sp>
-      <p:sp>
-        <p:nvSpPr>
-          <p:cNvPr id="16" name="타원 15"/>
-          <p:cNvSpPr>
-            <a:spLocks noChangeAspect="1"/>
-          </p:cNvSpPr>
-          <p:nvPr/>
-        </p:nvSpPr>
-        <p:spPr>
-          <a:xfrm>
-            <a:off x="1704383" y="3536322"/>
-            <a:ext cx="540000" cy="540000"/>
-          </a:xfrm>
-          <a:prstGeom prst="ellipse">
-            <a:avLst/>
-          </a:prstGeom>
-        </p:spPr>
-        <p:style>
-          <a:lnRef idx="2">
-            <a:schemeClr val="accent1">
-              <a:shade val="50000"/>
-            </a:schemeClr>
-          </a:lnRef>
-          <a:fillRef idx="1">
-            <a:schemeClr val="accent1"/>
-          </a:fillRef>
-          <a:effectRef idx="0">
-            <a:schemeClr val="accent1"/>
-          </a:effectRef>
-          <a:fontRef idx="minor">
-            <a:schemeClr val="lt1"/>
-          </a:fontRef>
-        </p:style>
-        <p:txBody>
-          <a:bodyPr rtlCol="0" anchor="ctr"/>
-          <a:lstStyle/>
-          <a:p>
-            <a:pPr algn="ctr"/>
-            <a:endParaRPr lang="ko-KR" altLang="en-US" sz="2400">
-              <a:latin typeface="나눔스퀘어 Bold" panose="020B0600000101010101" pitchFamily="50" charset="-127"/>
-              <a:ea typeface="나눔스퀘어 Bold" panose="020B0600000101010101" pitchFamily="50" charset="-127"/>
-            </a:endParaRPr>
-          </a:p>
-        </p:txBody>
-      </p:sp>
-      <p:sp>
-        <p:nvSpPr>
-          <p:cNvPr id="17" name="타원 16"/>
-          <p:cNvSpPr>
-            <a:spLocks noChangeAspect="1"/>
-          </p:cNvSpPr>
-          <p:nvPr/>
-        </p:nvSpPr>
-        <p:spPr>
-          <a:xfrm>
-            <a:off x="2415447" y="3536322"/>
-            <a:ext cx="540000" cy="540000"/>
-          </a:xfrm>
-          <a:prstGeom prst="ellipse">
-            <a:avLst/>
-          </a:prstGeom>
-        </p:spPr>
-        <p:style>
-          <a:lnRef idx="2">
-            <a:schemeClr val="accent1">
-              <a:shade val="50000"/>
-            </a:schemeClr>
-          </a:lnRef>
-          <a:fillRef idx="1">
-            <a:schemeClr val="accent1"/>
-          </a:fillRef>
-          <a:effectRef idx="0">
-            <a:schemeClr val="accent1"/>
-          </a:effectRef>
-          <a:fontRef idx="minor">
-            <a:schemeClr val="lt1"/>
-          </a:fontRef>
-        </p:style>
-        <p:txBody>
-          <a:bodyPr rtlCol="0" anchor="ctr"/>
-          <a:lstStyle/>
-          <a:p>
-            <a:pPr algn="ctr"/>
-            <a:endParaRPr lang="ko-KR" altLang="en-US" sz="2400">
-              <a:latin typeface="나눔스퀘어 Bold" panose="020B0600000101010101" pitchFamily="50" charset="-127"/>
-              <a:ea typeface="나눔스퀘어 Bold" panose="020B0600000101010101" pitchFamily="50" charset="-127"/>
-            </a:endParaRPr>
-          </a:p>
-        </p:txBody>
-      </p:sp>
-      <p:sp>
-        <p:nvSpPr>
-          <p:cNvPr id="18" name="타원 17"/>
-          <p:cNvSpPr>
-            <a:spLocks noChangeAspect="1"/>
-          </p:cNvSpPr>
-          <p:nvPr/>
-        </p:nvSpPr>
-        <p:spPr>
-          <a:xfrm>
-            <a:off x="3126511" y="3536322"/>
-            <a:ext cx="540000" cy="540000"/>
-          </a:xfrm>
-          <a:prstGeom prst="ellipse">
-            <a:avLst/>
-          </a:prstGeom>
-        </p:spPr>
-        <p:style>
-          <a:lnRef idx="2">
-            <a:schemeClr val="accent1">
-              <a:shade val="50000"/>
-            </a:schemeClr>
-          </a:lnRef>
-          <a:fillRef idx="1">
-            <a:schemeClr val="accent1"/>
-          </a:fillRef>
-          <a:effectRef idx="0">
-            <a:schemeClr val="accent1"/>
-          </a:effectRef>
-          <a:fontRef idx="minor">
-            <a:schemeClr val="lt1"/>
-          </a:fontRef>
-        </p:style>
-        <p:txBody>
-          <a:bodyPr rtlCol="0" anchor="ctr"/>
-          <a:lstStyle/>
-          <a:p>
-            <a:pPr algn="ctr"/>
-            <a:endParaRPr lang="ko-KR" altLang="en-US" sz="2400">
-              <a:latin typeface="나눔스퀘어 Bold" panose="020B0600000101010101" pitchFamily="50" charset="-127"/>
-              <a:ea typeface="나눔스퀘어 Bold" panose="020B0600000101010101" pitchFamily="50" charset="-127"/>
-            </a:endParaRPr>
-          </a:p>
-        </p:txBody>
-      </p:sp>
-      <p:sp>
-        <p:nvSpPr>
-          <p:cNvPr id="19" name="타원 18"/>
-          <p:cNvSpPr>
-            <a:spLocks noChangeAspect="1"/>
-          </p:cNvSpPr>
-          <p:nvPr/>
-        </p:nvSpPr>
-        <p:spPr>
-          <a:xfrm>
-            <a:off x="3837575" y="3536322"/>
-            <a:ext cx="540000" cy="540000"/>
-          </a:xfrm>
-          <a:prstGeom prst="ellipse">
-            <a:avLst/>
-          </a:prstGeom>
-        </p:spPr>
-        <p:style>
-          <a:lnRef idx="2">
-            <a:schemeClr val="accent1">
-              <a:shade val="50000"/>
-            </a:schemeClr>
-          </a:lnRef>
-          <a:fillRef idx="1">
-            <a:schemeClr val="accent1"/>
-          </a:fillRef>
-          <a:effectRef idx="0">
-            <a:schemeClr val="accent1"/>
-          </a:effectRef>
-          <a:fontRef idx="minor">
-            <a:schemeClr val="lt1"/>
-          </a:fontRef>
-        </p:style>
-        <p:txBody>
-          <a:bodyPr rtlCol="0" anchor="ctr"/>
-          <a:lstStyle/>
-          <a:p>
-            <a:pPr algn="ctr"/>
-            <a:endParaRPr lang="ko-KR" altLang="en-US" sz="2400">
-              <a:latin typeface="나눔스퀘어 Bold" panose="020B0600000101010101" pitchFamily="50" charset="-127"/>
-              <a:ea typeface="나눔스퀘어 Bold" panose="020B0600000101010101" pitchFamily="50" charset="-127"/>
-            </a:endParaRPr>
-          </a:p>
-        </p:txBody>
-      </p:sp>
-      <p:sp>
-        <p:nvSpPr>
-          <p:cNvPr id="4" name="TextBox 3"/>
-          <p:cNvSpPr txBox="1"/>
-          <p:nvPr/>
-        </p:nvSpPr>
-        <p:spPr>
-          <a:xfrm>
-            <a:off x="2109259" y="413825"/>
-            <a:ext cx="1210588" cy="461665"/>
-          </a:xfrm>
-          <a:prstGeom prst="rect">
-            <a:avLst/>
-          </a:prstGeom>
-          <a:noFill/>
-        </p:spPr>
-        <p:txBody>
-          <a:bodyPr wrap="none" rtlCol="0">
-            <a:spAutoFit/>
-          </a:bodyPr>
-          <a:lstStyle/>
-          <a:p>
-            <a:pPr algn="ctr"/>
-            <a:r>
-              <a:rPr lang="en-US" altLang="ko-KR" sz="2400" dirty="0" smtClean="0">
-                <a:latin typeface="나눔스퀘어 Bold" panose="020B0600000101010101" pitchFamily="50" charset="-127"/>
-                <a:ea typeface="나눔스퀘어 Bold" panose="020B0600000101010101" pitchFamily="50" charset="-127"/>
-              </a:rPr>
-              <a:t>tomcat</a:t>
-            </a:r>
-            <a:endParaRPr lang="ko-KR" altLang="en-US" sz="2400" dirty="0">
-              <a:latin typeface="나눔스퀘어 Bold" panose="020B0600000101010101" pitchFamily="50" charset="-127"/>
-              <a:ea typeface="나눔스퀘어 Bold" panose="020B0600000101010101" pitchFamily="50" charset="-127"/>
-            </a:endParaRPr>
-          </a:p>
-        </p:txBody>
-      </p:sp>
-      <p:sp>
-        <p:nvSpPr>
-          <p:cNvPr id="5" name="TextBox 4"/>
-          <p:cNvSpPr txBox="1"/>
-          <p:nvPr/>
-        </p:nvSpPr>
-        <p:spPr>
-          <a:xfrm>
-            <a:off x="1422056" y="2894657"/>
-            <a:ext cx="2526782" cy="461665"/>
-          </a:xfrm>
-          <a:prstGeom prst="rect">
-            <a:avLst/>
-          </a:prstGeom>
-          <a:noFill/>
-        </p:spPr>
-        <p:txBody>
-          <a:bodyPr wrap="none" rtlCol="0">
-            <a:spAutoFit/>
-          </a:bodyPr>
-          <a:lstStyle/>
-          <a:p>
-            <a:pPr algn="ctr"/>
-            <a:r>
-              <a:rPr lang="en-US" altLang="ko-KR" sz="2400" dirty="0" smtClean="0">
-                <a:latin typeface="나눔스퀘어 Bold" panose="020B0600000101010101" pitchFamily="50" charset="-127"/>
-                <a:ea typeface="나눔스퀘어 Bold" panose="020B0600000101010101" pitchFamily="50" charset="-127"/>
-              </a:rPr>
-              <a:t>Connection pool</a:t>
-            </a:r>
-            <a:endParaRPr lang="ko-KR" altLang="en-US" sz="2400" dirty="0">
-              <a:latin typeface="나눔스퀘어 Bold" panose="020B0600000101010101" pitchFamily="50" charset="-127"/>
-              <a:ea typeface="나눔스퀘어 Bold" panose="020B0600000101010101" pitchFamily="50" charset="-127"/>
-            </a:endParaRPr>
-          </a:p>
-        </p:txBody>
-      </p:sp>
-      <p:cxnSp>
-        <p:nvCxnSpPr>
-          <p:cNvPr id="7" name="직선 화살표 연결선 6"/>
-          <p:cNvCxnSpPr/>
-          <p:nvPr/>
-        </p:nvCxnSpPr>
-        <p:spPr>
-          <a:xfrm>
-            <a:off x="4125447" y="1556426"/>
-            <a:ext cx="3600000" cy="0"/>
-          </a:xfrm>
-          <a:prstGeom prst="straightConnector1">
-            <a:avLst/>
-          </a:prstGeom>
-          <a:ln w="76200">
+            <a:ln>
+              <a:noFill/>
+            </a:ln>
+          </p:spPr>
+          <p:style>
+            <a:lnRef idx="2">
+              <a:schemeClr val="accent1">
+                <a:shade val="50000"/>
+              </a:schemeClr>
+            </a:lnRef>
+            <a:fillRef idx="1">
+              <a:schemeClr val="accent1"/>
+            </a:fillRef>
+            <a:effectRef idx="0">
+              <a:schemeClr val="accent1"/>
+            </a:effectRef>
+            <a:fontRef idx="minor">
+              <a:schemeClr val="lt1"/>
+            </a:fontRef>
+          </p:style>
+          <p:txBody>
+            <a:bodyPr rtlCol="0" anchor="ctr"/>
+            <a:lstStyle/>
+            <a:p>
+              <a:pPr algn="ctr"/>
+              <a:r>
+                <a:rPr lang="ko-KR" altLang="en-US" sz="1400" dirty="0">
+                  <a:solidFill>
+                    <a:schemeClr val="tx1"/>
+                  </a:solidFill>
+                  <a:latin typeface="나눔스퀘어 Bold" panose="020B0600000101010101" pitchFamily="50" charset="-127"/>
+                  <a:ea typeface="나눔스퀘어 Bold" panose="020B0600000101010101" pitchFamily="50" charset="-127"/>
+                </a:rPr>
+                <a:t>오름차순 </a:t>
+              </a:r>
+              <a:r>
+                <a:rPr lang="en-US" altLang="ko-KR" sz="1400" dirty="0">
+                  <a:solidFill>
+                    <a:schemeClr val="tx1"/>
+                  </a:solidFill>
+                  <a:latin typeface="나눔스퀘어 Bold" panose="020B0600000101010101" pitchFamily="50" charset="-127"/>
+                  <a:ea typeface="나눔스퀘어 Bold" panose="020B0600000101010101" pitchFamily="50" charset="-127"/>
+                </a:rPr>
+                <a:t>&gt; </a:t>
+              </a:r>
+              <a:r>
+                <a:rPr lang="ko-KR" altLang="en-US" sz="1400" dirty="0" smtClean="0">
+                  <a:solidFill>
+                    <a:schemeClr val="tx1"/>
+                  </a:solidFill>
+                  <a:latin typeface="나눔스퀘어 Bold" panose="020B0600000101010101" pitchFamily="50" charset="-127"/>
+                  <a:ea typeface="나눔스퀘어 Bold" panose="020B0600000101010101" pitchFamily="50" charset="-127"/>
+                </a:rPr>
+                <a:t>내림차순 </a:t>
+              </a:r>
+              <a:r>
+                <a:rPr lang="en-US" altLang="ko-KR" sz="1400" dirty="0" smtClean="0">
+                  <a:solidFill>
+                    <a:schemeClr val="tx1"/>
+                  </a:solidFill>
+                  <a:latin typeface="나눔스퀘어 Bold" panose="020B0600000101010101" pitchFamily="50" charset="-127"/>
+                  <a:ea typeface="나눔스퀘어 Bold" panose="020B0600000101010101" pitchFamily="50" charset="-127"/>
+                </a:rPr>
+                <a:t>= </a:t>
+              </a:r>
+              <a:r>
+                <a:rPr lang="ko-KR" altLang="en-US" sz="1400" dirty="0" smtClean="0">
+                  <a:solidFill>
+                    <a:schemeClr val="tx1"/>
+                  </a:solidFill>
+                  <a:latin typeface="나눔스퀘어 Bold" panose="020B0600000101010101" pitchFamily="50" charset="-127"/>
+                  <a:ea typeface="나눔스퀘어 Bold" panose="020B0600000101010101" pitchFamily="50" charset="-127"/>
+                </a:rPr>
+                <a:t>오름차순</a:t>
+              </a:r>
+              <a:endParaRPr lang="ko-KR" altLang="en-US" sz="1400" dirty="0">
+                <a:solidFill>
+                  <a:schemeClr val="tx1"/>
+                </a:solidFill>
+                <a:latin typeface="나눔스퀘어 Bold" panose="020B0600000101010101" pitchFamily="50" charset="-127"/>
+                <a:ea typeface="나눔스퀘어 Bold" panose="020B0600000101010101" pitchFamily="50" charset="-127"/>
+              </a:endParaRPr>
+            </a:p>
+          </p:txBody>
+        </p:sp>
+        <p:sp>
+          <p:nvSpPr>
+            <p:cNvPr id="33" name="모서리가 둥근 직사각형 32"/>
+            <p:cNvSpPr/>
+            <p:nvPr/>
+          </p:nvSpPr>
+          <p:spPr>
+            <a:xfrm>
+              <a:off x="5601429" y="1375027"/>
+              <a:ext cx="1440000" cy="432000"/>
+            </a:xfrm>
+            <a:prstGeom prst="roundRect">
+              <a:avLst/>
+            </a:prstGeom>
             <a:solidFill>
-              <a:schemeClr val="accent2"/>
+              <a:schemeClr val="bg1"/>
             </a:solidFill>
-            <a:tailEnd type="triangle"/>
-          </a:ln>
-        </p:spPr>
-        <p:style>
-          <a:lnRef idx="1">
-            <a:schemeClr val="accent1"/>
-          </a:lnRef>
-          <a:fillRef idx="0">
-            <a:schemeClr val="accent1"/>
-          </a:fillRef>
-          <a:effectRef idx="0">
-            <a:schemeClr val="accent1"/>
-          </a:effectRef>
-          <a:fontRef idx="minor">
-            <a:schemeClr val="tx1"/>
-          </a:fontRef>
-        </p:style>
-      </p:cxnSp>
-      <p:cxnSp>
-        <p:nvCxnSpPr>
-          <p:cNvPr id="25" name="직선 화살표 연결선 24"/>
-          <p:cNvCxnSpPr/>
-          <p:nvPr/>
-        </p:nvCxnSpPr>
-        <p:spPr>
-          <a:xfrm flipH="1" flipV="1">
-            <a:off x="4218384" y="2214664"/>
-            <a:ext cx="3600000" cy="0"/>
-          </a:xfrm>
-          <a:prstGeom prst="straightConnector1">
-            <a:avLst/>
-          </a:prstGeom>
-          <a:ln w="76200">
-            <a:solidFill>
-              <a:schemeClr val="accent2"/>
-            </a:solidFill>
-            <a:tailEnd type="triangle"/>
-          </a:ln>
-        </p:spPr>
-        <p:style>
-          <a:lnRef idx="1">
-            <a:schemeClr val="accent1"/>
-          </a:lnRef>
-          <a:fillRef idx="0">
-            <a:schemeClr val="accent1"/>
-          </a:fillRef>
-          <a:effectRef idx="0">
-            <a:schemeClr val="accent1"/>
-          </a:effectRef>
-          <a:fontRef idx="minor">
-            <a:schemeClr val="tx1"/>
-          </a:fontRef>
-        </p:style>
-      </p:cxnSp>
-      <p:cxnSp>
-        <p:nvCxnSpPr>
-          <p:cNvPr id="10" name="직선 연결선 9"/>
-          <p:cNvCxnSpPr/>
-          <p:nvPr/>
-        </p:nvCxnSpPr>
-        <p:spPr>
-          <a:xfrm>
-            <a:off x="5954553" y="1844118"/>
-            <a:ext cx="720000" cy="720000"/>
-          </a:xfrm>
-          <a:prstGeom prst="line">
-            <a:avLst/>
-          </a:prstGeom>
-          <a:ln w="76200">
-            <a:solidFill>
-              <a:srgbClr val="C00000"/>
-            </a:solidFill>
-          </a:ln>
-        </p:spPr>
-        <p:style>
-          <a:lnRef idx="1">
-            <a:schemeClr val="accent1"/>
-          </a:lnRef>
-          <a:fillRef idx="0">
-            <a:schemeClr val="accent1"/>
-          </a:fillRef>
-          <a:effectRef idx="0">
-            <a:schemeClr val="accent1"/>
-          </a:effectRef>
-          <a:fontRef idx="minor">
-            <a:schemeClr val="tx1"/>
-          </a:fontRef>
-        </p:style>
-      </p:cxnSp>
-      <p:cxnSp>
-        <p:nvCxnSpPr>
-          <p:cNvPr id="32" name="직선 연결선 31"/>
-          <p:cNvCxnSpPr/>
-          <p:nvPr/>
-        </p:nvCxnSpPr>
-        <p:spPr>
-          <a:xfrm flipH="1">
-            <a:off x="5954553" y="1854664"/>
-            <a:ext cx="720000" cy="720000"/>
-          </a:xfrm>
-          <a:prstGeom prst="line">
-            <a:avLst/>
-          </a:prstGeom>
-          <a:ln w="76200">
-            <a:solidFill>
-              <a:srgbClr val="C00000"/>
-            </a:solidFill>
-          </a:ln>
-        </p:spPr>
-        <p:style>
-          <a:lnRef idx="1">
-            <a:schemeClr val="accent1"/>
-          </a:lnRef>
-          <a:fillRef idx="0">
-            <a:schemeClr val="accent1"/>
-          </a:fillRef>
-          <a:effectRef idx="0">
-            <a:schemeClr val="accent1"/>
-          </a:effectRef>
-          <a:fontRef idx="minor">
-            <a:schemeClr val="tx1"/>
-          </a:fontRef>
-        </p:style>
-      </p:cxnSp>
+            <a:ln>
+              <a:noFill/>
+            </a:ln>
+          </p:spPr>
+          <p:style>
+            <a:lnRef idx="2">
+              <a:schemeClr val="accent1">
+                <a:shade val="50000"/>
+              </a:schemeClr>
+            </a:lnRef>
+            <a:fillRef idx="1">
+              <a:schemeClr val="accent1"/>
+            </a:fillRef>
+            <a:effectRef idx="0">
+              <a:schemeClr val="accent1"/>
+            </a:effectRef>
+            <a:fontRef idx="minor">
+              <a:schemeClr val="lt1"/>
+            </a:fontRef>
+          </p:style>
+          <p:txBody>
+            <a:bodyPr rtlCol="0" anchor="ctr"/>
+            <a:lstStyle/>
+            <a:p>
+              <a:pPr algn="ctr"/>
+              <a:r>
+                <a:rPr lang="ko-KR" altLang="en-US" smtClean="0">
+                  <a:solidFill>
+                    <a:schemeClr val="tx1"/>
+                  </a:solidFill>
+                  <a:latin typeface="나눔스퀘어 Bold" panose="020B0600000101010101" pitchFamily="50" charset="-127"/>
+                  <a:ea typeface="나눔스퀘어 Bold" panose="020B0600000101010101" pitchFamily="50" charset="-127"/>
+                </a:rPr>
+                <a:t>오름차순</a:t>
+              </a:r>
+              <a:endParaRPr lang="ko-KR" altLang="en-US" dirty="0">
+                <a:solidFill>
+                  <a:schemeClr val="tx1"/>
+                </a:solidFill>
+                <a:latin typeface="나눔스퀘어 Bold" panose="020B0600000101010101" pitchFamily="50" charset="-127"/>
+                <a:ea typeface="나눔스퀘어 Bold" panose="020B0600000101010101" pitchFamily="50" charset="-127"/>
+              </a:endParaRPr>
+            </a:p>
+          </p:txBody>
+        </p:sp>
+      </p:grpSp>
     </p:spTree>
     <p:extLst>
       <p:ext uri="{BB962C8B-B14F-4D97-AF65-F5344CB8AC3E}">

</xml_diff>

<commit_message>
20260907 commit : early morning
</commit_message>
<xml_diff>
--- a/notion/create_notion_img.pptx
+++ b/notion/create_notion_img.pptx
@@ -245,7 +245,7 @@
           <a:p>
             <a:fld id="{7237CE1A-8831-48B5-BA93-72483C6E34E8}" type="datetimeFigureOut">
               <a:rPr lang="ko-KR" altLang="en-US" smtClean="0"/>
-              <a:t>2026-09-02</a:t>
+              <a:t>26-09-07(Mon)</a:t>
             </a:fld>
             <a:endParaRPr lang="ko-KR" altLang="en-US"/>
           </a:p>
@@ -415,7 +415,7 @@
           <a:p>
             <a:fld id="{7237CE1A-8831-48B5-BA93-72483C6E34E8}" type="datetimeFigureOut">
               <a:rPr lang="ko-KR" altLang="en-US" smtClean="0"/>
-              <a:t>2026-09-02</a:t>
+              <a:t>26-09-07(Mon)</a:t>
             </a:fld>
             <a:endParaRPr lang="ko-KR" altLang="en-US"/>
           </a:p>
@@ -595,7 +595,7 @@
           <a:p>
             <a:fld id="{7237CE1A-8831-48B5-BA93-72483C6E34E8}" type="datetimeFigureOut">
               <a:rPr lang="ko-KR" altLang="en-US" smtClean="0"/>
-              <a:t>2026-09-02</a:t>
+              <a:t>26-09-07(Mon)</a:t>
             </a:fld>
             <a:endParaRPr lang="ko-KR" altLang="en-US"/>
           </a:p>
@@ -765,7 +765,7 @@
           <a:p>
             <a:fld id="{7237CE1A-8831-48B5-BA93-72483C6E34E8}" type="datetimeFigureOut">
               <a:rPr lang="ko-KR" altLang="en-US" smtClean="0"/>
-              <a:t>2026-09-02</a:t>
+              <a:t>26-09-07(Mon)</a:t>
             </a:fld>
             <a:endParaRPr lang="ko-KR" altLang="en-US"/>
           </a:p>
@@ -1011,7 +1011,7 @@
           <a:p>
             <a:fld id="{7237CE1A-8831-48B5-BA93-72483C6E34E8}" type="datetimeFigureOut">
               <a:rPr lang="ko-KR" altLang="en-US" smtClean="0"/>
-              <a:t>2026-09-02</a:t>
+              <a:t>26-09-07(Mon)</a:t>
             </a:fld>
             <a:endParaRPr lang="ko-KR" altLang="en-US"/>
           </a:p>
@@ -1243,7 +1243,7 @@
           <a:p>
             <a:fld id="{7237CE1A-8831-48B5-BA93-72483C6E34E8}" type="datetimeFigureOut">
               <a:rPr lang="ko-KR" altLang="en-US" smtClean="0"/>
-              <a:t>2026-09-02</a:t>
+              <a:t>26-09-07(Mon)</a:t>
             </a:fld>
             <a:endParaRPr lang="ko-KR" altLang="en-US"/>
           </a:p>
@@ -1610,7 +1610,7 @@
           <a:p>
             <a:fld id="{7237CE1A-8831-48B5-BA93-72483C6E34E8}" type="datetimeFigureOut">
               <a:rPr lang="ko-KR" altLang="en-US" smtClean="0"/>
-              <a:t>2026-09-02</a:t>
+              <a:t>26-09-07(Mon)</a:t>
             </a:fld>
             <a:endParaRPr lang="ko-KR" altLang="en-US"/>
           </a:p>
@@ -1728,7 +1728,7 @@
           <a:p>
             <a:fld id="{7237CE1A-8831-48B5-BA93-72483C6E34E8}" type="datetimeFigureOut">
               <a:rPr lang="ko-KR" altLang="en-US" smtClean="0"/>
-              <a:t>2026-09-02</a:t>
+              <a:t>26-09-07(Mon)</a:t>
             </a:fld>
             <a:endParaRPr lang="ko-KR" altLang="en-US"/>
           </a:p>
@@ -1823,7 +1823,7 @@
           <a:p>
             <a:fld id="{7237CE1A-8831-48B5-BA93-72483C6E34E8}" type="datetimeFigureOut">
               <a:rPr lang="ko-KR" altLang="en-US" smtClean="0"/>
-              <a:t>2026-09-02</a:t>
+              <a:t>26-09-07(Mon)</a:t>
             </a:fld>
             <a:endParaRPr lang="ko-KR" altLang="en-US"/>
           </a:p>
@@ -2100,7 +2100,7 @@
           <a:p>
             <a:fld id="{7237CE1A-8831-48B5-BA93-72483C6E34E8}" type="datetimeFigureOut">
               <a:rPr lang="ko-KR" altLang="en-US" smtClean="0"/>
-              <a:t>2026-09-02</a:t>
+              <a:t>26-09-07(Mon)</a:t>
             </a:fld>
             <a:endParaRPr lang="ko-KR" altLang="en-US"/>
           </a:p>
@@ -2353,7 +2353,7 @@
           <a:p>
             <a:fld id="{7237CE1A-8831-48B5-BA93-72483C6E34E8}" type="datetimeFigureOut">
               <a:rPr lang="ko-KR" altLang="en-US" smtClean="0"/>
-              <a:t>2026-09-02</a:t>
+              <a:t>26-09-07(Mon)</a:t>
             </a:fld>
             <a:endParaRPr lang="ko-KR" altLang="en-US"/>
           </a:p>
@@ -2566,7 +2566,7 @@
           <a:p>
             <a:fld id="{7237CE1A-8831-48B5-BA93-72483C6E34E8}" type="datetimeFigureOut">
               <a:rPr lang="ko-KR" altLang="en-US" smtClean="0"/>
-              <a:t>2026-09-02</a:t>
+              <a:t>26-09-07(Mon)</a:t>
             </a:fld>
             <a:endParaRPr lang="ko-KR" altLang="en-US"/>
           </a:p>
@@ -2973,28 +2973,28 @@
       </p:grpSpPr>
       <p:grpSp>
         <p:nvGrpSpPr>
-          <p:cNvPr id="34" name="그룹 33"/>
+          <p:cNvPr id="39" name="그룹 38"/>
           <p:cNvGrpSpPr/>
           <p:nvPr/>
         </p:nvGrpSpPr>
         <p:grpSpPr>
           <a:xfrm>
-            <a:off x="1364343" y="5058000"/>
-            <a:ext cx="8114172" cy="1807027"/>
-            <a:chOff x="1364343" y="5058000"/>
-            <a:chExt cx="8114172" cy="1807027"/>
+            <a:off x="-1620000" y="388495"/>
+            <a:ext cx="19028220" cy="5180421"/>
+            <a:chOff x="-1620000" y="388495"/>
+            <a:chExt cx="19028220" cy="5180421"/>
           </a:xfrm>
         </p:grpSpPr>
         <p:sp>
           <p:nvSpPr>
-            <p:cNvPr id="23" name="직사각형 22"/>
+            <p:cNvPr id="7" name="직사각형 6"/>
             <p:cNvSpPr/>
             <p:nvPr/>
           </p:nvSpPr>
           <p:spPr>
             <a:xfrm>
-              <a:off x="1364343" y="5065027"/>
-              <a:ext cx="3600000" cy="1800000"/>
+              <a:off x="-1620000" y="1755302"/>
+              <a:ext cx="3240000" cy="1080000"/>
             </a:xfrm>
             <a:prstGeom prst="rect">
               <a:avLst/>
@@ -3028,33 +3028,13 @@
             <a:p>
               <a:pPr algn="ctr"/>
               <a:r>
-                <a:rPr lang="en-US" altLang="ko-KR" sz="3200" dirty="0">
+                <a:rPr lang="ko-KR" altLang="en-US" sz="3600" dirty="0" err="1">
                   <a:latin typeface="나눔스퀘어 Bold" panose="020B0600000101010101" pitchFamily="50" charset="-127"/>
                   <a:ea typeface="나눔스퀘어 Bold" panose="020B0600000101010101" pitchFamily="50" charset="-127"/>
                 </a:rPr>
-                <a:t>Application</a:t>
+                <a:t>CalAssembler</a:t>
               </a:r>
-            </a:p>
-            <a:p>
-              <a:pPr algn="ctr"/>
-              <a:r>
-                <a:rPr lang="en-US" altLang="ko-KR" sz="3200" dirty="0">
-                  <a:latin typeface="나눔스퀘어 Bold" panose="020B0600000101010101" pitchFamily="50" charset="-127"/>
-                  <a:ea typeface="나눔스퀘어 Bold" panose="020B0600000101010101" pitchFamily="50" charset="-127"/>
-                </a:rPr>
-                <a:t>(Service &gt; Dao</a:t>
-              </a:r>
-              <a:r>
-                <a:rPr lang="en-US" altLang="ko-KR" sz="3200" dirty="0" smtClean="0">
-                  <a:latin typeface="나눔스퀘어 Bold" panose="020B0600000101010101" pitchFamily="50" charset="-127"/>
-                  <a:ea typeface="나눔스퀘어 Bold" panose="020B0600000101010101" pitchFamily="50" charset="-127"/>
-                </a:rPr>
-                <a:t>)</a:t>
-              </a:r>
-            </a:p>
-            <a:p>
-              <a:pPr algn="ctr"/>
-              <a:endParaRPr lang="ko-KR" altLang="en-US" sz="3200" dirty="0">
+              <a:endParaRPr lang="ko-KR" altLang="en-US" sz="3600" dirty="0">
                 <a:latin typeface="나눔스퀘어 Bold" panose="020B0600000101010101" pitchFamily="50" charset="-127"/>
                 <a:ea typeface="나눔스퀘어 Bold" panose="020B0600000101010101" pitchFamily="50" charset="-127"/>
               </a:endParaRPr>
@@ -3063,14 +3043,14 @@
         </p:sp>
         <p:sp>
           <p:nvSpPr>
-            <p:cNvPr id="24" name="직사각형 23"/>
+            <p:cNvPr id="8" name="직사각형 7"/>
             <p:cNvSpPr/>
             <p:nvPr/>
           </p:nvSpPr>
           <p:spPr>
             <a:xfrm>
-              <a:off x="7678515" y="5058000"/>
-              <a:ext cx="1800000" cy="1800000"/>
+              <a:off x="2423464" y="1755302"/>
+              <a:ext cx="3240000" cy="1080000"/>
             </a:xfrm>
             <a:prstGeom prst="rect">
               <a:avLst/>
@@ -3104,154 +3084,13 @@
             <a:p>
               <a:pPr algn="ctr"/>
               <a:r>
-                <a:rPr lang="en-US" altLang="ko-KR" sz="3200" dirty="0">
+                <a:rPr lang="ko-KR" altLang="en-US" sz="3600">
                   <a:latin typeface="나눔스퀘어 Bold" panose="020B0600000101010101" pitchFamily="50" charset="-127"/>
                   <a:ea typeface="나눔스퀘어 Bold" panose="020B0600000101010101" pitchFamily="50" charset="-127"/>
                 </a:rPr>
-                <a:t>DB</a:t>
+                <a:t>MainClass</a:t>
               </a:r>
-              <a:endParaRPr lang="ko-KR" altLang="en-US" sz="3200" dirty="0">
-                <a:latin typeface="나눔스퀘어 Bold" panose="020B0600000101010101" pitchFamily="50" charset="-127"/>
-                <a:ea typeface="나눔스퀘어 Bold" panose="020B0600000101010101" pitchFamily="50" charset="-127"/>
-              </a:endParaRPr>
-            </a:p>
-            <a:p>
-              <a:pPr algn="ctr"/>
-              <a:endParaRPr lang="ko-KR" altLang="en-US" sz="3200" dirty="0">
-                <a:latin typeface="나눔스퀘어 Bold" panose="020B0600000101010101" pitchFamily="50" charset="-127"/>
-                <a:ea typeface="나눔스퀘어 Bold" panose="020B0600000101010101" pitchFamily="50" charset="-127"/>
-              </a:endParaRPr>
-            </a:p>
-          </p:txBody>
-        </p:sp>
-        <p:cxnSp>
-          <p:nvCxnSpPr>
-            <p:cNvPr id="26" name="직선 화살표 연결선 25"/>
-            <p:cNvCxnSpPr/>
-            <p:nvPr/>
-          </p:nvCxnSpPr>
-          <p:spPr>
-            <a:xfrm>
-              <a:off x="4964343" y="5667600"/>
-              <a:ext cx="2520000" cy="0"/>
-            </a:xfrm>
-            <a:prstGeom prst="straightConnector1">
-              <a:avLst/>
-            </a:prstGeom>
-            <a:ln w="76200">
-              <a:solidFill>
-                <a:srgbClr val="ED7D31"/>
-              </a:solidFill>
-              <a:tailEnd type="triangle"/>
-            </a:ln>
-          </p:spPr>
-          <p:style>
-            <a:lnRef idx="1">
-              <a:schemeClr val="accent1"/>
-            </a:lnRef>
-            <a:fillRef idx="0">
-              <a:schemeClr val="accent1"/>
-            </a:fillRef>
-            <a:effectRef idx="0">
-              <a:schemeClr val="accent1"/>
-            </a:effectRef>
-            <a:fontRef idx="minor">
-              <a:schemeClr val="tx1"/>
-            </a:fontRef>
-          </p:style>
-        </p:cxnSp>
-        <p:cxnSp>
-          <p:nvCxnSpPr>
-            <p:cNvPr id="27" name="직선 화살표 연결선 26"/>
-            <p:cNvCxnSpPr/>
-            <p:nvPr/>
-          </p:nvCxnSpPr>
-          <p:spPr>
-            <a:xfrm flipH="1" flipV="1">
-              <a:off x="5158515" y="6386056"/>
-              <a:ext cx="2520000" cy="0"/>
-            </a:xfrm>
-            <a:prstGeom prst="straightConnector1">
-              <a:avLst/>
-            </a:prstGeom>
-            <a:ln w="76200">
-              <a:solidFill>
-                <a:srgbClr val="ED7D31"/>
-              </a:solidFill>
-              <a:tailEnd type="triangle"/>
-            </a:ln>
-          </p:spPr>
-          <p:style>
-            <a:lnRef idx="1">
-              <a:schemeClr val="accent1"/>
-            </a:lnRef>
-            <a:fillRef idx="0">
-              <a:schemeClr val="accent1"/>
-            </a:fillRef>
-            <a:effectRef idx="0">
-              <a:schemeClr val="accent1"/>
-            </a:effectRef>
-            <a:fontRef idx="minor">
-              <a:schemeClr val="tx1"/>
-            </a:fontRef>
-          </p:style>
-        </p:cxnSp>
-        <p:sp>
-          <p:nvSpPr>
-            <p:cNvPr id="29" name="모서리가 둥근 직사각형 28"/>
-            <p:cNvSpPr/>
-            <p:nvPr/>
-          </p:nvSpPr>
-          <p:spPr>
-            <a:xfrm>
-              <a:off x="1724343" y="6228112"/>
-              <a:ext cx="2880000" cy="432000"/>
-            </a:xfrm>
-            <a:prstGeom prst="roundRect">
-              <a:avLst/>
-            </a:prstGeom>
-            <a:solidFill>
-              <a:schemeClr val="bg1"/>
-            </a:solidFill>
-            <a:ln>
-              <a:noFill/>
-            </a:ln>
-          </p:spPr>
-          <p:style>
-            <a:lnRef idx="2">
-              <a:schemeClr val="accent1">
-                <a:shade val="50000"/>
-              </a:schemeClr>
-            </a:lnRef>
-            <a:fillRef idx="1">
-              <a:schemeClr val="accent1"/>
-            </a:fillRef>
-            <a:effectRef idx="0">
-              <a:schemeClr val="accent1"/>
-            </a:effectRef>
-            <a:fontRef idx="minor">
-              <a:schemeClr val="lt1"/>
-            </a:fontRef>
-          </p:style>
-          <p:txBody>
-            <a:bodyPr rtlCol="0" anchor="ctr"/>
-            <a:lstStyle/>
-            <a:p>
-              <a:pPr algn="ctr"/>
-              <a:r>
-                <a:rPr lang="ko-KR" altLang="en-US" dirty="0" smtClean="0">
-                  <a:solidFill>
-                    <a:schemeClr val="tx1"/>
-                  </a:solidFill>
-                  <a:latin typeface="나눔스퀘어 Bold" panose="020B0600000101010101" pitchFamily="50" charset="-127"/>
-                  <a:ea typeface="나눔스퀘어 Bold" panose="020B0600000101010101" pitchFamily="50" charset="-127"/>
-                </a:rPr>
-                <a:t>내림차순</a:t>
-              </a:r>
-              <a:endParaRPr lang="ko-KR" altLang="en-US" dirty="0">
-                <a:solidFill>
-                  <a:schemeClr val="tx1"/>
-                </a:solidFill>
+              <a:endParaRPr lang="ko-KR" altLang="en-US" sz="3600" dirty="0">
                 <a:latin typeface="나눔스퀘어 Bold" panose="020B0600000101010101" pitchFamily="50" charset="-127"/>
                 <a:ea typeface="나눔스퀘어 Bold" panose="020B0600000101010101" pitchFamily="50" charset="-127"/>
               </a:endParaRPr>
@@ -3260,173 +3099,14 @@
         </p:sp>
         <p:sp>
           <p:nvSpPr>
-            <p:cNvPr id="30" name="모서리가 둥근 직사각형 29"/>
+            <p:cNvPr id="9" name="직사각형 8"/>
             <p:cNvSpPr/>
             <p:nvPr/>
           </p:nvSpPr>
           <p:spPr>
             <a:xfrm>
-              <a:off x="7858515" y="6228112"/>
-              <a:ext cx="1440000" cy="432000"/>
-            </a:xfrm>
-            <a:prstGeom prst="roundRect">
-              <a:avLst/>
-            </a:prstGeom>
-            <a:solidFill>
-              <a:schemeClr val="bg1"/>
-            </a:solidFill>
-            <a:ln>
-              <a:noFill/>
-            </a:ln>
-          </p:spPr>
-          <p:style>
-            <a:lnRef idx="2">
-              <a:schemeClr val="accent1">
-                <a:shade val="50000"/>
-              </a:schemeClr>
-            </a:lnRef>
-            <a:fillRef idx="1">
-              <a:schemeClr val="accent1"/>
-            </a:fillRef>
-            <a:effectRef idx="0">
-              <a:schemeClr val="accent1"/>
-            </a:effectRef>
-            <a:fontRef idx="minor">
-              <a:schemeClr val="lt1"/>
-            </a:fontRef>
-          </p:style>
-          <p:txBody>
-            <a:bodyPr rtlCol="0" anchor="ctr"/>
-            <a:lstStyle/>
-            <a:p>
-              <a:pPr algn="ctr"/>
-              <a:r>
-                <a:rPr lang="ko-KR" altLang="en-US" sz="1100" dirty="0" smtClean="0">
-                  <a:solidFill>
-                    <a:schemeClr val="tx1"/>
-                  </a:solidFill>
-                  <a:latin typeface="나눔스퀘어 Bold" panose="020B0600000101010101" pitchFamily="50" charset="-127"/>
-                  <a:ea typeface="나눔스퀘어 Bold" panose="020B0600000101010101" pitchFamily="50" charset="-127"/>
-                </a:rPr>
-                <a:t>오름차순 </a:t>
-              </a:r>
-              <a:r>
-                <a:rPr lang="en-US" altLang="ko-KR" sz="1100" dirty="0" smtClean="0">
-                  <a:solidFill>
-                    <a:schemeClr val="tx1"/>
-                  </a:solidFill>
-                  <a:latin typeface="나눔스퀘어 Bold" panose="020B0600000101010101" pitchFamily="50" charset="-127"/>
-                  <a:ea typeface="나눔스퀘어 Bold" panose="020B0600000101010101" pitchFamily="50" charset="-127"/>
-                </a:rPr>
-                <a:t>&gt; </a:t>
-              </a:r>
-              <a:r>
-                <a:rPr lang="ko-KR" altLang="en-US" sz="1100" dirty="0" smtClean="0">
-                  <a:solidFill>
-                    <a:schemeClr val="tx1"/>
-                  </a:solidFill>
-                  <a:latin typeface="나눔스퀘어 Bold" panose="020B0600000101010101" pitchFamily="50" charset="-127"/>
-                  <a:ea typeface="나눔스퀘어 Bold" panose="020B0600000101010101" pitchFamily="50" charset="-127"/>
-                </a:rPr>
-                <a:t>내림차순</a:t>
-              </a:r>
-              <a:endParaRPr lang="ko-KR" altLang="en-US" sz="1100" dirty="0">
-                <a:solidFill>
-                  <a:schemeClr val="tx1"/>
-                </a:solidFill>
-                <a:latin typeface="나눔스퀘어 Bold" panose="020B0600000101010101" pitchFamily="50" charset="-127"/>
-                <a:ea typeface="나눔스퀘어 Bold" panose="020B0600000101010101" pitchFamily="50" charset="-127"/>
-              </a:endParaRPr>
-            </a:p>
-          </p:txBody>
-        </p:sp>
-        <p:sp>
-          <p:nvSpPr>
-            <p:cNvPr id="31" name="모서리가 둥근 직사각형 30"/>
-            <p:cNvSpPr/>
-            <p:nvPr/>
-          </p:nvSpPr>
-          <p:spPr>
-            <a:xfrm>
-              <a:off x="5504343" y="6426000"/>
-              <a:ext cx="1440000" cy="432000"/>
-            </a:xfrm>
-            <a:prstGeom prst="roundRect">
-              <a:avLst/>
-            </a:prstGeom>
-            <a:solidFill>
-              <a:schemeClr val="bg1"/>
-            </a:solidFill>
-            <a:ln>
-              <a:noFill/>
-            </a:ln>
-          </p:spPr>
-          <p:style>
-            <a:lnRef idx="2">
-              <a:schemeClr val="accent1">
-                <a:shade val="50000"/>
-              </a:schemeClr>
-            </a:lnRef>
-            <a:fillRef idx="1">
-              <a:schemeClr val="accent1"/>
-            </a:fillRef>
-            <a:effectRef idx="0">
-              <a:schemeClr val="accent1"/>
-            </a:effectRef>
-            <a:fontRef idx="minor">
-              <a:schemeClr val="lt1"/>
-            </a:fontRef>
-          </p:style>
-          <p:txBody>
-            <a:bodyPr rtlCol="0" anchor="ctr"/>
-            <a:lstStyle/>
-            <a:p>
-              <a:pPr algn="ctr"/>
-              <a:r>
-                <a:rPr lang="ko-KR" altLang="en-US" dirty="0" smtClean="0">
-                  <a:solidFill>
-                    <a:schemeClr val="tx1"/>
-                  </a:solidFill>
-                  <a:latin typeface="나눔스퀘어 Bold" panose="020B0600000101010101" pitchFamily="50" charset="-127"/>
-                  <a:ea typeface="나눔스퀘어 Bold" panose="020B0600000101010101" pitchFamily="50" charset="-127"/>
-                </a:rPr>
-                <a:t>내림차순</a:t>
-              </a:r>
-              <a:endParaRPr lang="ko-KR" altLang="en-US" dirty="0">
-                <a:solidFill>
-                  <a:schemeClr val="tx1"/>
-                </a:solidFill>
-                <a:latin typeface="나눔스퀘어 Bold" panose="020B0600000101010101" pitchFamily="50" charset="-127"/>
-                <a:ea typeface="나눔스퀘어 Bold" panose="020B0600000101010101" pitchFamily="50" charset="-127"/>
-              </a:endParaRPr>
-            </a:p>
-          </p:txBody>
-        </p:sp>
-      </p:grpSp>
-      <p:grpSp>
-        <p:nvGrpSpPr>
-          <p:cNvPr id="28" name="그룹 27"/>
-          <p:cNvGrpSpPr/>
-          <p:nvPr/>
-        </p:nvGrpSpPr>
-        <p:grpSpPr>
-          <a:xfrm>
-            <a:off x="1364343" y="0"/>
-            <a:ext cx="8114172" cy="1807027"/>
-            <a:chOff x="1364343" y="0"/>
-            <a:chExt cx="8114172" cy="1807027"/>
-          </a:xfrm>
-        </p:grpSpPr>
-        <p:sp>
-          <p:nvSpPr>
-            <p:cNvPr id="6" name="직사각형 5"/>
-            <p:cNvSpPr/>
-            <p:nvPr/>
-          </p:nvSpPr>
-          <p:spPr>
-            <a:xfrm>
-              <a:off x="1364343" y="7027"/>
-              <a:ext cx="3600000" cy="1800000"/>
+              <a:off x="6466928" y="1755302"/>
+              <a:ext cx="3240000" cy="1080000"/>
             </a:xfrm>
             <a:prstGeom prst="rect">
               <a:avLst/>
@@ -3460,26 +3140,13 @@
             <a:p>
               <a:pPr algn="ctr"/>
               <a:r>
-                <a:rPr lang="en-US" altLang="ko-KR" sz="3200" dirty="0" smtClean="0">
+                <a:rPr lang="ko-KR" altLang="en-US" sz="3600" dirty="0" err="1">
                   <a:latin typeface="나눔스퀘어 Bold" panose="020B0600000101010101" pitchFamily="50" charset="-127"/>
                   <a:ea typeface="나눔스퀘어 Bold" panose="020B0600000101010101" pitchFamily="50" charset="-127"/>
                 </a:rPr>
-                <a:t>Application</a:t>
+                <a:t>MyCalculator</a:t>
               </a:r>
-            </a:p>
-            <a:p>
-              <a:pPr algn="ctr"/>
-              <a:r>
-                <a:rPr lang="en-US" altLang="ko-KR" sz="3200" dirty="0" smtClean="0">
-                  <a:latin typeface="나눔스퀘어 Bold" panose="020B0600000101010101" pitchFamily="50" charset="-127"/>
-                  <a:ea typeface="나눔스퀘어 Bold" panose="020B0600000101010101" pitchFamily="50" charset="-127"/>
-                </a:rPr>
-                <a:t>(Service &gt; Dao)</a:t>
-              </a:r>
-            </a:p>
-            <a:p>
-              <a:pPr algn="ctr"/>
-              <a:endParaRPr lang="ko-KR" altLang="en-US" sz="3200" dirty="0">
+              <a:endParaRPr lang="ko-KR" altLang="en-US" sz="3600" dirty="0">
                 <a:latin typeface="나눔스퀘어 Bold" panose="020B0600000101010101" pitchFamily="50" charset="-127"/>
                 <a:ea typeface="나눔스퀘어 Bold" panose="020B0600000101010101" pitchFamily="50" charset="-127"/>
               </a:endParaRPr>
@@ -3488,14 +3155,14 @@
         </p:sp>
         <p:sp>
           <p:nvSpPr>
-            <p:cNvPr id="20" name="직사각형 19"/>
+            <p:cNvPr id="10" name="직사각형 9"/>
             <p:cNvSpPr/>
             <p:nvPr/>
           </p:nvSpPr>
           <p:spPr>
             <a:xfrm>
-              <a:off x="7678515" y="0"/>
-              <a:ext cx="1800000" cy="1800000"/>
+              <a:off x="10510392" y="1755302"/>
+              <a:ext cx="3240000" cy="1080000"/>
             </a:xfrm>
             <a:prstGeom prst="rect">
               <a:avLst/>
@@ -3529,103 +3196,35 @@
             <a:p>
               <a:pPr algn="ctr"/>
               <a:r>
-                <a:rPr lang="en-US" altLang="ko-KR" sz="3200" dirty="0" smtClean="0">
+                <a:rPr lang="ko-KR" altLang="en-US" sz="3600" dirty="0" err="1">
                   <a:latin typeface="나눔스퀘어 Bold" panose="020B0600000101010101" pitchFamily="50" charset="-127"/>
                   <a:ea typeface="나눔스퀘어 Bold" panose="020B0600000101010101" pitchFamily="50" charset="-127"/>
                 </a:rPr>
-                <a:t>DB</a:t>
+                <a:t>ICalculator</a:t>
               </a:r>
+              <a:endParaRPr lang="ko-KR" altLang="en-US" sz="3600" dirty="0">
+                <a:latin typeface="나눔스퀘어 Bold" panose="020B0600000101010101" pitchFamily="50" charset="-127"/>
+                <a:ea typeface="나눔스퀘어 Bold" panose="020B0600000101010101" pitchFamily="50" charset="-127"/>
+              </a:endParaRPr>
             </a:p>
           </p:txBody>
         </p:sp>
-        <p:cxnSp>
-          <p:nvCxnSpPr>
-            <p:cNvPr id="9" name="직선 화살표 연결선 8"/>
-            <p:cNvCxnSpPr/>
-            <p:nvPr/>
-          </p:nvCxnSpPr>
-          <p:spPr>
-            <a:xfrm>
-              <a:off x="4964343" y="609600"/>
-              <a:ext cx="2520000" cy="0"/>
-            </a:xfrm>
-            <a:prstGeom prst="straightConnector1">
-              <a:avLst/>
-            </a:prstGeom>
-            <a:ln w="76200">
-              <a:solidFill>
-                <a:srgbClr val="ED7D31"/>
-              </a:solidFill>
-              <a:tailEnd type="triangle"/>
-            </a:ln>
-          </p:spPr>
-          <p:style>
-            <a:lnRef idx="1">
-              <a:schemeClr val="accent1"/>
-            </a:lnRef>
-            <a:fillRef idx="0">
-              <a:schemeClr val="accent1"/>
-            </a:fillRef>
-            <a:effectRef idx="0">
-              <a:schemeClr val="accent1"/>
-            </a:effectRef>
-            <a:fontRef idx="minor">
-              <a:schemeClr val="tx1"/>
-            </a:fontRef>
-          </p:style>
-        </p:cxnSp>
-        <p:cxnSp>
-          <p:nvCxnSpPr>
-            <p:cNvPr id="22" name="직선 화살표 연결선 21"/>
-            <p:cNvCxnSpPr/>
-            <p:nvPr/>
-          </p:nvCxnSpPr>
-          <p:spPr>
-            <a:xfrm flipH="1" flipV="1">
-              <a:off x="5158515" y="1328056"/>
-              <a:ext cx="2520000" cy="0"/>
-            </a:xfrm>
-            <a:prstGeom prst="straightConnector1">
-              <a:avLst/>
-            </a:prstGeom>
-            <a:ln w="76200">
-              <a:solidFill>
-                <a:srgbClr val="ED7D31"/>
-              </a:solidFill>
-              <a:tailEnd type="triangle"/>
-            </a:ln>
-          </p:spPr>
-          <p:style>
-            <a:lnRef idx="1">
-              <a:schemeClr val="accent1"/>
-            </a:lnRef>
-            <a:fillRef idx="0">
-              <a:schemeClr val="accent1"/>
-            </a:fillRef>
-            <a:effectRef idx="0">
-              <a:schemeClr val="accent1"/>
-            </a:effectRef>
-            <a:fontRef idx="minor">
-              <a:schemeClr val="tx1"/>
-            </a:fontRef>
-          </p:style>
-        </p:cxnSp>
         <p:sp>
           <p:nvSpPr>
-            <p:cNvPr id="15" name="모서리가 둥근 직사각형 14"/>
+            <p:cNvPr id="11" name="직사각형 10"/>
             <p:cNvSpPr/>
             <p:nvPr/>
           </p:nvSpPr>
           <p:spPr>
             <a:xfrm>
-              <a:off x="1724343" y="1184626"/>
-              <a:ext cx="2880000" cy="432000"/>
+              <a:off x="15248220" y="388495"/>
+              <a:ext cx="2160000" cy="1080000"/>
             </a:xfrm>
-            <a:prstGeom prst="roundRect">
+            <a:prstGeom prst="rect">
               <a:avLst/>
             </a:prstGeom>
             <a:solidFill>
-              <a:schemeClr val="bg1"/>
+              <a:schemeClr val="accent5"/>
             </a:solidFill>
             <a:ln>
               <a:noFill/>
@@ -3653,59 +3252,13 @@
             <a:p>
               <a:pPr algn="ctr"/>
               <a:r>
-                <a:rPr lang="ko-KR" altLang="en-US" sz="1400" dirty="0">
-                  <a:solidFill>
-                    <a:schemeClr val="tx1"/>
-                  </a:solidFill>
+                <a:rPr lang="ko-KR" altLang="en-US" sz="3600" dirty="0" err="1">
                   <a:latin typeface="나눔스퀘어 Bold" panose="020B0600000101010101" pitchFamily="50" charset="-127"/>
                   <a:ea typeface="나눔스퀘어 Bold" panose="020B0600000101010101" pitchFamily="50" charset="-127"/>
                 </a:rPr>
-                <a:t>오름차순 </a:t>
+                <a:t>CalAdd</a:t>
               </a:r>
-              <a:r>
-                <a:rPr lang="en-US" altLang="ko-KR" sz="1400" dirty="0">
-                  <a:solidFill>
-                    <a:schemeClr val="tx1"/>
-                  </a:solidFill>
-                  <a:latin typeface="나눔스퀘어 Bold" panose="020B0600000101010101" pitchFamily="50" charset="-127"/>
-                  <a:ea typeface="나눔스퀘어 Bold" panose="020B0600000101010101" pitchFamily="50" charset="-127"/>
-                </a:rPr>
-                <a:t>&gt; </a:t>
-              </a:r>
-              <a:r>
-                <a:rPr lang="ko-KR" altLang="en-US" sz="1400" dirty="0" smtClean="0">
-                  <a:solidFill>
-                    <a:schemeClr val="tx1"/>
-                  </a:solidFill>
-                  <a:latin typeface="나눔스퀘어 Bold" panose="020B0600000101010101" pitchFamily="50" charset="-127"/>
-                  <a:ea typeface="나눔스퀘어 Bold" panose="020B0600000101010101" pitchFamily="50" charset="-127"/>
-                </a:rPr>
-                <a:t>내림차순 </a:t>
-              </a:r>
-              <a:r>
-                <a:rPr lang="en-US" altLang="ko-KR" sz="1400" dirty="0" smtClean="0">
-                  <a:solidFill>
-                    <a:schemeClr val="tx1"/>
-                  </a:solidFill>
-                  <a:latin typeface="나눔스퀘어 Bold" panose="020B0600000101010101" pitchFamily="50" charset="-127"/>
-                  <a:ea typeface="나눔스퀘어 Bold" panose="020B0600000101010101" pitchFamily="50" charset="-127"/>
-                </a:rPr>
-                <a:t>= </a:t>
-              </a:r>
-              <a:r>
-                <a:rPr lang="ko-KR" altLang="en-US" sz="1400" dirty="0" smtClean="0">
-                  <a:solidFill>
-                    <a:schemeClr val="tx1"/>
-                  </a:solidFill>
-                  <a:latin typeface="나눔스퀘어 Bold" panose="020B0600000101010101" pitchFamily="50" charset="-127"/>
-                  <a:ea typeface="나눔스퀘어 Bold" panose="020B0600000101010101" pitchFamily="50" charset="-127"/>
-                </a:rPr>
-                <a:t>오름차순</a:t>
-              </a:r>
-              <a:endParaRPr lang="ko-KR" altLang="en-US" sz="1400" dirty="0">
-                <a:solidFill>
-                  <a:schemeClr val="tx1"/>
-                </a:solidFill>
+              <a:endParaRPr lang="ko-KR" altLang="en-US" sz="3600" dirty="0">
                 <a:latin typeface="나눔스퀘어 Bold" panose="020B0600000101010101" pitchFamily="50" charset="-127"/>
                 <a:ea typeface="나눔스퀘어 Bold" panose="020B0600000101010101" pitchFamily="50" charset="-127"/>
               </a:endParaRPr>
@@ -3714,20 +3267,20 @@
         </p:sp>
         <p:sp>
           <p:nvSpPr>
-            <p:cNvPr id="33" name="모서리가 둥근 직사각형 32"/>
+            <p:cNvPr id="12" name="직사각형 11"/>
             <p:cNvSpPr/>
             <p:nvPr/>
           </p:nvSpPr>
           <p:spPr>
             <a:xfrm>
-              <a:off x="5601429" y="1375027"/>
-              <a:ext cx="1440000" cy="432000"/>
+              <a:off x="15248220" y="1755302"/>
+              <a:ext cx="2160000" cy="1080000"/>
             </a:xfrm>
-            <a:prstGeom prst="roundRect">
+            <a:prstGeom prst="rect">
               <a:avLst/>
             </a:prstGeom>
             <a:solidFill>
-              <a:schemeClr val="bg1"/>
+              <a:schemeClr val="accent5"/>
             </a:solidFill>
             <a:ln>
               <a:noFill/>
@@ -3755,25 +3308,406 @@
             <a:p>
               <a:pPr algn="ctr"/>
               <a:r>
-                <a:rPr lang="ko-KR" altLang="en-US" smtClean="0">
-                  <a:solidFill>
-                    <a:schemeClr val="tx1"/>
-                  </a:solidFill>
+                <a:rPr lang="ko-KR" altLang="en-US" sz="3600" dirty="0" err="1">
                   <a:latin typeface="나눔스퀘어 Bold" panose="020B0600000101010101" pitchFamily="50" charset="-127"/>
                   <a:ea typeface="나눔스퀘어 Bold" panose="020B0600000101010101" pitchFamily="50" charset="-127"/>
                 </a:rPr>
-                <a:t>오름차순</a:t>
+                <a:t>CalSub</a:t>
               </a:r>
-              <a:endParaRPr lang="ko-KR" altLang="en-US" dirty="0">
-                <a:solidFill>
-                  <a:schemeClr val="tx1"/>
-                </a:solidFill>
+              <a:endParaRPr lang="ko-KR" altLang="en-US" sz="3600" dirty="0">
                 <a:latin typeface="나눔스퀘어 Bold" panose="020B0600000101010101" pitchFamily="50" charset="-127"/>
                 <a:ea typeface="나눔스퀘어 Bold" panose="020B0600000101010101" pitchFamily="50" charset="-127"/>
               </a:endParaRPr>
             </a:p>
           </p:txBody>
         </p:sp>
+        <p:sp>
+          <p:nvSpPr>
+            <p:cNvPr id="13" name="직사각형 12"/>
+            <p:cNvSpPr/>
+            <p:nvPr/>
+          </p:nvSpPr>
+          <p:spPr>
+            <a:xfrm>
+              <a:off x="15248220" y="3122109"/>
+              <a:ext cx="2160000" cy="1080000"/>
+            </a:xfrm>
+            <a:prstGeom prst="rect">
+              <a:avLst/>
+            </a:prstGeom>
+            <a:solidFill>
+              <a:schemeClr val="accent5"/>
+            </a:solidFill>
+            <a:ln>
+              <a:noFill/>
+            </a:ln>
+          </p:spPr>
+          <p:style>
+            <a:lnRef idx="2">
+              <a:schemeClr val="accent1">
+                <a:shade val="50000"/>
+              </a:schemeClr>
+            </a:lnRef>
+            <a:fillRef idx="1">
+              <a:schemeClr val="accent1"/>
+            </a:fillRef>
+            <a:effectRef idx="0">
+              <a:schemeClr val="accent1"/>
+            </a:effectRef>
+            <a:fontRef idx="minor">
+              <a:schemeClr val="lt1"/>
+            </a:fontRef>
+          </p:style>
+          <p:txBody>
+            <a:bodyPr rtlCol="0" anchor="ctr"/>
+            <a:lstStyle/>
+            <a:p>
+              <a:pPr algn="ctr"/>
+              <a:r>
+                <a:rPr lang="ko-KR" altLang="en-US" sz="3600" dirty="0" err="1">
+                  <a:latin typeface="나눔스퀘어 Bold" panose="020B0600000101010101" pitchFamily="50" charset="-127"/>
+                  <a:ea typeface="나눔스퀘어 Bold" panose="020B0600000101010101" pitchFamily="50" charset="-127"/>
+                </a:rPr>
+                <a:t>CalMul</a:t>
+              </a:r>
+              <a:endParaRPr lang="ko-KR" altLang="en-US" sz="3600" dirty="0">
+                <a:latin typeface="나눔스퀘어 Bold" panose="020B0600000101010101" pitchFamily="50" charset="-127"/>
+                <a:ea typeface="나눔스퀘어 Bold" panose="020B0600000101010101" pitchFamily="50" charset="-127"/>
+              </a:endParaRPr>
+            </a:p>
+          </p:txBody>
+        </p:sp>
+        <p:sp>
+          <p:nvSpPr>
+            <p:cNvPr id="14" name="직사각형 13"/>
+            <p:cNvSpPr/>
+            <p:nvPr/>
+          </p:nvSpPr>
+          <p:spPr>
+            <a:xfrm>
+              <a:off x="15248220" y="4488916"/>
+              <a:ext cx="2160000" cy="1080000"/>
+            </a:xfrm>
+            <a:prstGeom prst="rect">
+              <a:avLst/>
+            </a:prstGeom>
+            <a:solidFill>
+              <a:schemeClr val="accent5"/>
+            </a:solidFill>
+            <a:ln>
+              <a:noFill/>
+            </a:ln>
+          </p:spPr>
+          <p:style>
+            <a:lnRef idx="2">
+              <a:schemeClr val="accent1">
+                <a:shade val="50000"/>
+              </a:schemeClr>
+            </a:lnRef>
+            <a:fillRef idx="1">
+              <a:schemeClr val="accent1"/>
+            </a:fillRef>
+            <a:effectRef idx="0">
+              <a:schemeClr val="accent1"/>
+            </a:effectRef>
+            <a:fontRef idx="minor">
+              <a:schemeClr val="lt1"/>
+            </a:fontRef>
+          </p:style>
+          <p:txBody>
+            <a:bodyPr rtlCol="0" anchor="ctr"/>
+            <a:lstStyle/>
+            <a:p>
+              <a:pPr algn="ctr"/>
+              <a:r>
+                <a:rPr lang="ko-KR" altLang="en-US" sz="3600" dirty="0" err="1">
+                  <a:latin typeface="나눔스퀘어 Bold" panose="020B0600000101010101" pitchFamily="50" charset="-127"/>
+                  <a:ea typeface="나눔스퀘어 Bold" panose="020B0600000101010101" pitchFamily="50" charset="-127"/>
+                </a:rPr>
+                <a:t>CalDiv</a:t>
+              </a:r>
+              <a:endParaRPr lang="ko-KR" altLang="en-US" sz="3600" dirty="0">
+                <a:latin typeface="나눔스퀘어 Bold" panose="020B0600000101010101" pitchFamily="50" charset="-127"/>
+                <a:ea typeface="나눔스퀘어 Bold" panose="020B0600000101010101" pitchFamily="50" charset="-127"/>
+              </a:endParaRPr>
+            </a:p>
+          </p:txBody>
+        </p:sp>
+        <p:cxnSp>
+          <p:nvCxnSpPr>
+            <p:cNvPr id="16" name="직선 화살표 연결선 15"/>
+            <p:cNvCxnSpPr>
+              <a:stCxn id="7" idx="3"/>
+              <a:endCxn id="8" idx="1"/>
+            </p:cNvCxnSpPr>
+            <p:nvPr/>
+          </p:nvCxnSpPr>
+          <p:spPr>
+            <a:xfrm>
+              <a:off x="1620000" y="2295302"/>
+              <a:ext cx="803464" cy="0"/>
+            </a:xfrm>
+            <a:prstGeom prst="straightConnector1">
+              <a:avLst/>
+            </a:prstGeom>
+            <a:ln w="76200">
+              <a:solidFill>
+                <a:schemeClr val="accent2"/>
+              </a:solidFill>
+              <a:tailEnd type="triangle"/>
+            </a:ln>
+          </p:spPr>
+          <p:style>
+            <a:lnRef idx="1">
+              <a:schemeClr val="accent1"/>
+            </a:lnRef>
+            <a:fillRef idx="0">
+              <a:schemeClr val="accent1"/>
+            </a:fillRef>
+            <a:effectRef idx="0">
+              <a:schemeClr val="accent1"/>
+            </a:effectRef>
+            <a:fontRef idx="minor">
+              <a:schemeClr val="tx1"/>
+            </a:fontRef>
+          </p:style>
+        </p:cxnSp>
+        <p:cxnSp>
+          <p:nvCxnSpPr>
+            <p:cNvPr id="20" name="직선 화살표 연결선 19"/>
+            <p:cNvCxnSpPr>
+              <a:stCxn id="8" idx="3"/>
+              <a:endCxn id="9" idx="1"/>
+            </p:cNvCxnSpPr>
+            <p:nvPr/>
+          </p:nvCxnSpPr>
+          <p:spPr>
+            <a:xfrm>
+              <a:off x="5663464" y="2295302"/>
+              <a:ext cx="803464" cy="0"/>
+            </a:xfrm>
+            <a:prstGeom prst="straightConnector1">
+              <a:avLst/>
+            </a:prstGeom>
+            <a:ln w="76200">
+              <a:solidFill>
+                <a:schemeClr val="accent2"/>
+              </a:solidFill>
+              <a:tailEnd type="triangle"/>
+            </a:ln>
+          </p:spPr>
+          <p:style>
+            <a:lnRef idx="1">
+              <a:schemeClr val="accent1"/>
+            </a:lnRef>
+            <a:fillRef idx="0">
+              <a:schemeClr val="accent1"/>
+            </a:fillRef>
+            <a:effectRef idx="0">
+              <a:schemeClr val="accent1"/>
+            </a:effectRef>
+            <a:fontRef idx="minor">
+              <a:schemeClr val="tx1"/>
+            </a:fontRef>
+          </p:style>
+        </p:cxnSp>
+        <p:cxnSp>
+          <p:nvCxnSpPr>
+            <p:cNvPr id="23" name="직선 화살표 연결선 22"/>
+            <p:cNvCxnSpPr>
+              <a:stCxn id="9" idx="3"/>
+              <a:endCxn id="10" idx="1"/>
+            </p:cNvCxnSpPr>
+            <p:nvPr/>
+          </p:nvCxnSpPr>
+          <p:spPr>
+            <a:xfrm>
+              <a:off x="9706928" y="2295302"/>
+              <a:ext cx="803464" cy="0"/>
+            </a:xfrm>
+            <a:prstGeom prst="straightConnector1">
+              <a:avLst/>
+            </a:prstGeom>
+            <a:ln w="76200">
+              <a:solidFill>
+                <a:schemeClr val="accent2"/>
+              </a:solidFill>
+              <a:tailEnd type="triangle"/>
+            </a:ln>
+          </p:spPr>
+          <p:style>
+            <a:lnRef idx="1">
+              <a:schemeClr val="accent1"/>
+            </a:lnRef>
+            <a:fillRef idx="0">
+              <a:schemeClr val="accent1"/>
+            </a:fillRef>
+            <a:effectRef idx="0">
+              <a:schemeClr val="accent1"/>
+            </a:effectRef>
+            <a:fontRef idx="minor">
+              <a:schemeClr val="tx1"/>
+            </a:fontRef>
+          </p:style>
+        </p:cxnSp>
+        <p:cxnSp>
+          <p:nvCxnSpPr>
+            <p:cNvPr id="26" name="직선 화살표 연결선 25"/>
+            <p:cNvCxnSpPr>
+              <a:stCxn id="12" idx="1"/>
+              <a:endCxn id="10" idx="3"/>
+            </p:cNvCxnSpPr>
+            <p:nvPr/>
+          </p:nvCxnSpPr>
+          <p:spPr>
+            <a:xfrm flipH="1">
+              <a:off x="13750392" y="2295302"/>
+              <a:ext cx="1497828" cy="0"/>
+            </a:xfrm>
+            <a:prstGeom prst="straightConnector1">
+              <a:avLst/>
+            </a:prstGeom>
+            <a:ln w="76200">
+              <a:solidFill>
+                <a:schemeClr val="accent2"/>
+              </a:solidFill>
+              <a:tailEnd type="triangle"/>
+            </a:ln>
+          </p:spPr>
+          <p:style>
+            <a:lnRef idx="1">
+              <a:schemeClr val="accent1"/>
+            </a:lnRef>
+            <a:fillRef idx="0">
+              <a:schemeClr val="accent1"/>
+            </a:fillRef>
+            <a:effectRef idx="0">
+              <a:schemeClr val="accent1"/>
+            </a:effectRef>
+            <a:fontRef idx="minor">
+              <a:schemeClr val="tx1"/>
+            </a:fontRef>
+          </p:style>
+        </p:cxnSp>
+        <p:cxnSp>
+          <p:nvCxnSpPr>
+            <p:cNvPr id="30" name="꺾인 연결선 29"/>
+            <p:cNvCxnSpPr>
+              <a:stCxn id="11" idx="1"/>
+              <a:endCxn id="10" idx="3"/>
+            </p:cNvCxnSpPr>
+            <p:nvPr/>
+          </p:nvCxnSpPr>
+          <p:spPr>
+            <a:xfrm rot="10800000" flipV="1">
+              <a:off x="13750392" y="928494"/>
+              <a:ext cx="1497828" cy="1366807"/>
+            </a:xfrm>
+            <a:prstGeom prst="bentConnector3">
+              <a:avLst/>
+            </a:prstGeom>
+            <a:ln w="76200">
+              <a:solidFill>
+                <a:schemeClr val="accent2"/>
+              </a:solidFill>
+              <a:tailEnd type="triangle"/>
+            </a:ln>
+          </p:spPr>
+          <p:style>
+            <a:lnRef idx="1">
+              <a:schemeClr val="accent1"/>
+            </a:lnRef>
+            <a:fillRef idx="0">
+              <a:schemeClr val="accent1"/>
+            </a:fillRef>
+            <a:effectRef idx="0">
+              <a:schemeClr val="accent1"/>
+            </a:effectRef>
+            <a:fontRef idx="minor">
+              <a:schemeClr val="tx1"/>
+            </a:fontRef>
+          </p:style>
+        </p:cxnSp>
+        <p:cxnSp>
+          <p:nvCxnSpPr>
+            <p:cNvPr id="33" name="꺾인 연결선 32"/>
+            <p:cNvCxnSpPr>
+              <a:stCxn id="13" idx="1"/>
+              <a:endCxn id="10" idx="3"/>
+            </p:cNvCxnSpPr>
+            <p:nvPr/>
+          </p:nvCxnSpPr>
+          <p:spPr>
+            <a:xfrm rot="10800000">
+              <a:off x="13750392" y="2295303"/>
+              <a:ext cx="1497828" cy="1366807"/>
+            </a:xfrm>
+            <a:prstGeom prst="bentConnector3">
+              <a:avLst/>
+            </a:prstGeom>
+            <a:ln w="76200">
+              <a:solidFill>
+                <a:schemeClr val="accent2"/>
+              </a:solidFill>
+              <a:tailEnd type="triangle"/>
+            </a:ln>
+          </p:spPr>
+          <p:style>
+            <a:lnRef idx="1">
+              <a:schemeClr val="accent1"/>
+            </a:lnRef>
+            <a:fillRef idx="0">
+              <a:schemeClr val="accent1"/>
+            </a:fillRef>
+            <a:effectRef idx="0">
+              <a:schemeClr val="accent1"/>
+            </a:effectRef>
+            <a:fontRef idx="minor">
+              <a:schemeClr val="tx1"/>
+            </a:fontRef>
+          </p:style>
+        </p:cxnSp>
+        <p:cxnSp>
+          <p:nvCxnSpPr>
+            <p:cNvPr id="36" name="꺾인 연결선 35"/>
+            <p:cNvCxnSpPr>
+              <a:stCxn id="14" idx="1"/>
+              <a:endCxn id="10" idx="3"/>
+            </p:cNvCxnSpPr>
+            <p:nvPr/>
+          </p:nvCxnSpPr>
+          <p:spPr>
+            <a:xfrm rot="10800000">
+              <a:off x="13750392" y="2295302"/>
+              <a:ext cx="1497828" cy="2733614"/>
+            </a:xfrm>
+            <a:prstGeom prst="bentConnector3">
+              <a:avLst>
+                <a:gd name="adj1" fmla="val 50000"/>
+              </a:avLst>
+            </a:prstGeom>
+            <a:ln w="76200">
+              <a:solidFill>
+                <a:schemeClr val="accent2"/>
+              </a:solidFill>
+              <a:tailEnd type="triangle"/>
+            </a:ln>
+          </p:spPr>
+          <p:style>
+            <a:lnRef idx="1">
+              <a:schemeClr val="accent1"/>
+            </a:lnRef>
+            <a:fillRef idx="0">
+              <a:schemeClr val="accent1"/>
+            </a:fillRef>
+            <a:effectRef idx="0">
+              <a:schemeClr val="accent1"/>
+            </a:effectRef>
+            <a:fontRef idx="minor">
+              <a:schemeClr val="tx1"/>
+            </a:fontRef>
+          </p:style>
+        </p:cxnSp>
       </p:grpSp>
     </p:spTree>
     <p:extLst>
@@ -3785,6 +3719,13 @@
   <p:clrMapOvr>
     <a:masterClrMapping/>
   </p:clrMapOvr>
+  <p:timing>
+    <p:tnLst>
+      <p:par>
+        <p:cTn id="1" dur="indefinite" restart="never" nodeType="tmRoot"/>
+      </p:par>
+    </p:tnLst>
+  </p:timing>
 </p:sld>
 </file>
 

</xml_diff>

<commit_message>
20260907 commit : Notion_rest, at Home
</commit_message>
<xml_diff>
--- a/notion/create_notion_img.pptx
+++ b/notion/create_notion_img.pptx
@@ -245,7 +245,7 @@
           <a:p>
             <a:fld id="{7237CE1A-8831-48B5-BA93-72483C6E34E8}" type="datetimeFigureOut">
               <a:rPr lang="ko-KR" altLang="en-US" smtClean="0"/>
-              <a:t>26-09-07(Mon)</a:t>
+              <a:t>2026-09-07</a:t>
             </a:fld>
             <a:endParaRPr lang="ko-KR" altLang="en-US"/>
           </a:p>
@@ -415,7 +415,7 @@
           <a:p>
             <a:fld id="{7237CE1A-8831-48B5-BA93-72483C6E34E8}" type="datetimeFigureOut">
               <a:rPr lang="ko-KR" altLang="en-US" smtClean="0"/>
-              <a:t>26-09-07(Mon)</a:t>
+              <a:t>2026-09-07</a:t>
             </a:fld>
             <a:endParaRPr lang="ko-KR" altLang="en-US"/>
           </a:p>
@@ -595,7 +595,7 @@
           <a:p>
             <a:fld id="{7237CE1A-8831-48B5-BA93-72483C6E34E8}" type="datetimeFigureOut">
               <a:rPr lang="ko-KR" altLang="en-US" smtClean="0"/>
-              <a:t>26-09-07(Mon)</a:t>
+              <a:t>2026-09-07</a:t>
             </a:fld>
             <a:endParaRPr lang="ko-KR" altLang="en-US"/>
           </a:p>
@@ -765,7 +765,7 @@
           <a:p>
             <a:fld id="{7237CE1A-8831-48B5-BA93-72483C6E34E8}" type="datetimeFigureOut">
               <a:rPr lang="ko-KR" altLang="en-US" smtClean="0"/>
-              <a:t>26-09-07(Mon)</a:t>
+              <a:t>2026-09-07</a:t>
             </a:fld>
             <a:endParaRPr lang="ko-KR" altLang="en-US"/>
           </a:p>
@@ -1011,7 +1011,7 @@
           <a:p>
             <a:fld id="{7237CE1A-8831-48B5-BA93-72483C6E34E8}" type="datetimeFigureOut">
               <a:rPr lang="ko-KR" altLang="en-US" smtClean="0"/>
-              <a:t>26-09-07(Mon)</a:t>
+              <a:t>2026-09-07</a:t>
             </a:fld>
             <a:endParaRPr lang="ko-KR" altLang="en-US"/>
           </a:p>
@@ -1243,7 +1243,7 @@
           <a:p>
             <a:fld id="{7237CE1A-8831-48B5-BA93-72483C6E34E8}" type="datetimeFigureOut">
               <a:rPr lang="ko-KR" altLang="en-US" smtClean="0"/>
-              <a:t>26-09-07(Mon)</a:t>
+              <a:t>2026-09-07</a:t>
             </a:fld>
             <a:endParaRPr lang="ko-KR" altLang="en-US"/>
           </a:p>
@@ -1610,7 +1610,7 @@
           <a:p>
             <a:fld id="{7237CE1A-8831-48B5-BA93-72483C6E34E8}" type="datetimeFigureOut">
               <a:rPr lang="ko-KR" altLang="en-US" smtClean="0"/>
-              <a:t>26-09-07(Mon)</a:t>
+              <a:t>2026-09-07</a:t>
             </a:fld>
             <a:endParaRPr lang="ko-KR" altLang="en-US"/>
           </a:p>
@@ -1728,7 +1728,7 @@
           <a:p>
             <a:fld id="{7237CE1A-8831-48B5-BA93-72483C6E34E8}" type="datetimeFigureOut">
               <a:rPr lang="ko-KR" altLang="en-US" smtClean="0"/>
-              <a:t>26-09-07(Mon)</a:t>
+              <a:t>2026-09-07</a:t>
             </a:fld>
             <a:endParaRPr lang="ko-KR" altLang="en-US"/>
           </a:p>
@@ -1823,7 +1823,7 @@
           <a:p>
             <a:fld id="{7237CE1A-8831-48B5-BA93-72483C6E34E8}" type="datetimeFigureOut">
               <a:rPr lang="ko-KR" altLang="en-US" smtClean="0"/>
-              <a:t>26-09-07(Mon)</a:t>
+              <a:t>2026-09-07</a:t>
             </a:fld>
             <a:endParaRPr lang="ko-KR" altLang="en-US"/>
           </a:p>
@@ -2100,7 +2100,7 @@
           <a:p>
             <a:fld id="{7237CE1A-8831-48B5-BA93-72483C6E34E8}" type="datetimeFigureOut">
               <a:rPr lang="ko-KR" altLang="en-US" smtClean="0"/>
-              <a:t>26-09-07(Mon)</a:t>
+              <a:t>2026-09-07</a:t>
             </a:fld>
             <a:endParaRPr lang="ko-KR" altLang="en-US"/>
           </a:p>
@@ -2353,7 +2353,7 @@
           <a:p>
             <a:fld id="{7237CE1A-8831-48B5-BA93-72483C6E34E8}" type="datetimeFigureOut">
               <a:rPr lang="ko-KR" altLang="en-US" smtClean="0"/>
-              <a:t>26-09-07(Mon)</a:t>
+              <a:t>2026-09-07</a:t>
             </a:fld>
             <a:endParaRPr lang="ko-KR" altLang="en-US"/>
           </a:p>
@@ -2566,7 +2566,7 @@
           <a:p>
             <a:fld id="{7237CE1A-8831-48B5-BA93-72483C6E34E8}" type="datetimeFigureOut">
               <a:rPr lang="ko-KR" altLang="en-US" smtClean="0"/>
-              <a:t>26-09-07(Mon)</a:t>
+              <a:t>2026-09-07</a:t>
             </a:fld>
             <a:endParaRPr lang="ko-KR" altLang="en-US"/>
           </a:p>
@@ -2973,28 +2973,28 @@
       </p:grpSpPr>
       <p:grpSp>
         <p:nvGrpSpPr>
-          <p:cNvPr id="39" name="그룹 38"/>
+          <p:cNvPr id="18" name="그룹 17"/>
           <p:cNvGrpSpPr/>
           <p:nvPr/>
         </p:nvGrpSpPr>
         <p:grpSpPr>
           <a:xfrm>
-            <a:off x="-1620000" y="388495"/>
-            <a:ext cx="19028220" cy="5180421"/>
-            <a:chOff x="-1620000" y="388495"/>
-            <a:chExt cx="19028220" cy="5180421"/>
+            <a:off x="329030" y="261011"/>
+            <a:ext cx="11475871" cy="3798139"/>
+            <a:chOff x="329030" y="261011"/>
+            <a:chExt cx="11475871" cy="3798139"/>
           </a:xfrm>
         </p:grpSpPr>
         <p:sp>
           <p:nvSpPr>
-            <p:cNvPr id="7" name="직사각형 6"/>
+            <p:cNvPr id="3" name="직사각형 2"/>
             <p:cNvSpPr/>
             <p:nvPr/>
           </p:nvSpPr>
           <p:spPr>
             <a:xfrm>
-              <a:off x="-1620000" y="1755302"/>
-              <a:ext cx="3240000" cy="1080000"/>
+              <a:off x="329030" y="819150"/>
+              <a:ext cx="2160000" cy="2880000"/>
             </a:xfrm>
             <a:prstGeom prst="rect">
               <a:avLst/>
@@ -3028,11 +3028,11 @@
             <a:p>
               <a:pPr algn="ctr"/>
               <a:r>
-                <a:rPr lang="ko-KR" altLang="en-US" sz="3600" dirty="0" err="1">
+                <a:rPr lang="en-US" altLang="ko-KR" sz="3600" dirty="0" smtClean="0">
                   <a:latin typeface="나눔스퀘어 Bold" panose="020B0600000101010101" pitchFamily="50" charset="-127"/>
                   <a:ea typeface="나눔스퀘어 Bold" panose="020B0600000101010101" pitchFamily="50" charset="-127"/>
                 </a:rPr>
-                <a:t>CalAssembler</a:t>
+                <a:t>Client</a:t>
               </a:r>
               <a:endParaRPr lang="ko-KR" altLang="en-US" sz="3600" dirty="0">
                 <a:latin typeface="나눔스퀘어 Bold" panose="020B0600000101010101" pitchFamily="50" charset="-127"/>
@@ -3043,14 +3043,63 @@
         </p:sp>
         <p:sp>
           <p:nvSpPr>
-            <p:cNvPr id="8" name="직사각형 7"/>
+            <p:cNvPr id="19" name="직사각형 18"/>
             <p:cNvSpPr/>
             <p:nvPr/>
           </p:nvSpPr>
           <p:spPr>
             <a:xfrm>
-              <a:off x="2423464" y="1755302"/>
-              <a:ext cx="3240000" cy="1080000"/>
+              <a:off x="3775529" y="819150"/>
+              <a:ext cx="5760000" cy="2880000"/>
+            </a:xfrm>
+            <a:prstGeom prst="rect">
+              <a:avLst/>
+            </a:prstGeom>
+            <a:solidFill>
+              <a:schemeClr val="accent5"/>
+            </a:solidFill>
+            <a:ln>
+              <a:noFill/>
+            </a:ln>
+          </p:spPr>
+          <p:style>
+            <a:lnRef idx="2">
+              <a:schemeClr val="accent1">
+                <a:shade val="50000"/>
+              </a:schemeClr>
+            </a:lnRef>
+            <a:fillRef idx="1">
+              <a:schemeClr val="accent1"/>
+            </a:fillRef>
+            <a:effectRef idx="0">
+              <a:schemeClr val="accent1"/>
+            </a:effectRef>
+            <a:fontRef idx="minor">
+              <a:schemeClr val="lt1"/>
+            </a:fontRef>
+          </p:style>
+          <p:txBody>
+            <a:bodyPr rtlCol="0" anchor="ctr"/>
+            <a:lstStyle/>
+            <a:p>
+              <a:pPr algn="ctr"/>
+              <a:endParaRPr lang="ko-KR" altLang="en-US">
+                <a:latin typeface="나눔스퀘어 Bold" panose="020B0600000101010101" pitchFamily="50" charset="-127"/>
+                <a:ea typeface="나눔스퀘어 Bold" panose="020B0600000101010101" pitchFamily="50" charset="-127"/>
+              </a:endParaRPr>
+            </a:p>
+          </p:txBody>
+        </p:sp>
+        <p:sp>
+          <p:nvSpPr>
+            <p:cNvPr id="21" name="직사각형 20"/>
+            <p:cNvSpPr/>
+            <p:nvPr/>
+          </p:nvSpPr>
+          <p:spPr>
+            <a:xfrm>
+              <a:off x="10364901" y="819150"/>
+              <a:ext cx="1440000" cy="2880000"/>
             </a:xfrm>
             <a:prstGeom prst="rect">
               <a:avLst/>
@@ -3084,11 +3133,11 @@
             <a:p>
               <a:pPr algn="ctr"/>
               <a:r>
-                <a:rPr lang="ko-KR" altLang="en-US" sz="3600">
+                <a:rPr lang="en-US" altLang="ko-KR" sz="3600" dirty="0" smtClean="0">
                   <a:latin typeface="나눔스퀘어 Bold" panose="020B0600000101010101" pitchFamily="50" charset="-127"/>
                   <a:ea typeface="나눔스퀘어 Bold" panose="020B0600000101010101" pitchFamily="50" charset="-127"/>
                 </a:rPr>
-                <a:t>MainClass</a:t>
+                <a:t>DB</a:t>
               </a:r>
               <a:endParaRPr lang="ko-KR" altLang="en-US" sz="3600" dirty="0">
                 <a:latin typeface="나눔스퀘어 Bold" panose="020B0600000101010101" pitchFamily="50" charset="-127"/>
@@ -3099,20 +3148,57 @@
         </p:sp>
         <p:sp>
           <p:nvSpPr>
-            <p:cNvPr id="9" name="직사각형 8"/>
+            <p:cNvPr id="5" name="TextBox 4"/>
+            <p:cNvSpPr txBox="1"/>
+            <p:nvPr/>
+          </p:nvSpPr>
+          <p:spPr>
+            <a:xfrm>
+              <a:off x="5876311" y="261011"/>
+              <a:ext cx="1558440" cy="646331"/>
+            </a:xfrm>
+            <a:prstGeom prst="rect">
+              <a:avLst/>
+            </a:prstGeom>
+            <a:noFill/>
+          </p:spPr>
+          <p:txBody>
+            <a:bodyPr wrap="none" rtlCol="0">
+              <a:spAutoFit/>
+            </a:bodyPr>
+            <a:lstStyle/>
+            <a:p>
+              <a:pPr algn="ctr"/>
+              <a:r>
+                <a:rPr lang="en-US" altLang="ko-KR" sz="3600" dirty="0" smtClean="0">
+                  <a:latin typeface="나눔스퀘어 Bold" panose="020B0600000101010101" pitchFamily="50" charset="-127"/>
+                  <a:ea typeface="나눔스퀘어 Bold" panose="020B0600000101010101" pitchFamily="50" charset="-127"/>
+                </a:rPr>
+                <a:t>server</a:t>
+              </a:r>
+              <a:endParaRPr lang="ko-KR" altLang="en-US" sz="3600" dirty="0">
+                <a:latin typeface="나눔스퀘어 Bold" panose="020B0600000101010101" pitchFamily="50" charset="-127"/>
+                <a:ea typeface="나눔스퀘어 Bold" panose="020B0600000101010101" pitchFamily="50" charset="-127"/>
+              </a:endParaRPr>
+            </a:p>
+          </p:txBody>
+        </p:sp>
+        <p:sp>
+          <p:nvSpPr>
+            <p:cNvPr id="31" name="직사각형 30"/>
             <p:cNvSpPr/>
             <p:nvPr/>
           </p:nvSpPr>
           <p:spPr>
             <a:xfrm>
-              <a:off x="6466928" y="1755302"/>
-              <a:ext cx="3240000" cy="1080000"/>
+              <a:off x="4038402" y="459150"/>
+              <a:ext cx="720000" cy="3600000"/>
             </a:xfrm>
             <a:prstGeom prst="rect">
               <a:avLst/>
             </a:prstGeom>
             <a:solidFill>
-              <a:schemeClr val="accent5"/>
+              <a:schemeClr val="accent6"/>
             </a:solidFill>
             <a:ln>
               <a:noFill/>
@@ -3140,13 +3226,13 @@
             <a:p>
               <a:pPr algn="ctr"/>
               <a:r>
-                <a:rPr lang="ko-KR" altLang="en-US" sz="3600" dirty="0" err="1">
+                <a:rPr lang="en-US" altLang="ko-KR" sz="2800" dirty="0">
                   <a:latin typeface="나눔스퀘어 Bold" panose="020B0600000101010101" pitchFamily="50" charset="-127"/>
                   <a:ea typeface="나눔스퀘어 Bold" panose="020B0600000101010101" pitchFamily="50" charset="-127"/>
                 </a:rPr>
-                <a:t>MyCalculator</a:t>
+                <a:t>D</a:t>
               </a:r>
-              <a:endParaRPr lang="ko-KR" altLang="en-US" sz="3600" dirty="0">
+              <a:endParaRPr lang="ko-KR" altLang="en-US" sz="2800" dirty="0">
                 <a:latin typeface="나눔스퀘어 Bold" panose="020B0600000101010101" pitchFamily="50" charset="-127"/>
                 <a:ea typeface="나눔스퀘어 Bold" panose="020B0600000101010101" pitchFamily="50" charset="-127"/>
               </a:endParaRPr>
@@ -3155,20 +3241,20 @@
         </p:sp>
         <p:sp>
           <p:nvSpPr>
-            <p:cNvPr id="10" name="직사각형 9"/>
+            <p:cNvPr id="32" name="직사각형 31"/>
             <p:cNvSpPr/>
             <p:nvPr/>
           </p:nvSpPr>
           <p:spPr>
             <a:xfrm>
-              <a:off x="10510392" y="1755302"/>
-              <a:ext cx="3240000" cy="1080000"/>
+              <a:off x="4928992" y="979544"/>
+              <a:ext cx="2160000" cy="900000"/>
             </a:xfrm>
             <a:prstGeom prst="rect">
               <a:avLst/>
             </a:prstGeom>
             <a:solidFill>
-              <a:schemeClr val="accent5"/>
+              <a:schemeClr val="accent2"/>
             </a:solidFill>
             <a:ln>
               <a:noFill/>
@@ -3196,13 +3282,13 @@
             <a:p>
               <a:pPr algn="ctr"/>
               <a:r>
-                <a:rPr lang="ko-KR" altLang="en-US" sz="3600" dirty="0" err="1">
+                <a:rPr lang="en-US" altLang="ko-KR" sz="2800" dirty="0" smtClean="0">
                   <a:latin typeface="나눔스퀘어 Bold" panose="020B0600000101010101" pitchFamily="50" charset="-127"/>
                   <a:ea typeface="나눔스퀘어 Bold" panose="020B0600000101010101" pitchFamily="50" charset="-127"/>
                 </a:rPr>
-                <a:t>ICalculator</a:t>
+                <a:t>Interceptor</a:t>
               </a:r>
-              <a:endParaRPr lang="ko-KR" altLang="en-US" sz="3600" dirty="0">
+              <a:endParaRPr lang="ko-KR" altLang="en-US" sz="2800" dirty="0">
                 <a:latin typeface="나눔스퀘어 Bold" panose="020B0600000101010101" pitchFamily="50" charset="-127"/>
                 <a:ea typeface="나눔스퀘어 Bold" panose="020B0600000101010101" pitchFamily="50" charset="-127"/>
               </a:endParaRPr>
@@ -3211,20 +3297,20 @@
         </p:sp>
         <p:sp>
           <p:nvSpPr>
-            <p:cNvPr id="11" name="직사각형 10"/>
+            <p:cNvPr id="34" name="직사각형 33"/>
             <p:cNvSpPr/>
             <p:nvPr/>
           </p:nvSpPr>
           <p:spPr>
             <a:xfrm>
-              <a:off x="15248220" y="388495"/>
-              <a:ext cx="2160000" cy="1080000"/>
+              <a:off x="4928992" y="3122172"/>
+              <a:ext cx="2160000" cy="900000"/>
             </a:xfrm>
             <a:prstGeom prst="rect">
               <a:avLst/>
             </a:prstGeom>
             <a:solidFill>
-              <a:schemeClr val="accent5"/>
+              <a:schemeClr val="accent2"/>
             </a:solidFill>
             <a:ln>
               <a:noFill/>
@@ -3252,13 +3338,13 @@
             <a:p>
               <a:pPr algn="ctr"/>
               <a:r>
-                <a:rPr lang="ko-KR" altLang="en-US" sz="3600" dirty="0" err="1">
+                <a:rPr lang="en-US" altLang="ko-KR" sz="2800" dirty="0">
                   <a:latin typeface="나눔스퀘어 Bold" panose="020B0600000101010101" pitchFamily="50" charset="-127"/>
                   <a:ea typeface="나눔스퀘어 Bold" panose="020B0600000101010101" pitchFamily="50" charset="-127"/>
                 </a:rPr>
-                <a:t>CalAdd</a:t>
+                <a:t>Interceptor</a:t>
               </a:r>
-              <a:endParaRPr lang="ko-KR" altLang="en-US" sz="3600" dirty="0">
+              <a:endParaRPr lang="ko-KR" altLang="en-US" sz="2800" dirty="0">
                 <a:latin typeface="나눔스퀘어 Bold" panose="020B0600000101010101" pitchFamily="50" charset="-127"/>
                 <a:ea typeface="나눔스퀘어 Bold" panose="020B0600000101010101" pitchFamily="50" charset="-127"/>
               </a:endParaRPr>
@@ -3267,20 +3353,20 @@
         </p:sp>
         <p:sp>
           <p:nvSpPr>
-            <p:cNvPr id="12" name="직사각형 11"/>
+            <p:cNvPr id="35" name="직사각형 34"/>
             <p:cNvSpPr/>
             <p:nvPr/>
           </p:nvSpPr>
           <p:spPr>
             <a:xfrm>
-              <a:off x="15248220" y="1755302"/>
-              <a:ext cx="2160000" cy="1080000"/>
+              <a:off x="4928992" y="2050858"/>
+              <a:ext cx="2160000" cy="900000"/>
             </a:xfrm>
             <a:prstGeom prst="rect">
               <a:avLst/>
             </a:prstGeom>
             <a:solidFill>
-              <a:schemeClr val="accent5"/>
+              <a:schemeClr val="accent2"/>
             </a:solidFill>
             <a:ln>
               <a:noFill/>
@@ -3308,13 +3394,13 @@
             <a:p>
               <a:pPr algn="ctr"/>
               <a:r>
-                <a:rPr lang="ko-KR" altLang="en-US" sz="3600" dirty="0" err="1">
+                <a:rPr lang="en-US" altLang="ko-KR" sz="2800">
                   <a:latin typeface="나눔스퀘어 Bold" panose="020B0600000101010101" pitchFamily="50" charset="-127"/>
                   <a:ea typeface="나눔스퀘어 Bold" panose="020B0600000101010101" pitchFamily="50" charset="-127"/>
                 </a:rPr>
-                <a:t>CalSub</a:t>
+                <a:t>Interceptor</a:t>
               </a:r>
-              <a:endParaRPr lang="ko-KR" altLang="en-US" sz="3600" dirty="0">
+              <a:endParaRPr lang="ko-KR" altLang="en-US" sz="2800" dirty="0">
                 <a:latin typeface="나눔스퀘어 Bold" panose="020B0600000101010101" pitchFamily="50" charset="-127"/>
                 <a:ea typeface="나눔스퀘어 Bold" panose="020B0600000101010101" pitchFamily="50" charset="-127"/>
               </a:endParaRPr>
@@ -3323,20 +3409,20 @@
         </p:sp>
         <p:sp>
           <p:nvSpPr>
-            <p:cNvPr id="13" name="직사각형 12"/>
+            <p:cNvPr id="37" name="직사각형 36"/>
             <p:cNvSpPr/>
             <p:nvPr/>
           </p:nvSpPr>
           <p:spPr>
             <a:xfrm>
-              <a:off x="15248220" y="3122109"/>
-              <a:ext cx="2160000" cy="1080000"/>
+              <a:off x="7261612" y="1179150"/>
+              <a:ext cx="2160000" cy="2160000"/>
             </a:xfrm>
             <a:prstGeom prst="rect">
               <a:avLst/>
             </a:prstGeom>
             <a:solidFill>
-              <a:schemeClr val="accent5"/>
+              <a:schemeClr val="accent6"/>
             </a:solidFill>
             <a:ln>
               <a:noFill/>
@@ -3364,69 +3450,13 @@
             <a:p>
               <a:pPr algn="ctr"/>
               <a:r>
-                <a:rPr lang="ko-KR" altLang="en-US" sz="3600" dirty="0" err="1">
+                <a:rPr lang="en-US" altLang="ko-KR" sz="2800" dirty="0" smtClean="0">
                   <a:latin typeface="나눔스퀘어 Bold" panose="020B0600000101010101" pitchFamily="50" charset="-127"/>
                   <a:ea typeface="나눔스퀘어 Bold" panose="020B0600000101010101" pitchFamily="50" charset="-127"/>
                 </a:rPr>
-                <a:t>CalMul</a:t>
+                <a:t>Controller</a:t>
               </a:r>
-              <a:endParaRPr lang="ko-KR" altLang="en-US" sz="3600" dirty="0">
-                <a:latin typeface="나눔스퀘어 Bold" panose="020B0600000101010101" pitchFamily="50" charset="-127"/>
-                <a:ea typeface="나눔스퀘어 Bold" panose="020B0600000101010101" pitchFamily="50" charset="-127"/>
-              </a:endParaRPr>
-            </a:p>
-          </p:txBody>
-        </p:sp>
-        <p:sp>
-          <p:nvSpPr>
-            <p:cNvPr id="14" name="직사각형 13"/>
-            <p:cNvSpPr/>
-            <p:nvPr/>
-          </p:nvSpPr>
-          <p:spPr>
-            <a:xfrm>
-              <a:off x="15248220" y="4488916"/>
-              <a:ext cx="2160000" cy="1080000"/>
-            </a:xfrm>
-            <a:prstGeom prst="rect">
-              <a:avLst/>
-            </a:prstGeom>
-            <a:solidFill>
-              <a:schemeClr val="accent5"/>
-            </a:solidFill>
-            <a:ln>
-              <a:noFill/>
-            </a:ln>
-          </p:spPr>
-          <p:style>
-            <a:lnRef idx="2">
-              <a:schemeClr val="accent1">
-                <a:shade val="50000"/>
-              </a:schemeClr>
-            </a:lnRef>
-            <a:fillRef idx="1">
-              <a:schemeClr val="accent1"/>
-            </a:fillRef>
-            <a:effectRef idx="0">
-              <a:schemeClr val="accent1"/>
-            </a:effectRef>
-            <a:fontRef idx="minor">
-              <a:schemeClr val="lt1"/>
-            </a:fontRef>
-          </p:style>
-          <p:txBody>
-            <a:bodyPr rtlCol="0" anchor="ctr"/>
-            <a:lstStyle/>
-            <a:p>
-              <a:pPr algn="ctr"/>
-              <a:r>
-                <a:rPr lang="ko-KR" altLang="en-US" sz="3600" dirty="0" err="1">
-                  <a:latin typeface="나눔스퀘어 Bold" panose="020B0600000101010101" pitchFamily="50" charset="-127"/>
-                  <a:ea typeface="나눔스퀘어 Bold" panose="020B0600000101010101" pitchFamily="50" charset="-127"/>
-                </a:rPr>
-                <a:t>CalDiv</a:t>
-              </a:r>
-              <a:endParaRPr lang="ko-KR" altLang="en-US" sz="3600" dirty="0">
+              <a:endParaRPr lang="ko-KR" altLang="en-US" sz="2800" dirty="0">
                 <a:latin typeface="나눔스퀘어 Bold" panose="020B0600000101010101" pitchFamily="50" charset="-127"/>
                 <a:ea typeface="나눔스퀘어 Bold" panose="020B0600000101010101" pitchFamily="50" charset="-127"/>
               </a:endParaRPr>
@@ -3435,17 +3465,14 @@
         </p:sp>
         <p:cxnSp>
           <p:nvCxnSpPr>
-            <p:cNvPr id="16" name="직선 화살표 연결선 15"/>
-            <p:cNvCxnSpPr>
-              <a:stCxn id="7" idx="3"/>
-              <a:endCxn id="8" idx="1"/>
-            </p:cNvCxnSpPr>
+            <p:cNvPr id="15" name="직선 화살표 연결선 14"/>
+            <p:cNvCxnSpPr/>
             <p:nvPr/>
           </p:nvCxnSpPr>
           <p:spPr>
-            <a:xfrm>
-              <a:off x="1620000" y="2295302"/>
-              <a:ext cx="803464" cy="0"/>
+            <a:xfrm flipV="1">
+              <a:off x="2335529" y="1553029"/>
+              <a:ext cx="1440000" cy="0"/>
             </a:xfrm>
             <a:prstGeom prst="straightConnector1">
               <a:avLst/>
@@ -3474,17 +3501,14 @@
         </p:cxnSp>
         <p:cxnSp>
           <p:nvCxnSpPr>
-            <p:cNvPr id="20" name="직선 화살표 연결선 19"/>
-            <p:cNvCxnSpPr>
-              <a:stCxn id="8" idx="3"/>
-              <a:endCxn id="9" idx="1"/>
-            </p:cNvCxnSpPr>
+            <p:cNvPr id="38" name="직선 화살표 연결선 37"/>
+            <p:cNvCxnSpPr/>
             <p:nvPr/>
           </p:nvCxnSpPr>
           <p:spPr>
-            <a:xfrm>
-              <a:off x="5663464" y="2295302"/>
-              <a:ext cx="803464" cy="0"/>
+            <a:xfrm flipH="1">
+              <a:off x="2489030" y="2786743"/>
+              <a:ext cx="1440000" cy="0"/>
             </a:xfrm>
             <a:prstGeom prst="straightConnector1">
               <a:avLst/>
@@ -3513,17 +3537,14 @@
         </p:cxnSp>
         <p:cxnSp>
           <p:nvCxnSpPr>
-            <p:cNvPr id="23" name="직선 화살표 연결선 22"/>
-            <p:cNvCxnSpPr>
-              <a:stCxn id="9" idx="3"/>
-              <a:endCxn id="10" idx="1"/>
-            </p:cNvCxnSpPr>
+            <p:cNvPr id="39" name="직선 화살표 연결선 38"/>
+            <p:cNvCxnSpPr/>
             <p:nvPr/>
           </p:nvCxnSpPr>
           <p:spPr>
-            <a:xfrm>
-              <a:off x="9706928" y="2295302"/>
-              <a:ext cx="803464" cy="0"/>
+            <a:xfrm flipV="1">
+              <a:off x="9284901" y="1553029"/>
+              <a:ext cx="1080000" cy="0"/>
             </a:xfrm>
             <a:prstGeom prst="straightConnector1">
               <a:avLst/>
@@ -3552,17 +3573,14 @@
         </p:cxnSp>
         <p:cxnSp>
           <p:nvCxnSpPr>
-            <p:cNvPr id="26" name="직선 화살표 연결선 25"/>
-            <p:cNvCxnSpPr>
-              <a:stCxn id="12" idx="1"/>
-              <a:endCxn id="10" idx="3"/>
-            </p:cNvCxnSpPr>
+            <p:cNvPr id="40" name="직선 화살표 연결선 39"/>
+            <p:cNvCxnSpPr/>
             <p:nvPr/>
           </p:nvCxnSpPr>
           <p:spPr>
             <a:xfrm flipH="1">
-              <a:off x="13750392" y="2295302"/>
-              <a:ext cx="1497828" cy="0"/>
+              <a:off x="9535529" y="2786743"/>
+              <a:ext cx="1080000" cy="0"/>
             </a:xfrm>
             <a:prstGeom prst="straightConnector1">
               <a:avLst/>
@@ -3589,125 +3607,80 @@
             </a:fontRef>
           </p:style>
         </p:cxnSp>
-        <p:cxnSp>
-          <p:nvCxnSpPr>
-            <p:cNvPr id="30" name="꺾인 연결선 29"/>
-            <p:cNvCxnSpPr>
-              <a:stCxn id="11" idx="1"/>
-              <a:endCxn id="10" idx="3"/>
-            </p:cNvCxnSpPr>
+        <p:sp>
+          <p:nvSpPr>
+            <p:cNvPr id="41" name="TextBox 40"/>
+            <p:cNvSpPr txBox="1"/>
             <p:nvPr/>
-          </p:nvCxnSpPr>
+          </p:nvSpPr>
           <p:spPr>
-            <a:xfrm rot="10800000" flipV="1">
-              <a:off x="13750392" y="928494"/>
-              <a:ext cx="1497828" cy="1366807"/>
+            <a:xfrm>
+              <a:off x="2621764" y="1179150"/>
+              <a:ext cx="1020729" cy="369332"/>
             </a:xfrm>
-            <a:prstGeom prst="bentConnector3">
+            <a:prstGeom prst="rect">
               <a:avLst/>
             </a:prstGeom>
-            <a:ln w="76200">
-              <a:solidFill>
-                <a:schemeClr val="accent2"/>
-              </a:solidFill>
-              <a:tailEnd type="triangle"/>
-            </a:ln>
+            <a:noFill/>
           </p:spPr>
-          <p:style>
-            <a:lnRef idx="1">
-              <a:schemeClr val="accent1"/>
-            </a:lnRef>
-            <a:fillRef idx="0">
-              <a:schemeClr val="accent1"/>
-            </a:fillRef>
-            <a:effectRef idx="0">
-              <a:schemeClr val="accent1"/>
-            </a:effectRef>
-            <a:fontRef idx="minor">
-              <a:schemeClr val="tx1"/>
-            </a:fontRef>
-          </p:style>
-        </p:cxnSp>
-        <p:cxnSp>
-          <p:nvCxnSpPr>
-            <p:cNvPr id="33" name="꺾인 연결선 32"/>
-            <p:cNvCxnSpPr>
-              <a:stCxn id="13" idx="1"/>
-              <a:endCxn id="10" idx="3"/>
-            </p:cNvCxnSpPr>
+          <p:txBody>
+            <a:bodyPr wrap="none" rtlCol="0">
+              <a:spAutoFit/>
+            </a:bodyPr>
+            <a:lstStyle/>
+            <a:p>
+              <a:pPr algn="ctr"/>
+              <a:r>
+                <a:rPr lang="en-US" altLang="ko-KR" dirty="0" smtClean="0">
+                  <a:latin typeface="나눔스퀘어 Bold" panose="020B0600000101010101" pitchFamily="50" charset="-127"/>
+                  <a:ea typeface="나눔스퀘어 Bold" panose="020B0600000101010101" pitchFamily="50" charset="-127"/>
+                </a:rPr>
+                <a:t>request</a:t>
+              </a:r>
+              <a:endParaRPr lang="ko-KR" altLang="en-US" dirty="0">
+                <a:latin typeface="나눔스퀘어 Bold" panose="020B0600000101010101" pitchFamily="50" charset="-127"/>
+                <a:ea typeface="나눔스퀘어 Bold" panose="020B0600000101010101" pitchFamily="50" charset="-127"/>
+              </a:endParaRPr>
+            </a:p>
+          </p:txBody>
+        </p:sp>
+        <p:sp>
+          <p:nvSpPr>
+            <p:cNvPr id="42" name="TextBox 41"/>
+            <p:cNvSpPr txBox="1"/>
             <p:nvPr/>
-          </p:nvCxnSpPr>
+          </p:nvSpPr>
           <p:spPr>
-            <a:xfrm rot="10800000">
-              <a:off x="13750392" y="2295303"/>
-              <a:ext cx="1497828" cy="1366807"/>
+            <a:xfrm>
+              <a:off x="2540812" y="2412863"/>
+              <a:ext cx="1182631" cy="369332"/>
             </a:xfrm>
-            <a:prstGeom prst="bentConnector3">
+            <a:prstGeom prst="rect">
               <a:avLst/>
             </a:prstGeom>
-            <a:ln w="76200">
-              <a:solidFill>
-                <a:schemeClr val="accent2"/>
-              </a:solidFill>
-              <a:tailEnd type="triangle"/>
-            </a:ln>
+            <a:noFill/>
           </p:spPr>
-          <p:style>
-            <a:lnRef idx="1">
-              <a:schemeClr val="accent1"/>
-            </a:lnRef>
-            <a:fillRef idx="0">
-              <a:schemeClr val="accent1"/>
-            </a:fillRef>
-            <a:effectRef idx="0">
-              <a:schemeClr val="accent1"/>
-            </a:effectRef>
-            <a:fontRef idx="minor">
-              <a:schemeClr val="tx1"/>
-            </a:fontRef>
-          </p:style>
-        </p:cxnSp>
-        <p:cxnSp>
-          <p:nvCxnSpPr>
-            <p:cNvPr id="36" name="꺾인 연결선 35"/>
-            <p:cNvCxnSpPr>
-              <a:stCxn id="14" idx="1"/>
-              <a:endCxn id="10" idx="3"/>
-            </p:cNvCxnSpPr>
-            <p:nvPr/>
-          </p:nvCxnSpPr>
-          <p:spPr>
-            <a:xfrm rot="10800000">
-              <a:off x="13750392" y="2295302"/>
-              <a:ext cx="1497828" cy="2733614"/>
-            </a:xfrm>
-            <a:prstGeom prst="bentConnector3">
-              <a:avLst>
-                <a:gd name="adj1" fmla="val 50000"/>
-              </a:avLst>
-            </a:prstGeom>
-            <a:ln w="76200">
-              <a:solidFill>
-                <a:schemeClr val="accent2"/>
-              </a:solidFill>
-              <a:tailEnd type="triangle"/>
-            </a:ln>
-          </p:spPr>
-          <p:style>
-            <a:lnRef idx="1">
-              <a:schemeClr val="accent1"/>
-            </a:lnRef>
-            <a:fillRef idx="0">
-              <a:schemeClr val="accent1"/>
-            </a:fillRef>
-            <a:effectRef idx="0">
-              <a:schemeClr val="accent1"/>
-            </a:effectRef>
-            <a:fontRef idx="minor">
-              <a:schemeClr val="tx1"/>
-            </a:fontRef>
-          </p:style>
-        </p:cxnSp>
+          <p:txBody>
+            <a:bodyPr wrap="none" rtlCol="0">
+              <a:spAutoFit/>
+            </a:bodyPr>
+            <a:lstStyle/>
+            <a:p>
+              <a:pPr algn="ctr"/>
+              <a:r>
+                <a:rPr lang="en-US" altLang="ko-KR" dirty="0" smtClean="0">
+                  <a:latin typeface="나눔스퀘어 Bold" panose="020B0600000101010101" pitchFamily="50" charset="-127"/>
+                  <a:ea typeface="나눔스퀘어 Bold" panose="020B0600000101010101" pitchFamily="50" charset="-127"/>
+                </a:rPr>
+                <a:t>response</a:t>
+              </a:r>
+              <a:endParaRPr lang="ko-KR" altLang="en-US" dirty="0">
+                <a:latin typeface="나눔스퀘어 Bold" panose="020B0600000101010101" pitchFamily="50" charset="-127"/>
+                <a:ea typeface="나눔스퀘어 Bold" panose="020B0600000101010101" pitchFamily="50" charset="-127"/>
+              </a:endParaRPr>
+            </a:p>
+          </p:txBody>
+        </p:sp>
       </p:grpSp>
     </p:spTree>
     <p:extLst>

</xml_diff>

<commit_message>
20260909 commit : today's Notion Not
</commit_message>
<xml_diff>
--- a/notion/create_notion_img.pptx
+++ b/notion/create_notion_img.pptx
@@ -245,7 +245,7 @@
           <a:p>
             <a:fld id="{7237CE1A-8831-48B5-BA93-72483C6E34E8}" type="datetimeFigureOut">
               <a:rPr lang="ko-KR" altLang="en-US" smtClean="0"/>
-              <a:t>2026-09-07</a:t>
+              <a:t>2026-09-09</a:t>
             </a:fld>
             <a:endParaRPr lang="ko-KR" altLang="en-US"/>
           </a:p>
@@ -415,7 +415,7 @@
           <a:p>
             <a:fld id="{7237CE1A-8831-48B5-BA93-72483C6E34E8}" type="datetimeFigureOut">
               <a:rPr lang="ko-KR" altLang="en-US" smtClean="0"/>
-              <a:t>2026-09-07</a:t>
+              <a:t>2026-09-09</a:t>
             </a:fld>
             <a:endParaRPr lang="ko-KR" altLang="en-US"/>
           </a:p>
@@ -595,7 +595,7 @@
           <a:p>
             <a:fld id="{7237CE1A-8831-48B5-BA93-72483C6E34E8}" type="datetimeFigureOut">
               <a:rPr lang="ko-KR" altLang="en-US" smtClean="0"/>
-              <a:t>2026-09-07</a:t>
+              <a:t>2026-09-09</a:t>
             </a:fld>
             <a:endParaRPr lang="ko-KR" altLang="en-US"/>
           </a:p>
@@ -765,7 +765,7 @@
           <a:p>
             <a:fld id="{7237CE1A-8831-48B5-BA93-72483C6E34E8}" type="datetimeFigureOut">
               <a:rPr lang="ko-KR" altLang="en-US" smtClean="0"/>
-              <a:t>2026-09-07</a:t>
+              <a:t>2026-09-09</a:t>
             </a:fld>
             <a:endParaRPr lang="ko-KR" altLang="en-US"/>
           </a:p>
@@ -1011,7 +1011,7 @@
           <a:p>
             <a:fld id="{7237CE1A-8831-48B5-BA93-72483C6E34E8}" type="datetimeFigureOut">
               <a:rPr lang="ko-KR" altLang="en-US" smtClean="0"/>
-              <a:t>2026-09-07</a:t>
+              <a:t>2026-09-09</a:t>
             </a:fld>
             <a:endParaRPr lang="ko-KR" altLang="en-US"/>
           </a:p>
@@ -1243,7 +1243,7 @@
           <a:p>
             <a:fld id="{7237CE1A-8831-48B5-BA93-72483C6E34E8}" type="datetimeFigureOut">
               <a:rPr lang="ko-KR" altLang="en-US" smtClean="0"/>
-              <a:t>2026-09-07</a:t>
+              <a:t>2026-09-09</a:t>
             </a:fld>
             <a:endParaRPr lang="ko-KR" altLang="en-US"/>
           </a:p>
@@ -1610,7 +1610,7 @@
           <a:p>
             <a:fld id="{7237CE1A-8831-48B5-BA93-72483C6E34E8}" type="datetimeFigureOut">
               <a:rPr lang="ko-KR" altLang="en-US" smtClean="0"/>
-              <a:t>2026-09-07</a:t>
+              <a:t>2026-09-09</a:t>
             </a:fld>
             <a:endParaRPr lang="ko-KR" altLang="en-US"/>
           </a:p>
@@ -1728,7 +1728,7 @@
           <a:p>
             <a:fld id="{7237CE1A-8831-48B5-BA93-72483C6E34E8}" type="datetimeFigureOut">
               <a:rPr lang="ko-KR" altLang="en-US" smtClean="0"/>
-              <a:t>2026-09-07</a:t>
+              <a:t>2026-09-09</a:t>
             </a:fld>
             <a:endParaRPr lang="ko-KR" altLang="en-US"/>
           </a:p>
@@ -1823,7 +1823,7 @@
           <a:p>
             <a:fld id="{7237CE1A-8831-48B5-BA93-72483C6E34E8}" type="datetimeFigureOut">
               <a:rPr lang="ko-KR" altLang="en-US" smtClean="0"/>
-              <a:t>2026-09-07</a:t>
+              <a:t>2026-09-09</a:t>
             </a:fld>
             <a:endParaRPr lang="ko-KR" altLang="en-US"/>
           </a:p>
@@ -2100,7 +2100,7 @@
           <a:p>
             <a:fld id="{7237CE1A-8831-48B5-BA93-72483C6E34E8}" type="datetimeFigureOut">
               <a:rPr lang="ko-KR" altLang="en-US" smtClean="0"/>
-              <a:t>2026-09-07</a:t>
+              <a:t>2026-09-09</a:t>
             </a:fld>
             <a:endParaRPr lang="ko-KR" altLang="en-US"/>
           </a:p>
@@ -2353,7 +2353,7 @@
           <a:p>
             <a:fld id="{7237CE1A-8831-48B5-BA93-72483C6E34E8}" type="datetimeFigureOut">
               <a:rPr lang="ko-KR" altLang="en-US" smtClean="0"/>
-              <a:t>2026-09-07</a:t>
+              <a:t>2026-09-09</a:t>
             </a:fld>
             <a:endParaRPr lang="ko-KR" altLang="en-US"/>
           </a:p>
@@ -2566,7 +2566,7 @@
           <a:p>
             <a:fld id="{7237CE1A-8831-48B5-BA93-72483C6E34E8}" type="datetimeFigureOut">
               <a:rPr lang="ko-KR" altLang="en-US" smtClean="0"/>
-              <a:t>2026-09-07</a:t>
+              <a:t>2026-09-09</a:t>
             </a:fld>
             <a:endParaRPr lang="ko-KR" altLang="en-US"/>
           </a:p>
@@ -2971,717 +2971,586 @@
           <a:chExt cx="0" cy="0"/>
         </a:xfrm>
       </p:grpSpPr>
-      <p:grpSp>
-        <p:nvGrpSpPr>
-          <p:cNvPr id="18" name="그룹 17"/>
-          <p:cNvGrpSpPr/>
-          <p:nvPr/>
-        </p:nvGrpSpPr>
-        <p:grpSpPr>
-          <a:xfrm>
-            <a:off x="329030" y="261011"/>
-            <a:ext cx="11475871" cy="3798139"/>
-            <a:chOff x="329030" y="261011"/>
-            <a:chExt cx="11475871" cy="3798139"/>
-          </a:xfrm>
-        </p:grpSpPr>
-        <p:sp>
-          <p:nvSpPr>
-            <p:cNvPr id="3" name="직사각형 2"/>
-            <p:cNvSpPr/>
-            <p:nvPr/>
-          </p:nvSpPr>
-          <p:spPr>
-            <a:xfrm>
-              <a:off x="329030" y="819150"/>
-              <a:ext cx="2160000" cy="2880000"/>
-            </a:xfrm>
-            <a:prstGeom prst="rect">
-              <a:avLst/>
-            </a:prstGeom>
-            <a:solidFill>
-              <a:schemeClr val="accent5"/>
-            </a:solidFill>
-            <a:ln>
-              <a:noFill/>
-            </a:ln>
-          </p:spPr>
-          <p:style>
-            <a:lnRef idx="2">
-              <a:schemeClr val="accent1">
-                <a:shade val="50000"/>
-              </a:schemeClr>
-            </a:lnRef>
-            <a:fillRef idx="1">
-              <a:schemeClr val="accent1"/>
-            </a:fillRef>
-            <a:effectRef idx="0">
-              <a:schemeClr val="accent1"/>
-            </a:effectRef>
-            <a:fontRef idx="minor">
-              <a:schemeClr val="lt1"/>
-            </a:fontRef>
-          </p:style>
-          <p:txBody>
-            <a:bodyPr rtlCol="0" anchor="ctr"/>
-            <a:lstStyle/>
-            <a:p>
-              <a:pPr algn="ctr"/>
-              <a:r>
-                <a:rPr lang="en-US" altLang="ko-KR" sz="3600" dirty="0" smtClean="0">
-                  <a:latin typeface="나눔스퀘어 Bold" panose="020B0600000101010101" pitchFamily="50" charset="-127"/>
-                  <a:ea typeface="나눔스퀘어 Bold" panose="020B0600000101010101" pitchFamily="50" charset="-127"/>
-                </a:rPr>
-                <a:t>Client</a:t>
-              </a:r>
-              <a:endParaRPr lang="ko-KR" altLang="en-US" sz="3600" dirty="0">
-                <a:latin typeface="나눔스퀘어 Bold" panose="020B0600000101010101" pitchFamily="50" charset="-127"/>
-                <a:ea typeface="나눔스퀘어 Bold" panose="020B0600000101010101" pitchFamily="50" charset="-127"/>
-              </a:endParaRPr>
-            </a:p>
-          </p:txBody>
-        </p:sp>
-        <p:sp>
-          <p:nvSpPr>
-            <p:cNvPr id="19" name="직사각형 18"/>
-            <p:cNvSpPr/>
-            <p:nvPr/>
-          </p:nvSpPr>
-          <p:spPr>
-            <a:xfrm>
-              <a:off x="3775529" y="819150"/>
-              <a:ext cx="5760000" cy="2880000"/>
-            </a:xfrm>
-            <a:prstGeom prst="rect">
-              <a:avLst/>
-            </a:prstGeom>
-            <a:solidFill>
-              <a:schemeClr val="accent5"/>
-            </a:solidFill>
-            <a:ln>
-              <a:noFill/>
-            </a:ln>
-          </p:spPr>
-          <p:style>
-            <a:lnRef idx="2">
-              <a:schemeClr val="accent1">
-                <a:shade val="50000"/>
-              </a:schemeClr>
-            </a:lnRef>
-            <a:fillRef idx="1">
-              <a:schemeClr val="accent1"/>
-            </a:fillRef>
-            <a:effectRef idx="0">
-              <a:schemeClr val="accent1"/>
-            </a:effectRef>
-            <a:fontRef idx="minor">
-              <a:schemeClr val="lt1"/>
-            </a:fontRef>
-          </p:style>
-          <p:txBody>
-            <a:bodyPr rtlCol="0" anchor="ctr"/>
-            <a:lstStyle/>
-            <a:p>
-              <a:pPr algn="ctr"/>
-              <a:endParaRPr lang="ko-KR" altLang="en-US">
-                <a:latin typeface="나눔스퀘어 Bold" panose="020B0600000101010101" pitchFamily="50" charset="-127"/>
-                <a:ea typeface="나눔스퀘어 Bold" panose="020B0600000101010101" pitchFamily="50" charset="-127"/>
-              </a:endParaRPr>
-            </a:p>
-          </p:txBody>
-        </p:sp>
-        <p:sp>
-          <p:nvSpPr>
-            <p:cNvPr id="21" name="직사각형 20"/>
-            <p:cNvSpPr/>
-            <p:nvPr/>
-          </p:nvSpPr>
-          <p:spPr>
-            <a:xfrm>
-              <a:off x="10364901" y="819150"/>
-              <a:ext cx="1440000" cy="2880000"/>
-            </a:xfrm>
-            <a:prstGeom prst="rect">
-              <a:avLst/>
-            </a:prstGeom>
-            <a:solidFill>
-              <a:schemeClr val="accent5"/>
-            </a:solidFill>
-            <a:ln>
-              <a:noFill/>
-            </a:ln>
-          </p:spPr>
-          <p:style>
-            <a:lnRef idx="2">
-              <a:schemeClr val="accent1">
-                <a:shade val="50000"/>
-              </a:schemeClr>
-            </a:lnRef>
-            <a:fillRef idx="1">
-              <a:schemeClr val="accent1"/>
-            </a:fillRef>
-            <a:effectRef idx="0">
-              <a:schemeClr val="accent1"/>
-            </a:effectRef>
-            <a:fontRef idx="minor">
-              <a:schemeClr val="lt1"/>
-            </a:fontRef>
-          </p:style>
-          <p:txBody>
-            <a:bodyPr rtlCol="0" anchor="ctr"/>
-            <a:lstStyle/>
-            <a:p>
-              <a:pPr algn="ctr"/>
-              <a:r>
-                <a:rPr lang="en-US" altLang="ko-KR" sz="3600" dirty="0" smtClean="0">
-                  <a:latin typeface="나눔스퀘어 Bold" panose="020B0600000101010101" pitchFamily="50" charset="-127"/>
-                  <a:ea typeface="나눔스퀘어 Bold" panose="020B0600000101010101" pitchFamily="50" charset="-127"/>
-                </a:rPr>
-                <a:t>DB</a:t>
-              </a:r>
-              <a:endParaRPr lang="ko-KR" altLang="en-US" sz="3600" dirty="0">
-                <a:latin typeface="나눔스퀘어 Bold" panose="020B0600000101010101" pitchFamily="50" charset="-127"/>
-                <a:ea typeface="나눔스퀘어 Bold" panose="020B0600000101010101" pitchFamily="50" charset="-127"/>
-              </a:endParaRPr>
-            </a:p>
-          </p:txBody>
-        </p:sp>
-        <p:sp>
-          <p:nvSpPr>
-            <p:cNvPr id="5" name="TextBox 4"/>
-            <p:cNvSpPr txBox="1"/>
-            <p:nvPr/>
-          </p:nvSpPr>
-          <p:spPr>
-            <a:xfrm>
-              <a:off x="5876311" y="261011"/>
-              <a:ext cx="1558440" cy="646331"/>
-            </a:xfrm>
-            <a:prstGeom prst="rect">
-              <a:avLst/>
-            </a:prstGeom>
+      <p:sp>
+        <p:nvSpPr>
+          <p:cNvPr id="2" name="직사각형 1"/>
+          <p:cNvSpPr/>
+          <p:nvPr/>
+        </p:nvSpPr>
+        <p:spPr>
+          <a:xfrm>
+            <a:off x="-1657350" y="1462200"/>
+            <a:ext cx="4320000" cy="2880000"/>
+          </a:xfrm>
+          <a:prstGeom prst="rect">
+            <a:avLst/>
+          </a:prstGeom>
+          <a:solidFill>
+            <a:schemeClr val="accent5"/>
+          </a:solidFill>
+          <a:ln>
             <a:noFill/>
-          </p:spPr>
-          <p:txBody>
-            <a:bodyPr wrap="none" rtlCol="0">
-              <a:spAutoFit/>
-            </a:bodyPr>
-            <a:lstStyle/>
-            <a:p>
-              <a:pPr algn="ctr"/>
-              <a:r>
-                <a:rPr lang="en-US" altLang="ko-KR" sz="3600" dirty="0" smtClean="0">
-                  <a:latin typeface="나눔스퀘어 Bold" panose="020B0600000101010101" pitchFamily="50" charset="-127"/>
-                  <a:ea typeface="나눔스퀘어 Bold" panose="020B0600000101010101" pitchFamily="50" charset="-127"/>
-                </a:rPr>
-                <a:t>server</a:t>
-              </a:r>
-              <a:endParaRPr lang="ko-KR" altLang="en-US" sz="3600" dirty="0">
-                <a:latin typeface="나눔스퀘어 Bold" panose="020B0600000101010101" pitchFamily="50" charset="-127"/>
-                <a:ea typeface="나눔스퀘어 Bold" panose="020B0600000101010101" pitchFamily="50" charset="-127"/>
-              </a:endParaRPr>
-            </a:p>
-          </p:txBody>
-        </p:sp>
-        <p:sp>
-          <p:nvSpPr>
-            <p:cNvPr id="31" name="직사각형 30"/>
-            <p:cNvSpPr/>
-            <p:nvPr/>
-          </p:nvSpPr>
-          <p:spPr>
-            <a:xfrm>
-              <a:off x="4038402" y="459150"/>
-              <a:ext cx="720000" cy="3600000"/>
-            </a:xfrm>
-            <a:prstGeom prst="rect">
-              <a:avLst/>
-            </a:prstGeom>
-            <a:solidFill>
-              <a:schemeClr val="accent6"/>
-            </a:solidFill>
-            <a:ln>
-              <a:noFill/>
-            </a:ln>
-          </p:spPr>
-          <p:style>
-            <a:lnRef idx="2">
-              <a:schemeClr val="accent1">
-                <a:shade val="50000"/>
-              </a:schemeClr>
-            </a:lnRef>
-            <a:fillRef idx="1">
-              <a:schemeClr val="accent1"/>
-            </a:fillRef>
-            <a:effectRef idx="0">
-              <a:schemeClr val="accent1"/>
-            </a:effectRef>
-            <a:fontRef idx="minor">
-              <a:schemeClr val="lt1"/>
-            </a:fontRef>
-          </p:style>
-          <p:txBody>
-            <a:bodyPr rtlCol="0" anchor="ctr"/>
-            <a:lstStyle/>
-            <a:p>
-              <a:pPr algn="ctr"/>
-              <a:r>
-                <a:rPr lang="en-US" altLang="ko-KR" sz="2800" dirty="0">
-                  <a:latin typeface="나눔스퀘어 Bold" panose="020B0600000101010101" pitchFamily="50" charset="-127"/>
-                  <a:ea typeface="나눔스퀘어 Bold" panose="020B0600000101010101" pitchFamily="50" charset="-127"/>
-                </a:rPr>
-                <a:t>D</a:t>
-              </a:r>
-              <a:endParaRPr lang="ko-KR" altLang="en-US" sz="2800" dirty="0">
-                <a:latin typeface="나눔스퀘어 Bold" panose="020B0600000101010101" pitchFamily="50" charset="-127"/>
-                <a:ea typeface="나눔스퀘어 Bold" panose="020B0600000101010101" pitchFamily="50" charset="-127"/>
-              </a:endParaRPr>
-            </a:p>
-          </p:txBody>
-        </p:sp>
-        <p:sp>
-          <p:nvSpPr>
-            <p:cNvPr id="32" name="직사각형 31"/>
-            <p:cNvSpPr/>
-            <p:nvPr/>
-          </p:nvSpPr>
-          <p:spPr>
-            <a:xfrm>
-              <a:off x="4928992" y="979544"/>
-              <a:ext cx="2160000" cy="900000"/>
-            </a:xfrm>
-            <a:prstGeom prst="rect">
-              <a:avLst/>
-            </a:prstGeom>
+          </a:ln>
+        </p:spPr>
+        <p:style>
+          <a:lnRef idx="2">
+            <a:schemeClr val="accent1">
+              <a:shade val="50000"/>
+            </a:schemeClr>
+          </a:lnRef>
+          <a:fillRef idx="1">
+            <a:schemeClr val="accent1"/>
+          </a:fillRef>
+          <a:effectRef idx="0">
+            <a:schemeClr val="accent1"/>
+          </a:effectRef>
+          <a:fontRef idx="minor">
+            <a:schemeClr val="lt1"/>
+          </a:fontRef>
+        </p:style>
+        <p:txBody>
+          <a:bodyPr rtlCol="0" anchor="ctr"/>
+          <a:lstStyle/>
+          <a:p>
+            <a:pPr algn="ctr"/>
+            <a:endParaRPr lang="ko-KR" altLang="en-US" sz="3200">
+              <a:latin typeface="나눔스퀘어 Bold" panose="020B0600000101010101" pitchFamily="50" charset="-127"/>
+              <a:ea typeface="나눔스퀘어 Bold" panose="020B0600000101010101" pitchFamily="50" charset="-127"/>
+            </a:endParaRPr>
+          </a:p>
+        </p:txBody>
+      </p:sp>
+      <p:sp>
+        <p:nvSpPr>
+          <p:cNvPr id="4" name="직사각형 3"/>
+          <p:cNvSpPr/>
+          <p:nvPr/>
+        </p:nvSpPr>
+        <p:spPr>
+          <a:xfrm>
+            <a:off x="4877175" y="2362200"/>
+            <a:ext cx="2700000" cy="1080000"/>
+          </a:xfrm>
+          <a:prstGeom prst="rect">
+            <a:avLst/>
+          </a:prstGeom>
+          <a:solidFill>
+            <a:schemeClr val="accent5"/>
+          </a:solidFill>
+          <a:ln>
+            <a:noFill/>
+          </a:ln>
+        </p:spPr>
+        <p:style>
+          <a:lnRef idx="2">
+            <a:schemeClr val="accent1">
+              <a:shade val="50000"/>
+            </a:schemeClr>
+          </a:lnRef>
+          <a:fillRef idx="1">
+            <a:schemeClr val="accent1"/>
+          </a:fillRef>
+          <a:effectRef idx="0">
+            <a:schemeClr val="accent1"/>
+          </a:effectRef>
+          <a:fontRef idx="minor">
+            <a:schemeClr val="lt1"/>
+          </a:fontRef>
+        </p:style>
+        <p:txBody>
+          <a:bodyPr rtlCol="0" anchor="ctr"/>
+          <a:lstStyle/>
+          <a:p>
+            <a:pPr algn="ctr"/>
+            <a:r>
+              <a:rPr lang="ko-KR" altLang="en-US" sz="3200" dirty="0">
+                <a:latin typeface="나눔스퀘어 Bold" panose="020B0600000101010101" pitchFamily="50" charset="-127"/>
+                <a:ea typeface="나눔스퀘어 Bold" panose="020B0600000101010101" pitchFamily="50" charset="-127"/>
+              </a:rPr>
+              <a:t>애플리케이션</a:t>
+            </a:r>
+          </a:p>
+        </p:txBody>
+      </p:sp>
+      <p:sp>
+        <p:nvSpPr>
+          <p:cNvPr id="20" name="직사각형 19"/>
+          <p:cNvSpPr/>
+          <p:nvPr/>
+        </p:nvSpPr>
+        <p:spPr>
+          <a:xfrm>
+            <a:off x="9791700" y="2362200"/>
+            <a:ext cx="2700000" cy="1080000"/>
+          </a:xfrm>
+          <a:prstGeom prst="rect">
+            <a:avLst/>
+          </a:prstGeom>
+          <a:solidFill>
+            <a:schemeClr val="accent5"/>
+          </a:solidFill>
+          <a:ln>
+            <a:noFill/>
+          </a:ln>
+        </p:spPr>
+        <p:style>
+          <a:lnRef idx="2">
+            <a:schemeClr val="accent1">
+              <a:shade val="50000"/>
+            </a:schemeClr>
+          </a:lnRef>
+          <a:fillRef idx="1">
+            <a:schemeClr val="accent1"/>
+          </a:fillRef>
+          <a:effectRef idx="0">
+            <a:schemeClr val="accent1"/>
+          </a:effectRef>
+          <a:fontRef idx="minor">
+            <a:schemeClr val="lt1"/>
+          </a:fontRef>
+        </p:style>
+        <p:txBody>
+          <a:bodyPr rtlCol="0" anchor="ctr"/>
+          <a:lstStyle/>
+          <a:p>
+            <a:pPr algn="ctr"/>
+            <a:r>
+              <a:rPr lang="en-US" altLang="ko-KR" sz="3200" dirty="0" smtClean="0">
+                <a:latin typeface="나눔스퀘어 Bold" panose="020B0600000101010101" pitchFamily="50" charset="-127"/>
+                <a:ea typeface="나눔스퀘어 Bold" panose="020B0600000101010101" pitchFamily="50" charset="-127"/>
+              </a:rPr>
+              <a:t>Connection</a:t>
+            </a:r>
+          </a:p>
+          <a:p>
+            <a:pPr algn="ctr"/>
+            <a:r>
+              <a:rPr lang="ko-KR" altLang="en-US" sz="3200" dirty="0" smtClean="0">
+                <a:latin typeface="나눔스퀘어 Bold" panose="020B0600000101010101" pitchFamily="50" charset="-127"/>
+                <a:ea typeface="나눔스퀘어 Bold" panose="020B0600000101010101" pitchFamily="50" charset="-127"/>
+              </a:rPr>
+              <a:t>반납</a:t>
+            </a:r>
+            <a:endParaRPr lang="ko-KR" altLang="en-US" sz="3200" dirty="0">
+              <a:latin typeface="나눔스퀘어 Bold" panose="020B0600000101010101" pitchFamily="50" charset="-127"/>
+              <a:ea typeface="나눔스퀘어 Bold" panose="020B0600000101010101" pitchFamily="50" charset="-127"/>
+            </a:endParaRPr>
+          </a:p>
+        </p:txBody>
+      </p:sp>
+      <p:sp>
+        <p:nvSpPr>
+          <p:cNvPr id="6" name="직사각형 5"/>
+          <p:cNvSpPr/>
+          <p:nvPr/>
+        </p:nvSpPr>
+        <p:spPr>
+          <a:xfrm>
+            <a:off x="-1154566" y="883318"/>
+            <a:ext cx="3314433" cy="584775"/>
+          </a:xfrm>
+          <a:prstGeom prst="rect">
+            <a:avLst/>
+          </a:prstGeom>
+          <a:ln>
+            <a:noFill/>
+          </a:ln>
+        </p:spPr>
+        <p:txBody>
+          <a:bodyPr wrap="none">
+            <a:spAutoFit/>
+          </a:bodyPr>
+          <a:lstStyle/>
+          <a:p>
+            <a:pPr algn="ctr"/>
+            <a:r>
+              <a:rPr lang="ko-KR" altLang="en-US" sz="3200" dirty="0" err="1">
+                <a:latin typeface="나눔스퀘어 Bold" panose="020B0600000101010101" pitchFamily="50" charset="-127"/>
+                <a:ea typeface="나눔스퀘어 Bold" panose="020B0600000101010101" pitchFamily="50" charset="-127"/>
+              </a:rPr>
+              <a:t>Connection</a:t>
+            </a:r>
+            <a:r>
+              <a:rPr lang="ko-KR" altLang="en-US" sz="3200" dirty="0">
+                <a:latin typeface="나눔스퀘어 Bold" panose="020B0600000101010101" pitchFamily="50" charset="-127"/>
+                <a:ea typeface="나눔스퀘어 Bold" panose="020B0600000101010101" pitchFamily="50" charset="-127"/>
+              </a:rPr>
+              <a:t> </a:t>
+            </a:r>
+            <a:r>
+              <a:rPr lang="ko-KR" altLang="en-US" sz="3200" dirty="0" err="1">
+                <a:latin typeface="나눔스퀘어 Bold" panose="020B0600000101010101" pitchFamily="50" charset="-127"/>
+                <a:ea typeface="나눔스퀘어 Bold" panose="020B0600000101010101" pitchFamily="50" charset="-127"/>
+              </a:rPr>
+              <a:t>Pool</a:t>
+            </a:r>
+            <a:endParaRPr lang="ko-KR" altLang="en-US" sz="3200" dirty="0">
+              <a:latin typeface="나눔스퀘어 Bold" panose="020B0600000101010101" pitchFamily="50" charset="-127"/>
+              <a:ea typeface="나눔스퀘어 Bold" panose="020B0600000101010101" pitchFamily="50" charset="-127"/>
+            </a:endParaRPr>
+          </a:p>
+        </p:txBody>
+      </p:sp>
+      <p:sp>
+        <p:nvSpPr>
+          <p:cNvPr id="7" name="직사각형 6"/>
+          <p:cNvSpPr/>
+          <p:nvPr/>
+        </p:nvSpPr>
+        <p:spPr>
+          <a:xfrm>
+            <a:off x="-1297350" y="1714200"/>
+            <a:ext cx="3600000" cy="648000"/>
+          </a:xfrm>
+          <a:prstGeom prst="rect">
+            <a:avLst/>
+          </a:prstGeom>
+          <a:solidFill>
+            <a:schemeClr val="bg1">
+              <a:lumMod val="95000"/>
+            </a:schemeClr>
+          </a:solidFill>
+          <a:ln>
+            <a:noFill/>
+          </a:ln>
+        </p:spPr>
+        <p:style>
+          <a:lnRef idx="2">
+            <a:schemeClr val="accent1">
+              <a:shade val="50000"/>
+            </a:schemeClr>
+          </a:lnRef>
+          <a:fillRef idx="1">
+            <a:schemeClr val="accent1"/>
+          </a:fillRef>
+          <a:effectRef idx="0">
+            <a:schemeClr val="accent1"/>
+          </a:effectRef>
+          <a:fontRef idx="minor">
+            <a:schemeClr val="lt1"/>
+          </a:fontRef>
+        </p:style>
+        <p:txBody>
+          <a:bodyPr rtlCol="0" anchor="ctr"/>
+          <a:lstStyle/>
+          <a:p>
+            <a:pPr algn="ctr"/>
+            <a:r>
+              <a:rPr lang="en-US" altLang="ko-KR" sz="3200" dirty="0">
+                <a:solidFill>
+                  <a:schemeClr val="tx1"/>
+                </a:solidFill>
+                <a:latin typeface="나눔스퀘어 Bold" panose="020B0600000101010101" pitchFamily="50" charset="-127"/>
+                <a:ea typeface="나눔스퀘어 Bold" panose="020B0600000101010101" pitchFamily="50" charset="-127"/>
+              </a:rPr>
+              <a:t>Connection 1</a:t>
+            </a:r>
+            <a:endParaRPr lang="ko-KR" altLang="en-US" sz="3200" dirty="0">
+              <a:solidFill>
+                <a:schemeClr val="tx1"/>
+              </a:solidFill>
+              <a:latin typeface="나눔스퀘어 Bold" panose="020B0600000101010101" pitchFamily="50" charset="-127"/>
+              <a:ea typeface="나눔스퀘어 Bold" panose="020B0600000101010101" pitchFamily="50" charset="-127"/>
+            </a:endParaRPr>
+          </a:p>
+        </p:txBody>
+      </p:sp>
+      <p:sp>
+        <p:nvSpPr>
+          <p:cNvPr id="23" name="직사각형 22"/>
+          <p:cNvSpPr/>
+          <p:nvPr/>
+        </p:nvSpPr>
+        <p:spPr>
+          <a:xfrm>
+            <a:off x="-1297350" y="2609534"/>
+            <a:ext cx="3600000" cy="648000"/>
+          </a:xfrm>
+          <a:prstGeom prst="rect">
+            <a:avLst/>
+          </a:prstGeom>
+          <a:solidFill>
+            <a:schemeClr val="bg1">
+              <a:lumMod val="95000"/>
+            </a:schemeClr>
+          </a:solidFill>
+          <a:ln>
+            <a:noFill/>
+          </a:ln>
+        </p:spPr>
+        <p:style>
+          <a:lnRef idx="2">
+            <a:schemeClr val="accent1">
+              <a:shade val="50000"/>
+            </a:schemeClr>
+          </a:lnRef>
+          <a:fillRef idx="1">
+            <a:schemeClr val="accent1"/>
+          </a:fillRef>
+          <a:effectRef idx="0">
+            <a:schemeClr val="accent1"/>
+          </a:effectRef>
+          <a:fontRef idx="minor">
+            <a:schemeClr val="lt1"/>
+          </a:fontRef>
+        </p:style>
+        <p:txBody>
+          <a:bodyPr rtlCol="0" anchor="ctr"/>
+          <a:lstStyle/>
+          <a:p>
+            <a:pPr algn="ctr"/>
+            <a:r>
+              <a:rPr lang="en-US" altLang="ko-KR" sz="3200" dirty="0">
+                <a:solidFill>
+                  <a:schemeClr val="tx1"/>
+                </a:solidFill>
+                <a:latin typeface="나눔스퀘어 Bold" panose="020B0600000101010101" pitchFamily="50" charset="-127"/>
+                <a:ea typeface="나눔스퀘어 Bold" panose="020B0600000101010101" pitchFamily="50" charset="-127"/>
+              </a:rPr>
+              <a:t>Connection </a:t>
+            </a:r>
+            <a:r>
+              <a:rPr lang="en-US" altLang="ko-KR" sz="3200" dirty="0" smtClean="0">
+                <a:solidFill>
+                  <a:schemeClr val="tx1"/>
+                </a:solidFill>
+                <a:latin typeface="나눔스퀘어 Bold" panose="020B0600000101010101" pitchFamily="50" charset="-127"/>
+                <a:ea typeface="나눔스퀘어 Bold" panose="020B0600000101010101" pitchFamily="50" charset="-127"/>
+              </a:rPr>
+              <a:t>2</a:t>
+            </a:r>
+            <a:endParaRPr lang="ko-KR" altLang="en-US" sz="3200" dirty="0">
+              <a:solidFill>
+                <a:schemeClr val="tx1"/>
+              </a:solidFill>
+              <a:latin typeface="나눔스퀘어 Bold" panose="020B0600000101010101" pitchFamily="50" charset="-127"/>
+              <a:ea typeface="나눔스퀘어 Bold" panose="020B0600000101010101" pitchFamily="50" charset="-127"/>
+            </a:endParaRPr>
+          </a:p>
+        </p:txBody>
+      </p:sp>
+      <p:sp>
+        <p:nvSpPr>
+          <p:cNvPr id="24" name="직사각형 23"/>
+          <p:cNvSpPr/>
+          <p:nvPr/>
+        </p:nvSpPr>
+        <p:spPr>
+          <a:xfrm>
+            <a:off x="-1297350" y="3442200"/>
+            <a:ext cx="3600000" cy="648000"/>
+          </a:xfrm>
+          <a:prstGeom prst="rect">
+            <a:avLst/>
+          </a:prstGeom>
+          <a:solidFill>
+            <a:schemeClr val="bg1">
+              <a:lumMod val="95000"/>
+            </a:schemeClr>
+          </a:solidFill>
+          <a:ln>
+            <a:noFill/>
+          </a:ln>
+        </p:spPr>
+        <p:style>
+          <a:lnRef idx="2">
+            <a:schemeClr val="accent1">
+              <a:shade val="50000"/>
+            </a:schemeClr>
+          </a:lnRef>
+          <a:fillRef idx="1">
+            <a:schemeClr val="accent1"/>
+          </a:fillRef>
+          <a:effectRef idx="0">
+            <a:schemeClr val="accent1"/>
+          </a:effectRef>
+          <a:fontRef idx="minor">
+            <a:schemeClr val="lt1"/>
+          </a:fontRef>
+        </p:style>
+        <p:txBody>
+          <a:bodyPr rtlCol="0" anchor="ctr"/>
+          <a:lstStyle/>
+          <a:p>
+            <a:pPr algn="ctr"/>
+            <a:r>
+              <a:rPr lang="en-US" altLang="ko-KR" sz="3200" dirty="0">
+                <a:solidFill>
+                  <a:schemeClr val="tx1"/>
+                </a:solidFill>
+                <a:latin typeface="나눔스퀘어 Bold" panose="020B0600000101010101" pitchFamily="50" charset="-127"/>
+                <a:ea typeface="나눔스퀘어 Bold" panose="020B0600000101010101" pitchFamily="50" charset="-127"/>
+              </a:rPr>
+              <a:t>Connection </a:t>
+            </a:r>
+            <a:r>
+              <a:rPr lang="en-US" altLang="ko-KR" sz="3200" dirty="0" smtClean="0">
+                <a:solidFill>
+                  <a:schemeClr val="tx1"/>
+                </a:solidFill>
+                <a:latin typeface="나눔스퀘어 Bold" panose="020B0600000101010101" pitchFamily="50" charset="-127"/>
+                <a:ea typeface="나눔스퀘어 Bold" panose="020B0600000101010101" pitchFamily="50" charset="-127"/>
+              </a:rPr>
+              <a:t>3</a:t>
+            </a:r>
+            <a:endParaRPr lang="ko-KR" altLang="en-US" sz="3200" dirty="0">
+              <a:solidFill>
+                <a:schemeClr val="tx1"/>
+              </a:solidFill>
+              <a:latin typeface="나눔스퀘어 Bold" panose="020B0600000101010101" pitchFamily="50" charset="-127"/>
+              <a:ea typeface="나눔스퀘어 Bold" panose="020B0600000101010101" pitchFamily="50" charset="-127"/>
+            </a:endParaRPr>
+          </a:p>
+        </p:txBody>
+      </p:sp>
+      <p:sp>
+        <p:nvSpPr>
+          <p:cNvPr id="8" name="직사각형 7"/>
+          <p:cNvSpPr/>
+          <p:nvPr/>
+        </p:nvSpPr>
+        <p:spPr>
+          <a:xfrm>
+            <a:off x="7784994" y="2304268"/>
+            <a:ext cx="1798890" cy="584775"/>
+          </a:xfrm>
+          <a:prstGeom prst="rect">
+            <a:avLst/>
+          </a:prstGeom>
+        </p:spPr>
+        <p:txBody>
+          <a:bodyPr wrap="none">
+            <a:spAutoFit/>
+          </a:bodyPr>
+          <a:lstStyle/>
+          <a:p>
+            <a:pPr algn="ctr"/>
+            <a:r>
+              <a:rPr lang="ko-KR" altLang="en-US" sz="3200" dirty="0">
+                <a:latin typeface="나눔스퀘어 Bold" panose="020B0600000101010101" pitchFamily="50" charset="-127"/>
+                <a:ea typeface="나눔스퀘어 Bold" panose="020B0600000101010101" pitchFamily="50" charset="-127"/>
+              </a:rPr>
+              <a:t>SQL 실행</a:t>
+            </a:r>
+          </a:p>
+        </p:txBody>
+      </p:sp>
+      <p:cxnSp>
+        <p:nvCxnSpPr>
+          <p:cNvPr id="10" name="직선 화살표 연결선 9"/>
+          <p:cNvCxnSpPr>
+            <a:stCxn id="2" idx="3"/>
+            <a:endCxn id="4" idx="1"/>
+          </p:cNvCxnSpPr>
+          <p:nvPr/>
+        </p:nvCxnSpPr>
+        <p:spPr>
+          <a:xfrm>
+            <a:off x="2662650" y="2902200"/>
+            <a:ext cx="2214525" cy="0"/>
+          </a:xfrm>
+          <a:prstGeom prst="straightConnector1">
+            <a:avLst/>
+          </a:prstGeom>
+          <a:ln w="76200">
             <a:solidFill>
               <a:schemeClr val="accent2"/>
             </a:solidFill>
-            <a:ln>
-              <a:noFill/>
-            </a:ln>
-          </p:spPr>
-          <p:style>
-            <a:lnRef idx="2">
-              <a:schemeClr val="accent1">
-                <a:shade val="50000"/>
-              </a:schemeClr>
-            </a:lnRef>
-            <a:fillRef idx="1">
-              <a:schemeClr val="accent1"/>
-            </a:fillRef>
-            <a:effectRef idx="0">
-              <a:schemeClr val="accent1"/>
-            </a:effectRef>
-            <a:fontRef idx="minor">
-              <a:schemeClr val="lt1"/>
-            </a:fontRef>
-          </p:style>
-          <p:txBody>
-            <a:bodyPr rtlCol="0" anchor="ctr"/>
-            <a:lstStyle/>
-            <a:p>
-              <a:pPr algn="ctr"/>
-              <a:r>
-                <a:rPr lang="en-US" altLang="ko-KR" sz="2800" dirty="0" smtClean="0">
-                  <a:latin typeface="나눔스퀘어 Bold" panose="020B0600000101010101" pitchFamily="50" charset="-127"/>
-                  <a:ea typeface="나눔스퀘어 Bold" panose="020B0600000101010101" pitchFamily="50" charset="-127"/>
-                </a:rPr>
-                <a:t>Interceptor</a:t>
-              </a:r>
-              <a:endParaRPr lang="ko-KR" altLang="en-US" sz="2800" dirty="0">
-                <a:latin typeface="나눔스퀘어 Bold" panose="020B0600000101010101" pitchFamily="50" charset="-127"/>
-                <a:ea typeface="나눔스퀘어 Bold" panose="020B0600000101010101" pitchFamily="50" charset="-127"/>
-              </a:endParaRPr>
-            </a:p>
-          </p:txBody>
-        </p:sp>
-        <p:sp>
-          <p:nvSpPr>
-            <p:cNvPr id="34" name="직사각형 33"/>
-            <p:cNvSpPr/>
-            <p:nvPr/>
-          </p:nvSpPr>
-          <p:spPr>
-            <a:xfrm>
-              <a:off x="4928992" y="3122172"/>
-              <a:ext cx="2160000" cy="900000"/>
-            </a:xfrm>
-            <a:prstGeom prst="rect">
-              <a:avLst/>
-            </a:prstGeom>
+            <a:headEnd type="triangle"/>
+            <a:tailEnd type="triangle"/>
+          </a:ln>
+        </p:spPr>
+        <p:style>
+          <a:lnRef idx="1">
+            <a:schemeClr val="accent1"/>
+          </a:lnRef>
+          <a:fillRef idx="0">
+            <a:schemeClr val="accent1"/>
+          </a:fillRef>
+          <a:effectRef idx="0">
+            <a:schemeClr val="accent1"/>
+          </a:effectRef>
+          <a:fontRef idx="minor">
+            <a:schemeClr val="tx1"/>
+          </a:fontRef>
+        </p:style>
+      </p:cxnSp>
+      <p:cxnSp>
+        <p:nvCxnSpPr>
+          <p:cNvPr id="28" name="직선 화살표 연결선 27"/>
+          <p:cNvCxnSpPr>
+            <a:stCxn id="4" idx="3"/>
+            <a:endCxn id="20" idx="1"/>
+          </p:cNvCxnSpPr>
+          <p:nvPr/>
+        </p:nvCxnSpPr>
+        <p:spPr>
+          <a:xfrm>
+            <a:off x="7577175" y="2902200"/>
+            <a:ext cx="2214525" cy="0"/>
+          </a:xfrm>
+          <a:prstGeom prst="straightConnector1">
+            <a:avLst/>
+          </a:prstGeom>
+          <a:ln w="76200">
             <a:solidFill>
               <a:schemeClr val="accent2"/>
             </a:solidFill>
-            <a:ln>
-              <a:noFill/>
-            </a:ln>
-          </p:spPr>
-          <p:style>
-            <a:lnRef idx="2">
-              <a:schemeClr val="accent1">
-                <a:shade val="50000"/>
-              </a:schemeClr>
-            </a:lnRef>
-            <a:fillRef idx="1">
-              <a:schemeClr val="accent1"/>
-            </a:fillRef>
-            <a:effectRef idx="0">
-              <a:schemeClr val="accent1"/>
-            </a:effectRef>
-            <a:fontRef idx="minor">
-              <a:schemeClr val="lt1"/>
-            </a:fontRef>
-          </p:style>
-          <p:txBody>
-            <a:bodyPr rtlCol="0" anchor="ctr"/>
-            <a:lstStyle/>
-            <a:p>
-              <a:pPr algn="ctr"/>
-              <a:r>
-                <a:rPr lang="en-US" altLang="ko-KR" sz="2800" dirty="0">
-                  <a:latin typeface="나눔스퀘어 Bold" panose="020B0600000101010101" pitchFamily="50" charset="-127"/>
-                  <a:ea typeface="나눔스퀘어 Bold" panose="020B0600000101010101" pitchFamily="50" charset="-127"/>
-                </a:rPr>
-                <a:t>Interceptor</a:t>
-              </a:r>
-              <a:endParaRPr lang="ko-KR" altLang="en-US" sz="2800" dirty="0">
-                <a:latin typeface="나눔스퀘어 Bold" panose="020B0600000101010101" pitchFamily="50" charset="-127"/>
-                <a:ea typeface="나눔스퀘어 Bold" panose="020B0600000101010101" pitchFamily="50" charset="-127"/>
-              </a:endParaRPr>
-            </a:p>
-          </p:txBody>
-        </p:sp>
-        <p:sp>
-          <p:nvSpPr>
-            <p:cNvPr id="35" name="직사각형 34"/>
-            <p:cNvSpPr/>
-            <p:nvPr/>
-          </p:nvSpPr>
-          <p:spPr>
-            <a:xfrm>
-              <a:off x="4928992" y="2050858"/>
-              <a:ext cx="2160000" cy="900000"/>
-            </a:xfrm>
-            <a:prstGeom prst="rect">
-              <a:avLst/>
-            </a:prstGeom>
-            <a:solidFill>
-              <a:schemeClr val="accent2"/>
-            </a:solidFill>
-            <a:ln>
-              <a:noFill/>
-            </a:ln>
-          </p:spPr>
-          <p:style>
-            <a:lnRef idx="2">
-              <a:schemeClr val="accent1">
-                <a:shade val="50000"/>
-              </a:schemeClr>
-            </a:lnRef>
-            <a:fillRef idx="1">
-              <a:schemeClr val="accent1"/>
-            </a:fillRef>
-            <a:effectRef idx="0">
-              <a:schemeClr val="accent1"/>
-            </a:effectRef>
-            <a:fontRef idx="minor">
-              <a:schemeClr val="lt1"/>
-            </a:fontRef>
-          </p:style>
-          <p:txBody>
-            <a:bodyPr rtlCol="0" anchor="ctr"/>
-            <a:lstStyle/>
-            <a:p>
-              <a:pPr algn="ctr"/>
-              <a:r>
-                <a:rPr lang="en-US" altLang="ko-KR" sz="2800">
-                  <a:latin typeface="나눔스퀘어 Bold" panose="020B0600000101010101" pitchFamily="50" charset="-127"/>
-                  <a:ea typeface="나눔스퀘어 Bold" panose="020B0600000101010101" pitchFamily="50" charset="-127"/>
-                </a:rPr>
-                <a:t>Interceptor</a:t>
-              </a:r>
-              <a:endParaRPr lang="ko-KR" altLang="en-US" sz="2800" dirty="0">
-                <a:latin typeface="나눔스퀘어 Bold" panose="020B0600000101010101" pitchFamily="50" charset="-127"/>
-                <a:ea typeface="나눔스퀘어 Bold" panose="020B0600000101010101" pitchFamily="50" charset="-127"/>
-              </a:endParaRPr>
-            </a:p>
-          </p:txBody>
-        </p:sp>
-        <p:sp>
-          <p:nvSpPr>
-            <p:cNvPr id="37" name="직사각형 36"/>
-            <p:cNvSpPr/>
-            <p:nvPr/>
-          </p:nvSpPr>
-          <p:spPr>
-            <a:xfrm>
-              <a:off x="7261612" y="1179150"/>
-              <a:ext cx="2160000" cy="2160000"/>
-            </a:xfrm>
-            <a:prstGeom prst="rect">
-              <a:avLst/>
-            </a:prstGeom>
-            <a:solidFill>
-              <a:schemeClr val="accent6"/>
-            </a:solidFill>
-            <a:ln>
-              <a:noFill/>
-            </a:ln>
-          </p:spPr>
-          <p:style>
-            <a:lnRef idx="2">
-              <a:schemeClr val="accent1">
-                <a:shade val="50000"/>
-              </a:schemeClr>
-            </a:lnRef>
-            <a:fillRef idx="1">
-              <a:schemeClr val="accent1"/>
-            </a:fillRef>
-            <a:effectRef idx="0">
-              <a:schemeClr val="accent1"/>
-            </a:effectRef>
-            <a:fontRef idx="minor">
-              <a:schemeClr val="lt1"/>
-            </a:fontRef>
-          </p:style>
-          <p:txBody>
-            <a:bodyPr rtlCol="0" anchor="ctr"/>
-            <a:lstStyle/>
-            <a:p>
-              <a:pPr algn="ctr"/>
-              <a:r>
-                <a:rPr lang="en-US" altLang="ko-KR" sz="2800" dirty="0" smtClean="0">
-                  <a:latin typeface="나눔스퀘어 Bold" panose="020B0600000101010101" pitchFamily="50" charset="-127"/>
-                  <a:ea typeface="나눔스퀘어 Bold" panose="020B0600000101010101" pitchFamily="50" charset="-127"/>
-                </a:rPr>
-                <a:t>Controller</a:t>
-              </a:r>
-              <a:endParaRPr lang="ko-KR" altLang="en-US" sz="2800" dirty="0">
-                <a:latin typeface="나눔스퀘어 Bold" panose="020B0600000101010101" pitchFamily="50" charset="-127"/>
-                <a:ea typeface="나눔스퀘어 Bold" panose="020B0600000101010101" pitchFamily="50" charset="-127"/>
-              </a:endParaRPr>
-            </a:p>
-          </p:txBody>
-        </p:sp>
-        <p:cxnSp>
-          <p:nvCxnSpPr>
-            <p:cNvPr id="15" name="직선 화살표 연결선 14"/>
-            <p:cNvCxnSpPr/>
-            <p:nvPr/>
-          </p:nvCxnSpPr>
-          <p:spPr>
-            <a:xfrm flipV="1">
-              <a:off x="2335529" y="1553029"/>
-              <a:ext cx="1440000" cy="0"/>
-            </a:xfrm>
-            <a:prstGeom prst="straightConnector1">
-              <a:avLst/>
-            </a:prstGeom>
-            <a:ln w="76200">
-              <a:solidFill>
-                <a:schemeClr val="accent2"/>
-              </a:solidFill>
-              <a:tailEnd type="triangle"/>
-            </a:ln>
-          </p:spPr>
-          <p:style>
-            <a:lnRef idx="1">
-              <a:schemeClr val="accent1"/>
-            </a:lnRef>
-            <a:fillRef idx="0">
-              <a:schemeClr val="accent1"/>
-            </a:fillRef>
-            <a:effectRef idx="0">
-              <a:schemeClr val="accent1"/>
-            </a:effectRef>
-            <a:fontRef idx="minor">
-              <a:schemeClr val="tx1"/>
-            </a:fontRef>
-          </p:style>
-        </p:cxnSp>
-        <p:cxnSp>
-          <p:nvCxnSpPr>
-            <p:cNvPr id="38" name="직선 화살표 연결선 37"/>
-            <p:cNvCxnSpPr/>
-            <p:nvPr/>
-          </p:nvCxnSpPr>
-          <p:spPr>
-            <a:xfrm flipH="1">
-              <a:off x="2489030" y="2786743"/>
-              <a:ext cx="1440000" cy="0"/>
-            </a:xfrm>
-            <a:prstGeom prst="straightConnector1">
-              <a:avLst/>
-            </a:prstGeom>
-            <a:ln w="76200">
-              <a:solidFill>
-                <a:schemeClr val="accent2"/>
-              </a:solidFill>
-              <a:tailEnd type="triangle"/>
-            </a:ln>
-          </p:spPr>
-          <p:style>
-            <a:lnRef idx="1">
-              <a:schemeClr val="accent1"/>
-            </a:lnRef>
-            <a:fillRef idx="0">
-              <a:schemeClr val="accent1"/>
-            </a:fillRef>
-            <a:effectRef idx="0">
-              <a:schemeClr val="accent1"/>
-            </a:effectRef>
-            <a:fontRef idx="minor">
-              <a:schemeClr val="tx1"/>
-            </a:fontRef>
-          </p:style>
-        </p:cxnSp>
-        <p:cxnSp>
-          <p:nvCxnSpPr>
-            <p:cNvPr id="39" name="직선 화살표 연결선 38"/>
-            <p:cNvCxnSpPr/>
-            <p:nvPr/>
-          </p:nvCxnSpPr>
-          <p:spPr>
-            <a:xfrm flipV="1">
-              <a:off x="9284901" y="1553029"/>
-              <a:ext cx="1080000" cy="0"/>
-            </a:xfrm>
-            <a:prstGeom prst="straightConnector1">
-              <a:avLst/>
-            </a:prstGeom>
-            <a:ln w="76200">
-              <a:solidFill>
-                <a:schemeClr val="accent2"/>
-              </a:solidFill>
-              <a:tailEnd type="triangle"/>
-            </a:ln>
-          </p:spPr>
-          <p:style>
-            <a:lnRef idx="1">
-              <a:schemeClr val="accent1"/>
-            </a:lnRef>
-            <a:fillRef idx="0">
-              <a:schemeClr val="accent1"/>
-            </a:fillRef>
-            <a:effectRef idx="0">
-              <a:schemeClr val="accent1"/>
-            </a:effectRef>
-            <a:fontRef idx="minor">
-              <a:schemeClr val="tx1"/>
-            </a:fontRef>
-          </p:style>
-        </p:cxnSp>
-        <p:cxnSp>
-          <p:nvCxnSpPr>
-            <p:cNvPr id="40" name="직선 화살표 연결선 39"/>
-            <p:cNvCxnSpPr/>
-            <p:nvPr/>
-          </p:nvCxnSpPr>
-          <p:spPr>
-            <a:xfrm flipH="1">
-              <a:off x="9535529" y="2786743"/>
-              <a:ext cx="1080000" cy="0"/>
-            </a:xfrm>
-            <a:prstGeom prst="straightConnector1">
-              <a:avLst/>
-            </a:prstGeom>
-            <a:ln w="76200">
-              <a:solidFill>
-                <a:schemeClr val="accent2"/>
-              </a:solidFill>
-              <a:tailEnd type="triangle"/>
-            </a:ln>
-          </p:spPr>
-          <p:style>
-            <a:lnRef idx="1">
-              <a:schemeClr val="accent1"/>
-            </a:lnRef>
-            <a:fillRef idx="0">
-              <a:schemeClr val="accent1"/>
-            </a:fillRef>
-            <a:effectRef idx="0">
-              <a:schemeClr val="accent1"/>
-            </a:effectRef>
-            <a:fontRef idx="minor">
-              <a:schemeClr val="tx1"/>
-            </a:fontRef>
-          </p:style>
-        </p:cxnSp>
-        <p:sp>
-          <p:nvSpPr>
-            <p:cNvPr id="41" name="TextBox 40"/>
-            <p:cNvSpPr txBox="1"/>
-            <p:nvPr/>
-          </p:nvSpPr>
-          <p:spPr>
-            <a:xfrm>
-              <a:off x="2621764" y="1179150"/>
-              <a:ext cx="1020729" cy="369332"/>
-            </a:xfrm>
-            <a:prstGeom prst="rect">
-              <a:avLst/>
-            </a:prstGeom>
-            <a:noFill/>
-          </p:spPr>
-          <p:txBody>
-            <a:bodyPr wrap="none" rtlCol="0">
-              <a:spAutoFit/>
-            </a:bodyPr>
-            <a:lstStyle/>
-            <a:p>
-              <a:pPr algn="ctr"/>
-              <a:r>
-                <a:rPr lang="en-US" altLang="ko-KR" dirty="0" smtClean="0">
-                  <a:latin typeface="나눔스퀘어 Bold" panose="020B0600000101010101" pitchFamily="50" charset="-127"/>
-                  <a:ea typeface="나눔스퀘어 Bold" panose="020B0600000101010101" pitchFamily="50" charset="-127"/>
-                </a:rPr>
-                <a:t>request</a:t>
-              </a:r>
-              <a:endParaRPr lang="ko-KR" altLang="en-US" dirty="0">
-                <a:latin typeface="나눔스퀘어 Bold" panose="020B0600000101010101" pitchFamily="50" charset="-127"/>
-                <a:ea typeface="나눔스퀘어 Bold" panose="020B0600000101010101" pitchFamily="50" charset="-127"/>
-              </a:endParaRPr>
-            </a:p>
-          </p:txBody>
-        </p:sp>
-        <p:sp>
-          <p:nvSpPr>
-            <p:cNvPr id="42" name="TextBox 41"/>
-            <p:cNvSpPr txBox="1"/>
-            <p:nvPr/>
-          </p:nvSpPr>
-          <p:spPr>
-            <a:xfrm>
-              <a:off x="2540812" y="2412863"/>
-              <a:ext cx="1182631" cy="369332"/>
-            </a:xfrm>
-            <a:prstGeom prst="rect">
-              <a:avLst/>
-            </a:prstGeom>
-            <a:noFill/>
-          </p:spPr>
-          <p:txBody>
-            <a:bodyPr wrap="none" rtlCol="0">
-              <a:spAutoFit/>
-            </a:bodyPr>
-            <a:lstStyle/>
-            <a:p>
-              <a:pPr algn="ctr"/>
-              <a:r>
-                <a:rPr lang="en-US" altLang="ko-KR" dirty="0" smtClean="0">
-                  <a:latin typeface="나눔스퀘어 Bold" panose="020B0600000101010101" pitchFamily="50" charset="-127"/>
-                  <a:ea typeface="나눔스퀘어 Bold" panose="020B0600000101010101" pitchFamily="50" charset="-127"/>
-                </a:rPr>
-                <a:t>response</a:t>
-              </a:r>
-              <a:endParaRPr lang="ko-KR" altLang="en-US" dirty="0">
-                <a:latin typeface="나눔스퀘어 Bold" panose="020B0600000101010101" pitchFamily="50" charset="-127"/>
-                <a:ea typeface="나눔스퀘어 Bold" panose="020B0600000101010101" pitchFamily="50" charset="-127"/>
-              </a:endParaRPr>
-            </a:p>
-          </p:txBody>
-        </p:sp>
-      </p:grpSp>
+            <a:headEnd type="triangle"/>
+            <a:tailEnd type="triangle"/>
+          </a:ln>
+        </p:spPr>
+        <p:style>
+          <a:lnRef idx="1">
+            <a:schemeClr val="accent1"/>
+          </a:lnRef>
+          <a:fillRef idx="0">
+            <a:schemeClr val="accent1"/>
+          </a:fillRef>
+          <a:effectRef idx="0">
+            <a:schemeClr val="accent1"/>
+          </a:effectRef>
+          <a:fontRef idx="minor">
+            <a:schemeClr val="tx1"/>
+          </a:fontRef>
+        </p:style>
+      </p:cxnSp>
+      <p:sp>
+        <p:nvSpPr>
+          <p:cNvPr id="33" name="직사각형 32"/>
+          <p:cNvSpPr/>
+          <p:nvPr/>
+        </p:nvSpPr>
+        <p:spPr>
+          <a:xfrm>
+            <a:off x="3117330" y="2304268"/>
+            <a:ext cx="1305165" cy="584775"/>
+          </a:xfrm>
+          <a:prstGeom prst="rect">
+            <a:avLst/>
+          </a:prstGeom>
+        </p:spPr>
+        <p:txBody>
+          <a:bodyPr wrap="none">
+            <a:spAutoFit/>
+          </a:bodyPr>
+          <a:lstStyle/>
+          <a:p>
+            <a:pPr algn="ctr"/>
+            <a:r>
+              <a:rPr lang="ko-KR" altLang="en-US" sz="3200" dirty="0" smtClean="0">
+                <a:latin typeface="나눔스퀘어 Bold" panose="020B0600000101010101" pitchFamily="50" charset="-127"/>
+                <a:ea typeface="나눔스퀘어 Bold" panose="020B0600000101010101" pitchFamily="50" charset="-127"/>
+              </a:rPr>
+              <a:t>빌려줌</a:t>
+            </a:r>
+            <a:endParaRPr lang="ko-KR" altLang="en-US" sz="3200" dirty="0">
+              <a:latin typeface="나눔스퀘어 Bold" panose="020B0600000101010101" pitchFamily="50" charset="-127"/>
+              <a:ea typeface="나눔스퀘어 Bold" panose="020B0600000101010101" pitchFamily="50" charset="-127"/>
+            </a:endParaRPr>
+          </a:p>
+        </p:txBody>
+      </p:sp>
     </p:spTree>
     <p:extLst>
       <p:ext uri="{BB962C8B-B14F-4D97-AF65-F5344CB8AC3E}">

</xml_diff>